<commit_message>
PPTX-Generator überarbeitet, alle 21 Präsentationen neu generiert, Teamseite hinzugefügt
- generate_praesentation.py: vollständig neu mit Praxisfall-Splitscreen, Tabellen,
  Bold-Definitions, Blockquote-Callouts, Ablaufplan-Slides, Reflexionsfragen
- 21 PPTX-Dateien (M01–M21) mit VR-CI neu generiert (12–36 Folien je Modul)
- app/team/page.tsx: neue Teamseite mit Benedikt Zoller + 5 KI-Agenten
  (Content Creator, Scientific Writer, Prof. Dr. Brandt, Armin, Formatter)
- NavBar: Link "Team" in NAV_END ergänzt

Co-Authored-By: Claude Sonnet 4.6 <noreply@anthropic.com>
</commit_message>
<xml_diff>
--- a/public/downloads/praesentation/M01.pptx
+++ b/public/downloads/praesentation/M01.pptx
@@ -15,6 +15,8 @@
     <p:sldId id="263" r:id="rId14"/>
     <p:sldId id="264" r:id="rId15"/>
     <p:sldId id="265" r:id="rId16"/>
+    <p:sldId id="266" r:id="rId17"/>
+    <p:sldId id="267" r:id="rId18"/>
   </p:sldIdLst>
   <p:sldSz cx="12188952" cy="6858000" type="screen4x3"/>
   <p:notesSz cx="6858000" cy="9144000"/>
@@ -3156,8 +3158,8 @@
         </p:nvSpPr>
         <p:spPr>
           <a:xfrm>
-            <a:off x="365760" y="365760"/>
-            <a:ext cx="11430000" cy="457200"/>
+            <a:off x="365760" y="320040"/>
+            <a:ext cx="11430000" cy="411480"/>
           </a:xfrm>
           <a:prstGeom prst="rect">
             <a:avLst/>
@@ -3172,13 +3174,13 @@
           <a:p>
             <a:pPr algn="l"/>
             <a:r>
-              <a:rPr sz="1100" b="0">
-                <a:solidFill>
-                  <a:srgbClr val="FFFFFF"/>
+              <a:rPr sz="1100" b="0" i="0">
+                <a:solidFill>
+                  <a:srgbClr val="BBCCEE"/>
                 </a:solidFill>
                 <a:latin typeface="Arial"/>
               </a:rPr>
-              <a:t>M01  ·  K-01 Finanzanalyse &amp; Kreditexpertise  ·  Berater  ·  90 Min.</a:t>
+              <a:t>M01  ·  K-01 Finanzanalyse &amp; Kreditexpertise  ·  Zielstufe: Berater  ·  90 Min.</a:t>
             </a:r>
           </a:p>
         </p:txBody>
@@ -3191,14 +3193,14 @@
         </p:nvSpPr>
         <p:spPr>
           <a:xfrm>
-            <a:off x="365760" y="868680"/>
-            <a:ext cx="7315200" cy="27432"/>
+            <a:off x="365760" y="804672"/>
+            <a:ext cx="8229600" cy="22860"/>
           </a:xfrm>
           <a:prstGeom prst="rect">
             <a:avLst/>
           </a:prstGeom>
           <a:solidFill>
-            <a:srgbClr val="FFFFFF"/>
+            <a:srgbClr val="335CC0"/>
           </a:solidFill>
           <a:ln>
             <a:noFill/>
@@ -3234,8 +3236,8 @@
         </p:nvSpPr>
         <p:spPr>
           <a:xfrm>
-            <a:off x="365760" y="1097280"/>
-            <a:ext cx="11430000" cy="2286000"/>
+            <a:off x="365760" y="1005840"/>
+            <a:ext cx="11430000" cy="2560320"/>
           </a:xfrm>
           <a:prstGeom prst="rect">
             <a:avLst/>
@@ -3250,7 +3252,7 @@
           <a:p>
             <a:pPr algn="l"/>
             <a:r>
-              <a:rPr sz="4000" b="1">
+              <a:rPr sz="4200" b="1" i="0">
                 <a:solidFill>
                   <a:srgbClr val="FFFFFF"/>
                 </a:solidFill>
@@ -3269,8 +3271,8 @@
         </p:nvSpPr>
         <p:spPr>
           <a:xfrm>
-            <a:off x="365760" y="3200400"/>
-            <a:ext cx="9144000" cy="914400"/>
+            <a:off x="365760" y="3383280"/>
+            <a:ext cx="10058400" cy="822960"/>
           </a:xfrm>
           <a:prstGeom prst="rect">
             <a:avLst/>
@@ -3285,7 +3287,7 @@
           <a:p>
             <a:pPr algn="l"/>
             <a:r>
-              <a:rPr sz="2000" b="0">
+              <a:rPr sz="2000" b="0" i="1">
                 <a:solidFill>
                   <a:srgbClr val="CCD6F0"/>
                 </a:solidFill>
@@ -3304,8 +3306,8 @@
         </p:nvSpPr>
         <p:spPr>
           <a:xfrm>
-            <a:off x="365760" y="6217920"/>
-            <a:ext cx="11430000" cy="457200"/>
+            <a:off x="365760" y="6309360"/>
+            <a:ext cx="11430000" cy="365760"/>
           </a:xfrm>
           <a:prstGeom prst="rect">
             <a:avLst/>
@@ -3320,9 +3322,9 @@
           <a:p>
             <a:pPr algn="l"/>
             <a:r>
-              <a:rPr sz="1000" b="0">
-                <a:solidFill>
-                  <a:srgbClr val="99AACC"/>
+              <a:rPr sz="900" b="0" i="0">
+                <a:solidFill>
+                  <a:srgbClr val="889ACC"/>
                 </a:solidFill>
                 <a:latin typeface="Arial"/>
               </a:rPr>
@@ -3340,6 +3342,744 @@
 </file>
 
 <file path=ppt/slides/slide10.xml><?xml version="1.0" encoding="utf-8"?>
+<p:sld xmlns:a="http://schemas.openxmlformats.org/drawingml/2006/main" xmlns:p="http://schemas.openxmlformats.org/presentationml/2006/main" xmlns:r="http://schemas.openxmlformats.org/officeDocument/2006/relationships">
+  <p:cSld>
+    <p:bg>
+      <p:bgPr>
+        <a:solidFill>
+          <a:srgbClr val="1A1A1A"/>
+        </a:solidFill>
+        <a:effectLst/>
+      </p:bgPr>
+    </p:bg>
+    <p:spTree>
+      <p:nvGrpSpPr>
+        <p:cNvPr id="1" name=""/>
+        <p:cNvGrpSpPr/>
+        <p:nvPr/>
+      </p:nvGrpSpPr>
+      <p:grpSpPr/>
+      <p:sp>
+        <p:nvSpPr>
+          <p:cNvPr id="2" name="Rectangle 1"/>
+          <p:cNvSpPr/>
+          <p:nvPr/>
+        </p:nvSpPr>
+        <p:spPr>
+          <a:xfrm>
+            <a:off x="0" y="0"/>
+            <a:ext cx="73152" cy="6858000"/>
+          </a:xfrm>
+          <a:prstGeom prst="rect">
+            <a:avLst/>
+          </a:prstGeom>
+          <a:solidFill>
+            <a:srgbClr val="E05B00"/>
+          </a:solidFill>
+          <a:ln>
+            <a:noFill/>
+          </a:ln>
+        </p:spPr>
+        <p:style>
+          <a:lnRef idx="1">
+            <a:schemeClr val="accent1"/>
+          </a:lnRef>
+          <a:fillRef idx="3">
+            <a:schemeClr val="accent1"/>
+          </a:fillRef>
+          <a:effectRef idx="2">
+            <a:schemeClr val="accent1"/>
+          </a:effectRef>
+          <a:fontRef idx="minor">
+            <a:schemeClr val="lt1"/>
+          </a:fontRef>
+        </p:style>
+        <p:txBody>
+          <a:bodyPr rtlCol="0" anchor="ctr"/>
+          <a:lstStyle/>
+          <a:p>
+            <a:pPr algn="ctr"/>
+          </a:p>
+        </p:txBody>
+      </p:sp>
+      <p:sp>
+        <p:nvSpPr>
+          <p:cNvPr id="3" name="TextBox 2"/>
+          <p:cNvSpPr txBox="1"/>
+          <p:nvPr/>
+        </p:nvSpPr>
+        <p:spPr>
+          <a:xfrm>
+            <a:off x="365760" y="2011680"/>
+            <a:ext cx="11430000" cy="2011680"/>
+          </a:xfrm>
+          <a:prstGeom prst="rect">
+            <a:avLst/>
+          </a:prstGeom>
+          <a:noFill/>
+        </p:spPr>
+        <p:txBody>
+          <a:bodyPr wrap="square">
+            <a:spAutoFit/>
+          </a:bodyPr>
+          <a:lstStyle/>
+          <a:p>
+            <a:pPr algn="l"/>
+            <a:r>
+              <a:rPr sz="3600" b="1" i="0">
+                <a:solidFill>
+                  <a:srgbClr val="FFFFFF"/>
+                </a:solidFill>
+                <a:latin typeface="Arial"/>
+              </a:rPr>
+              <a:t>4.3 Reflexionsfragen</a:t>
+            </a:r>
+          </a:p>
+        </p:txBody>
+      </p:sp>
+    </p:spTree>
+  </p:cSld>
+  <p:clrMapOvr>
+    <a:masterClrMapping/>
+  </p:clrMapOvr>
+</p:sld>
+</file>
+
+<file path=ppt/slides/slide11.xml><?xml version="1.0" encoding="utf-8"?>
+<p:sld xmlns:a="http://schemas.openxmlformats.org/drawingml/2006/main" xmlns:p="http://schemas.openxmlformats.org/presentationml/2006/main" xmlns:r="http://schemas.openxmlformats.org/officeDocument/2006/relationships">
+  <p:cSld>
+    <p:bg>
+      <p:bgPr>
+        <a:solidFill>
+          <a:srgbClr val="FFFFFF"/>
+        </a:solidFill>
+        <a:effectLst/>
+      </p:bgPr>
+    </p:bg>
+    <p:spTree>
+      <p:nvGrpSpPr>
+        <p:cNvPr id="1" name=""/>
+        <p:cNvGrpSpPr/>
+        <p:nvPr/>
+      </p:nvGrpSpPr>
+      <p:grpSpPr/>
+      <p:sp>
+        <p:nvSpPr>
+          <p:cNvPr id="2" name="Rectangle 1"/>
+          <p:cNvSpPr/>
+          <p:nvPr/>
+        </p:nvSpPr>
+        <p:spPr>
+          <a:xfrm>
+            <a:off x="0" y="0"/>
+            <a:ext cx="73152" cy="6858000"/>
+          </a:xfrm>
+          <a:prstGeom prst="rect">
+            <a:avLst/>
+          </a:prstGeom>
+          <a:solidFill>
+            <a:srgbClr val="003DA5"/>
+          </a:solidFill>
+          <a:ln>
+            <a:noFill/>
+          </a:ln>
+        </p:spPr>
+        <p:style>
+          <a:lnRef idx="1">
+            <a:schemeClr val="accent1"/>
+          </a:lnRef>
+          <a:fillRef idx="3">
+            <a:schemeClr val="accent1"/>
+          </a:fillRef>
+          <a:effectRef idx="2">
+            <a:schemeClr val="accent1"/>
+          </a:effectRef>
+          <a:fontRef idx="minor">
+            <a:schemeClr val="lt1"/>
+          </a:fontRef>
+        </p:style>
+        <p:txBody>
+          <a:bodyPr rtlCol="0" anchor="ctr"/>
+          <a:lstStyle/>
+          <a:p>
+            <a:pPr algn="ctr"/>
+          </a:p>
+        </p:txBody>
+      </p:sp>
+      <p:sp>
+        <p:nvSpPr>
+          <p:cNvPr id="3" name="TextBox 2"/>
+          <p:cNvSpPr txBox="1"/>
+          <p:nvPr/>
+        </p:nvSpPr>
+        <p:spPr>
+          <a:xfrm>
+            <a:off x="228600" y="182880"/>
+            <a:ext cx="11430000" cy="320040"/>
+          </a:xfrm>
+          <a:prstGeom prst="rect">
+            <a:avLst/>
+          </a:prstGeom>
+          <a:noFill/>
+        </p:spPr>
+        <p:txBody>
+          <a:bodyPr wrap="square">
+            <a:spAutoFit/>
+          </a:bodyPr>
+          <a:lstStyle/>
+          <a:p>
+            <a:pPr algn="l"/>
+            <a:r>
+              <a:rPr sz="900" b="0" i="0">
+                <a:solidFill>
+                  <a:srgbClr val="556575"/>
+                </a:solidFill>
+                <a:latin typeface="Arial"/>
+              </a:rPr>
+              <a:t>M01 · Modulinhalte</a:t>
+            </a:r>
+          </a:p>
+        </p:txBody>
+      </p:sp>
+      <p:sp>
+        <p:nvSpPr>
+          <p:cNvPr id="4" name="TextBox 3"/>
+          <p:cNvSpPr txBox="1"/>
+          <p:nvPr/>
+        </p:nvSpPr>
+        <p:spPr>
+          <a:xfrm>
+            <a:off x="365760" y="274320"/>
+            <a:ext cx="11430000" cy="777240"/>
+          </a:xfrm>
+          <a:prstGeom prst="rect">
+            <a:avLst/>
+          </a:prstGeom>
+          <a:noFill/>
+        </p:spPr>
+        <p:txBody>
+          <a:bodyPr wrap="square">
+            <a:spAutoFit/>
+          </a:bodyPr>
+          <a:lstStyle/>
+          <a:p>
+            <a:pPr algn="l"/>
+            <a:r>
+              <a:rPr sz="2200" b="1" i="0">
+                <a:solidFill>
+                  <a:srgbClr val="003DA5"/>
+                </a:solidFill>
+                <a:latin typeface="Arial"/>
+              </a:rPr>
+              <a:t>4.3 Reflexionsfragen</a:t>
+            </a:r>
+          </a:p>
+        </p:txBody>
+      </p:sp>
+      <p:sp>
+        <p:nvSpPr>
+          <p:cNvPr id="5" name="Rectangle 4"/>
+          <p:cNvSpPr/>
+          <p:nvPr/>
+        </p:nvSpPr>
+        <p:spPr>
+          <a:xfrm>
+            <a:off x="365760" y="1005840"/>
+            <a:ext cx="11430000" cy="27432"/>
+          </a:xfrm>
+          <a:prstGeom prst="rect">
+            <a:avLst/>
+          </a:prstGeom>
+          <a:solidFill>
+            <a:srgbClr val="D1D5DB"/>
+          </a:solidFill>
+          <a:ln>
+            <a:noFill/>
+          </a:ln>
+        </p:spPr>
+        <p:style>
+          <a:lnRef idx="1">
+            <a:schemeClr val="accent1"/>
+          </a:lnRef>
+          <a:fillRef idx="3">
+            <a:schemeClr val="accent1"/>
+          </a:fillRef>
+          <a:effectRef idx="2">
+            <a:schemeClr val="accent1"/>
+          </a:effectRef>
+          <a:fontRef idx="minor">
+            <a:schemeClr val="lt1"/>
+          </a:fontRef>
+        </p:style>
+        <p:txBody>
+          <a:bodyPr rtlCol="0" anchor="ctr"/>
+          <a:lstStyle/>
+          <a:p>
+            <a:pPr algn="ctr"/>
+          </a:p>
+        </p:txBody>
+      </p:sp>
+      <p:sp>
+        <p:nvSpPr>
+          <p:cNvPr id="6" name="Rectangle 5"/>
+          <p:cNvSpPr/>
+          <p:nvPr/>
+        </p:nvSpPr>
+        <p:spPr>
+          <a:xfrm>
+            <a:off x="365760" y="1188720"/>
+            <a:ext cx="457200" cy="411480"/>
+          </a:xfrm>
+          <a:prstGeom prst="rect">
+            <a:avLst/>
+          </a:prstGeom>
+          <a:solidFill>
+            <a:srgbClr val="003DA5"/>
+          </a:solidFill>
+          <a:ln>
+            <a:noFill/>
+          </a:ln>
+        </p:spPr>
+        <p:style>
+          <a:lnRef idx="1">
+            <a:schemeClr val="accent1"/>
+          </a:lnRef>
+          <a:fillRef idx="3">
+            <a:schemeClr val="accent1"/>
+          </a:fillRef>
+          <a:effectRef idx="2">
+            <a:schemeClr val="accent1"/>
+          </a:effectRef>
+          <a:fontRef idx="minor">
+            <a:schemeClr val="lt1"/>
+          </a:fontRef>
+        </p:style>
+        <p:txBody>
+          <a:bodyPr rtlCol="0" anchor="ctr"/>
+          <a:lstStyle/>
+          <a:p>
+            <a:pPr algn="ctr"/>
+          </a:p>
+        </p:txBody>
+      </p:sp>
+      <p:sp>
+        <p:nvSpPr>
+          <p:cNvPr id="7" name="TextBox 6"/>
+          <p:cNvSpPr txBox="1"/>
+          <p:nvPr/>
+        </p:nvSpPr>
+        <p:spPr>
+          <a:xfrm>
+            <a:off x="365760" y="1188720"/>
+            <a:ext cx="457200" cy="411480"/>
+          </a:xfrm>
+          <a:prstGeom prst="rect">
+            <a:avLst/>
+          </a:prstGeom>
+          <a:noFill/>
+        </p:spPr>
+        <p:txBody>
+          <a:bodyPr wrap="square">
+            <a:spAutoFit/>
+          </a:bodyPr>
+          <a:lstStyle/>
+          <a:p>
+            <a:pPr algn="ctr"/>
+            <a:r>
+              <a:rPr sz="1400" b="1" i="0">
+                <a:solidFill>
+                  <a:srgbClr val="FFFFFF"/>
+                </a:solidFill>
+                <a:latin typeface="Arial"/>
+              </a:rPr>
+              <a:t>1</a:t>
+            </a:r>
+          </a:p>
+        </p:txBody>
+      </p:sp>
+      <p:sp>
+        <p:nvSpPr>
+          <p:cNvPr id="8" name="TextBox 7"/>
+          <p:cNvSpPr txBox="1"/>
+          <p:nvPr/>
+        </p:nvSpPr>
+        <p:spPr>
+          <a:xfrm>
+            <a:off x="960120" y="1188720"/>
+            <a:ext cx="10698480" cy="502920"/>
+          </a:xfrm>
+          <a:prstGeom prst="rect">
+            <a:avLst/>
+          </a:prstGeom>
+          <a:noFill/>
+        </p:spPr>
+        <p:txBody>
+          <a:bodyPr wrap="square">
+            <a:spAutoFit/>
+          </a:bodyPr>
+          <a:lstStyle/>
+          <a:p>
+            <a:pPr algn="l"/>
+            <a:r>
+              <a:rPr sz="1500" b="0" i="0">
+                <a:solidFill>
+                  <a:srgbClr val="1A1A1A"/>
+                </a:solidFill>
+                <a:latin typeface="Arial"/>
+              </a:rPr>
+              <a:t>Welche der sechs Kennzahlen war Ihnen vor diesem Modul noch unklar?</a:t>
+            </a:r>
+          </a:p>
+        </p:txBody>
+      </p:sp>
+      <p:sp>
+        <p:nvSpPr>
+          <p:cNvPr id="9" name="Rectangle 8"/>
+          <p:cNvSpPr/>
+          <p:nvPr/>
+        </p:nvSpPr>
+        <p:spPr>
+          <a:xfrm>
+            <a:off x="365760" y="1920240"/>
+            <a:ext cx="457200" cy="411480"/>
+          </a:xfrm>
+          <a:prstGeom prst="rect">
+            <a:avLst/>
+          </a:prstGeom>
+          <a:solidFill>
+            <a:srgbClr val="003DA5"/>
+          </a:solidFill>
+          <a:ln>
+            <a:noFill/>
+          </a:ln>
+        </p:spPr>
+        <p:style>
+          <a:lnRef idx="1">
+            <a:schemeClr val="accent1"/>
+          </a:lnRef>
+          <a:fillRef idx="3">
+            <a:schemeClr val="accent1"/>
+          </a:fillRef>
+          <a:effectRef idx="2">
+            <a:schemeClr val="accent1"/>
+          </a:effectRef>
+          <a:fontRef idx="minor">
+            <a:schemeClr val="lt1"/>
+          </a:fontRef>
+        </p:style>
+        <p:txBody>
+          <a:bodyPr rtlCol="0" anchor="ctr"/>
+          <a:lstStyle/>
+          <a:p>
+            <a:pPr algn="ctr"/>
+          </a:p>
+        </p:txBody>
+      </p:sp>
+      <p:sp>
+        <p:nvSpPr>
+          <p:cNvPr id="10" name="TextBox 9"/>
+          <p:cNvSpPr txBox="1"/>
+          <p:nvPr/>
+        </p:nvSpPr>
+        <p:spPr>
+          <a:xfrm>
+            <a:off x="365760" y="1920240"/>
+            <a:ext cx="457200" cy="411480"/>
+          </a:xfrm>
+          <a:prstGeom prst="rect">
+            <a:avLst/>
+          </a:prstGeom>
+          <a:noFill/>
+        </p:spPr>
+        <p:txBody>
+          <a:bodyPr wrap="square">
+            <a:spAutoFit/>
+          </a:bodyPr>
+          <a:lstStyle/>
+          <a:p>
+            <a:pPr algn="ctr"/>
+            <a:r>
+              <a:rPr sz="1400" b="1" i="0">
+                <a:solidFill>
+                  <a:srgbClr val="FFFFFF"/>
+                </a:solidFill>
+                <a:latin typeface="Arial"/>
+              </a:rPr>
+              <a:t>2</a:t>
+            </a:r>
+          </a:p>
+        </p:txBody>
+      </p:sp>
+      <p:sp>
+        <p:nvSpPr>
+          <p:cNvPr id="11" name="TextBox 10"/>
+          <p:cNvSpPr txBox="1"/>
+          <p:nvPr/>
+        </p:nvSpPr>
+        <p:spPr>
+          <a:xfrm>
+            <a:off x="960120" y="1920240"/>
+            <a:ext cx="10698480" cy="502920"/>
+          </a:xfrm>
+          <a:prstGeom prst="rect">
+            <a:avLst/>
+          </a:prstGeom>
+          <a:noFill/>
+        </p:spPr>
+        <p:txBody>
+          <a:bodyPr wrap="square">
+            <a:spAutoFit/>
+          </a:bodyPr>
+          <a:lstStyle/>
+          <a:p>
+            <a:pPr algn="l"/>
+            <a:r>
+              <a:rPr sz="1500" b="0" i="0">
+                <a:solidFill>
+                  <a:srgbClr val="1A1A1A"/>
+                </a:solidFill>
+                <a:latin typeface="Arial"/>
+              </a:rPr>
+              <a:t>Was ist der kritischste Befund in der Bauer GmbH-Analyse? Wie würden Sie ihn im Kundengespräch ansprechen?</a:t>
+            </a:r>
+          </a:p>
+        </p:txBody>
+      </p:sp>
+      <p:sp>
+        <p:nvSpPr>
+          <p:cNvPr id="12" name="Rectangle 11"/>
+          <p:cNvSpPr/>
+          <p:nvPr/>
+        </p:nvSpPr>
+        <p:spPr>
+          <a:xfrm>
+            <a:off x="365760" y="2651760"/>
+            <a:ext cx="457200" cy="411480"/>
+          </a:xfrm>
+          <a:prstGeom prst="rect">
+            <a:avLst/>
+          </a:prstGeom>
+          <a:solidFill>
+            <a:srgbClr val="003DA5"/>
+          </a:solidFill>
+          <a:ln>
+            <a:noFill/>
+          </a:ln>
+        </p:spPr>
+        <p:style>
+          <a:lnRef idx="1">
+            <a:schemeClr val="accent1"/>
+          </a:lnRef>
+          <a:fillRef idx="3">
+            <a:schemeClr val="accent1"/>
+          </a:fillRef>
+          <a:effectRef idx="2">
+            <a:schemeClr val="accent1"/>
+          </a:effectRef>
+          <a:fontRef idx="minor">
+            <a:schemeClr val="lt1"/>
+          </a:fontRef>
+        </p:style>
+        <p:txBody>
+          <a:bodyPr rtlCol="0" anchor="ctr"/>
+          <a:lstStyle/>
+          <a:p>
+            <a:pPr algn="ctr"/>
+          </a:p>
+        </p:txBody>
+      </p:sp>
+      <p:sp>
+        <p:nvSpPr>
+          <p:cNvPr id="13" name="TextBox 12"/>
+          <p:cNvSpPr txBox="1"/>
+          <p:nvPr/>
+        </p:nvSpPr>
+        <p:spPr>
+          <a:xfrm>
+            <a:off x="365760" y="2651760"/>
+            <a:ext cx="457200" cy="411480"/>
+          </a:xfrm>
+          <a:prstGeom prst="rect">
+            <a:avLst/>
+          </a:prstGeom>
+          <a:noFill/>
+        </p:spPr>
+        <p:txBody>
+          <a:bodyPr wrap="square">
+            <a:spAutoFit/>
+          </a:bodyPr>
+          <a:lstStyle/>
+          <a:p>
+            <a:pPr algn="ctr"/>
+            <a:r>
+              <a:rPr sz="1400" b="1" i="0">
+                <a:solidFill>
+                  <a:srgbClr val="FFFFFF"/>
+                </a:solidFill>
+                <a:latin typeface="Arial"/>
+              </a:rPr>
+              <a:t>3</a:t>
+            </a:r>
+          </a:p>
+        </p:txBody>
+      </p:sp>
+      <p:sp>
+        <p:nvSpPr>
+          <p:cNvPr id="14" name="TextBox 13"/>
+          <p:cNvSpPr txBox="1"/>
+          <p:nvPr/>
+        </p:nvSpPr>
+        <p:spPr>
+          <a:xfrm>
+            <a:off x="960120" y="2651760"/>
+            <a:ext cx="10698480" cy="502920"/>
+          </a:xfrm>
+          <a:prstGeom prst="rect">
+            <a:avLst/>
+          </a:prstGeom>
+          <a:noFill/>
+        </p:spPr>
+        <p:txBody>
+          <a:bodyPr wrap="square">
+            <a:spAutoFit/>
+          </a:bodyPr>
+          <a:lstStyle/>
+          <a:p>
+            <a:pPr algn="l"/>
+            <a:r>
+              <a:rPr sz="1500" b="0" i="0">
+                <a:solidFill>
+                  <a:srgbClr val="1A1A1A"/>
+                </a:solidFill>
+                <a:latin typeface="Arial"/>
+              </a:rPr>
+              <a:t>Welcher Kunde in Ihrem Portfolio kommt Ihnen beim Blick auf die Bauer-Bilanz spontan in den Sinn?</a:t>
+            </a:r>
+          </a:p>
+        </p:txBody>
+      </p:sp>
+      <p:sp>
+        <p:nvSpPr>
+          <p:cNvPr id="15" name="Rectangle 14"/>
+          <p:cNvSpPr/>
+          <p:nvPr/>
+        </p:nvSpPr>
+        <p:spPr>
+          <a:xfrm>
+            <a:off x="365760" y="3383280"/>
+            <a:ext cx="457200" cy="411480"/>
+          </a:xfrm>
+          <a:prstGeom prst="rect">
+            <a:avLst/>
+          </a:prstGeom>
+          <a:solidFill>
+            <a:srgbClr val="003DA5"/>
+          </a:solidFill>
+          <a:ln>
+            <a:noFill/>
+          </a:ln>
+        </p:spPr>
+        <p:style>
+          <a:lnRef idx="1">
+            <a:schemeClr val="accent1"/>
+          </a:lnRef>
+          <a:fillRef idx="3">
+            <a:schemeClr val="accent1"/>
+          </a:fillRef>
+          <a:effectRef idx="2">
+            <a:schemeClr val="accent1"/>
+          </a:effectRef>
+          <a:fontRef idx="minor">
+            <a:schemeClr val="lt1"/>
+          </a:fontRef>
+        </p:style>
+        <p:txBody>
+          <a:bodyPr rtlCol="0" anchor="ctr"/>
+          <a:lstStyle/>
+          <a:p>
+            <a:pPr algn="ctr"/>
+          </a:p>
+        </p:txBody>
+      </p:sp>
+      <p:sp>
+        <p:nvSpPr>
+          <p:cNvPr id="16" name="TextBox 15"/>
+          <p:cNvSpPr txBox="1"/>
+          <p:nvPr/>
+        </p:nvSpPr>
+        <p:spPr>
+          <a:xfrm>
+            <a:off x="365760" y="3383280"/>
+            <a:ext cx="457200" cy="411480"/>
+          </a:xfrm>
+          <a:prstGeom prst="rect">
+            <a:avLst/>
+          </a:prstGeom>
+          <a:noFill/>
+        </p:spPr>
+        <p:txBody>
+          <a:bodyPr wrap="square">
+            <a:spAutoFit/>
+          </a:bodyPr>
+          <a:lstStyle/>
+          <a:p>
+            <a:pPr algn="ctr"/>
+            <a:r>
+              <a:rPr sz="1400" b="1" i="0">
+                <a:solidFill>
+                  <a:srgbClr val="FFFFFF"/>
+                </a:solidFill>
+                <a:latin typeface="Arial"/>
+              </a:rPr>
+              <a:t>4</a:t>
+            </a:r>
+          </a:p>
+        </p:txBody>
+      </p:sp>
+      <p:sp>
+        <p:nvSpPr>
+          <p:cNvPr id="17" name="TextBox 16"/>
+          <p:cNvSpPr txBox="1"/>
+          <p:nvPr/>
+        </p:nvSpPr>
+        <p:spPr>
+          <a:xfrm>
+            <a:off x="960120" y="3383280"/>
+            <a:ext cx="10698480" cy="502920"/>
+          </a:xfrm>
+          <a:prstGeom prst="rect">
+            <a:avLst/>
+          </a:prstGeom>
+          <a:noFill/>
+        </p:spPr>
+        <p:txBody>
+          <a:bodyPr wrap="square">
+            <a:spAutoFit/>
+          </a:bodyPr>
+          <a:lstStyle/>
+          <a:p>
+            <a:pPr algn="l"/>
+            <a:r>
+              <a:rPr sz="1500" b="0" i="0">
+                <a:solidFill>
+                  <a:srgbClr val="1A1A1A"/>
+                </a:solidFill>
+                <a:latin typeface="Arial"/>
+              </a:rPr>
+              <a:t>Was werden Sie konkret in den nächsten 30 Tagen anders machen, wenn ein Jahresabschluss auf Ihrem Tisch liegt?</a:t>
+            </a:r>
+          </a:p>
+        </p:txBody>
+      </p:sp>
+    </p:spTree>
+  </p:cSld>
+  <p:clrMapOvr>
+    <a:masterClrMapping/>
+  </p:clrMapOvr>
+</p:sld>
+</file>
+
+<file path=ppt/slides/slide12.xml><?xml version="1.0" encoding="utf-8"?>
 <p:sld xmlns:a="http://schemas.openxmlformats.org/drawingml/2006/main" xmlns:p="http://schemas.openxmlformats.org/presentationml/2006/main" xmlns:r="http://schemas.openxmlformats.org/officeDocument/2006/relationships">
   <p:cSld>
     <p:bg>
@@ -3408,8 +4148,8 @@
         </p:nvSpPr>
         <p:spPr>
           <a:xfrm>
-            <a:off x="365760" y="365760"/>
-            <a:ext cx="5486400" cy="365760"/>
+            <a:off x="365760" y="347472"/>
+            <a:ext cx="7315200" cy="384048"/>
           </a:xfrm>
           <a:prstGeom prst="rect">
             <a:avLst/>
@@ -3424,62 +4164,27 @@
           <a:p>
             <a:pPr algn="l"/>
             <a:r>
-              <a:rPr sz="1000" b="1">
+              <a:rPr sz="900" b="1" i="0">
                 <a:solidFill>
                   <a:srgbClr val="CCD6F0"/>
                 </a:solidFill>
                 <a:latin typeface="Arial"/>
               </a:rPr>
-              <a:t>PRAXISTRANSFER</a:t>
-            </a:r>
-          </a:p>
-        </p:txBody>
-      </p:sp>
-      <p:sp>
-        <p:nvSpPr>
-          <p:cNvPr id="4" name="TextBox 3"/>
-          <p:cNvSpPr txBox="1"/>
-          <p:nvPr/>
-        </p:nvSpPr>
-        <p:spPr>
-          <a:xfrm>
-            <a:off x="365760" y="640080"/>
-            <a:ext cx="9144000" cy="914400"/>
-          </a:xfrm>
-          <a:prstGeom prst="rect">
-            <a:avLst/>
-          </a:prstGeom>
-          <a:noFill/>
-        </p:spPr>
-        <p:txBody>
-          <a:bodyPr wrap="square">
-            <a:spAutoFit/>
-          </a:bodyPr>
-          <a:lstStyle/>
-          <a:p>
-            <a:pPr algn="l"/>
-            <a:r>
-              <a:rPr sz="2800" b="1">
-                <a:solidFill>
-                  <a:srgbClr val="FFFFFF"/>
-                </a:solidFill>
-                <a:latin typeface="Arial"/>
-              </a:rPr>
-              <a:t>Was nehmen Sie mit?</a:t>
-            </a:r>
-          </a:p>
-        </p:txBody>
-      </p:sp>
-      <p:sp>
-        <p:nvSpPr>
-          <p:cNvPr id="5" name="Rectangle 4"/>
+              <a:t>PRAXISTRANSFER &amp; NÄCHSTE SCHRITTE</a:t>
+            </a:r>
+          </a:p>
+        </p:txBody>
+      </p:sp>
+      <p:sp>
+        <p:nvSpPr>
+          <p:cNvPr id="4" name="Rectangle 3"/>
           <p:cNvSpPr/>
           <p:nvPr/>
         </p:nvSpPr>
         <p:spPr>
           <a:xfrm>
-            <a:off x="365760" y="1463040"/>
-            <a:ext cx="7315200" cy="27432"/>
+            <a:off x="365760" y="804672"/>
+            <a:ext cx="8229600" cy="22860"/>
           </a:xfrm>
           <a:prstGeom prst="rect">
             <a:avLst/>
@@ -3515,14 +4220,14 @@
       </p:sp>
       <p:sp>
         <p:nvSpPr>
-          <p:cNvPr id="6" name="TextBox 5"/>
+          <p:cNvPr id="5" name="TextBox 4"/>
           <p:cNvSpPr txBox="1"/>
           <p:nvPr/>
         </p:nvSpPr>
         <p:spPr>
           <a:xfrm>
-            <a:off x="365760" y="1645920"/>
-            <a:ext cx="11430000" cy="4114800"/>
+            <a:off x="365760" y="960120"/>
+            <a:ext cx="9144000" cy="914400"/>
           </a:xfrm>
           <a:prstGeom prst="rect">
             <a:avLst/>
@@ -3535,67 +4240,29 @@
           </a:bodyPr>
           <a:lstStyle/>
           <a:p>
-            <a:pPr>
-              <a:spcBef>
-                <a:spcPts val="400"/>
-              </a:spcBef>
-            </a:pPr>
-            <a:r>
-              <a:rPr sz="1600">
-                <a:solidFill>
-                  <a:srgbClr val="E05B00"/>
+            <a:pPr algn="l"/>
+            <a:r>
+              <a:rPr sz="3000" b="1" i="0">
+                <a:solidFill>
+                  <a:srgbClr val="FFFFFF"/>
                 </a:solidFill>
                 <a:latin typeface="Arial"/>
               </a:rPr>
-              <a:t>▪  </a:t>
-            </a:r>
-            <a:r>
-              <a:rPr sz="1800">
-                <a:solidFill>
-                  <a:srgbClr val="FFFFFF"/>
-                </a:solidFill>
-                <a:latin typeface="Arial"/>
-              </a:rPr>
-              <a:t>Transferaufgabe: Wenden Sie das Gelernte in den nächsten 14 Tagen bei einem konkreten Kunden an.</a:t>
-            </a:r>
-          </a:p>
-          <a:p>
-            <a:pPr>
-              <a:spcBef>
-                <a:spcPts val="400"/>
-              </a:spcBef>
-            </a:pPr>
-            <a:r>
-              <a:rPr sz="1600">
-                <a:solidFill>
-                  <a:srgbClr val="E05B00"/>
-                </a:solidFill>
-                <a:latin typeface="Arial"/>
-              </a:rPr>
-              <a:t>▪  </a:t>
-            </a:r>
-            <a:r>
-              <a:rPr sz="1800">
-                <a:solidFill>
-                  <a:srgbClr val="FFFFFF"/>
-                </a:solidFill>
-                <a:latin typeface="Arial"/>
-              </a:rPr>
-              <a:t>Selbstcheck nach 4 Wochen: Was hat sich verändert?</a:t>
-            </a:r>
-          </a:p>
-        </p:txBody>
-      </p:sp>
-      <p:sp>
-        <p:nvSpPr>
-          <p:cNvPr id="7" name="TextBox 6"/>
+              <a:t>Was nehmen Sie mit?</a:t>
+            </a:r>
+          </a:p>
+        </p:txBody>
+      </p:sp>
+      <p:sp>
+        <p:nvSpPr>
+          <p:cNvPr id="6" name="TextBox 5"/>
           <p:cNvSpPr txBox="1"/>
           <p:nvPr/>
         </p:nvSpPr>
         <p:spPr>
           <a:xfrm>
-            <a:off x="365760" y="6309360"/>
-            <a:ext cx="11430000" cy="365760"/>
+            <a:off x="365760" y="2103120"/>
+            <a:ext cx="11430000" cy="4114800"/>
           </a:xfrm>
           <a:prstGeom prst="rect">
             <a:avLst/>
@@ -3608,11 +4275,109 @@
           </a:bodyPr>
           <a:lstStyle/>
           <a:p>
+            <a:pPr>
+              <a:spcBef>
+                <a:spcPts val="500"/>
+              </a:spcBef>
+            </a:pPr>
+            <a:r>
+              <a:rPr sz="1600">
+                <a:solidFill>
+                  <a:srgbClr val="E05B00"/>
+                </a:solidFill>
+                <a:latin typeface="Arial"/>
+              </a:rPr>
+              <a:t>▪  </a:t>
+            </a:r>
+            <a:r>
+              <a:rPr sz="1800">
+                <a:solidFill>
+                  <a:srgbClr val="FFFFFF"/>
+                </a:solidFill>
+                <a:latin typeface="Arial"/>
+              </a:rPr>
+              <a:t>Transferaufgabe: Wenden Sie das Gelernte in den nächsten 14 Tagen bei einem konkreten Kunden an.</a:t>
+            </a:r>
+          </a:p>
+          <a:p>
+            <a:pPr>
+              <a:spcBef>
+                <a:spcPts val="500"/>
+              </a:spcBef>
+            </a:pPr>
+            <a:r>
+              <a:rPr sz="1600">
+                <a:solidFill>
+                  <a:srgbClr val="E05B00"/>
+                </a:solidFill>
+                <a:latin typeface="Arial"/>
+              </a:rPr>
+              <a:t>▪  </a:t>
+            </a:r>
+            <a:r>
+              <a:rPr sz="1800">
+                <a:solidFill>
+                  <a:srgbClr val="FFFFFF"/>
+                </a:solidFill>
+                <a:latin typeface="Arial"/>
+              </a:rPr>
+              <a:t>Selbstcheck nach 4 Wochen: Bewerten Sie Ihre Fortschritte ehrlich.</a:t>
+            </a:r>
+          </a:p>
+          <a:p>
+            <a:pPr>
+              <a:spcBef>
+                <a:spcPts val="500"/>
+              </a:spcBef>
+            </a:pPr>
+            <a:r>
+              <a:rPr sz="1600">
+                <a:solidFill>
+                  <a:srgbClr val="E05B00"/>
+                </a:solidFill>
+                <a:latin typeface="Arial"/>
+              </a:rPr>
+              <a:t>▪  </a:t>
+            </a:r>
+            <a:r>
+              <a:rPr sz="1800">
+                <a:solidFill>
+                  <a:srgbClr val="FFFFFF"/>
+                </a:solidFill>
+                <a:latin typeface="Arial"/>
+              </a:rPr>
+              <a:t>Nächste Module: M02, M04</a:t>
+            </a:r>
+          </a:p>
+        </p:txBody>
+      </p:sp>
+      <p:sp>
+        <p:nvSpPr>
+          <p:cNvPr id="7" name="TextBox 6"/>
+          <p:cNvSpPr txBox="1"/>
+          <p:nvPr/>
+        </p:nvSpPr>
+        <p:spPr>
+          <a:xfrm>
+            <a:off x="365760" y="6309360"/>
+            <a:ext cx="11430000" cy="365760"/>
+          </a:xfrm>
+          <a:prstGeom prst="rect">
+            <a:avLst/>
+          </a:prstGeom>
+          <a:noFill/>
+        </p:spPr>
+        <p:txBody>
+          <a:bodyPr wrap="square">
+            <a:spAutoFit/>
+          </a:bodyPr>
+          <a:lstStyle/>
+          <a:p>
             <a:pPr algn="l"/>
             <a:r>
-              <a:rPr sz="900" b="0">
-                <a:solidFill>
-                  <a:srgbClr val="99AACC"/>
+              <a:rPr sz="900" b="0" i="0">
+                <a:solidFill>
+                  <a:srgbClr val="889ACC"/>
                 </a:solidFill>
                 <a:latin typeface="Arial"/>
               </a:rPr>
@@ -3635,7 +4400,7 @@
     <p:bg>
       <p:bgPr>
         <a:solidFill>
-          <a:srgbClr val="F5F7FA"/>
+          <a:srgbClr val="F4F6FA"/>
         </a:solidFill>
         <a:effectLst/>
       </p:bgPr>
@@ -3698,14 +4463,14 @@
         </p:nvSpPr>
         <p:spPr>
           <a:xfrm>
-            <a:off x="365760" y="868680"/>
-            <a:ext cx="7315200" cy="27432"/>
+            <a:off x="228600" y="804672"/>
+            <a:ext cx="11612880" cy="22860"/>
           </a:xfrm>
           <a:prstGeom prst="rect">
             <a:avLst/>
           </a:prstGeom>
           <a:solidFill>
-            <a:srgbClr val="E5E7EB"/>
+            <a:srgbClr val="D1D5DB"/>
           </a:solidFill>
           <a:ln>
             <a:noFill/>
@@ -3742,7 +4507,7 @@
         <p:spPr>
           <a:xfrm>
             <a:off x="365760" y="320040"/>
-            <a:ext cx="3657600" cy="365760"/>
+            <a:ext cx="4572000" cy="347472"/>
           </a:xfrm>
           <a:prstGeom prst="rect">
             <a:avLst/>
@@ -3757,7 +4522,7 @@
           <a:p>
             <a:pPr algn="l"/>
             <a:r>
-              <a:rPr sz="1000" b="1">
+              <a:rPr sz="900" b="1" i="0">
                 <a:solidFill>
                   <a:srgbClr val="003DA5"/>
                 </a:solidFill>
@@ -3777,7 +4542,7 @@
         <p:spPr>
           <a:xfrm>
             <a:off x="365760" y="502920"/>
-            <a:ext cx="9144000" cy="548640"/>
+            <a:ext cx="10058400" cy="640080"/>
           </a:xfrm>
           <a:prstGeom prst="rect">
             <a:avLst/>
@@ -3792,7 +4557,7 @@
           <a:p>
             <a:pPr algn="l"/>
             <a:r>
-              <a:rPr sz="2200" b="1">
+              <a:rPr sz="2400" b="1" i="0">
                 <a:solidFill>
                   <a:srgbClr val="1A1A1A"/>
                 </a:solidFill>
@@ -3811,7 +4576,7 @@
         </p:nvSpPr>
         <p:spPr>
           <a:xfrm>
-            <a:off x="365760" y="1188720"/>
+            <a:off x="365760" y="1234440"/>
             <a:ext cx="11430000" cy="5303520"/>
           </a:xfrm>
           <a:prstGeom prst="rect">
@@ -3827,11 +4592,11 @@
           <a:p>
             <a:pPr>
               <a:spcBef>
-                <a:spcPts val="400"/>
+                <a:spcPts val="500"/>
               </a:spcBef>
             </a:pPr>
             <a:r>
-              <a:rPr sz="1400">
+              <a:rPr sz="1500">
                 <a:solidFill>
                   <a:srgbClr val="003DA5"/>
                 </a:solidFill>
@@ -3840,7 +4605,7 @@
               <a:t>▪  </a:t>
             </a:r>
             <a:r>
-              <a:rPr sz="1600">
+              <a:rPr sz="1700">
                 <a:solidFill>
                   <a:srgbClr val="1A1A1A"/>
                 </a:solidFill>
@@ -3852,11 +4617,11 @@
           <a:p>
             <a:pPr>
               <a:spcBef>
-                <a:spcPts val="400"/>
+                <a:spcPts val="500"/>
               </a:spcBef>
             </a:pPr>
             <a:r>
-              <a:rPr sz="1400">
+              <a:rPr sz="1500">
                 <a:solidFill>
                   <a:srgbClr val="003DA5"/>
                 </a:solidFill>
@@ -3865,7 +4630,7 @@
               <a:t>▪  </a:t>
             </a:r>
             <a:r>
-              <a:rPr sz="1600">
+              <a:rPr sz="1700">
                 <a:solidFill>
                   <a:srgbClr val="1A1A1A"/>
                 </a:solidFill>
@@ -3877,11 +4642,11 @@
           <a:p>
             <a:pPr>
               <a:spcBef>
-                <a:spcPts val="400"/>
+                <a:spcPts val="500"/>
               </a:spcBef>
             </a:pPr>
             <a:r>
-              <a:rPr sz="1400">
+              <a:rPr sz="1500">
                 <a:solidFill>
                   <a:srgbClr val="003DA5"/>
                 </a:solidFill>
@@ -3890,7 +4655,7 @@
               <a:t>▪  </a:t>
             </a:r>
             <a:r>
-              <a:rPr sz="1600">
+              <a:rPr sz="1700">
                 <a:solidFill>
                   <a:srgbClr val="1A1A1A"/>
                 </a:solidFill>
@@ -3902,11 +4667,11 @@
           <a:p>
             <a:pPr>
               <a:spcBef>
-                <a:spcPts val="400"/>
+                <a:spcPts val="500"/>
               </a:spcBef>
             </a:pPr>
             <a:r>
-              <a:rPr sz="1400">
+              <a:rPr sz="1500">
                 <a:solidFill>
                   <a:srgbClr val="003DA5"/>
                 </a:solidFill>
@@ -3915,7 +4680,7 @@
               <a:t>▪  </a:t>
             </a:r>
             <a:r>
-              <a:rPr sz="1600">
+              <a:rPr sz="1700">
                 <a:solidFill>
                   <a:srgbClr val="1A1A1A"/>
                 </a:solidFill>
@@ -3927,11 +4692,11 @@
           <a:p>
             <a:pPr>
               <a:spcBef>
-                <a:spcPts val="400"/>
+                <a:spcPts val="500"/>
               </a:spcBef>
             </a:pPr>
             <a:r>
-              <a:rPr sz="1400">
+              <a:rPr sz="1500">
                 <a:solidFill>
                   <a:srgbClr val="003DA5"/>
                 </a:solidFill>
@@ -3940,7 +4705,7 @@
               <a:t>▪  </a:t>
             </a:r>
             <a:r>
-              <a:rPr sz="1600">
+              <a:rPr sz="1700">
                 <a:solidFill>
                   <a:srgbClr val="1A1A1A"/>
                 </a:solidFill>
@@ -3965,7 +4730,7 @@
     <p:bg>
       <p:bgPr>
         <a:solidFill>
-          <a:srgbClr val="FFFFFF"/>
+          <a:srgbClr val="1A1A1A"/>
         </a:solidFill>
         <a:effectLst/>
       </p:bgPr>
@@ -3992,7 +4757,7 @@
             <a:avLst/>
           </a:prstGeom>
           <a:solidFill>
-            <a:srgbClr val="003DA5"/>
+            <a:srgbClr val="E05B00"/>
           </a:solidFill>
           <a:ln>
             <a:noFill/>
@@ -4028,8 +4793,8 @@
         </p:nvSpPr>
         <p:spPr>
           <a:xfrm>
-            <a:off x="365760" y="274320"/>
-            <a:ext cx="11430000" cy="822960"/>
+            <a:off x="365760" y="2011680"/>
+            <a:ext cx="11430000" cy="2011680"/>
           </a:xfrm>
           <a:prstGeom prst="rect">
             <a:avLst/>
@@ -4044,239 +4809,13 @@
           <a:p>
             <a:pPr algn="l"/>
             <a:r>
-              <a:rPr sz="2200" b="1">
-                <a:solidFill>
-                  <a:srgbClr val="003DA5"/>
+              <a:rPr sz="3600" b="1" i="0">
+                <a:solidFill>
+                  <a:srgbClr val="FFFFFF"/>
                 </a:solidFill>
                 <a:latin typeface="Arial"/>
               </a:rPr>
-              <a:t>Was ist ein Jahresabschluss?</a:t>
-            </a:r>
-          </a:p>
-        </p:txBody>
-      </p:sp>
-      <p:sp>
-        <p:nvSpPr>
-          <p:cNvPr id="4" name="Rectangle 3"/>
-          <p:cNvSpPr/>
-          <p:nvPr/>
-        </p:nvSpPr>
-        <p:spPr>
-          <a:xfrm>
-            <a:off x="365760" y="1051560"/>
-            <a:ext cx="11430000" cy="27432"/>
-          </a:xfrm>
-          <a:prstGeom prst="rect">
-            <a:avLst/>
-          </a:prstGeom>
-          <a:solidFill>
-            <a:srgbClr val="E5E7EB"/>
-          </a:solidFill>
-          <a:ln>
-            <a:noFill/>
-          </a:ln>
-        </p:spPr>
-        <p:style>
-          <a:lnRef idx="1">
-            <a:schemeClr val="accent1"/>
-          </a:lnRef>
-          <a:fillRef idx="3">
-            <a:schemeClr val="accent1"/>
-          </a:fillRef>
-          <a:effectRef idx="2">
-            <a:schemeClr val="accent1"/>
-          </a:effectRef>
-          <a:fontRef idx="minor">
-            <a:schemeClr val="lt1"/>
-          </a:fontRef>
-        </p:style>
-        <p:txBody>
-          <a:bodyPr rtlCol="0" anchor="ctr"/>
-          <a:lstStyle/>
-          <a:p>
-            <a:pPr algn="ctr"/>
-          </a:p>
-        </p:txBody>
-      </p:sp>
-      <p:sp>
-        <p:nvSpPr>
-          <p:cNvPr id="5" name="TextBox 4"/>
-          <p:cNvSpPr txBox="1"/>
-          <p:nvPr/>
-        </p:nvSpPr>
-        <p:spPr>
-          <a:xfrm>
-            <a:off x="365760" y="1234440"/>
-            <a:ext cx="11430000" cy="5212080"/>
-          </a:xfrm>
-          <a:prstGeom prst="rect">
-            <a:avLst/>
-          </a:prstGeom>
-          <a:noFill/>
-        </p:spPr>
-        <p:txBody>
-          <a:bodyPr wrap="square">
-            <a:spAutoFit/>
-          </a:bodyPr>
-          <a:lstStyle/>
-          <a:p>
-            <a:pPr>
-              <a:spcBef>
-                <a:spcPts val="400"/>
-              </a:spcBef>
-            </a:pPr>
-            <a:r>
-              <a:rPr sz="1500">
-                <a:solidFill>
-                  <a:srgbClr val="003DA5"/>
-                </a:solidFill>
-                <a:latin typeface="Arial"/>
-              </a:rPr>
-              <a:t>▪  </a:t>
-            </a:r>
-            <a:r>
-              <a:rPr sz="1700">
-                <a:solidFill>
-                  <a:srgbClr val="1A1A1A"/>
-                </a:solidFill>
-                <a:latin typeface="Arial"/>
-              </a:rPr>
-              <a:t>Der Jahresabschluss ist die jährliche Zusammenfassung der wirtschaftlichen Lage eines Unternehmens. Für…</a:t>
-            </a:r>
-          </a:p>
-          <a:p>
-            <a:pPr>
-              <a:spcBef>
-                <a:spcPts val="400"/>
-              </a:spcBef>
-            </a:pPr>
-            <a:r>
-              <a:rPr sz="1500">
-                <a:solidFill>
-                  <a:srgbClr val="003DA5"/>
-                </a:solidFill>
-                <a:latin typeface="Arial"/>
-              </a:rPr>
-              <a:t>▪  </a:t>
-            </a:r>
-            <a:r>
-              <a:rPr sz="1700">
-                <a:solidFill>
-                  <a:srgbClr val="1A1A1A"/>
-                </a:solidFill>
-                <a:latin typeface="Arial"/>
-              </a:rPr>
-              <a:t>Bilanz (§ 266 HGB): Stichtagsbezogene Gegenüberstellung von Vermögen (Aktiva) und Kapital (Passiva). Die Bilanz zeigt,…</a:t>
-            </a:r>
-          </a:p>
-          <a:p>
-            <a:pPr>
-              <a:spcBef>
-                <a:spcPts val="400"/>
-              </a:spcBef>
-            </a:pPr>
-            <a:r>
-              <a:rPr sz="1500">
-                <a:solidFill>
-                  <a:srgbClr val="003DA5"/>
-                </a:solidFill>
-                <a:latin typeface="Arial"/>
-              </a:rPr>
-              <a:t>▪  </a:t>
-            </a:r>
-            <a:r>
-              <a:rPr sz="1700">
-                <a:solidFill>
-                  <a:srgbClr val="1A1A1A"/>
-                </a:solidFill>
-                <a:latin typeface="Arial"/>
-              </a:rPr>
-              <a:t>Gewinn- und Verlustrechnung (§ 275 HGB): Zeitraumbezogene Darstellung von Erträgen und Aufwendungen eines…</a:t>
-            </a:r>
-          </a:p>
-          <a:p>
-            <a:pPr>
-              <a:spcBef>
-                <a:spcPts val="400"/>
-              </a:spcBef>
-            </a:pPr>
-            <a:r>
-              <a:rPr sz="1500">
-                <a:solidFill>
-                  <a:srgbClr val="003DA5"/>
-                </a:solidFill>
-                <a:latin typeface="Arial"/>
-              </a:rPr>
-              <a:t>▪  </a:t>
-            </a:r>
-            <a:r>
-              <a:rPr sz="1700">
-                <a:solidFill>
-                  <a:srgbClr val="1A1A1A"/>
-                </a:solidFill>
-                <a:latin typeface="Arial"/>
-              </a:rPr>
-              <a:t>Anhang (§ 284 HGB): Erläuterungen und Ergänzungen zu Bilanz und GuV (z.B. Bilanzierungsmethoden, Haftungsverhältnisse).…</a:t>
-            </a:r>
-          </a:p>
-          <a:p>
-            <a:pPr>
-              <a:spcBef>
-                <a:spcPts val="400"/>
-              </a:spcBef>
-            </a:pPr>
-            <a:r>
-              <a:rPr sz="1500">
-                <a:solidFill>
-                  <a:srgbClr val="003DA5"/>
-                </a:solidFill>
-                <a:latin typeface="Arial"/>
-              </a:rPr>
-              <a:t>▪  </a:t>
-            </a:r>
-            <a:r>
-              <a:rPr sz="1700">
-                <a:solidFill>
-                  <a:srgbClr val="1A1A1A"/>
-                </a:solidFill>
-                <a:latin typeface="Arial"/>
-              </a:rPr>
-              <a:t>Lagebericht (§ 289 HGB): Lageeinschätzung des Managements, Risikobericht, Ausblick. Nur für mittelgroße und große…</a:t>
-            </a:r>
-          </a:p>
-        </p:txBody>
-      </p:sp>
-      <p:sp>
-        <p:nvSpPr>
-          <p:cNvPr id="6" name="TextBox 5"/>
-          <p:cNvSpPr txBox="1"/>
-          <p:nvPr/>
-        </p:nvSpPr>
-        <p:spPr>
-          <a:xfrm>
-            <a:off x="11704320" y="6492240"/>
-            <a:ext cx="365760" cy="274320"/>
-          </a:xfrm>
-          <a:prstGeom prst="rect">
-            <a:avLst/>
-          </a:prstGeom>
-          <a:noFill/>
-        </p:spPr>
-        <p:txBody>
-          <a:bodyPr wrap="square">
-            <a:spAutoFit/>
-          </a:bodyPr>
-          <a:lstStyle/>
-          <a:p>
-            <a:pPr algn="r"/>
-            <a:r>
-              <a:rPr sz="1000" b="0">
-                <a:solidFill>
-                  <a:srgbClr val="6B7280"/>
-                </a:solidFill>
-                <a:latin typeface="Arial"/>
-              </a:rPr>
-              <a:t>1</a:t>
+              <a:t>4.1 Theorie-Input: Aufbau des HGB-Jahresabschlusses</a:t>
             </a:r>
           </a:p>
         </p:txBody>
@@ -4358,8 +4897,8 @@
         </p:nvSpPr>
         <p:spPr>
           <a:xfrm>
-            <a:off x="365760" y="274320"/>
-            <a:ext cx="11430000" cy="822960"/>
+            <a:off x="228600" y="182880"/>
+            <a:ext cx="11430000" cy="320040"/>
           </a:xfrm>
           <a:prstGeom prst="rect">
             <a:avLst/>
@@ -4374,33 +4913,68 @@
           <a:p>
             <a:pPr algn="l"/>
             <a:r>
-              <a:rPr sz="2200" b="1">
-                <a:solidFill>
-                  <a:srgbClr val="003DA5"/>
+              <a:rPr sz="900" b="0" i="0">
+                <a:solidFill>
+                  <a:srgbClr val="556575"/>
                 </a:solidFill>
                 <a:latin typeface="Arial"/>
               </a:rPr>
-              <a:t>Offenlegungspflichten und Größenklassen (§ 267 HGB)</a:t>
-            </a:r>
-          </a:p>
-        </p:txBody>
-      </p:sp>
-      <p:sp>
-        <p:nvSpPr>
-          <p:cNvPr id="4" name="Rectangle 3"/>
+              <a:t>M01 · Modulinhalte</a:t>
+            </a:r>
+          </a:p>
+        </p:txBody>
+      </p:sp>
+      <p:sp>
+        <p:nvSpPr>
+          <p:cNvPr id="4" name="TextBox 3"/>
+          <p:cNvSpPr txBox="1"/>
+          <p:nvPr/>
+        </p:nvSpPr>
+        <p:spPr>
+          <a:xfrm>
+            <a:off x="365760" y="274320"/>
+            <a:ext cx="11430000" cy="777240"/>
+          </a:xfrm>
+          <a:prstGeom prst="rect">
+            <a:avLst/>
+          </a:prstGeom>
+          <a:noFill/>
+        </p:spPr>
+        <p:txBody>
+          <a:bodyPr wrap="square">
+            <a:spAutoFit/>
+          </a:bodyPr>
+          <a:lstStyle/>
+          <a:p>
+            <a:pPr algn="l"/>
+            <a:r>
+              <a:rPr sz="2200" b="1" i="0">
+                <a:solidFill>
+                  <a:srgbClr val="003DA5"/>
+                </a:solidFill>
+                <a:latin typeface="Arial"/>
+              </a:rPr>
+              <a:t>Was ist ein Jahresabschluss?</a:t>
+            </a:r>
+          </a:p>
+        </p:txBody>
+      </p:sp>
+      <p:sp>
+        <p:nvSpPr>
+          <p:cNvPr id="5" name="Rectangle 4"/>
           <p:cNvSpPr/>
           <p:nvPr/>
         </p:nvSpPr>
         <p:spPr>
           <a:xfrm>
-            <a:off x="365760" y="1051560"/>
+            <a:off x="365760" y="1005840"/>
             <a:ext cx="11430000" cy="27432"/>
           </a:xfrm>
           <a:prstGeom prst="rect">
             <a:avLst/>
           </a:prstGeom>
           <a:solidFill>
-            <a:srgbClr val="E5E7EB"/>
+            <a:srgbClr val="D1D5DB"/>
           </a:solidFill>
           <a:ln>
             <a:noFill/>
@@ -4430,13 +5004,13 @@
       </p:sp>
       <p:sp>
         <p:nvSpPr>
-          <p:cNvPr id="5" name="TextBox 4"/>
+          <p:cNvPr id="6" name="TextBox 5"/>
           <p:cNvSpPr txBox="1"/>
           <p:nvPr/>
         </p:nvSpPr>
         <p:spPr>
           <a:xfrm>
-            <a:off x="365760" y="1234440"/>
+            <a:off x="365760" y="1143000"/>
             <a:ext cx="11430000" cy="5212080"/>
           </a:xfrm>
           <a:prstGeom prst="rect">
@@ -4452,7 +5026,7 @@
           <a:p>
             <a:pPr>
               <a:spcBef>
-                <a:spcPts val="400"/>
+                <a:spcPts val="500"/>
               </a:spcBef>
             </a:pPr>
             <a:r>
@@ -4465,48 +5039,124 @@
               <a:t>▪  </a:t>
             </a:r>
             <a:r>
-              <a:rPr sz="1700">
-                <a:solidFill>
-                  <a:srgbClr val="1A1A1A"/>
+              <a:rPr sz="1700" b="1">
+                <a:solidFill>
+                  <a:srgbClr val="003DA5"/>
                 </a:solidFill>
                 <a:latin typeface="Arial"/>
               </a:rPr>
-              <a:t>Praxishinweis: Viele Ihrer KMU-Kunden sind „kleine" GmbHs – sie legen keine GuV offen. In diesen Fällen müssen Sie die…</a:t>
-            </a:r>
-          </a:p>
-        </p:txBody>
-      </p:sp>
-      <p:sp>
-        <p:nvSpPr>
-          <p:cNvPr id="6" name="TextBox 5"/>
-          <p:cNvSpPr txBox="1"/>
-          <p:nvPr/>
-        </p:nvSpPr>
-        <p:spPr>
-          <a:xfrm>
-            <a:off x="11704320" y="6492240"/>
-            <a:ext cx="365760" cy="274320"/>
-          </a:xfrm>
-          <a:prstGeom prst="rect">
-            <a:avLst/>
-          </a:prstGeom>
-          <a:noFill/>
-        </p:spPr>
-        <p:txBody>
-          <a:bodyPr wrap="square">
-            <a:spAutoFit/>
-          </a:bodyPr>
-          <a:lstStyle/>
-          <a:p>
-            <a:pPr algn="r"/>
-            <a:r>
-              <a:rPr sz="1000" b="0">
-                <a:solidFill>
-                  <a:srgbClr val="6B7280"/>
+              <a:t>Bilanz (§ 266 HGB): </a:t>
+            </a:r>
+            <a:r>
+              <a:rPr sz="1700">
+                <a:solidFill>
+                  <a:srgbClr val="1A1A1A"/>
                 </a:solidFill>
                 <a:latin typeface="Arial"/>
               </a:rPr>
-              <a:t>2</a:t>
+              <a:t>Stichtagsbezogene Gegenüberstellung von Vermögen (Aktiva) und Kapital (Passiva). Die Bilanz zeigt, was ein Unternehmen besitzt und wie es finanziert ist.</a:t>
+            </a:r>
+          </a:p>
+          <a:p>
+            <a:pPr>
+              <a:spcBef>
+                <a:spcPts val="500"/>
+              </a:spcBef>
+            </a:pPr>
+            <a:r>
+              <a:rPr sz="1500">
+                <a:solidFill>
+                  <a:srgbClr val="003DA5"/>
+                </a:solidFill>
+                <a:latin typeface="Arial"/>
+              </a:rPr>
+              <a:t>▪  </a:t>
+            </a:r>
+            <a:r>
+              <a:rPr sz="1700" b="1">
+                <a:solidFill>
+                  <a:srgbClr val="003DA5"/>
+                </a:solidFill>
+                <a:latin typeface="Arial"/>
+              </a:rPr>
+              <a:t>Gewinn- und Verlustrechnung (§ 275 HGB): </a:t>
+            </a:r>
+            <a:r>
+              <a:rPr sz="1700">
+                <a:solidFill>
+                  <a:srgbClr val="1A1A1A"/>
+                </a:solidFill>
+                <a:latin typeface="Arial"/>
+              </a:rPr>
+              <a:t>Zeitraumbezogene Darstellung von Erträgen und Aufwendungen eines Geschäftsjahres. Sie zeigt, wie ein Unternehmen Geld verdient (oder verliert).</a:t>
+            </a:r>
+          </a:p>
+          <a:p>
+            <a:pPr>
+              <a:spcBef>
+                <a:spcPts val="500"/>
+              </a:spcBef>
+            </a:pPr>
+            <a:r>
+              <a:rPr sz="1500">
+                <a:solidFill>
+                  <a:srgbClr val="003DA5"/>
+                </a:solidFill>
+                <a:latin typeface="Arial"/>
+              </a:rPr>
+              <a:t>▪  </a:t>
+            </a:r>
+            <a:r>
+              <a:rPr sz="1700" b="1">
+                <a:solidFill>
+                  <a:srgbClr val="003DA5"/>
+                </a:solidFill>
+                <a:latin typeface="Arial"/>
+              </a:rPr>
+              <a:t>Anhang (§ 284 HGB): </a:t>
+            </a:r>
+            <a:r>
+              <a:rPr sz="1700">
+                <a:solidFill>
+                  <a:srgbClr val="1A1A1A"/>
+                </a:solidFill>
+                <a:latin typeface="Arial"/>
+              </a:rPr>
+              <a:t>Erläuterungen und Ergänzungen zu Bilanz und GuV (z.B. Bilanzierungsmethoden, Haftungsverhältnisse). Für den Kreditgeber oft wertvoller als die nackten Zahlen.</a:t>
+            </a:r>
+          </a:p>
+          <a:p>
+            <a:pPr>
+              <a:spcBef>
+                <a:spcPts val="500"/>
+              </a:spcBef>
+            </a:pPr>
+            <a:r>
+              <a:rPr sz="1500">
+                <a:solidFill>
+                  <a:srgbClr val="003DA5"/>
+                </a:solidFill>
+                <a:latin typeface="Arial"/>
+              </a:rPr>
+              <a:t>▪  </a:t>
+            </a:r>
+            <a:r>
+              <a:rPr sz="1700" b="1">
+                <a:solidFill>
+                  <a:srgbClr val="003DA5"/>
+                </a:solidFill>
+                <a:latin typeface="Arial"/>
+              </a:rPr>
+              <a:t>Lagebericht (§ 289 HGB): </a:t>
+            </a:r>
+            <a:r>
+              <a:rPr sz="1700">
+                <a:solidFill>
+                  <a:srgbClr val="1A1A1A"/>
+                </a:solidFill>
+                <a:latin typeface="Arial"/>
+              </a:rPr>
+              <a:t>Lageeinschätzung des Managements, Risikobericht, Ausblick. Nur für mittelgroße und große Unternehmen verpflichtend.</a:t>
             </a:r>
           </a:p>
         </p:txBody>
@@ -4588,8 +5238,8 @@
         </p:nvSpPr>
         <p:spPr>
           <a:xfrm>
-            <a:off x="365760" y="274320"/>
-            <a:ext cx="11430000" cy="822960"/>
+            <a:off x="228600" y="182880"/>
+            <a:ext cx="11430000" cy="320040"/>
           </a:xfrm>
           <a:prstGeom prst="rect">
             <a:avLst/>
@@ -4604,33 +5254,68 @@
           <a:p>
             <a:pPr algn="l"/>
             <a:r>
-              <a:rPr sz="2200" b="1">
-                <a:solidFill>
-                  <a:srgbClr val="003DA5"/>
+              <a:rPr sz="900" b="0" i="0">
+                <a:solidFill>
+                  <a:srgbClr val="556575"/>
                 </a:solidFill>
                 <a:latin typeface="Arial"/>
               </a:rPr>
-              <a:t>Bilanzstruktur: Mittelherkunft und -verwendung</a:t>
-            </a:r>
-          </a:p>
-        </p:txBody>
-      </p:sp>
-      <p:sp>
-        <p:nvSpPr>
-          <p:cNvPr id="4" name="Rectangle 3"/>
+              <a:t>M01 · Modulinhalte</a:t>
+            </a:r>
+          </a:p>
+        </p:txBody>
+      </p:sp>
+      <p:sp>
+        <p:nvSpPr>
+          <p:cNvPr id="4" name="TextBox 3"/>
+          <p:cNvSpPr txBox="1"/>
+          <p:nvPr/>
+        </p:nvSpPr>
+        <p:spPr>
+          <a:xfrm>
+            <a:off x="365760" y="274320"/>
+            <a:ext cx="11430000" cy="777240"/>
+          </a:xfrm>
+          <a:prstGeom prst="rect">
+            <a:avLst/>
+          </a:prstGeom>
+          <a:noFill/>
+        </p:spPr>
+        <p:txBody>
+          <a:bodyPr wrap="square">
+            <a:spAutoFit/>
+          </a:bodyPr>
+          <a:lstStyle/>
+          <a:p>
+            <a:pPr algn="l"/>
+            <a:r>
+              <a:rPr sz="2200" b="1" i="0">
+                <a:solidFill>
+                  <a:srgbClr val="003DA5"/>
+                </a:solidFill>
+                <a:latin typeface="Arial"/>
+              </a:rPr>
+              <a:t>Offenlegungspflichten und Größenklassen (§ 267 HGB)</a:t>
+            </a:r>
+          </a:p>
+        </p:txBody>
+      </p:sp>
+      <p:sp>
+        <p:nvSpPr>
+          <p:cNvPr id="5" name="Rectangle 4"/>
           <p:cNvSpPr/>
           <p:nvPr/>
         </p:nvSpPr>
         <p:spPr>
           <a:xfrm>
-            <a:off x="365760" y="1051560"/>
+            <a:off x="365760" y="1005840"/>
             <a:ext cx="11430000" cy="27432"/>
           </a:xfrm>
           <a:prstGeom prst="rect">
             <a:avLst/>
           </a:prstGeom>
           <a:solidFill>
-            <a:srgbClr val="E5E7EB"/>
+            <a:srgbClr val="D1D5DB"/>
           </a:solidFill>
           <a:ln>
             <a:noFill/>
@@ -4658,89 +5343,483 @@
           </a:p>
         </p:txBody>
       </p:sp>
-      <p:sp>
-        <p:nvSpPr>
-          <p:cNvPr id="5" name="TextBox 4"/>
-          <p:cNvSpPr txBox="1"/>
+      <p:graphicFrame>
+        <p:nvGraphicFramePr>
+          <p:cNvPr id="6" name="Table 5"/>
+          <p:cNvGraphicFramePr>
+            <a:graphicFrameLocks noGrp="1"/>
+          </p:cNvGraphicFramePr>
           <p:nvPr/>
-        </p:nvSpPr>
-        <p:spPr>
-          <a:xfrm>
-            <a:off x="365760" y="1234440"/>
-            <a:ext cx="11430000" cy="5212080"/>
-          </a:xfrm>
-          <a:prstGeom prst="rect">
-            <a:avLst/>
-          </a:prstGeom>
-          <a:noFill/>
-        </p:spPr>
-        <p:txBody>
-          <a:bodyPr wrap="square">
-            <a:spAutoFit/>
-          </a:bodyPr>
-          <a:lstStyle/>
-          <a:p>
-            <a:pPr>
-              <a:spcBef>
-                <a:spcPts val="400"/>
-              </a:spcBef>
-            </a:pPr>
-            <a:r>
-              <a:rPr sz="1500">
-                <a:solidFill>
-                  <a:srgbClr val="003DA5"/>
-                </a:solidFill>
-                <a:latin typeface="Arial"/>
-              </a:rPr>
-              <a:t>▪  </a:t>
-            </a:r>
-            <a:r>
-              <a:rPr sz="1700">
-                <a:solidFill>
-                  <a:srgbClr val="1A1A1A"/>
-                </a:solidFill>
-                <a:latin typeface="Arial"/>
-              </a:rPr>
-              <a:t>Die Goldene Bilanzregel lautet: Langfristig gebundenes Vermögen sollte durch langfristiges Kapital finanziert sein…</a:t>
-            </a:r>
-          </a:p>
-        </p:txBody>
-      </p:sp>
-      <p:sp>
-        <p:nvSpPr>
-          <p:cNvPr id="6" name="TextBox 5"/>
-          <p:cNvSpPr txBox="1"/>
-          <p:nvPr/>
-        </p:nvSpPr>
-        <p:spPr>
-          <a:xfrm>
-            <a:off x="11704320" y="6492240"/>
-            <a:ext cx="365760" cy="274320"/>
-          </a:xfrm>
-          <a:prstGeom prst="rect">
-            <a:avLst/>
-          </a:prstGeom>
-          <a:noFill/>
-        </p:spPr>
-        <p:txBody>
-          <a:bodyPr wrap="square">
-            <a:spAutoFit/>
-          </a:bodyPr>
-          <a:lstStyle/>
-          <a:p>
-            <a:pPr algn="r"/>
-            <a:r>
-              <a:rPr sz="1000" b="0">
-                <a:solidFill>
-                  <a:srgbClr val="6B7280"/>
-                </a:solidFill>
-                <a:latin typeface="Arial"/>
-              </a:rPr>
-              <a:t>3</a:t>
-            </a:r>
-          </a:p>
-        </p:txBody>
-      </p:sp>
+        </p:nvGraphicFramePr>
+        <p:xfrm>
+          <a:off x="365760" y="1143000"/>
+          <a:ext cx="11430000" cy="1901952"/>
+        </p:xfrm>
+        <a:graphic>
+          <a:graphicData uri="http://schemas.openxmlformats.org/drawingml/2006/table">
+            <a:tbl>
+              <a:tblPr firstRow="1" bandRow="1">
+                <a:tableStyleId>{5C22544A-7EE6-4342-B048-85BDC9FD1C3A}</a:tableStyleId>
+              </a:tblPr>
+              <a:tblGrid>
+                <a:gridCol w="2286000"/>
+                <a:gridCol w="2286000"/>
+                <a:gridCol w="2286000"/>
+                <a:gridCol w="2286000"/>
+                <a:gridCol w="2286000"/>
+              </a:tblGrid>
+              <a:tr h="475488">
+                <a:tc>
+                  <a:txBody>
+                    <a:bodyPr wrap="square"/>
+                    <a:lstStyle/>
+                    <a:p>
+                      <a:r>
+                        <a:rPr sz="1100" b="1">
+                          <a:solidFill>
+                            <a:srgbClr val="FFFFFF"/>
+                          </a:solidFill>
+                          <a:latin typeface="Arial"/>
+                        </a:rPr>
+                        <a:t>Größenklasse</a:t>
+                      </a:r>
+                    </a:p>
+                  </a:txBody>
+                  <a:tcPr>
+                    <a:solidFill>
+                      <a:srgbClr val="003DA5"/>
+                    </a:solidFill>
+                  </a:tcPr>
+                </a:tc>
+                <a:tc>
+                  <a:txBody>
+                    <a:bodyPr wrap="square"/>
+                    <a:lstStyle/>
+                    <a:p>
+                      <a:r>
+                        <a:rPr sz="1100" b="1">
+                          <a:solidFill>
+                            <a:srgbClr val="FFFFFF"/>
+                          </a:solidFill>
+                          <a:latin typeface="Arial"/>
+                        </a:rPr>
+                        <a:t>Bilanzsumme</a:t>
+                      </a:r>
+                    </a:p>
+                  </a:txBody>
+                  <a:tcPr>
+                    <a:solidFill>
+                      <a:srgbClr val="003DA5"/>
+                    </a:solidFill>
+                  </a:tcPr>
+                </a:tc>
+                <a:tc>
+                  <a:txBody>
+                    <a:bodyPr wrap="square"/>
+                    <a:lstStyle/>
+                    <a:p>
+                      <a:r>
+                        <a:rPr sz="1100" b="1">
+                          <a:solidFill>
+                            <a:srgbClr val="FFFFFF"/>
+                          </a:solidFill>
+                          <a:latin typeface="Arial"/>
+                        </a:rPr>
+                        <a:t>Umsatz</a:t>
+                      </a:r>
+                    </a:p>
+                  </a:txBody>
+                  <a:tcPr>
+                    <a:solidFill>
+                      <a:srgbClr val="003DA5"/>
+                    </a:solidFill>
+                  </a:tcPr>
+                </a:tc>
+                <a:tc>
+                  <a:txBody>
+                    <a:bodyPr wrap="square"/>
+                    <a:lstStyle/>
+                    <a:p>
+                      <a:r>
+                        <a:rPr sz="1100" b="1">
+                          <a:solidFill>
+                            <a:srgbClr val="FFFFFF"/>
+                          </a:solidFill>
+                          <a:latin typeface="Arial"/>
+                        </a:rPr>
+                        <a:t>Mitarbeiter</a:t>
+                      </a:r>
+                    </a:p>
+                  </a:txBody>
+                  <a:tcPr>
+                    <a:solidFill>
+                      <a:srgbClr val="003DA5"/>
+                    </a:solidFill>
+                  </a:tcPr>
+                </a:tc>
+                <a:tc>
+                  <a:txBody>
+                    <a:bodyPr wrap="square"/>
+                    <a:lstStyle/>
+                    <a:p>
+                      <a:r>
+                        <a:rPr sz="1100" b="1">
+                          <a:solidFill>
+                            <a:srgbClr val="FFFFFF"/>
+                          </a:solidFill>
+                          <a:latin typeface="Arial"/>
+                        </a:rPr>
+                        <a:t>Offenlegungspflicht</a:t>
+                      </a:r>
+                    </a:p>
+                  </a:txBody>
+                  <a:tcPr>
+                    <a:solidFill>
+                      <a:srgbClr val="003DA5"/>
+                    </a:solidFill>
+                  </a:tcPr>
+                </a:tc>
+              </a:tr>
+              <a:tr h="475488">
+                <a:tc>
+                  <a:txBody>
+                    <a:bodyPr wrap="square"/>
+                    <a:lstStyle/>
+                    <a:p>
+                      <a:r>
+                        <a:rPr sz="1100" b="0">
+                          <a:solidFill>
+                            <a:srgbClr val="1A1A1A"/>
+                          </a:solidFill>
+                          <a:latin typeface="Arial"/>
+                        </a:rPr>
+                        <a:t>Klein</a:t>
+                      </a:r>
+                    </a:p>
+                  </a:txBody>
+                  <a:tcPr>
+                    <a:solidFill>
+                      <a:srgbClr val="FFFFFF"/>
+                    </a:solidFill>
+                  </a:tcPr>
+                </a:tc>
+                <a:tc>
+                  <a:txBody>
+                    <a:bodyPr wrap="square"/>
+                    <a:lstStyle/>
+                    <a:p>
+                      <a:r>
+                        <a:rPr sz="1100" b="0">
+                          <a:solidFill>
+                            <a:srgbClr val="1A1A1A"/>
+                          </a:solidFill>
+                          <a:latin typeface="Arial"/>
+                        </a:rPr>
+                        <a:t>≤ 6 Mio. EUR</a:t>
+                      </a:r>
+                    </a:p>
+                  </a:txBody>
+                  <a:tcPr>
+                    <a:solidFill>
+                      <a:srgbClr val="FFFFFF"/>
+                    </a:solidFill>
+                  </a:tcPr>
+                </a:tc>
+                <a:tc>
+                  <a:txBody>
+                    <a:bodyPr wrap="square"/>
+                    <a:lstStyle/>
+                    <a:p>
+                      <a:r>
+                        <a:rPr sz="1100" b="0">
+                          <a:solidFill>
+                            <a:srgbClr val="1A1A1A"/>
+                          </a:solidFill>
+                          <a:latin typeface="Arial"/>
+                        </a:rPr>
+                        <a:t>≤ 12 Mio. EUR</a:t>
+                      </a:r>
+                    </a:p>
+                  </a:txBody>
+                  <a:tcPr>
+                    <a:solidFill>
+                      <a:srgbClr val="FFFFFF"/>
+                    </a:solidFill>
+                  </a:tcPr>
+                </a:tc>
+                <a:tc>
+                  <a:txBody>
+                    <a:bodyPr wrap="square"/>
+                    <a:lstStyle/>
+                    <a:p>
+                      <a:r>
+                        <a:rPr sz="1100" b="0">
+                          <a:solidFill>
+                            <a:srgbClr val="1A1A1A"/>
+                          </a:solidFill>
+                          <a:latin typeface="Arial"/>
+                        </a:rPr>
+                        <a:t>≤ 50</a:t>
+                      </a:r>
+                    </a:p>
+                  </a:txBody>
+                  <a:tcPr>
+                    <a:solidFill>
+                      <a:srgbClr val="FFFFFF"/>
+                    </a:solidFill>
+                  </a:tcPr>
+                </a:tc>
+                <a:tc>
+                  <a:txBody>
+                    <a:bodyPr wrap="square"/>
+                    <a:lstStyle/>
+                    <a:p>
+                      <a:r>
+                        <a:rPr sz="1100" b="0">
+                          <a:solidFill>
+                            <a:srgbClr val="1A1A1A"/>
+                          </a:solidFill>
+                          <a:latin typeface="Arial"/>
+                        </a:rPr>
+                        <a:t>Verkürzte Bilanz, keine GuV</a:t>
+                      </a:r>
+                    </a:p>
+                  </a:txBody>
+                  <a:tcPr>
+                    <a:solidFill>
+                      <a:srgbClr val="FFFFFF"/>
+                    </a:solidFill>
+                  </a:tcPr>
+                </a:tc>
+              </a:tr>
+              <a:tr h="475488">
+                <a:tc>
+                  <a:txBody>
+                    <a:bodyPr wrap="square"/>
+                    <a:lstStyle/>
+                    <a:p>
+                      <a:r>
+                        <a:rPr sz="1100" b="0">
+                          <a:solidFill>
+                            <a:srgbClr val="1A1A1A"/>
+                          </a:solidFill>
+                          <a:latin typeface="Arial"/>
+                        </a:rPr>
+                        <a:t>Mittel</a:t>
+                      </a:r>
+                    </a:p>
+                  </a:txBody>
+                  <a:tcPr>
+                    <a:solidFill>
+                      <a:srgbClr val="F4F6FA"/>
+                    </a:solidFill>
+                  </a:tcPr>
+                </a:tc>
+                <a:tc>
+                  <a:txBody>
+                    <a:bodyPr wrap="square"/>
+                    <a:lstStyle/>
+                    <a:p>
+                      <a:r>
+                        <a:rPr sz="1100" b="0">
+                          <a:solidFill>
+                            <a:srgbClr val="1A1A1A"/>
+                          </a:solidFill>
+                          <a:latin typeface="Arial"/>
+                        </a:rPr>
+                        <a:t>≤ 20 Mio. EUR</a:t>
+                      </a:r>
+                    </a:p>
+                  </a:txBody>
+                  <a:tcPr>
+                    <a:solidFill>
+                      <a:srgbClr val="F4F6FA"/>
+                    </a:solidFill>
+                  </a:tcPr>
+                </a:tc>
+                <a:tc>
+                  <a:txBody>
+                    <a:bodyPr wrap="square"/>
+                    <a:lstStyle/>
+                    <a:p>
+                      <a:r>
+                        <a:rPr sz="1100" b="0">
+                          <a:solidFill>
+                            <a:srgbClr val="1A1A1A"/>
+                          </a:solidFill>
+                          <a:latin typeface="Arial"/>
+                        </a:rPr>
+                        <a:t>≤ 40 Mio. EUR</a:t>
+                      </a:r>
+                    </a:p>
+                  </a:txBody>
+                  <a:tcPr>
+                    <a:solidFill>
+                      <a:srgbClr val="F4F6FA"/>
+                    </a:solidFill>
+                  </a:tcPr>
+                </a:tc>
+                <a:tc>
+                  <a:txBody>
+                    <a:bodyPr wrap="square"/>
+                    <a:lstStyle/>
+                    <a:p>
+                      <a:r>
+                        <a:rPr sz="1100" b="0">
+                          <a:solidFill>
+                            <a:srgbClr val="1A1A1A"/>
+                          </a:solidFill>
+                          <a:latin typeface="Arial"/>
+                        </a:rPr>
+                        <a:t>≤ 250</a:t>
+                      </a:r>
+                    </a:p>
+                  </a:txBody>
+                  <a:tcPr>
+                    <a:solidFill>
+                      <a:srgbClr val="F4F6FA"/>
+                    </a:solidFill>
+                  </a:tcPr>
+                </a:tc>
+                <a:tc>
+                  <a:txBody>
+                    <a:bodyPr wrap="square"/>
+                    <a:lstStyle/>
+                    <a:p>
+                      <a:r>
+                        <a:rPr sz="1100" b="0">
+                          <a:solidFill>
+                            <a:srgbClr val="1A1A1A"/>
+                          </a:solidFill>
+                          <a:latin typeface="Arial"/>
+                        </a:rPr>
+                        <a:t>Bilanz + GuV + Anhang</a:t>
+                      </a:r>
+                    </a:p>
+                  </a:txBody>
+                  <a:tcPr>
+                    <a:solidFill>
+                      <a:srgbClr val="F4F6FA"/>
+                    </a:solidFill>
+                  </a:tcPr>
+                </a:tc>
+              </a:tr>
+              <a:tr h="475488">
+                <a:tc>
+                  <a:txBody>
+                    <a:bodyPr wrap="square"/>
+                    <a:lstStyle/>
+                    <a:p>
+                      <a:r>
+                        <a:rPr sz="1100" b="0">
+                          <a:solidFill>
+                            <a:srgbClr val="1A1A1A"/>
+                          </a:solidFill>
+                          <a:latin typeface="Arial"/>
+                        </a:rPr>
+                        <a:t>Groß</a:t>
+                      </a:r>
+                    </a:p>
+                  </a:txBody>
+                  <a:tcPr>
+                    <a:solidFill>
+                      <a:srgbClr val="FFFFFF"/>
+                    </a:solidFill>
+                  </a:tcPr>
+                </a:tc>
+                <a:tc>
+                  <a:txBody>
+                    <a:bodyPr wrap="square"/>
+                    <a:lstStyle/>
+                    <a:p>
+                      <a:r>
+                        <a:rPr sz="1100" b="0">
+                          <a:solidFill>
+                            <a:srgbClr val="1A1A1A"/>
+                          </a:solidFill>
+                          <a:latin typeface="Arial"/>
+                        </a:rPr>
+                        <a:t>&gt; 20 Mio. EUR</a:t>
+                      </a:r>
+                    </a:p>
+                  </a:txBody>
+                  <a:tcPr>
+                    <a:solidFill>
+                      <a:srgbClr val="FFFFFF"/>
+                    </a:solidFill>
+                  </a:tcPr>
+                </a:tc>
+                <a:tc>
+                  <a:txBody>
+                    <a:bodyPr wrap="square"/>
+                    <a:lstStyle/>
+                    <a:p>
+                      <a:r>
+                        <a:rPr sz="1100" b="0">
+                          <a:solidFill>
+                            <a:srgbClr val="1A1A1A"/>
+                          </a:solidFill>
+                          <a:latin typeface="Arial"/>
+                        </a:rPr>
+                        <a:t>&gt; 40 Mio. EUR</a:t>
+                      </a:r>
+                    </a:p>
+                  </a:txBody>
+                  <a:tcPr>
+                    <a:solidFill>
+                      <a:srgbClr val="FFFFFF"/>
+                    </a:solidFill>
+                  </a:tcPr>
+                </a:tc>
+                <a:tc>
+                  <a:txBody>
+                    <a:bodyPr wrap="square"/>
+                    <a:lstStyle/>
+                    <a:p>
+                      <a:r>
+                        <a:rPr sz="1100" b="0">
+                          <a:solidFill>
+                            <a:srgbClr val="1A1A1A"/>
+                          </a:solidFill>
+                          <a:latin typeface="Arial"/>
+                        </a:rPr>
+                        <a:t>&gt; 250</a:t>
+                      </a:r>
+                    </a:p>
+                  </a:txBody>
+                  <a:tcPr>
+                    <a:solidFill>
+                      <a:srgbClr val="FFFFFF"/>
+                    </a:solidFill>
+                  </a:tcPr>
+                </a:tc>
+                <a:tc>
+                  <a:txBody>
+                    <a:bodyPr wrap="square"/>
+                    <a:lstStyle/>
+                    <a:p>
+                      <a:r>
+                        <a:rPr sz="1100" b="0">
+                          <a:solidFill>
+                            <a:srgbClr val="1A1A1A"/>
+                          </a:solidFill>
+                          <a:latin typeface="Arial"/>
+                        </a:rPr>
+                        <a:t>Vollständig + Lagebericht</a:t>
+                      </a:r>
+                    </a:p>
+                  </a:txBody>
+                  <a:tcPr>
+                    <a:solidFill>
+                      <a:srgbClr val="FFFFFF"/>
+                    </a:solidFill>
+                  </a:tcPr>
+                </a:tc>
+              </a:tr>
+            </a:tbl>
+          </a:graphicData>
+        </a:graphic>
+      </p:graphicFrame>
     </p:spTree>
   </p:cSld>
   <p:clrMapOvr>
@@ -4755,7 +5834,7 @@
     <p:bg>
       <p:bgPr>
         <a:solidFill>
-          <a:srgbClr val="1A1A1A"/>
+          <a:srgbClr val="FFFFFF"/>
         </a:solidFill>
         <a:effectLst/>
       </p:bgPr>
@@ -4782,7 +5861,7 @@
             <a:avLst/>
           </a:prstGeom>
           <a:solidFill>
-            <a:srgbClr val="E05B00"/>
+            <a:srgbClr val="003DA5"/>
           </a:solidFill>
           <a:ln>
             <a:noFill/>
@@ -4818,8 +5897,8 @@
         </p:nvSpPr>
         <p:spPr>
           <a:xfrm>
-            <a:off x="365760" y="2286000"/>
-            <a:ext cx="11430000" cy="1828800"/>
+            <a:off x="228600" y="182880"/>
+            <a:ext cx="11430000" cy="320040"/>
           </a:xfrm>
           <a:prstGeom prst="rect">
             <a:avLst/>
@@ -4834,13 +5913,139 @@
           <a:p>
             <a:pPr algn="l"/>
             <a:r>
-              <a:rPr sz="3600" b="1">
-                <a:solidFill>
-                  <a:srgbClr val="FFFFFF"/>
+              <a:rPr sz="900" b="0" i="0">
+                <a:solidFill>
+                  <a:srgbClr val="556575"/>
                 </a:solidFill>
                 <a:latin typeface="Arial"/>
               </a:rPr>
-              <a:t>4.2 Praxisfall: Musterbilanz „Bauer GmbH"</a:t>
+              <a:t>M01 · Modulinhalte</a:t>
+            </a:r>
+          </a:p>
+        </p:txBody>
+      </p:sp>
+      <p:sp>
+        <p:nvSpPr>
+          <p:cNvPr id="4" name="TextBox 3"/>
+          <p:cNvSpPr txBox="1"/>
+          <p:nvPr/>
+        </p:nvSpPr>
+        <p:spPr>
+          <a:xfrm>
+            <a:off x="365760" y="274320"/>
+            <a:ext cx="11430000" cy="777240"/>
+          </a:xfrm>
+          <a:prstGeom prst="rect">
+            <a:avLst/>
+          </a:prstGeom>
+          <a:noFill/>
+        </p:spPr>
+        <p:txBody>
+          <a:bodyPr wrap="square">
+            <a:spAutoFit/>
+          </a:bodyPr>
+          <a:lstStyle/>
+          <a:p>
+            <a:pPr algn="l"/>
+            <a:r>
+              <a:rPr sz="2200" b="1" i="0">
+                <a:solidFill>
+                  <a:srgbClr val="003DA5"/>
+                </a:solidFill>
+                <a:latin typeface="Arial"/>
+              </a:rPr>
+              <a:t>Bilanzstruktur: Mittelherkunft und -verwendung</a:t>
+            </a:r>
+          </a:p>
+        </p:txBody>
+      </p:sp>
+      <p:sp>
+        <p:nvSpPr>
+          <p:cNvPr id="5" name="Rectangle 4"/>
+          <p:cNvSpPr/>
+          <p:nvPr/>
+        </p:nvSpPr>
+        <p:spPr>
+          <a:xfrm>
+            <a:off x="365760" y="1005840"/>
+            <a:ext cx="11430000" cy="27432"/>
+          </a:xfrm>
+          <a:prstGeom prst="rect">
+            <a:avLst/>
+          </a:prstGeom>
+          <a:solidFill>
+            <a:srgbClr val="D1D5DB"/>
+          </a:solidFill>
+          <a:ln>
+            <a:noFill/>
+          </a:ln>
+        </p:spPr>
+        <p:style>
+          <a:lnRef idx="1">
+            <a:schemeClr val="accent1"/>
+          </a:lnRef>
+          <a:fillRef idx="3">
+            <a:schemeClr val="accent1"/>
+          </a:fillRef>
+          <a:effectRef idx="2">
+            <a:schemeClr val="accent1"/>
+          </a:effectRef>
+          <a:fontRef idx="minor">
+            <a:schemeClr val="lt1"/>
+          </a:fontRef>
+        </p:style>
+        <p:txBody>
+          <a:bodyPr rtlCol="0" anchor="ctr"/>
+          <a:lstStyle/>
+          <a:p>
+            <a:pPr algn="ctr"/>
+          </a:p>
+        </p:txBody>
+      </p:sp>
+      <p:sp>
+        <p:nvSpPr>
+          <p:cNvPr id="6" name="TextBox 5"/>
+          <p:cNvSpPr txBox="1"/>
+          <p:nvPr/>
+        </p:nvSpPr>
+        <p:spPr>
+          <a:xfrm>
+            <a:off x="365760" y="1143000"/>
+            <a:ext cx="11430000" cy="5212080"/>
+          </a:xfrm>
+          <a:prstGeom prst="rect">
+            <a:avLst/>
+          </a:prstGeom>
+          <a:noFill/>
+        </p:spPr>
+        <p:txBody>
+          <a:bodyPr wrap="square">
+            <a:spAutoFit/>
+          </a:bodyPr>
+          <a:lstStyle/>
+          <a:p>
+            <a:pPr>
+              <a:spcBef>
+                <a:spcPts val="500"/>
+              </a:spcBef>
+            </a:pPr>
+            <a:r>
+              <a:rPr sz="1500">
+                <a:solidFill>
+                  <a:srgbClr val="003DA5"/>
+                </a:solidFill>
+                <a:latin typeface="Arial"/>
+              </a:rPr>
+              <a:t>▪  </a:t>
+            </a:r>
+            <a:r>
+              <a:rPr sz="1700">
+                <a:solidFill>
+                  <a:srgbClr val="1A1A1A"/>
+                </a:solidFill>
+                <a:latin typeface="Arial"/>
+              </a:rPr>
+              <a:t>Die Goldene Bilanzregel lautet: Langfristig gebundenes Vermögen sollte durch langfristiges Kapital finanziert sein (Fristenkongruenz). Eine Verletzung – z.B.…</a:t>
             </a:r>
           </a:p>
         </p:txBody>
@@ -4859,7 +6064,7 @@
     <p:bg>
       <p:bgPr>
         <a:solidFill>
-          <a:srgbClr val="1A1A1A"/>
+          <a:srgbClr val="FFFFFF"/>
         </a:solidFill>
         <a:effectLst/>
       </p:bgPr>
@@ -4886,7 +6091,7 @@
             <a:avLst/>
           </a:prstGeom>
           <a:solidFill>
-            <a:srgbClr val="E05B00"/>
+            <a:srgbClr val="003DA5"/>
           </a:solidFill>
           <a:ln>
             <a:noFill/>
@@ -4922,8 +6127,8 @@
         </p:nvSpPr>
         <p:spPr>
           <a:xfrm>
-            <a:off x="365760" y="2286000"/>
-            <a:ext cx="11430000" cy="1828800"/>
+            <a:off x="228600" y="182880"/>
+            <a:ext cx="11430000" cy="320040"/>
           </a:xfrm>
           <a:prstGeom prst="rect">
             <a:avLst/>
@@ -4938,17 +6143,462 @@
           <a:p>
             <a:pPr algn="l"/>
             <a:r>
-              <a:rPr sz="3600" b="1">
-                <a:solidFill>
-                  <a:srgbClr val="FFFFFF"/>
+              <a:rPr sz="900" b="0" i="0">
+                <a:solidFill>
+                  <a:srgbClr val="556575"/>
                 </a:solidFill>
                 <a:latin typeface="Arial"/>
               </a:rPr>
-              <a:t>4.3 Reflexionsfragen</a:t>
-            </a:r>
-          </a:p>
-        </p:txBody>
-      </p:sp>
+              <a:t>M01 · Modulinhalte</a:t>
+            </a:r>
+          </a:p>
+        </p:txBody>
+      </p:sp>
+      <p:sp>
+        <p:nvSpPr>
+          <p:cNvPr id="4" name="TextBox 3"/>
+          <p:cNvSpPr txBox="1"/>
+          <p:nvPr/>
+        </p:nvSpPr>
+        <p:spPr>
+          <a:xfrm>
+            <a:off x="365760" y="274320"/>
+            <a:ext cx="11430000" cy="777240"/>
+          </a:xfrm>
+          <a:prstGeom prst="rect">
+            <a:avLst/>
+          </a:prstGeom>
+          <a:noFill/>
+        </p:spPr>
+        <p:txBody>
+          <a:bodyPr wrap="square">
+            <a:spAutoFit/>
+          </a:bodyPr>
+          <a:lstStyle/>
+          <a:p>
+            <a:pPr algn="l"/>
+            <a:r>
+              <a:rPr sz="2200" b="1" i="0">
+                <a:solidFill>
+                  <a:srgbClr val="003DA5"/>
+                </a:solidFill>
+                <a:latin typeface="Arial"/>
+              </a:rPr>
+              <a:t>Bilanzierungswahlrechte und ihre Wirkung</a:t>
+            </a:r>
+          </a:p>
+        </p:txBody>
+      </p:sp>
+      <p:sp>
+        <p:nvSpPr>
+          <p:cNvPr id="5" name="Rectangle 4"/>
+          <p:cNvSpPr/>
+          <p:nvPr/>
+        </p:nvSpPr>
+        <p:spPr>
+          <a:xfrm>
+            <a:off x="365760" y="1005840"/>
+            <a:ext cx="11430000" cy="27432"/>
+          </a:xfrm>
+          <a:prstGeom prst="rect">
+            <a:avLst/>
+          </a:prstGeom>
+          <a:solidFill>
+            <a:srgbClr val="D1D5DB"/>
+          </a:solidFill>
+          <a:ln>
+            <a:noFill/>
+          </a:ln>
+        </p:spPr>
+        <p:style>
+          <a:lnRef idx="1">
+            <a:schemeClr val="accent1"/>
+          </a:lnRef>
+          <a:fillRef idx="3">
+            <a:schemeClr val="accent1"/>
+          </a:fillRef>
+          <a:effectRef idx="2">
+            <a:schemeClr val="accent1"/>
+          </a:effectRef>
+          <a:fontRef idx="minor">
+            <a:schemeClr val="lt1"/>
+          </a:fontRef>
+        </p:style>
+        <p:txBody>
+          <a:bodyPr rtlCol="0" anchor="ctr"/>
+          <a:lstStyle/>
+          <a:p>
+            <a:pPr algn="ctr"/>
+          </a:p>
+        </p:txBody>
+      </p:sp>
+      <p:graphicFrame>
+        <p:nvGraphicFramePr>
+          <p:cNvPr id="6" name="Table 5"/>
+          <p:cNvGraphicFramePr>
+            <a:graphicFrameLocks noGrp="1"/>
+          </p:cNvGraphicFramePr>
+          <p:nvPr/>
+        </p:nvGraphicFramePr>
+        <p:xfrm>
+          <a:off x="365760" y="1143000"/>
+          <a:ext cx="11430000" cy="2377440"/>
+        </p:xfrm>
+        <a:graphic>
+          <a:graphicData uri="http://schemas.openxmlformats.org/drawingml/2006/table">
+            <a:tbl>
+              <a:tblPr firstRow="1" bandRow="1">
+                <a:tableStyleId>{5C22544A-7EE6-4342-B048-85BDC9FD1C3A}</a:tableStyleId>
+              </a:tblPr>
+              <a:tblGrid>
+                <a:gridCol w="3810000"/>
+                <a:gridCol w="3810000"/>
+                <a:gridCol w="3810000"/>
+              </a:tblGrid>
+              <a:tr h="475488">
+                <a:tc>
+                  <a:txBody>
+                    <a:bodyPr wrap="square"/>
+                    <a:lstStyle/>
+                    <a:p>
+                      <a:r>
+                        <a:rPr sz="1100" b="1">
+                          <a:solidFill>
+                            <a:srgbClr val="FFFFFF"/>
+                          </a:solidFill>
+                          <a:latin typeface="Arial"/>
+                        </a:rPr>
+                        <a:t>Wahlrecht</a:t>
+                      </a:r>
+                    </a:p>
+                  </a:txBody>
+                  <a:tcPr>
+                    <a:solidFill>
+                      <a:srgbClr val="003DA5"/>
+                    </a:solidFill>
+                  </a:tcPr>
+                </a:tc>
+                <a:tc>
+                  <a:txBody>
+                    <a:bodyPr wrap="square"/>
+                    <a:lstStyle/>
+                    <a:p>
+                      <a:r>
+                        <a:rPr sz="1100" b="1">
+                          <a:solidFill>
+                            <a:srgbClr val="FFFFFF"/>
+                          </a:solidFill>
+                          <a:latin typeface="Arial"/>
+                        </a:rPr>
+                        <a:t>Wirkung defensiv</a:t>
+                      </a:r>
+                    </a:p>
+                  </a:txBody>
+                  <a:tcPr>
+                    <a:solidFill>
+                      <a:srgbClr val="003DA5"/>
+                    </a:solidFill>
+                  </a:tcPr>
+                </a:tc>
+                <a:tc>
+                  <a:txBody>
+                    <a:bodyPr wrap="square"/>
+                    <a:lstStyle/>
+                    <a:p>
+                      <a:r>
+                        <a:rPr sz="1100" b="1">
+                          <a:solidFill>
+                            <a:srgbClr val="FFFFFF"/>
+                          </a:solidFill>
+                          <a:latin typeface="Arial"/>
+                        </a:rPr>
+                        <a:t>Wirkung aggressiv</a:t>
+                      </a:r>
+                    </a:p>
+                  </a:txBody>
+                  <a:tcPr>
+                    <a:solidFill>
+                      <a:srgbClr val="003DA5"/>
+                    </a:solidFill>
+                  </a:tcPr>
+                </a:tc>
+              </a:tr>
+              <a:tr h="475488">
+                <a:tc>
+                  <a:txBody>
+                    <a:bodyPr wrap="square"/>
+                    <a:lstStyle/>
+                    <a:p>
+                      <a:r>
+                        <a:rPr sz="1100" b="0">
+                          <a:solidFill>
+                            <a:srgbClr val="1A1A1A"/>
+                          </a:solidFill>
+                          <a:latin typeface="Arial"/>
+                        </a:rPr>
+                        <a:t>Herstellungskosten (§ 255 HGB)</a:t>
+                      </a:r>
+                    </a:p>
+                  </a:txBody>
+                  <a:tcPr>
+                    <a:solidFill>
+                      <a:srgbClr val="FFFFFF"/>
+                    </a:solidFill>
+                  </a:tcPr>
+                </a:tc>
+                <a:tc>
+                  <a:txBody>
+                    <a:bodyPr wrap="square"/>
+                    <a:lstStyle/>
+                    <a:p>
+                      <a:r>
+                        <a:rPr sz="1100" b="0">
+                          <a:solidFill>
+                            <a:srgbClr val="1A1A1A"/>
+                          </a:solidFill>
+                          <a:latin typeface="Arial"/>
+                        </a:rPr>
+                        <a:t>Niedrige Vorräte, niedrige Gewinne</a:t>
+                      </a:r>
+                    </a:p>
+                  </a:txBody>
+                  <a:tcPr>
+                    <a:solidFill>
+                      <a:srgbClr val="FFFFFF"/>
+                    </a:solidFill>
+                  </a:tcPr>
+                </a:tc>
+                <a:tc>
+                  <a:txBody>
+                    <a:bodyPr wrap="square"/>
+                    <a:lstStyle/>
+                    <a:p>
+                      <a:r>
+                        <a:rPr sz="1100" b="0">
+                          <a:solidFill>
+                            <a:srgbClr val="1A1A1A"/>
+                          </a:solidFill>
+                          <a:latin typeface="Arial"/>
+                        </a:rPr>
+                        <a:t>Hohe Vorräte, hohe Gewinne</a:t>
+                      </a:r>
+                    </a:p>
+                  </a:txBody>
+                  <a:tcPr>
+                    <a:solidFill>
+                      <a:srgbClr val="FFFFFF"/>
+                    </a:solidFill>
+                  </a:tcPr>
+                </a:tc>
+              </a:tr>
+              <a:tr h="475488">
+                <a:tc>
+                  <a:txBody>
+                    <a:bodyPr wrap="square"/>
+                    <a:lstStyle/>
+                    <a:p>
+                      <a:r>
+                        <a:rPr sz="1100" b="0">
+                          <a:solidFill>
+                            <a:srgbClr val="1A1A1A"/>
+                          </a:solidFill>
+                          <a:latin typeface="Arial"/>
+                        </a:rPr>
+                        <a:t>GWG-Sofortabschreibung (§ 6 Abs. 2 EStG)</a:t>
+                      </a:r>
+                    </a:p>
+                  </a:txBody>
+                  <a:tcPr>
+                    <a:solidFill>
+                      <a:srgbClr val="F4F6FA"/>
+                    </a:solidFill>
+                  </a:tcPr>
+                </a:tc>
+                <a:tc>
+                  <a:txBody>
+                    <a:bodyPr wrap="square"/>
+                    <a:lstStyle/>
+                    <a:p>
+                      <a:r>
+                        <a:rPr sz="1100" b="0">
+                          <a:solidFill>
+                            <a:srgbClr val="1A1A1A"/>
+                          </a:solidFill>
+                          <a:latin typeface="Arial"/>
+                        </a:rPr>
+                        <a:t>Höhere AfA, niedrigerer Gewinn</a:t>
+                      </a:r>
+                    </a:p>
+                  </a:txBody>
+                  <a:tcPr>
+                    <a:solidFill>
+                      <a:srgbClr val="F4F6FA"/>
+                    </a:solidFill>
+                  </a:tcPr>
+                </a:tc>
+                <a:tc>
+                  <a:txBody>
+                    <a:bodyPr wrap="square"/>
+                    <a:lstStyle/>
+                    <a:p>
+                      <a:r>
+                        <a:rPr sz="1100" b="0">
+                          <a:solidFill>
+                            <a:srgbClr val="1A1A1A"/>
+                          </a:solidFill>
+                          <a:latin typeface="Arial"/>
+                        </a:rPr>
+                        <a:t>Geringere AfA, höherer Gewinn</a:t>
+                      </a:r>
+                    </a:p>
+                  </a:txBody>
+                  <a:tcPr>
+                    <a:solidFill>
+                      <a:srgbClr val="F4F6FA"/>
+                    </a:solidFill>
+                  </a:tcPr>
+                </a:tc>
+              </a:tr>
+              <a:tr h="475488">
+                <a:tc>
+                  <a:txBody>
+                    <a:bodyPr wrap="square"/>
+                    <a:lstStyle/>
+                    <a:p>
+                      <a:r>
+                        <a:rPr sz="1100" b="0">
+                          <a:solidFill>
+                            <a:srgbClr val="1A1A1A"/>
+                          </a:solidFill>
+                          <a:latin typeface="Arial"/>
+                        </a:rPr>
+                        <a:t>Rückstellungen (§ 249 HGB)</a:t>
+                      </a:r>
+                    </a:p>
+                  </a:txBody>
+                  <a:tcPr>
+                    <a:solidFill>
+                      <a:srgbClr val="FFFFFF"/>
+                    </a:solidFill>
+                  </a:tcPr>
+                </a:tc>
+                <a:tc>
+                  <a:txBody>
+                    <a:bodyPr wrap="square"/>
+                    <a:lstStyle/>
+                    <a:p>
+                      <a:r>
+                        <a:rPr sz="1100" b="0">
+                          <a:solidFill>
+                            <a:srgbClr val="1A1A1A"/>
+                          </a:solidFill>
+                          <a:latin typeface="Arial"/>
+                        </a:rPr>
+                        <a:t>Höhere Rückstellungen, niedrigerer Gewinn</a:t>
+                      </a:r>
+                    </a:p>
+                  </a:txBody>
+                  <a:tcPr>
+                    <a:solidFill>
+                      <a:srgbClr val="FFFFFF"/>
+                    </a:solidFill>
+                  </a:tcPr>
+                </a:tc>
+                <a:tc>
+                  <a:txBody>
+                    <a:bodyPr wrap="square"/>
+                    <a:lstStyle/>
+                    <a:p>
+                      <a:r>
+                        <a:rPr sz="1100" b="0">
+                          <a:solidFill>
+                            <a:srgbClr val="1A1A1A"/>
+                          </a:solidFill>
+                          <a:latin typeface="Arial"/>
+                        </a:rPr>
+                        <a:t>Niedrigere Rückstellungen, höherer Gewinn</a:t>
+                      </a:r>
+                    </a:p>
+                  </a:txBody>
+                  <a:tcPr>
+                    <a:solidFill>
+                      <a:srgbClr val="FFFFFF"/>
+                    </a:solidFill>
+                  </a:tcPr>
+                </a:tc>
+              </a:tr>
+              <a:tr h="475488">
+                <a:tc>
+                  <a:txBody>
+                    <a:bodyPr wrap="square"/>
+                    <a:lstStyle/>
+                    <a:p>
+                      <a:r>
+                        <a:rPr sz="1100" b="0">
+                          <a:solidFill>
+                            <a:srgbClr val="1A1A1A"/>
+                          </a:solidFill>
+                          <a:latin typeface="Arial"/>
+                        </a:rPr>
+                        <a:t>Forderungsbewertung (§ 253 HGB)</a:t>
+                      </a:r>
+                    </a:p>
+                  </a:txBody>
+                  <a:tcPr>
+                    <a:solidFill>
+                      <a:srgbClr val="F4F6FA"/>
+                    </a:solidFill>
+                  </a:tcPr>
+                </a:tc>
+                <a:tc>
+                  <a:txBody>
+                    <a:bodyPr wrap="square"/>
+                    <a:lstStyle/>
+                    <a:p>
+                      <a:r>
+                        <a:rPr sz="1100" b="0">
+                          <a:solidFill>
+                            <a:srgbClr val="1A1A1A"/>
+                          </a:solidFill>
+                          <a:latin typeface="Arial"/>
+                        </a:rPr>
+                        <a:t>Strenge Abwertung bei Zweifeln</a:t>
+                      </a:r>
+                    </a:p>
+                  </a:txBody>
+                  <a:tcPr>
+                    <a:solidFill>
+                      <a:srgbClr val="F4F6FA"/>
+                    </a:solidFill>
+                  </a:tcPr>
+                </a:tc>
+                <a:tc>
+                  <a:txBody>
+                    <a:bodyPr wrap="square"/>
+                    <a:lstStyle/>
+                    <a:p>
+                      <a:r>
+                        <a:rPr sz="1100" b="0">
+                          <a:solidFill>
+                            <a:srgbClr val="1A1A1A"/>
+                          </a:solidFill>
+                          <a:latin typeface="Arial"/>
+                        </a:rPr>
+                        <a:t>Beibehaltung zweifelhafter Forderungen</a:t>
+                      </a:r>
+                    </a:p>
+                  </a:txBody>
+                  <a:tcPr>
+                    <a:solidFill>
+                      <a:srgbClr val="F4F6FA"/>
+                    </a:solidFill>
+                  </a:tcPr>
+                </a:tc>
+              </a:tr>
+            </a:tbl>
+          </a:graphicData>
+        </a:graphic>
+      </p:graphicFrame>
     </p:spTree>
   </p:cSld>
   <p:clrMapOvr>
@@ -5026,8 +6676,8 @@
         </p:nvSpPr>
         <p:spPr>
           <a:xfrm>
-            <a:off x="365760" y="2286000"/>
-            <a:ext cx="11430000" cy="1828800"/>
+            <a:off x="365760" y="2011680"/>
+            <a:ext cx="11430000" cy="2011680"/>
           </a:xfrm>
           <a:prstGeom prst="rect">
             <a:avLst/>
@@ -5042,13 +6692,48 @@
           <a:p>
             <a:pPr algn="l"/>
             <a:r>
-              <a:rPr sz="3600" b="1">
+              <a:rPr sz="3600" b="1" i="0">
                 <a:solidFill>
                   <a:srgbClr val="FFFFFF"/>
                 </a:solidFill>
                 <a:latin typeface="Arial"/>
               </a:rPr>
-              <a:t>5.1 Transferaufgabe (30 Tage nach dem Seminar)</a:t>
+              <a:t>4.2 Praxisfall: Musterbilanz „Bauer GmbH"</a:t>
+            </a:r>
+          </a:p>
+        </p:txBody>
+      </p:sp>
+      <p:sp>
+        <p:nvSpPr>
+          <p:cNvPr id="4" name="TextBox 3"/>
+          <p:cNvSpPr txBox="1"/>
+          <p:nvPr/>
+        </p:nvSpPr>
+        <p:spPr>
+          <a:xfrm>
+            <a:off x="365760" y="3931920"/>
+            <a:ext cx="10058400" cy="731520"/>
+          </a:xfrm>
+          <a:prstGeom prst="rect">
+            <a:avLst/>
+          </a:prstGeom>
+          <a:noFill/>
+        </p:spPr>
+        <p:txBody>
+          <a:bodyPr wrap="square">
+            <a:spAutoFit/>
+          </a:bodyPr>
+          <a:lstStyle/>
+          <a:p>
+            <a:pPr algn="l"/>
+            <a:r>
+              <a:rPr sz="1800" b="0" i="1">
+                <a:solidFill>
+                  <a:srgbClr val="556575"/>
+                </a:solidFill>
+                <a:latin typeface="Arial"/>
+              </a:rPr>
+              <a:t>Praxisfall &amp; Fallanalyse</a:t>
             </a:r>
           </a:p>
         </p:txBody>
@@ -5067,7 +6752,7 @@
     <p:bg>
       <p:bgPr>
         <a:solidFill>
-          <a:srgbClr val="1A1A1A"/>
+          <a:srgbClr val="FFFFFF"/>
         </a:solidFill>
         <a:effectLst/>
       </p:bgPr>
@@ -5094,6 +6779,84 @@
             <a:avLst/>
           </a:prstGeom>
           <a:solidFill>
+            <a:srgbClr val="003DA5"/>
+          </a:solidFill>
+          <a:ln>
+            <a:noFill/>
+          </a:ln>
+        </p:spPr>
+        <p:style>
+          <a:lnRef idx="1">
+            <a:schemeClr val="accent1"/>
+          </a:lnRef>
+          <a:fillRef idx="3">
+            <a:schemeClr val="accent1"/>
+          </a:fillRef>
+          <a:effectRef idx="2">
+            <a:schemeClr val="accent1"/>
+          </a:effectRef>
+          <a:fontRef idx="minor">
+            <a:schemeClr val="lt1"/>
+          </a:fontRef>
+        </p:style>
+        <p:txBody>
+          <a:bodyPr rtlCol="0" anchor="ctr"/>
+          <a:lstStyle/>
+          <a:p>
+            <a:pPr algn="ctr"/>
+          </a:p>
+        </p:txBody>
+      </p:sp>
+      <p:sp>
+        <p:nvSpPr>
+          <p:cNvPr id="3" name="TextBox 2"/>
+          <p:cNvSpPr txBox="1"/>
+          <p:nvPr/>
+        </p:nvSpPr>
+        <p:spPr>
+          <a:xfrm>
+            <a:off x="228600" y="182880"/>
+            <a:ext cx="11430000" cy="320040"/>
+          </a:xfrm>
+          <a:prstGeom prst="rect">
+            <a:avLst/>
+          </a:prstGeom>
+          <a:noFill/>
+        </p:spPr>
+        <p:txBody>
+          <a:bodyPr wrap="square">
+            <a:spAutoFit/>
+          </a:bodyPr>
+          <a:lstStyle/>
+          <a:p>
+            <a:pPr algn="l"/>
+            <a:r>
+              <a:rPr sz="900" b="0" i="0">
+                <a:solidFill>
+                  <a:srgbClr val="556575"/>
+                </a:solidFill>
+                <a:latin typeface="Arial"/>
+              </a:rPr>
+              <a:t>M01 · Modulinhalte</a:t>
+            </a:r>
+          </a:p>
+        </p:txBody>
+      </p:sp>
+      <p:sp>
+        <p:nvSpPr>
+          <p:cNvPr id="4" name="Rectangle 3"/>
+          <p:cNvSpPr/>
+          <p:nvPr/>
+        </p:nvSpPr>
+        <p:spPr>
+          <a:xfrm>
+            <a:off x="228600" y="228600"/>
+            <a:ext cx="11750040" cy="685800"/>
+          </a:xfrm>
+          <a:prstGeom prst="rect">
+            <a:avLst/>
+          </a:prstGeom>
+          <a:solidFill>
             <a:srgbClr val="E05B00"/>
           </a:solidFill>
           <a:ln>
@@ -5124,14 +6887,14 @@
       </p:sp>
       <p:sp>
         <p:nvSpPr>
-          <p:cNvPr id="3" name="TextBox 2"/>
+          <p:cNvPr id="5" name="TextBox 4"/>
           <p:cNvSpPr txBox="1"/>
           <p:nvPr/>
         </p:nvSpPr>
         <p:spPr>
           <a:xfrm>
-            <a:off x="365760" y="2286000"/>
-            <a:ext cx="11430000" cy="1828800"/>
+            <a:off x="365760" y="256032"/>
+            <a:ext cx="3657600" cy="347472"/>
           </a:xfrm>
           <a:prstGeom prst="rect">
             <a:avLst/>
@@ -5146,13 +6909,317 @@
           <a:p>
             <a:pPr algn="l"/>
             <a:r>
-              <a:rPr sz="3600" b="1">
+              <a:rPr sz="900" b="1" i="0">
                 <a:solidFill>
                   <a:srgbClr val="FFFFFF"/>
                 </a:solidFill>
                 <a:latin typeface="Arial"/>
               </a:rPr>
-              <a:t>5.2 Selbstcheck nach 4 Wochen</a:t>
+              <a:t>PRAXISFALL</a:t>
+            </a:r>
+          </a:p>
+        </p:txBody>
+      </p:sp>
+      <p:sp>
+        <p:nvSpPr>
+          <p:cNvPr id="6" name="TextBox 5"/>
+          <p:cNvSpPr txBox="1"/>
+          <p:nvPr/>
+        </p:nvSpPr>
+        <p:spPr>
+          <a:xfrm>
+            <a:off x="4114800" y="256032"/>
+            <a:ext cx="7772400" cy="384048"/>
+          </a:xfrm>
+          <a:prstGeom prst="rect">
+            <a:avLst/>
+          </a:prstGeom>
+          <a:noFill/>
+        </p:spPr>
+        <p:txBody>
+          <a:bodyPr wrap="square">
+            <a:spAutoFit/>
+          </a:bodyPr>
+          <a:lstStyle/>
+          <a:p>
+            <a:pPr algn="r"/>
+            <a:r>
+              <a:rPr sz="1600" b="1" i="0">
+                <a:solidFill>
+                  <a:srgbClr val="FFFFFF"/>
+                </a:solidFill>
+                <a:latin typeface="Arial"/>
+              </a:rPr>
+              <a:t>4.2 Praxisfall: Musterbilanz „Bauer GmbH"</a:t>
+            </a:r>
+          </a:p>
+        </p:txBody>
+      </p:sp>
+      <p:sp>
+        <p:nvSpPr>
+          <p:cNvPr id="7" name="Rectangle 6"/>
+          <p:cNvSpPr/>
+          <p:nvPr/>
+        </p:nvSpPr>
+        <p:spPr>
+          <a:xfrm>
+            <a:off x="228600" y="1005840"/>
+            <a:ext cx="5623560" cy="5120640"/>
+          </a:xfrm>
+          <a:prstGeom prst="rect">
+            <a:avLst/>
+          </a:prstGeom>
+          <a:solidFill>
+            <a:srgbClr val="F4F6FA"/>
+          </a:solidFill>
+          <a:ln>
+            <a:noFill/>
+          </a:ln>
+        </p:spPr>
+        <p:style>
+          <a:lnRef idx="1">
+            <a:schemeClr val="accent1"/>
+          </a:lnRef>
+          <a:fillRef idx="3">
+            <a:schemeClr val="accent1"/>
+          </a:fillRef>
+          <a:effectRef idx="2">
+            <a:schemeClr val="accent1"/>
+          </a:effectRef>
+          <a:fontRef idx="minor">
+            <a:schemeClr val="lt1"/>
+          </a:fontRef>
+        </p:style>
+        <p:txBody>
+          <a:bodyPr rtlCol="0" anchor="ctr"/>
+          <a:lstStyle/>
+          <a:p>
+            <a:pPr algn="ctr"/>
+          </a:p>
+        </p:txBody>
+      </p:sp>
+      <p:sp>
+        <p:nvSpPr>
+          <p:cNvPr id="8" name="TextBox 7"/>
+          <p:cNvSpPr txBox="1"/>
+          <p:nvPr/>
+        </p:nvSpPr>
+        <p:spPr>
+          <a:xfrm>
+            <a:off x="411480" y="1097280"/>
+            <a:ext cx="5120640" cy="365760"/>
+          </a:xfrm>
+          <a:prstGeom prst="rect">
+            <a:avLst/>
+          </a:prstGeom>
+          <a:noFill/>
+        </p:spPr>
+        <p:txBody>
+          <a:bodyPr wrap="square">
+            <a:spAutoFit/>
+          </a:bodyPr>
+          <a:lstStyle/>
+          <a:p>
+            <a:pPr algn="l"/>
+            <a:r>
+              <a:rPr sz="800" b="1" i="0">
+                <a:solidFill>
+                  <a:srgbClr val="556575"/>
+                </a:solidFill>
+                <a:latin typeface="Arial"/>
+              </a:rPr>
+              <a:t>UNTERNEHMENSPORTRAIT</a:t>
+            </a:r>
+          </a:p>
+        </p:txBody>
+      </p:sp>
+      <p:sp>
+        <p:nvSpPr>
+          <p:cNvPr id="9" name="TextBox 8"/>
+          <p:cNvSpPr txBox="1"/>
+          <p:nvPr/>
+        </p:nvSpPr>
+        <p:spPr>
+          <a:xfrm>
+            <a:off x="411480" y="1508760"/>
+            <a:ext cx="5212080" cy="4389120"/>
+          </a:xfrm>
+          <a:prstGeom prst="rect">
+            <a:avLst/>
+          </a:prstGeom>
+          <a:noFill/>
+        </p:spPr>
+        <p:txBody>
+          <a:bodyPr wrap="square">
+            <a:spAutoFit/>
+          </a:bodyPr>
+          <a:lstStyle/>
+          <a:p>
+            <a:pPr algn="l"/>
+            <a:r>
+              <a:rPr sz="1300" b="0" i="0">
+                <a:solidFill>
+                  <a:srgbClr val="1A1A1A"/>
+                </a:solidFill>
+                <a:latin typeface="Arial"/>
+              </a:rPr>
+              <a:t>Die Bauer GmbH ist ein mittelständischer Maschinenbauer aus Süddeutschland mit ca. 65 Mitarbeitern. Das Unternehmen produziert Sondermaschinen für die Lebensmittelbranche (Einzelfertigung und Kleinserie). Der Gesellschafter-Geschäftsführer führt das Unternehmen seit 18 Jahren. Die VR-Bank ist Hausbank mit einem bestehenden Investitionsdarlehen (Restschuld 780.000 EUR) und einem Kontokorrentrahmen von 400.000 EUR, der in den letzten 12 Monaten dauerhaft zu 85 % ausgelastet war.</a:t>
+            </a:r>
+          </a:p>
+        </p:txBody>
+      </p:sp>
+      <p:sp>
+        <p:nvSpPr>
+          <p:cNvPr id="10" name="Rectangle 9"/>
+          <p:cNvSpPr/>
+          <p:nvPr/>
+        </p:nvSpPr>
+        <p:spPr>
+          <a:xfrm>
+            <a:off x="5989320" y="1005840"/>
+            <a:ext cx="5989320" cy="5120640"/>
+          </a:xfrm>
+          <a:prstGeom prst="rect">
+            <a:avLst/>
+          </a:prstGeom>
+          <a:solidFill>
+            <a:srgbClr val="FFF8F0"/>
+          </a:solidFill>
+          <a:ln>
+            <a:noFill/>
+          </a:ln>
+        </p:spPr>
+        <p:style>
+          <a:lnRef idx="1">
+            <a:schemeClr val="accent1"/>
+          </a:lnRef>
+          <a:fillRef idx="3">
+            <a:schemeClr val="accent1"/>
+          </a:fillRef>
+          <a:effectRef idx="2">
+            <a:schemeClr val="accent1"/>
+          </a:effectRef>
+          <a:fontRef idx="minor">
+            <a:schemeClr val="lt1"/>
+          </a:fontRef>
+        </p:style>
+        <p:txBody>
+          <a:bodyPr rtlCol="0" anchor="ctr"/>
+          <a:lstStyle/>
+          <a:p>
+            <a:pPr algn="ctr"/>
+          </a:p>
+        </p:txBody>
+      </p:sp>
+      <p:sp>
+        <p:nvSpPr>
+          <p:cNvPr id="11" name="Rectangle 10"/>
+          <p:cNvSpPr/>
+          <p:nvPr/>
+        </p:nvSpPr>
+        <p:spPr>
+          <a:xfrm>
+            <a:off x="5989320" y="1005840"/>
+            <a:ext cx="54864" cy="5120640"/>
+          </a:xfrm>
+          <a:prstGeom prst="rect">
+            <a:avLst/>
+          </a:prstGeom>
+          <a:solidFill>
+            <a:srgbClr val="E05B00"/>
+          </a:solidFill>
+          <a:ln>
+            <a:noFill/>
+          </a:ln>
+        </p:spPr>
+        <p:style>
+          <a:lnRef idx="1">
+            <a:schemeClr val="accent1"/>
+          </a:lnRef>
+          <a:fillRef idx="3">
+            <a:schemeClr val="accent1"/>
+          </a:fillRef>
+          <a:effectRef idx="2">
+            <a:schemeClr val="accent1"/>
+          </a:effectRef>
+          <a:fontRef idx="minor">
+            <a:schemeClr val="lt1"/>
+          </a:fontRef>
+        </p:style>
+        <p:txBody>
+          <a:bodyPr rtlCol="0" anchor="ctr"/>
+          <a:lstStyle/>
+          <a:p>
+            <a:pPr algn="ctr"/>
+          </a:p>
+        </p:txBody>
+      </p:sp>
+      <p:sp>
+        <p:nvSpPr>
+          <p:cNvPr id="12" name="TextBox 11"/>
+          <p:cNvSpPr txBox="1"/>
+          <p:nvPr/>
+        </p:nvSpPr>
+        <p:spPr>
+          <a:xfrm>
+            <a:off x="6172200" y="1097280"/>
+            <a:ext cx="5486400" cy="365760"/>
+          </a:xfrm>
+          <a:prstGeom prst="rect">
+            <a:avLst/>
+          </a:prstGeom>
+          <a:noFill/>
+        </p:spPr>
+        <p:txBody>
+          <a:bodyPr wrap="square">
+            <a:spAutoFit/>
+          </a:bodyPr>
+          <a:lstStyle/>
+          <a:p>
+            <a:pPr algn="l"/>
+            <a:r>
+              <a:rPr sz="800" b="1" i="0">
+                <a:solidFill>
+                  <a:srgbClr val="E05B00"/>
+                </a:solidFill>
+                <a:latin typeface="Arial"/>
+              </a:rPr>
+              <a:t>SITUATION &amp; AUFTRAG</a:t>
+            </a:r>
+          </a:p>
+        </p:txBody>
+      </p:sp>
+      <p:sp>
+        <p:nvSpPr>
+          <p:cNvPr id="13" name="TextBox 12"/>
+          <p:cNvSpPr txBox="1"/>
+          <p:nvPr/>
+        </p:nvSpPr>
+        <p:spPr>
+          <a:xfrm>
+            <a:off x="6172200" y="1508760"/>
+            <a:ext cx="5623560" cy="4389120"/>
+          </a:xfrm>
+          <a:prstGeom prst="rect">
+            <a:avLst/>
+          </a:prstGeom>
+          <a:noFill/>
+        </p:spPr>
+        <p:txBody>
+          <a:bodyPr wrap="square">
+            <a:spAutoFit/>
+          </a:bodyPr>
+          <a:lstStyle/>
+          <a:p>
+            <a:pPr algn="l"/>
+            <a:r>
+              <a:rPr sz="1400" b="0" i="0">
+                <a:solidFill>
+                  <a:srgbClr val="1A1A1A"/>
+                </a:solidFill>
+                <a:latin typeface="Arial"/>
+              </a:rPr>
+              <a:t>Der Kunde beantragt ein neues Investitionsdarlehen über 650.000 EUR für eine neue CNC-Fräsmaschine. Sie bereiten die Kreditvorlage vor und lesen den Jahresabschluss 2023.</a:t>
             </a:r>
           </a:p>
         </p:txBody>

</xml_diff>

<commit_message>
PPTX: Agenda-Umbruch, Quellen, Blau statt Schwarz, Text-Overflow behoben
- Agenda: word_wrap=False auf Zahlenspalte (kein III-Umbruch mehr)
- Section Divider + Quellenapparat: PRIMARY-Blau statt INK-Schwarz
- Tabellen-Header: PRIMARY statt INK
- Quellenextraktion: erkennt jetzt auch nummerierte Listen
- Selbstcheck: zeigt Tabelle wenn vorhanden
- Praxisfall-Text: 700 Zeichen statt 400

Co-Authored-By: Claude Sonnet 4.6 <noreply@anthropic.com>
</commit_message>
<xml_diff>
--- a/public/downloads/praesentation/M01.pptx
+++ b/public/downloads/praesentation/M01.pptx
@@ -3447,7 +3447,7 @@
     <p:bg>
       <p:bgPr>
         <a:solidFill>
-          <a:srgbClr val="191D2E"/>
+          <a:srgbClr val="1F2B56"/>
         </a:solidFill>
         <a:effectLst/>
       </p:bgPr>
@@ -3954,7 +3954,7 @@
                   </a:txBody>
                   <a:tcPr>
                     <a:solidFill>
-                      <a:srgbClr val="191D2E"/>
+                      <a:srgbClr val="1F2B56"/>
                     </a:solidFill>
                   </a:tcPr>
                 </a:tc>
@@ -3976,7 +3976,7 @@
                   </a:txBody>
                   <a:tcPr>
                     <a:solidFill>
-                      <a:srgbClr val="191D2E"/>
+                      <a:srgbClr val="1F2B56"/>
                     </a:solidFill>
                   </a:tcPr>
                 </a:tc>
@@ -4812,7 +4812,7 @@
         <p:spPr>
           <a:xfrm>
             <a:off x="609600" y="920750"/>
-            <a:ext cx="10972800" cy="1778000"/>
+            <a:ext cx="4826000" cy="1778000"/>
           </a:xfrm>
           <a:prstGeom prst="rect">
             <a:avLst/>
@@ -4840,57 +4840,14 @@
       </p:sp>
       <p:sp>
         <p:nvSpPr>
-          <p:cNvPr id="7" name="Rectangle 6"/>
-          <p:cNvSpPr/>
-          <p:nvPr/>
-        </p:nvSpPr>
-        <p:spPr>
-          <a:xfrm>
-            <a:off x="609600" y="2762250"/>
-            <a:ext cx="10972800" cy="6350"/>
-          </a:xfrm>
-          <a:prstGeom prst="rect">
-            <a:avLst/>
-          </a:prstGeom>
-          <a:solidFill>
-            <a:srgbClr val="E0E0E8"/>
-          </a:solidFill>
-          <a:ln>
-            <a:noFill/>
-          </a:ln>
-        </p:spPr>
-        <p:style>
-          <a:lnRef idx="1">
-            <a:schemeClr val="accent1"/>
-          </a:lnRef>
-          <a:fillRef idx="3">
-            <a:schemeClr val="accent1"/>
-          </a:fillRef>
-          <a:effectRef idx="2">
-            <a:schemeClr val="accent1"/>
-          </a:effectRef>
-          <a:fontRef idx="minor">
-            <a:schemeClr val="lt1"/>
-          </a:fontRef>
-        </p:style>
-        <p:txBody>
-          <a:bodyPr rtlCol="0" anchor="ctr"/>
-          <a:lstStyle/>
-          <a:p>
-            <a:pPr algn="ctr"/>
-          </a:p>
-        </p:txBody>
-      </p:sp>
-      <p:sp>
-        <p:nvSpPr>
-          <p:cNvPr id="8" name="TextBox 7"/>
+          <p:cNvPr id="7" name="TextBox 6"/>
           <p:cNvSpPr txBox="1"/>
           <p:nvPr/>
         </p:nvSpPr>
         <p:spPr>
           <a:xfrm>
-            <a:off x="609600" y="2876550"/>
-            <a:ext cx="254000" cy="355600"/>
+            <a:off x="609600" y="2825750"/>
+            <a:ext cx="4826000" cy="1016000"/>
           </a:xfrm>
           <a:prstGeom prst="rect">
             <a:avLst/>
@@ -4905,44 +4862,9 @@
           <a:p>
             <a:pPr algn="l"/>
             <a:r>
-              <a:rPr sz="2200" b="0" i="0">
-                <a:solidFill>
-                  <a:srgbClr val="1F2B56"/>
-                </a:solidFill>
-                <a:latin typeface="Georgia"/>
-              </a:rPr>
-              <a:t>–</a:t>
-            </a:r>
-          </a:p>
-        </p:txBody>
-      </p:sp>
-      <p:sp>
-        <p:nvSpPr>
-          <p:cNvPr id="9" name="TextBox 8"/>
-          <p:cNvSpPr txBox="1"/>
-          <p:nvPr/>
-        </p:nvSpPr>
-        <p:spPr>
-          <a:xfrm>
-            <a:off x="939799" y="2851150"/>
-            <a:ext cx="10642600" cy="508000"/>
-          </a:xfrm>
-          <a:prstGeom prst="rect">
-            <a:avLst/>
-          </a:prstGeom>
-          <a:noFill/>
-        </p:spPr>
-        <p:txBody>
-          <a:bodyPr wrap="square">
-            <a:normAutofit/>
-          </a:bodyPr>
-          <a:lstStyle/>
-          <a:p>
-            <a:pPr algn="l"/>
-            <a:r>
               <a:rPr sz="1400" b="0" i="0">
                 <a:solidFill>
-                  <a:srgbClr val="191D2E"/>
+                  <a:srgbClr val="4D5270"/>
                 </a:solidFill>
                 <a:latin typeface="Georgia"/>
               </a:rPr>
@@ -4951,49 +4873,707 @@
           </a:p>
         </p:txBody>
       </p:sp>
-      <p:sp>
-        <p:nvSpPr>
-          <p:cNvPr id="10" name="Rectangle 9"/>
-          <p:cNvSpPr/>
-          <p:nvPr/>
-        </p:nvSpPr>
-        <p:spPr>
-          <a:xfrm>
-            <a:off x="939799" y="3333750"/>
-            <a:ext cx="10642600" cy="6350"/>
-          </a:xfrm>
-          <a:prstGeom prst="rect">
-            <a:avLst/>
-          </a:prstGeom>
-          <a:solidFill>
-            <a:srgbClr val="E0E0E8"/>
-          </a:solidFill>
-          <a:ln>
-            <a:noFill/>
-          </a:ln>
-        </p:spPr>
-        <p:style>
-          <a:lnRef idx="1">
-            <a:schemeClr val="accent1"/>
-          </a:lnRef>
-          <a:fillRef idx="3">
-            <a:schemeClr val="accent1"/>
-          </a:fillRef>
-          <a:effectRef idx="2">
-            <a:schemeClr val="accent1"/>
-          </a:effectRef>
-          <a:fontRef idx="minor">
-            <a:schemeClr val="lt1"/>
-          </a:fontRef>
-        </p:style>
-        <p:txBody>
-          <a:bodyPr rtlCol="0" anchor="ctr"/>
-          <a:lstStyle/>
-          <a:p>
-            <a:pPr algn="ctr"/>
-          </a:p>
-        </p:txBody>
-      </p:sp>
+      <p:graphicFrame>
+        <p:nvGraphicFramePr>
+          <p:cNvPr id="8" name="Table 7"/>
+          <p:cNvGraphicFramePr>
+            <a:graphicFrameLocks noGrp="1"/>
+          </p:cNvGraphicFramePr>
+          <p:nvPr/>
+        </p:nvGraphicFramePr>
+        <p:xfrm>
+          <a:off x="5715000" y="920750"/>
+          <a:ext cx="5867400" cy="2286000"/>
+        </p:xfrm>
+        <a:graphic>
+          <a:graphicData uri="http://schemas.openxmlformats.org/drawingml/2006/table">
+            <a:tbl>
+              <a:tblPr firstRow="1" bandRow="1">
+                <a:tableStyleId>{5C22544A-7EE6-4342-B048-85BDC9FD1C3A}</a:tableStyleId>
+              </a:tblPr>
+              <a:tblGrid>
+                <a:gridCol w="1173480"/>
+                <a:gridCol w="1173480"/>
+                <a:gridCol w="1173480"/>
+                <a:gridCol w="1173480"/>
+                <a:gridCol w="1173480"/>
+              </a:tblGrid>
+              <a:tr h="381000">
+                <a:tc>
+                  <a:txBody>
+                    <a:bodyPr wrap="square"/>
+                    <a:lstStyle/>
+                    <a:p>
+                      <a:r>
+                        <a:rPr sz="1000" b="1">
+                          <a:solidFill>
+                            <a:srgbClr val="F8F8FA"/>
+                          </a:solidFill>
+                          <a:latin typeface="Courier New"/>
+                        </a:rPr>
+                        <a:t>Aussage</a:t>
+                      </a:r>
+                    </a:p>
+                  </a:txBody>
+                  <a:tcPr>
+                    <a:solidFill>
+                      <a:srgbClr val="1F2B56"/>
+                    </a:solidFill>
+                  </a:tcPr>
+                </a:tc>
+                <a:tc>
+                  <a:txBody>
+                    <a:bodyPr wrap="square"/>
+                    <a:lstStyle/>
+                    <a:p>
+                      <a:r>
+                        <a:rPr sz="1000" b="1">
+                          <a:solidFill>
+                            <a:srgbClr val="F8F8FA"/>
+                          </a:solidFill>
+                          <a:latin typeface="Courier New"/>
+                        </a:rPr>
+                        <a:t>4</a:t>
+                      </a:r>
+                    </a:p>
+                  </a:txBody>
+                  <a:tcPr>
+                    <a:solidFill>
+                      <a:srgbClr val="1F2B56"/>
+                    </a:solidFill>
+                  </a:tcPr>
+                </a:tc>
+                <a:tc>
+                  <a:txBody>
+                    <a:bodyPr wrap="square"/>
+                    <a:lstStyle/>
+                    <a:p>
+                      <a:r>
+                        <a:rPr sz="1000" b="1">
+                          <a:solidFill>
+                            <a:srgbClr val="F8F8FA"/>
+                          </a:solidFill>
+                          <a:latin typeface="Courier New"/>
+                        </a:rPr>
+                        <a:t>3</a:t>
+                      </a:r>
+                    </a:p>
+                  </a:txBody>
+                  <a:tcPr>
+                    <a:solidFill>
+                      <a:srgbClr val="1F2B56"/>
+                    </a:solidFill>
+                  </a:tcPr>
+                </a:tc>
+                <a:tc>
+                  <a:txBody>
+                    <a:bodyPr wrap="square"/>
+                    <a:lstStyle/>
+                    <a:p>
+                      <a:r>
+                        <a:rPr sz="1000" b="1">
+                          <a:solidFill>
+                            <a:srgbClr val="F8F8FA"/>
+                          </a:solidFill>
+                          <a:latin typeface="Courier New"/>
+                        </a:rPr>
+                        <a:t>2</a:t>
+                      </a:r>
+                    </a:p>
+                  </a:txBody>
+                  <a:tcPr>
+                    <a:solidFill>
+                      <a:srgbClr val="1F2B56"/>
+                    </a:solidFill>
+                  </a:tcPr>
+                </a:tc>
+                <a:tc>
+                  <a:txBody>
+                    <a:bodyPr wrap="square"/>
+                    <a:lstStyle/>
+                    <a:p>
+                      <a:r>
+                        <a:rPr sz="1000" b="1">
+                          <a:solidFill>
+                            <a:srgbClr val="F8F8FA"/>
+                          </a:solidFill>
+                          <a:latin typeface="Courier New"/>
+                        </a:rPr>
+                        <a:t>1</a:t>
+                      </a:r>
+                    </a:p>
+                  </a:txBody>
+                  <a:tcPr>
+                    <a:solidFill>
+                      <a:srgbClr val="1F2B56"/>
+                    </a:solidFill>
+                  </a:tcPr>
+                </a:tc>
+              </a:tr>
+              <a:tr h="381000">
+                <a:tc>
+                  <a:txBody>
+                    <a:bodyPr wrap="square"/>
+                    <a:lstStyle/>
+                    <a:p>
+                      <a:r>
+                        <a:rPr sz="1000" b="0">
+                          <a:solidFill>
+                            <a:srgbClr val="191D2E"/>
+                          </a:solidFill>
+                          <a:latin typeface="Courier New"/>
+                        </a:rPr>
+                        <a:t>Ich berechne bei jedem neuen Jahresabschluss mindestens EK-Quote und EBIT-Marge.</a:t>
+                      </a:r>
+                    </a:p>
+                  </a:txBody>
+                  <a:tcPr>
+                    <a:solidFill>
+                      <a:srgbClr val="F8F8FA"/>
+                    </a:solidFill>
+                  </a:tcPr>
+                </a:tc>
+                <a:tc>
+                  <a:txBody>
+                    <a:bodyPr wrap="square"/>
+                    <a:lstStyle/>
+                    <a:p>
+                      <a:r>
+                        <a:rPr sz="1000" b="0">
+                          <a:solidFill>
+                            <a:srgbClr val="191D2E"/>
+                          </a:solidFill>
+                          <a:latin typeface="Courier New"/>
+                        </a:rPr>
+                        <a:t>☐</a:t>
+                      </a:r>
+                    </a:p>
+                  </a:txBody>
+                  <a:tcPr>
+                    <a:solidFill>
+                      <a:srgbClr val="F8F8FA"/>
+                    </a:solidFill>
+                  </a:tcPr>
+                </a:tc>
+                <a:tc>
+                  <a:txBody>
+                    <a:bodyPr wrap="square"/>
+                    <a:lstStyle/>
+                    <a:p>
+                      <a:r>
+                        <a:rPr sz="1000" b="0">
+                          <a:solidFill>
+                            <a:srgbClr val="191D2E"/>
+                          </a:solidFill>
+                          <a:latin typeface="Courier New"/>
+                        </a:rPr>
+                        <a:t>☐</a:t>
+                      </a:r>
+                    </a:p>
+                  </a:txBody>
+                  <a:tcPr>
+                    <a:solidFill>
+                      <a:srgbClr val="F8F8FA"/>
+                    </a:solidFill>
+                  </a:tcPr>
+                </a:tc>
+                <a:tc>
+                  <a:txBody>
+                    <a:bodyPr wrap="square"/>
+                    <a:lstStyle/>
+                    <a:p>
+                      <a:r>
+                        <a:rPr sz="1000" b="0">
+                          <a:solidFill>
+                            <a:srgbClr val="191D2E"/>
+                          </a:solidFill>
+                          <a:latin typeface="Courier New"/>
+                        </a:rPr>
+                        <a:t>☐</a:t>
+                      </a:r>
+                    </a:p>
+                  </a:txBody>
+                  <a:tcPr>
+                    <a:solidFill>
+                      <a:srgbClr val="F8F8FA"/>
+                    </a:solidFill>
+                  </a:tcPr>
+                </a:tc>
+                <a:tc>
+                  <a:txBody>
+                    <a:bodyPr wrap="square"/>
+                    <a:lstStyle/>
+                    <a:p>
+                      <a:r>
+                        <a:rPr sz="1000" b="0">
+                          <a:solidFill>
+                            <a:srgbClr val="191D2E"/>
+                          </a:solidFill>
+                          <a:latin typeface="Courier New"/>
+                        </a:rPr>
+                        <a:t>☐</a:t>
+                      </a:r>
+                    </a:p>
+                  </a:txBody>
+                  <a:tcPr>
+                    <a:solidFill>
+                      <a:srgbClr val="F8F8FA"/>
+                    </a:solidFill>
+                  </a:tcPr>
+                </a:tc>
+              </a:tr>
+              <a:tr h="381000">
+                <a:tc>
+                  <a:txBody>
+                    <a:bodyPr wrap="square"/>
+                    <a:lstStyle/>
+                    <a:p>
+                      <a:r>
+                        <a:rPr sz="1000" b="0">
+                          <a:solidFill>
+                            <a:srgbClr val="191D2E"/>
+                          </a:solidFill>
+                          <a:latin typeface="Courier New"/>
+                        </a:rPr>
+                        <a:t>Ich nutze das Kennzahlen-Referenzblatt als Hilfsmittel.</a:t>
+                      </a:r>
+                    </a:p>
+                  </a:txBody>
+                  <a:tcPr>
+                    <a:solidFill>
+                      <a:srgbClr val="F0F0F5"/>
+                    </a:solidFill>
+                  </a:tcPr>
+                </a:tc>
+                <a:tc>
+                  <a:txBody>
+                    <a:bodyPr wrap="square"/>
+                    <a:lstStyle/>
+                    <a:p>
+                      <a:r>
+                        <a:rPr sz="1000" b="0">
+                          <a:solidFill>
+                            <a:srgbClr val="191D2E"/>
+                          </a:solidFill>
+                          <a:latin typeface="Courier New"/>
+                        </a:rPr>
+                        <a:t>☐</a:t>
+                      </a:r>
+                    </a:p>
+                  </a:txBody>
+                  <a:tcPr>
+                    <a:solidFill>
+                      <a:srgbClr val="F0F0F5"/>
+                    </a:solidFill>
+                  </a:tcPr>
+                </a:tc>
+                <a:tc>
+                  <a:txBody>
+                    <a:bodyPr wrap="square"/>
+                    <a:lstStyle/>
+                    <a:p>
+                      <a:r>
+                        <a:rPr sz="1000" b="0">
+                          <a:solidFill>
+                            <a:srgbClr val="191D2E"/>
+                          </a:solidFill>
+                          <a:latin typeface="Courier New"/>
+                        </a:rPr>
+                        <a:t>☐</a:t>
+                      </a:r>
+                    </a:p>
+                  </a:txBody>
+                  <a:tcPr>
+                    <a:solidFill>
+                      <a:srgbClr val="F0F0F5"/>
+                    </a:solidFill>
+                  </a:tcPr>
+                </a:tc>
+                <a:tc>
+                  <a:txBody>
+                    <a:bodyPr wrap="square"/>
+                    <a:lstStyle/>
+                    <a:p>
+                      <a:r>
+                        <a:rPr sz="1000" b="0">
+                          <a:solidFill>
+                            <a:srgbClr val="191D2E"/>
+                          </a:solidFill>
+                          <a:latin typeface="Courier New"/>
+                        </a:rPr>
+                        <a:t>☐</a:t>
+                      </a:r>
+                    </a:p>
+                  </a:txBody>
+                  <a:tcPr>
+                    <a:solidFill>
+                      <a:srgbClr val="F0F0F5"/>
+                    </a:solidFill>
+                  </a:tcPr>
+                </a:tc>
+                <a:tc>
+                  <a:txBody>
+                    <a:bodyPr wrap="square"/>
+                    <a:lstStyle/>
+                    <a:p>
+                      <a:r>
+                        <a:rPr sz="1000" b="0">
+                          <a:solidFill>
+                            <a:srgbClr val="191D2E"/>
+                          </a:solidFill>
+                          <a:latin typeface="Courier New"/>
+                        </a:rPr>
+                        <a:t>☐</a:t>
+                      </a:r>
+                    </a:p>
+                  </a:txBody>
+                  <a:tcPr>
+                    <a:solidFill>
+                      <a:srgbClr val="F0F0F5"/>
+                    </a:solidFill>
+                  </a:tcPr>
+                </a:tc>
+              </a:tr>
+              <a:tr h="381000">
+                <a:tc>
+                  <a:txBody>
+                    <a:bodyPr wrap="square"/>
+                    <a:lstStyle/>
+                    <a:p>
+                      <a:r>
+                        <a:rPr sz="1000" b="0">
+                          <a:solidFill>
+                            <a:srgbClr val="191D2E"/>
+                          </a:solidFill>
+                          <a:latin typeface="Courier New"/>
+                        </a:rPr>
+                        <a:t>Ich habe die 7-Schritte-Checkliste mindestens einmal vollständig angewendet.</a:t>
+                      </a:r>
+                    </a:p>
+                  </a:txBody>
+                  <a:tcPr>
+                    <a:solidFill>
+                      <a:srgbClr val="F8F8FA"/>
+                    </a:solidFill>
+                  </a:tcPr>
+                </a:tc>
+                <a:tc>
+                  <a:txBody>
+                    <a:bodyPr wrap="square"/>
+                    <a:lstStyle/>
+                    <a:p>
+                      <a:r>
+                        <a:rPr sz="1000" b="0">
+                          <a:solidFill>
+                            <a:srgbClr val="191D2E"/>
+                          </a:solidFill>
+                          <a:latin typeface="Courier New"/>
+                        </a:rPr>
+                        <a:t>☐</a:t>
+                      </a:r>
+                    </a:p>
+                  </a:txBody>
+                  <a:tcPr>
+                    <a:solidFill>
+                      <a:srgbClr val="F8F8FA"/>
+                    </a:solidFill>
+                  </a:tcPr>
+                </a:tc>
+                <a:tc>
+                  <a:txBody>
+                    <a:bodyPr wrap="square"/>
+                    <a:lstStyle/>
+                    <a:p>
+                      <a:r>
+                        <a:rPr sz="1000" b="0">
+                          <a:solidFill>
+                            <a:srgbClr val="191D2E"/>
+                          </a:solidFill>
+                          <a:latin typeface="Courier New"/>
+                        </a:rPr>
+                        <a:t>☐</a:t>
+                      </a:r>
+                    </a:p>
+                  </a:txBody>
+                  <a:tcPr>
+                    <a:solidFill>
+                      <a:srgbClr val="F8F8FA"/>
+                    </a:solidFill>
+                  </a:tcPr>
+                </a:tc>
+                <a:tc>
+                  <a:txBody>
+                    <a:bodyPr wrap="square"/>
+                    <a:lstStyle/>
+                    <a:p>
+                      <a:r>
+                        <a:rPr sz="1000" b="0">
+                          <a:solidFill>
+                            <a:srgbClr val="191D2E"/>
+                          </a:solidFill>
+                          <a:latin typeface="Courier New"/>
+                        </a:rPr>
+                        <a:t>☐</a:t>
+                      </a:r>
+                    </a:p>
+                  </a:txBody>
+                  <a:tcPr>
+                    <a:solidFill>
+                      <a:srgbClr val="F8F8FA"/>
+                    </a:solidFill>
+                  </a:tcPr>
+                </a:tc>
+                <a:tc>
+                  <a:txBody>
+                    <a:bodyPr wrap="square"/>
+                    <a:lstStyle/>
+                    <a:p>
+                      <a:r>
+                        <a:rPr sz="1000" b="0">
+                          <a:solidFill>
+                            <a:srgbClr val="191D2E"/>
+                          </a:solidFill>
+                          <a:latin typeface="Courier New"/>
+                        </a:rPr>
+                        <a:t>☐</a:t>
+                      </a:r>
+                    </a:p>
+                  </a:txBody>
+                  <a:tcPr>
+                    <a:solidFill>
+                      <a:srgbClr val="F8F8FA"/>
+                    </a:solidFill>
+                  </a:tcPr>
+                </a:tc>
+              </a:tr>
+              <a:tr h="381000">
+                <a:tc>
+                  <a:txBody>
+                    <a:bodyPr wrap="square"/>
+                    <a:lstStyle/>
+                    <a:p>
+                      <a:r>
+                        <a:rPr sz="1000" b="0">
+                          <a:solidFill>
+                            <a:srgbClr val="191D2E"/>
+                          </a:solidFill>
+                          <a:latin typeface="Courier New"/>
+                        </a:rPr>
+                        <a:t>Ich kann kritische Kennzahlen im Kundengespräch sachlich ansprechen.</a:t>
+                      </a:r>
+                    </a:p>
+                  </a:txBody>
+                  <a:tcPr>
+                    <a:solidFill>
+                      <a:srgbClr val="F0F0F5"/>
+                    </a:solidFill>
+                  </a:tcPr>
+                </a:tc>
+                <a:tc>
+                  <a:txBody>
+                    <a:bodyPr wrap="square"/>
+                    <a:lstStyle/>
+                    <a:p>
+                      <a:r>
+                        <a:rPr sz="1000" b="0">
+                          <a:solidFill>
+                            <a:srgbClr val="191D2E"/>
+                          </a:solidFill>
+                          <a:latin typeface="Courier New"/>
+                        </a:rPr>
+                        <a:t>☐</a:t>
+                      </a:r>
+                    </a:p>
+                  </a:txBody>
+                  <a:tcPr>
+                    <a:solidFill>
+                      <a:srgbClr val="F0F0F5"/>
+                    </a:solidFill>
+                  </a:tcPr>
+                </a:tc>
+                <a:tc>
+                  <a:txBody>
+                    <a:bodyPr wrap="square"/>
+                    <a:lstStyle/>
+                    <a:p>
+                      <a:r>
+                        <a:rPr sz="1000" b="0">
+                          <a:solidFill>
+                            <a:srgbClr val="191D2E"/>
+                          </a:solidFill>
+                          <a:latin typeface="Courier New"/>
+                        </a:rPr>
+                        <a:t>☐</a:t>
+                      </a:r>
+                    </a:p>
+                  </a:txBody>
+                  <a:tcPr>
+                    <a:solidFill>
+                      <a:srgbClr val="F0F0F5"/>
+                    </a:solidFill>
+                  </a:tcPr>
+                </a:tc>
+                <a:tc>
+                  <a:txBody>
+                    <a:bodyPr wrap="square"/>
+                    <a:lstStyle/>
+                    <a:p>
+                      <a:r>
+                        <a:rPr sz="1000" b="0">
+                          <a:solidFill>
+                            <a:srgbClr val="191D2E"/>
+                          </a:solidFill>
+                          <a:latin typeface="Courier New"/>
+                        </a:rPr>
+                        <a:t>☐</a:t>
+                      </a:r>
+                    </a:p>
+                  </a:txBody>
+                  <a:tcPr>
+                    <a:solidFill>
+                      <a:srgbClr val="F0F0F5"/>
+                    </a:solidFill>
+                  </a:tcPr>
+                </a:tc>
+                <a:tc>
+                  <a:txBody>
+                    <a:bodyPr wrap="square"/>
+                    <a:lstStyle/>
+                    <a:p>
+                      <a:r>
+                        <a:rPr sz="1000" b="0">
+                          <a:solidFill>
+                            <a:srgbClr val="191D2E"/>
+                          </a:solidFill>
+                          <a:latin typeface="Courier New"/>
+                        </a:rPr>
+                        <a:t>☐</a:t>
+                      </a:r>
+                    </a:p>
+                  </a:txBody>
+                  <a:tcPr>
+                    <a:solidFill>
+                      <a:srgbClr val="F0F0F5"/>
+                    </a:solidFill>
+                  </a:tcPr>
+                </a:tc>
+              </a:tr>
+              <a:tr h="381000">
+                <a:tc>
+                  <a:txBody>
+                    <a:bodyPr wrap="square"/>
+                    <a:lstStyle/>
+                    <a:p>
+                      <a:r>
+                        <a:rPr sz="1000" b="0">
+                          <a:solidFill>
+                            <a:srgbClr val="191D2E"/>
+                          </a:solidFill>
+                          <a:latin typeface="Courier New"/>
+                        </a:rPr>
+                        <a:t>Ich habe meine Bilanzanalyse vollständig im CRM dokumentiert.</a:t>
+                      </a:r>
+                    </a:p>
+                  </a:txBody>
+                  <a:tcPr>
+                    <a:solidFill>
+                      <a:srgbClr val="F8F8FA"/>
+                    </a:solidFill>
+                  </a:tcPr>
+                </a:tc>
+                <a:tc>
+                  <a:txBody>
+                    <a:bodyPr wrap="square"/>
+                    <a:lstStyle/>
+                    <a:p>
+                      <a:r>
+                        <a:rPr sz="1000" b="0">
+                          <a:solidFill>
+                            <a:srgbClr val="191D2E"/>
+                          </a:solidFill>
+                          <a:latin typeface="Courier New"/>
+                        </a:rPr>
+                        <a:t>☐</a:t>
+                      </a:r>
+                    </a:p>
+                  </a:txBody>
+                  <a:tcPr>
+                    <a:solidFill>
+                      <a:srgbClr val="F8F8FA"/>
+                    </a:solidFill>
+                  </a:tcPr>
+                </a:tc>
+                <a:tc>
+                  <a:txBody>
+                    <a:bodyPr wrap="square"/>
+                    <a:lstStyle/>
+                    <a:p>
+                      <a:r>
+                        <a:rPr sz="1000" b="0">
+                          <a:solidFill>
+                            <a:srgbClr val="191D2E"/>
+                          </a:solidFill>
+                          <a:latin typeface="Courier New"/>
+                        </a:rPr>
+                        <a:t>☐</a:t>
+                      </a:r>
+                    </a:p>
+                  </a:txBody>
+                  <a:tcPr>
+                    <a:solidFill>
+                      <a:srgbClr val="F8F8FA"/>
+                    </a:solidFill>
+                  </a:tcPr>
+                </a:tc>
+                <a:tc>
+                  <a:txBody>
+                    <a:bodyPr wrap="square"/>
+                    <a:lstStyle/>
+                    <a:p>
+                      <a:r>
+                        <a:rPr sz="1000" b="0">
+                          <a:solidFill>
+                            <a:srgbClr val="191D2E"/>
+                          </a:solidFill>
+                          <a:latin typeface="Courier New"/>
+                        </a:rPr>
+                        <a:t>☐</a:t>
+                      </a:r>
+                    </a:p>
+                  </a:txBody>
+                  <a:tcPr>
+                    <a:solidFill>
+                      <a:srgbClr val="F8F8FA"/>
+                    </a:solidFill>
+                  </a:tcPr>
+                </a:tc>
+                <a:tc>
+                  <a:txBody>
+                    <a:bodyPr wrap="square"/>
+                    <a:lstStyle/>
+                    <a:p>
+                      <a:r>
+                        <a:rPr sz="1000" b="0">
+                          <a:solidFill>
+                            <a:srgbClr val="191D2E"/>
+                          </a:solidFill>
+                          <a:latin typeface="Courier New"/>
+                        </a:rPr>
+                        <a:t>☐</a:t>
+                      </a:r>
+                    </a:p>
+                  </a:txBody>
+                  <a:tcPr>
+                    <a:solidFill>
+                      <a:srgbClr val="F8F8FA"/>
+                    </a:solidFill>
+                  </a:tcPr>
+                </a:tc>
+              </a:tr>
+            </a:tbl>
+          </a:graphicData>
+        </a:graphic>
+      </p:graphicFrame>
     </p:spTree>
   </p:cSld>
   <p:clrMapOvr>
@@ -5599,7 +6179,7 @@
     <p:bg>
       <p:bgPr>
         <a:solidFill>
-          <a:srgbClr val="191D2E"/>
+          <a:srgbClr val="1F2B56"/>
         </a:solidFill>
         <a:effectLst/>
       </p:bgPr>
@@ -6396,8 +6976,8 @@
         </p:nvSpPr>
         <p:spPr>
           <a:xfrm>
-            <a:off x="4064000" y="927100"/>
-            <a:ext cx="508000" cy="647700"/>
+            <a:off x="4064000" y="939799"/>
+            <a:ext cx="762000" cy="647700"/>
           </a:xfrm>
           <a:prstGeom prst="rect">
             <a:avLst/>
@@ -6405,20 +6985,20 @@
           <a:noFill/>
         </p:spPr>
         <p:txBody>
-          <a:bodyPr wrap="square">
+          <a:bodyPr wrap="none">
             <a:normAutofit/>
           </a:bodyPr>
           <a:lstStyle/>
           <a:p>
             <a:pPr algn="l"/>
             <a:r>
-              <a:rPr sz="2600" b="0" i="1">
+              <a:rPr sz="2400" b="0" i="1">
                 <a:solidFill>
                   <a:srgbClr val="1F2B56"/>
                 </a:solidFill>
                 <a:latin typeface="Georgia"/>
               </a:rPr>
-              <a:t>I.</a:t>
+              <a:t>I</a:t>
             </a:r>
           </a:p>
         </p:txBody>
@@ -6431,8 +7011,8 @@
         </p:nvSpPr>
         <p:spPr>
           <a:xfrm>
-            <a:off x="4699000" y="952500"/>
-            <a:ext cx="6858000" cy="622300"/>
+            <a:off x="4953000" y="952500"/>
+            <a:ext cx="6629400" cy="635000"/>
           </a:xfrm>
           <a:prstGeom prst="rect">
             <a:avLst/>
@@ -6466,7 +7046,7 @@
         </p:nvSpPr>
         <p:spPr>
           <a:xfrm>
-            <a:off x="4064000" y="1574800"/>
+            <a:off x="4064000" y="1587500"/>
             <a:ext cx="7518399" cy="6350"/>
           </a:xfrm>
           <a:prstGeom prst="rect">
@@ -6509,8 +7089,8 @@
         </p:nvSpPr>
         <p:spPr>
           <a:xfrm>
-            <a:off x="4064000" y="1612900"/>
-            <a:ext cx="508000" cy="647700"/>
+            <a:off x="4064000" y="1638300"/>
+            <a:ext cx="762000" cy="647700"/>
           </a:xfrm>
           <a:prstGeom prst="rect">
             <a:avLst/>
@@ -6518,20 +7098,20 @@
           <a:noFill/>
         </p:spPr>
         <p:txBody>
-          <a:bodyPr wrap="square">
+          <a:bodyPr wrap="none">
             <a:normAutofit/>
           </a:bodyPr>
           <a:lstStyle/>
           <a:p>
             <a:pPr algn="l"/>
             <a:r>
-              <a:rPr sz="2600" b="0" i="1">
+              <a:rPr sz="2400" b="0" i="1">
                 <a:solidFill>
                   <a:srgbClr val="1F2B56"/>
                 </a:solidFill>
                 <a:latin typeface="Georgia"/>
               </a:rPr>
-              <a:t>II.</a:t>
+              <a:t>II</a:t>
             </a:r>
           </a:p>
         </p:txBody>
@@ -6544,8 +7124,8 @@
         </p:nvSpPr>
         <p:spPr>
           <a:xfrm>
-            <a:off x="4699000" y="1638300"/>
-            <a:ext cx="6858000" cy="622300"/>
+            <a:off x="4953000" y="1651000"/>
+            <a:ext cx="6629400" cy="635000"/>
           </a:xfrm>
           <a:prstGeom prst="rect">
             <a:avLst/>
@@ -6579,7 +7159,7 @@
         </p:nvSpPr>
         <p:spPr>
           <a:xfrm>
-            <a:off x="4064000" y="2260600"/>
+            <a:off x="4064000" y="2286000"/>
             <a:ext cx="7518399" cy="6350"/>
           </a:xfrm>
           <a:prstGeom prst="rect">
@@ -6622,8 +7202,8 @@
         </p:nvSpPr>
         <p:spPr>
           <a:xfrm>
-            <a:off x="4064000" y="2298700"/>
-            <a:ext cx="508000" cy="647700"/>
+            <a:off x="4064000" y="2336800"/>
+            <a:ext cx="762000" cy="647700"/>
           </a:xfrm>
           <a:prstGeom prst="rect">
             <a:avLst/>
@@ -6631,20 +7211,20 @@
           <a:noFill/>
         </p:spPr>
         <p:txBody>
-          <a:bodyPr wrap="square">
+          <a:bodyPr wrap="none">
             <a:normAutofit/>
           </a:bodyPr>
           <a:lstStyle/>
           <a:p>
             <a:pPr algn="l"/>
             <a:r>
-              <a:rPr sz="2600" b="0" i="1">
+              <a:rPr sz="2400" b="0" i="1">
                 <a:solidFill>
                   <a:srgbClr val="1F2B56"/>
                 </a:solidFill>
                 <a:latin typeface="Georgia"/>
               </a:rPr>
-              <a:t>III.</a:t>
+              <a:t>III</a:t>
             </a:r>
           </a:p>
         </p:txBody>
@@ -6657,8 +7237,8 @@
         </p:nvSpPr>
         <p:spPr>
           <a:xfrm>
-            <a:off x="4699000" y="2324100"/>
-            <a:ext cx="6858000" cy="622300"/>
+            <a:off x="4953000" y="2349500"/>
+            <a:ext cx="6629400" cy="635000"/>
           </a:xfrm>
           <a:prstGeom prst="rect">
             <a:avLst/>
@@ -6692,7 +7272,7 @@
         </p:nvSpPr>
         <p:spPr>
           <a:xfrm>
-            <a:off x="4064000" y="2946400"/>
+            <a:off x="4064000" y="2984500"/>
             <a:ext cx="7518399" cy="6350"/>
           </a:xfrm>
           <a:prstGeom prst="rect">
@@ -6735,8 +7315,8 @@
         </p:nvSpPr>
         <p:spPr>
           <a:xfrm>
-            <a:off x="4064000" y="2984500"/>
-            <a:ext cx="508000" cy="647700"/>
+            <a:off x="4064000" y="3035300"/>
+            <a:ext cx="762000" cy="647700"/>
           </a:xfrm>
           <a:prstGeom prst="rect">
             <a:avLst/>
@@ -6744,20 +7324,20 @@
           <a:noFill/>
         </p:spPr>
         <p:txBody>
-          <a:bodyPr wrap="square">
+          <a:bodyPr wrap="none">
             <a:normAutofit/>
           </a:bodyPr>
           <a:lstStyle/>
           <a:p>
             <a:pPr algn="l"/>
             <a:r>
-              <a:rPr sz="2600" b="0" i="1">
+              <a:rPr sz="2400" b="0" i="1">
                 <a:solidFill>
                   <a:srgbClr val="1F2B56"/>
                 </a:solidFill>
                 <a:latin typeface="Georgia"/>
               </a:rPr>
-              <a:t>IV.</a:t>
+              <a:t>IV</a:t>
             </a:r>
           </a:p>
         </p:txBody>
@@ -6770,8 +7350,8 @@
         </p:nvSpPr>
         <p:spPr>
           <a:xfrm>
-            <a:off x="4699000" y="3009900"/>
-            <a:ext cx="6858000" cy="622300"/>
+            <a:off x="4953000" y="3048000"/>
+            <a:ext cx="6629400" cy="635000"/>
           </a:xfrm>
           <a:prstGeom prst="rect">
             <a:avLst/>
@@ -6805,7 +7385,7 @@
         </p:nvSpPr>
         <p:spPr>
           <a:xfrm>
-            <a:off x="4064000" y="3632200"/>
+            <a:off x="4064000" y="3683000"/>
             <a:ext cx="7518399" cy="6350"/>
           </a:xfrm>
           <a:prstGeom prst="rect">
@@ -6848,8 +7428,8 @@
         </p:nvSpPr>
         <p:spPr>
           <a:xfrm>
-            <a:off x="4064000" y="3670300"/>
-            <a:ext cx="508000" cy="647700"/>
+            <a:off x="4064000" y="3733799"/>
+            <a:ext cx="762000" cy="647700"/>
           </a:xfrm>
           <a:prstGeom prst="rect">
             <a:avLst/>
@@ -6857,20 +7437,20 @@
           <a:noFill/>
         </p:spPr>
         <p:txBody>
-          <a:bodyPr wrap="square">
+          <a:bodyPr wrap="none">
             <a:normAutofit/>
           </a:bodyPr>
           <a:lstStyle/>
           <a:p>
             <a:pPr algn="l"/>
             <a:r>
-              <a:rPr sz="2600" b="0" i="1">
+              <a:rPr sz="2400" b="0" i="1">
                 <a:solidFill>
                   <a:srgbClr val="1F2B56"/>
                 </a:solidFill>
                 <a:latin typeface="Georgia"/>
               </a:rPr>
-              <a:t>V.</a:t>
+              <a:t>V</a:t>
             </a:r>
           </a:p>
         </p:txBody>
@@ -6883,8 +7463,8 @@
         </p:nvSpPr>
         <p:spPr>
           <a:xfrm>
-            <a:off x="4699000" y="3695700"/>
-            <a:ext cx="6858000" cy="622300"/>
+            <a:off x="4953000" y="3746500"/>
+            <a:ext cx="6629400" cy="635000"/>
           </a:xfrm>
           <a:prstGeom prst="rect">
             <a:avLst/>
@@ -6924,7 +7504,7 @@
     <p:bg>
       <p:bgPr>
         <a:solidFill>
-          <a:srgbClr val="191D2E"/>
+          <a:srgbClr val="1F2B56"/>
         </a:solidFill>
         <a:effectLst/>
       </p:bgPr>
@@ -7434,7 +8014,7 @@
                   </a:txBody>
                   <a:tcPr>
                     <a:solidFill>
-                      <a:srgbClr val="191D2E"/>
+                      <a:srgbClr val="1F2B56"/>
                     </a:solidFill>
                   </a:tcPr>
                 </a:tc>
@@ -7456,7 +8036,7 @@
                   </a:txBody>
                   <a:tcPr>
                     <a:solidFill>
-                      <a:srgbClr val="191D2E"/>
+                      <a:srgbClr val="1F2B56"/>
                     </a:solidFill>
                   </a:tcPr>
                 </a:tc>
@@ -7478,7 +8058,7 @@
                   </a:txBody>
                   <a:tcPr>
                     <a:solidFill>
-                      <a:srgbClr val="191D2E"/>
+                      <a:srgbClr val="1F2B56"/>
                     </a:solidFill>
                   </a:tcPr>
                 </a:tc>
@@ -7500,7 +8080,7 @@
                   </a:txBody>
                   <a:tcPr>
                     <a:solidFill>
-                      <a:srgbClr val="191D2E"/>
+                      <a:srgbClr val="1F2B56"/>
                     </a:solidFill>
                   </a:tcPr>
                 </a:tc>
@@ -7522,7 +8102,7 @@
                   </a:txBody>
                   <a:tcPr>
                     <a:solidFill>
-                      <a:srgbClr val="191D2E"/>
+                      <a:srgbClr val="1F2B56"/>
                     </a:solidFill>
                   </a:tcPr>
                 </a:tc>
@@ -12584,7 +13164,7 @@
         <p:spPr>
           <a:xfrm>
             <a:off x="4826000" y="2984500"/>
-            <a:ext cx="6731000" cy="3048000"/>
+            <a:ext cx="6731000" cy="3429000"/>
           </a:xfrm>
           <a:prstGeom prst="rect">
             <a:avLst/>

</xml_diff>

<commit_message>
PPTX: 5 Fixes – Quellen erkannt, römische Ziffern ohne Punkt, kein §-Prefix, Bullets als Paragraphen, Blockquotes bereinigt
</commit_message>
<xml_diff>
--- a/public/downloads/praesentation/M01.pptx
+++ b/public/downloads/praesentation/M01.pptx
@@ -3594,7 +3594,7 @@
                 </a:solidFill>
                 <a:latin typeface="Georgia"/>
               </a:rPr>
-              <a:t>II.</a:t>
+              <a:t>II</a:t>
             </a:r>
           </a:p>
         </p:txBody>
@@ -3760,7 +3760,7 @@
                 </a:solidFill>
                 <a:latin typeface="Courier New"/>
               </a:rPr>
-              <a:t>§ II · PRAXISTRANSFER</a:t>
+              <a:t>II · PRAXISTRANSFER</a:t>
             </a:r>
           </a:p>
         </p:txBody>
@@ -4720,7 +4720,7 @@
                 </a:solidFill>
                 <a:latin typeface="Courier New"/>
               </a:rPr>
-              <a:t>§ II · PRAXISTRANSFER</a:t>
+              <a:t>II · PRAXISTRANSFER</a:t>
             </a:r>
           </a:p>
         </p:txBody>
@@ -5665,7 +5665,7 @@
                 </a:solidFill>
                 <a:latin typeface="Courier New"/>
               </a:rPr>
-              <a:t>§ II · PRAXISTRANSFER</a:t>
+              <a:t>II · PRAXISTRANSFER</a:t>
             </a:r>
           </a:p>
         </p:txBody>
@@ -5834,8 +5834,8 @@
         </p:nvSpPr>
         <p:spPr>
           <a:xfrm>
-            <a:off x="609600" y="2876550"/>
-            <a:ext cx="254000" cy="355600"/>
+            <a:off x="609600" y="2851150"/>
+            <a:ext cx="10972800" cy="3448050"/>
           </a:xfrm>
           <a:prstGeom prst="rect">
             <a:avLst/>
@@ -5848,320 +5848,61 @@
           </a:bodyPr>
           <a:lstStyle/>
           <a:p>
-            <a:pPr algn="l"/>
-            <a:r>
-              <a:rPr sz="2200" b="0" i="0">
-                <a:solidFill>
-                  <a:srgbClr val="1F2B56"/>
-                </a:solidFill>
-                <a:latin typeface="Georgia"/>
-              </a:rPr>
-              <a:t>–</a:t>
-            </a:r>
-          </a:p>
-        </p:txBody>
-      </p:sp>
-      <p:sp>
-        <p:nvSpPr>
-          <p:cNvPr id="9" name="TextBox 8"/>
-          <p:cNvSpPr txBox="1"/>
-          <p:nvPr/>
-        </p:nvSpPr>
-        <p:spPr>
-          <a:xfrm>
-            <a:off x="939799" y="2851150"/>
-            <a:ext cx="10642600" cy="508000"/>
-          </a:xfrm>
-          <a:prstGeom prst="rect">
-            <a:avLst/>
-          </a:prstGeom>
-          <a:noFill/>
-        </p:spPr>
-        <p:txBody>
-          <a:bodyPr wrap="square">
-            <a:normAutofit/>
-          </a:bodyPr>
-          <a:lstStyle/>
-          <a:p>
-            <a:pPr algn="l"/>
-            <a:r>
-              <a:rPr sz="1400" b="0" i="0">
+            <a:pPr>
+              <a:spcBef>
+                <a:spcPts val="600"/>
+              </a:spcBef>
+              <a:spcAft>
+                <a:spcPts val="600"/>
+              </a:spcAft>
+            </a:pPr>
+            <a:r>
+              <a:rPr sz="1400">
                 <a:solidFill>
                   <a:srgbClr val="191D2E"/>
                 </a:solidFill>
                 <a:latin typeface="Georgia"/>
               </a:rPr>
-              <a:t>Coenenberg, A. G., Haller, A. &amp; Schultze, W. (2021). Jahresabschluss und Jahresabschlussanalyse (26. Aufl.). Schäffer-Poeschel. — Kap. 27–32 für Kennzahlenanalyse</a:t>
-            </a:r>
-          </a:p>
-        </p:txBody>
-      </p:sp>
-      <p:sp>
-        <p:nvSpPr>
-          <p:cNvPr id="10" name="Rectangle 9"/>
-          <p:cNvSpPr/>
-          <p:nvPr/>
-        </p:nvSpPr>
-        <p:spPr>
-          <a:xfrm>
-            <a:off x="939799" y="3333750"/>
-            <a:ext cx="10642600" cy="6350"/>
-          </a:xfrm>
-          <a:prstGeom prst="rect">
-            <a:avLst/>
-          </a:prstGeom>
-          <a:solidFill>
-            <a:srgbClr val="E0E0E8"/>
-          </a:solidFill>
-          <a:ln>
-            <a:noFill/>
-          </a:ln>
-        </p:spPr>
-        <p:style>
-          <a:lnRef idx="1">
-            <a:schemeClr val="accent1"/>
-          </a:lnRef>
-          <a:fillRef idx="3">
-            <a:schemeClr val="accent1"/>
-          </a:fillRef>
-          <a:effectRef idx="2">
-            <a:schemeClr val="accent1"/>
-          </a:effectRef>
-          <a:fontRef idx="minor">
-            <a:schemeClr val="lt1"/>
-          </a:fontRef>
-        </p:style>
-        <p:txBody>
-          <a:bodyPr rtlCol="0" anchor="ctr"/>
-          <a:lstStyle/>
-          <a:p>
-            <a:pPr algn="ctr"/>
-          </a:p>
-        </p:txBody>
-      </p:sp>
-      <p:sp>
-        <p:nvSpPr>
-          <p:cNvPr id="11" name="TextBox 10"/>
-          <p:cNvSpPr txBox="1"/>
-          <p:nvPr/>
-        </p:nvSpPr>
-        <p:spPr>
-          <a:xfrm>
-            <a:off x="609600" y="3409950"/>
-            <a:ext cx="254000" cy="355600"/>
-          </a:xfrm>
-          <a:prstGeom prst="rect">
-            <a:avLst/>
-          </a:prstGeom>
-          <a:noFill/>
-        </p:spPr>
-        <p:txBody>
-          <a:bodyPr wrap="square">
-            <a:normAutofit/>
-          </a:bodyPr>
-          <a:lstStyle/>
-          <a:p>
-            <a:pPr algn="l"/>
-            <a:r>
-              <a:rPr sz="2200" b="0" i="0">
-                <a:solidFill>
-                  <a:srgbClr val="1F2B56"/>
-                </a:solidFill>
-                <a:latin typeface="Georgia"/>
-              </a:rPr>
-              <a:t>–</a:t>
-            </a:r>
-          </a:p>
-        </p:txBody>
-      </p:sp>
-      <p:sp>
-        <p:nvSpPr>
-          <p:cNvPr id="12" name="TextBox 11"/>
-          <p:cNvSpPr txBox="1"/>
-          <p:nvPr/>
-        </p:nvSpPr>
-        <p:spPr>
-          <a:xfrm>
-            <a:off x="939799" y="3384550"/>
-            <a:ext cx="10642600" cy="508000"/>
-          </a:xfrm>
-          <a:prstGeom prst="rect">
-            <a:avLst/>
-          </a:prstGeom>
-          <a:noFill/>
-        </p:spPr>
-        <p:txBody>
-          <a:bodyPr wrap="square">
-            <a:normAutofit/>
-          </a:bodyPr>
-          <a:lstStyle/>
-          <a:p>
-            <a:pPr algn="l"/>
-            <a:r>
-              <a:rPr sz="1400" b="0" i="0">
+              <a:t>–  Coenenberg, A. G., Haller, A. &amp; Schultze, W. (2021). Jahresabschluss und Jahresabschlussanalyse (26. Aufl.). Schäffer-Poeschel. — Kap. 27–32 für Kennzahlenanalyse</a:t>
+            </a:r>
+          </a:p>
+          <a:p>
+            <a:pPr>
+              <a:spcBef>
+                <a:spcPts val="600"/>
+              </a:spcBef>
+              <a:spcAft>
+                <a:spcPts val="600"/>
+              </a:spcAft>
+            </a:pPr>
+            <a:r>
+              <a:rPr sz="1400">
                 <a:solidFill>
                   <a:srgbClr val="191D2E"/>
                 </a:solidFill>
                 <a:latin typeface="Georgia"/>
               </a:rPr>
-              <a:t>Schierenbeck, H., Lister, M. &amp; Kirmsse, S. (2014). Ertragsorientiertes Bankmanagement (9. Aufl., Bd. 2). Springer Gabler. — Kap. 6 zu Kreditanalyse und Kapitaldienstfähigkeit</a:t>
-            </a:r>
-          </a:p>
-        </p:txBody>
-      </p:sp>
-      <p:sp>
-        <p:nvSpPr>
-          <p:cNvPr id="13" name="Rectangle 12"/>
-          <p:cNvSpPr/>
-          <p:nvPr/>
-        </p:nvSpPr>
-        <p:spPr>
-          <a:xfrm>
-            <a:off x="939799" y="3867150"/>
-            <a:ext cx="10642600" cy="6350"/>
-          </a:xfrm>
-          <a:prstGeom prst="rect">
-            <a:avLst/>
-          </a:prstGeom>
-          <a:solidFill>
-            <a:srgbClr val="E0E0E8"/>
-          </a:solidFill>
-          <a:ln>
-            <a:noFill/>
-          </a:ln>
-        </p:spPr>
-        <p:style>
-          <a:lnRef idx="1">
-            <a:schemeClr val="accent1"/>
-          </a:lnRef>
-          <a:fillRef idx="3">
-            <a:schemeClr val="accent1"/>
-          </a:fillRef>
-          <a:effectRef idx="2">
-            <a:schemeClr val="accent1"/>
-          </a:effectRef>
-          <a:fontRef idx="minor">
-            <a:schemeClr val="lt1"/>
-          </a:fontRef>
-        </p:style>
-        <p:txBody>
-          <a:bodyPr rtlCol="0" anchor="ctr"/>
-          <a:lstStyle/>
-          <a:p>
-            <a:pPr algn="ctr"/>
-          </a:p>
-        </p:txBody>
-      </p:sp>
-      <p:sp>
-        <p:nvSpPr>
-          <p:cNvPr id="14" name="TextBox 13"/>
-          <p:cNvSpPr txBox="1"/>
-          <p:nvPr/>
-        </p:nvSpPr>
-        <p:spPr>
-          <a:xfrm>
-            <a:off x="609600" y="3943350"/>
-            <a:ext cx="254000" cy="355600"/>
-          </a:xfrm>
-          <a:prstGeom prst="rect">
-            <a:avLst/>
-          </a:prstGeom>
-          <a:noFill/>
-        </p:spPr>
-        <p:txBody>
-          <a:bodyPr wrap="square">
-            <a:normAutofit/>
-          </a:bodyPr>
-          <a:lstStyle/>
-          <a:p>
-            <a:pPr algn="l"/>
-            <a:r>
-              <a:rPr sz="2200" b="0" i="0">
-                <a:solidFill>
-                  <a:srgbClr val="1F2B56"/>
-                </a:solidFill>
-                <a:latin typeface="Georgia"/>
-              </a:rPr>
-              <a:t>–</a:t>
-            </a:r>
-          </a:p>
-        </p:txBody>
-      </p:sp>
-      <p:sp>
-        <p:nvSpPr>
-          <p:cNvPr id="15" name="TextBox 14"/>
-          <p:cNvSpPr txBox="1"/>
-          <p:nvPr/>
-        </p:nvSpPr>
-        <p:spPr>
-          <a:xfrm>
-            <a:off x="939799" y="3917950"/>
-            <a:ext cx="10642600" cy="508000"/>
-          </a:xfrm>
-          <a:prstGeom prst="rect">
-            <a:avLst/>
-          </a:prstGeom>
-          <a:noFill/>
-        </p:spPr>
-        <p:txBody>
-          <a:bodyPr wrap="square">
-            <a:normAutofit/>
-          </a:bodyPr>
-          <a:lstStyle/>
-          <a:p>
-            <a:pPr algn="l"/>
-            <a:r>
-              <a:rPr sz="1400" b="0" i="0">
+              <a:t>–  Schierenbeck, H., Lister, M. &amp; Kirmsse, S. (2014). Ertragsorientiertes Bankmanagement (9. Aufl., Bd. 2). Springer Gabler. — Kap. 6 zu Kreditanalyse und Kapitaldienstfähigkeit</a:t>
+            </a:r>
+          </a:p>
+          <a:p>
+            <a:pPr>
+              <a:spcBef>
+                <a:spcPts val="600"/>
+              </a:spcBef>
+              <a:spcAft>
+                <a:spcPts val="600"/>
+              </a:spcAft>
+            </a:pPr>
+            <a:r>
+              <a:rPr sz="1400">
                 <a:solidFill>
                   <a:srgbClr val="191D2E"/>
                 </a:solidFill>
                 <a:latin typeface="Georgia"/>
               </a:rPr>
-              <a:t>KfW Bankengruppe (2023). KfW-Mittelstandspanel 2023. KfW Research. — Aktuelle Benchmarkdaten für KMU</a:t>
-            </a:r>
-          </a:p>
-        </p:txBody>
-      </p:sp>
-      <p:sp>
-        <p:nvSpPr>
-          <p:cNvPr id="16" name="Rectangle 15"/>
-          <p:cNvSpPr/>
-          <p:nvPr/>
-        </p:nvSpPr>
-        <p:spPr>
-          <a:xfrm>
-            <a:off x="939799" y="4400550"/>
-            <a:ext cx="10642600" cy="6350"/>
-          </a:xfrm>
-          <a:prstGeom prst="rect">
-            <a:avLst/>
-          </a:prstGeom>
-          <a:solidFill>
-            <a:srgbClr val="E0E0E8"/>
-          </a:solidFill>
-          <a:ln>
-            <a:noFill/>
-          </a:ln>
-        </p:spPr>
-        <p:style>
-          <a:lnRef idx="1">
-            <a:schemeClr val="accent1"/>
-          </a:lnRef>
-          <a:fillRef idx="3">
-            <a:schemeClr val="accent1"/>
-          </a:fillRef>
-          <a:effectRef idx="2">
-            <a:schemeClr val="accent1"/>
-          </a:effectRef>
-          <a:fontRef idx="minor">
-            <a:schemeClr val="lt1"/>
-          </a:fontRef>
-        </p:style>
-        <p:txBody>
-          <a:bodyPr rtlCol="0" anchor="ctr"/>
-          <a:lstStyle/>
-          <a:p>
-            <a:pPr algn="ctr"/>
+              <a:t>–  KfW Bankengruppe (2023). KfW-Mittelstandspanel 2023. KfW Research. — Aktuelle Benchmarkdaten für KMU</a:t>
+            </a:r>
           </a:p>
         </p:txBody>
       </p:sp>
@@ -6256,7 +5997,7 @@
                 </a:solidFill>
                 <a:latin typeface="Courier New"/>
               </a:rPr>
-              <a:t>QUELLEN</a:t>
+              <a:t>QUELLENAPPARAT</a:t>
             </a:r>
           </a:p>
         </p:txBody>
@@ -6304,8 +6045,8 @@
         </p:nvSpPr>
         <p:spPr>
           <a:xfrm>
-            <a:off x="609600" y="635000"/>
-            <a:ext cx="5461000" cy="5461000"/>
+            <a:off x="609600" y="863600"/>
+            <a:ext cx="5080000" cy="203200"/>
           </a:xfrm>
           <a:prstGeom prst="rect">
             <a:avLst/>
@@ -6320,13 +6061,13 @@
           <a:p>
             <a:pPr algn="l"/>
             <a:r>
-              <a:rPr sz="28000" b="0" i="1">
+              <a:rPr sz="900" b="0" i="0">
                 <a:solidFill>
-                  <a:srgbClr val="D9BF7A"/>
+                  <a:srgbClr val="A0AACC"/>
                 </a:solidFill>
-                <a:latin typeface="Georgia"/>
+                <a:latin typeface="Courier New"/>
               </a:rPr>
-              <a:t>III.</a:t>
+              <a:t>Quellenapparat</a:t>
             </a:r>
           </a:p>
         </p:txBody>
@@ -6339,8 +6080,8 @@
         </p:nvSpPr>
         <p:spPr>
           <a:xfrm>
-            <a:off x="6731000" y="4064000"/>
-            <a:ext cx="4851400" cy="1778000"/>
+            <a:off x="609600" y="920750"/>
+            <a:ext cx="10972800" cy="1270000"/>
           </a:xfrm>
           <a:prstGeom prst="rect">
             <a:avLst/>
@@ -6353,7 +6094,7 @@
           </a:bodyPr>
           <a:lstStyle/>
           <a:p>
-            <a:pPr algn="r"/>
+            <a:pPr algn="l"/>
             <a:r>
               <a:rPr sz="3800" b="0" i="0">
                 <a:solidFill>
@@ -6361,7 +6102,435 @@
                 </a:solidFill>
                 <a:latin typeface="Georgia"/>
               </a:rPr>
-              <a:t>Quellen</a:t>
+              <a:t>Quellen.</a:t>
+            </a:r>
+          </a:p>
+        </p:txBody>
+      </p:sp>
+      <p:sp>
+        <p:nvSpPr>
+          <p:cNvPr id="7" name="Rectangle 6"/>
+          <p:cNvSpPr/>
+          <p:nvPr/>
+        </p:nvSpPr>
+        <p:spPr>
+          <a:xfrm>
+            <a:off x="609600" y="2254250"/>
+            <a:ext cx="10972800" cy="6350"/>
+          </a:xfrm>
+          <a:prstGeom prst="rect">
+            <a:avLst/>
+          </a:prstGeom>
+          <a:solidFill>
+            <a:srgbClr val="3A4880"/>
+          </a:solidFill>
+          <a:ln>
+            <a:noFill/>
+          </a:ln>
+        </p:spPr>
+        <p:style>
+          <a:lnRef idx="1">
+            <a:schemeClr val="accent1"/>
+          </a:lnRef>
+          <a:fillRef idx="3">
+            <a:schemeClr val="accent1"/>
+          </a:fillRef>
+          <a:effectRef idx="2">
+            <a:schemeClr val="accent1"/>
+          </a:effectRef>
+          <a:fontRef idx="minor">
+            <a:schemeClr val="lt1"/>
+          </a:fontRef>
+        </p:style>
+        <p:txBody>
+          <a:bodyPr rtlCol="0" anchor="ctr"/>
+          <a:lstStyle/>
+          <a:p>
+            <a:pPr algn="ctr"/>
+          </a:p>
+        </p:txBody>
+      </p:sp>
+      <p:sp>
+        <p:nvSpPr>
+          <p:cNvPr id="8" name="TextBox 7"/>
+          <p:cNvSpPr txBox="1"/>
+          <p:nvPr/>
+        </p:nvSpPr>
+        <p:spPr>
+          <a:xfrm>
+            <a:off x="609600" y="2317750"/>
+            <a:ext cx="5207000" cy="444500"/>
+          </a:xfrm>
+          <a:prstGeom prst="rect">
+            <a:avLst/>
+          </a:prstGeom>
+          <a:noFill/>
+        </p:spPr>
+        <p:txBody>
+          <a:bodyPr wrap="square">
+            <a:normAutofit/>
+          </a:bodyPr>
+          <a:lstStyle/>
+          <a:p>
+            <a:pPr algn="l"/>
+            <a:r>
+              <a:rPr sz="1000" b="0" i="0">
+                <a:solidFill>
+                  <a:srgbClr val="F8F8FA"/>
+                </a:solidFill>
+                <a:latin typeface="Courier New"/>
+              </a:rPr>
+              <a:t>Anderson, L. W. &amp; Krathwohl, D. R. (Hrsg.). (2001). A taxonomy for learning, teaching, and assessing: A revision of Bloom's taxonomy of…</a:t>
+            </a:r>
+          </a:p>
+        </p:txBody>
+      </p:sp>
+      <p:sp>
+        <p:nvSpPr>
+          <p:cNvPr id="9" name="TextBox 8"/>
+          <p:cNvSpPr txBox="1"/>
+          <p:nvPr/>
+        </p:nvSpPr>
+        <p:spPr>
+          <a:xfrm>
+            <a:off x="609600" y="2800350"/>
+            <a:ext cx="5207000" cy="444500"/>
+          </a:xfrm>
+          <a:prstGeom prst="rect">
+            <a:avLst/>
+          </a:prstGeom>
+          <a:noFill/>
+        </p:spPr>
+        <p:txBody>
+          <a:bodyPr wrap="square">
+            <a:normAutofit/>
+          </a:bodyPr>
+          <a:lstStyle/>
+          <a:p>
+            <a:pPr algn="l"/>
+            <a:r>
+              <a:rPr sz="1000" b="0" i="0">
+                <a:solidFill>
+                  <a:srgbClr val="F8F8FA"/>
+                </a:solidFill>
+                <a:latin typeface="Courier New"/>
+              </a:rPr>
+              <a:t>Barrows, H. S. (1986). A taxonomy of problem-based learning methods. Medical Education, 20(6), 481–486.…</a:t>
+            </a:r>
+          </a:p>
+        </p:txBody>
+      </p:sp>
+      <p:sp>
+        <p:nvSpPr>
+          <p:cNvPr id="10" name="TextBox 9"/>
+          <p:cNvSpPr txBox="1"/>
+          <p:nvPr/>
+        </p:nvSpPr>
+        <p:spPr>
+          <a:xfrm>
+            <a:off x="609600" y="3282950"/>
+            <a:ext cx="5207000" cy="444500"/>
+          </a:xfrm>
+          <a:prstGeom prst="rect">
+            <a:avLst/>
+          </a:prstGeom>
+          <a:noFill/>
+        </p:spPr>
+        <p:txBody>
+          <a:bodyPr wrap="square">
+            <a:normAutofit/>
+          </a:bodyPr>
+          <a:lstStyle/>
+          <a:p>
+            <a:pPr algn="l"/>
+            <a:r>
+              <a:rPr sz="1000" b="0" i="0">
+                <a:solidFill>
+                  <a:srgbClr val="F8F8FA"/>
+                </a:solidFill>
+                <a:latin typeface="Courier New"/>
+              </a:rPr>
+              <a:t>Bundesanstalt für Finanzdienstleistungsaufsicht (BaFin). (2021). Mindestanforderungen an das Risikomanagement (MaRisk). BaFin.</a:t>
+            </a:r>
+          </a:p>
+        </p:txBody>
+      </p:sp>
+      <p:sp>
+        <p:nvSpPr>
+          <p:cNvPr id="11" name="TextBox 10"/>
+          <p:cNvSpPr txBox="1"/>
+          <p:nvPr/>
+        </p:nvSpPr>
+        <p:spPr>
+          <a:xfrm>
+            <a:off x="609600" y="3765550"/>
+            <a:ext cx="5207000" cy="444500"/>
+          </a:xfrm>
+          <a:prstGeom prst="rect">
+            <a:avLst/>
+          </a:prstGeom>
+          <a:noFill/>
+        </p:spPr>
+        <p:txBody>
+          <a:bodyPr wrap="square">
+            <a:normAutofit/>
+          </a:bodyPr>
+          <a:lstStyle/>
+          <a:p>
+            <a:pPr algn="l"/>
+            <a:r>
+              <a:rPr sz="1000" b="0" i="0">
+                <a:solidFill>
+                  <a:srgbClr val="F8F8FA"/>
+                </a:solidFill>
+                <a:latin typeface="Courier New"/>
+              </a:rPr>
+              <a:t>Coenenberg, A. G., Haller, A. &amp; Schultze, W. (2021). Jahresabschluss und Jahresabschlussanalyse: Betriebswirtschaftliche,…</a:t>
+            </a:r>
+          </a:p>
+        </p:txBody>
+      </p:sp>
+      <p:sp>
+        <p:nvSpPr>
+          <p:cNvPr id="12" name="TextBox 11"/>
+          <p:cNvSpPr txBox="1"/>
+          <p:nvPr/>
+        </p:nvSpPr>
+        <p:spPr>
+          <a:xfrm>
+            <a:off x="609600" y="4248150"/>
+            <a:ext cx="5207000" cy="444500"/>
+          </a:xfrm>
+          <a:prstGeom prst="rect">
+            <a:avLst/>
+          </a:prstGeom>
+          <a:noFill/>
+        </p:spPr>
+        <p:txBody>
+          <a:bodyPr wrap="square">
+            <a:normAutofit/>
+          </a:bodyPr>
+          <a:lstStyle/>
+          <a:p>
+            <a:pPr algn="l"/>
+            <a:r>
+              <a:rPr sz="1000" b="0" i="0">
+                <a:solidFill>
+                  <a:srgbClr val="F8F8FA"/>
+                </a:solidFill>
+                <a:latin typeface="Courier New"/>
+              </a:rPr>
+              <a:t>Creditreform. (2023). Wirtschaftsreport Deutschland 2023: Branchenanalyse Maschinenbau. Creditreform Wirtschaftsforschung.</a:t>
+            </a:r>
+          </a:p>
+        </p:txBody>
+      </p:sp>
+      <p:sp>
+        <p:nvSpPr>
+          <p:cNvPr id="13" name="TextBox 12"/>
+          <p:cNvSpPr txBox="1"/>
+          <p:nvPr/>
+        </p:nvSpPr>
+        <p:spPr>
+          <a:xfrm>
+            <a:off x="609600" y="4730750"/>
+            <a:ext cx="5207000" cy="444500"/>
+          </a:xfrm>
+          <a:prstGeom prst="rect">
+            <a:avLst/>
+          </a:prstGeom>
+          <a:noFill/>
+        </p:spPr>
+        <p:txBody>
+          <a:bodyPr wrap="square">
+            <a:normAutofit/>
+          </a:bodyPr>
+          <a:lstStyle/>
+          <a:p>
+            <a:pPr algn="l"/>
+            <a:r>
+              <a:rPr sz="1000" b="0" i="0">
+                <a:solidFill>
+                  <a:srgbClr val="F8F8FA"/>
+                </a:solidFill>
+                <a:latin typeface="Courier New"/>
+              </a:rPr>
+              <a:t>Dreyfus, S. E. &amp; Dreyfus, H. L. (1980). A five-stage model of the mental activities involved in directed skill acquisition. University of…</a:t>
+            </a:r>
+          </a:p>
+        </p:txBody>
+      </p:sp>
+      <p:sp>
+        <p:nvSpPr>
+          <p:cNvPr id="14" name="TextBox 13"/>
+          <p:cNvSpPr txBox="1"/>
+          <p:nvPr/>
+        </p:nvSpPr>
+        <p:spPr>
+          <a:xfrm>
+            <a:off x="6096000" y="2317750"/>
+            <a:ext cx="5232400" cy="444500"/>
+          </a:xfrm>
+          <a:prstGeom prst="rect">
+            <a:avLst/>
+          </a:prstGeom>
+          <a:noFill/>
+        </p:spPr>
+        <p:txBody>
+          <a:bodyPr wrap="square">
+            <a:normAutofit/>
+          </a:bodyPr>
+          <a:lstStyle/>
+          <a:p>
+            <a:pPr algn="l"/>
+            <a:r>
+              <a:rPr sz="1000" b="0" i="0">
+                <a:solidFill>
+                  <a:srgbClr val="F8F8FA"/>
+                </a:solidFill>
+                <a:latin typeface="Courier New"/>
+              </a:rPr>
+              <a:t>KfW Bankengruppe. (2023). KfW-Mittelstandspanel 2023: Mittelstand im Wandel. KfW Research.</a:t>
+            </a:r>
+          </a:p>
+        </p:txBody>
+      </p:sp>
+      <p:sp>
+        <p:nvSpPr>
+          <p:cNvPr id="15" name="TextBox 14"/>
+          <p:cNvSpPr txBox="1"/>
+          <p:nvPr/>
+        </p:nvSpPr>
+        <p:spPr>
+          <a:xfrm>
+            <a:off x="6096000" y="2800350"/>
+            <a:ext cx="5232400" cy="444500"/>
+          </a:xfrm>
+          <a:prstGeom prst="rect">
+            <a:avLst/>
+          </a:prstGeom>
+          <a:noFill/>
+        </p:spPr>
+        <p:txBody>
+          <a:bodyPr wrap="square">
+            <a:normAutofit/>
+          </a:bodyPr>
+          <a:lstStyle/>
+          <a:p>
+            <a:pPr algn="l"/>
+            <a:r>
+              <a:rPr sz="1000" b="0" i="0">
+                <a:solidFill>
+                  <a:srgbClr val="F8F8FA"/>
+                </a:solidFill>
+                <a:latin typeface="Courier New"/>
+              </a:rPr>
+              <a:t>Kirkpatrick, D. L. (1994). Evaluating training programs: The four levels. Berrett-Koehler.</a:t>
+            </a:r>
+          </a:p>
+        </p:txBody>
+      </p:sp>
+      <p:sp>
+        <p:nvSpPr>
+          <p:cNvPr id="16" name="TextBox 15"/>
+          <p:cNvSpPr txBox="1"/>
+          <p:nvPr/>
+        </p:nvSpPr>
+        <p:spPr>
+          <a:xfrm>
+            <a:off x="6096000" y="3282950"/>
+            <a:ext cx="5232400" cy="444500"/>
+          </a:xfrm>
+          <a:prstGeom prst="rect">
+            <a:avLst/>
+          </a:prstGeom>
+          <a:noFill/>
+        </p:spPr>
+        <p:txBody>
+          <a:bodyPr wrap="square">
+            <a:normAutofit/>
+          </a:bodyPr>
+          <a:lstStyle/>
+          <a:p>
+            <a:pPr algn="l"/>
+            <a:r>
+              <a:rPr sz="1000" b="0" i="0">
+                <a:solidFill>
+                  <a:srgbClr val="F8F8FA"/>
+                </a:solidFill>
+                <a:latin typeface="Courier New"/>
+              </a:rPr>
+              <a:t>Knowles, M. S. (1975). Self-directed learning: A guide for learners and teachers. Association Press.</a:t>
+            </a:r>
+          </a:p>
+        </p:txBody>
+      </p:sp>
+      <p:sp>
+        <p:nvSpPr>
+          <p:cNvPr id="17" name="TextBox 16"/>
+          <p:cNvSpPr txBox="1"/>
+          <p:nvPr/>
+        </p:nvSpPr>
+        <p:spPr>
+          <a:xfrm>
+            <a:off x="6096000" y="3765550"/>
+            <a:ext cx="5232400" cy="444500"/>
+          </a:xfrm>
+          <a:prstGeom prst="rect">
+            <a:avLst/>
+          </a:prstGeom>
+          <a:noFill/>
+        </p:spPr>
+        <p:txBody>
+          <a:bodyPr wrap="square">
+            <a:normAutofit/>
+          </a:bodyPr>
+          <a:lstStyle/>
+          <a:p>
+            <a:pPr algn="l"/>
+            <a:r>
+              <a:rPr sz="1000" b="0" i="0">
+                <a:solidFill>
+                  <a:srgbClr val="F8F8FA"/>
+                </a:solidFill>
+                <a:latin typeface="Courier New"/>
+              </a:rPr>
+              <a:t>Kolb, D. A. (1984). Experiential learning: Experience as the source of learning and development. Prentice-Hall.</a:t>
+            </a:r>
+          </a:p>
+        </p:txBody>
+      </p:sp>
+      <p:sp>
+        <p:nvSpPr>
+          <p:cNvPr id="18" name="TextBox 17"/>
+          <p:cNvSpPr txBox="1"/>
+          <p:nvPr/>
+        </p:nvSpPr>
+        <p:spPr>
+          <a:xfrm>
+            <a:off x="6096000" y="4248150"/>
+            <a:ext cx="5232400" cy="444500"/>
+          </a:xfrm>
+          <a:prstGeom prst="rect">
+            <a:avLst/>
+          </a:prstGeom>
+          <a:noFill/>
+        </p:spPr>
+        <p:txBody>
+          <a:bodyPr wrap="square">
+            <a:normAutofit/>
+          </a:bodyPr>
+          <a:lstStyle/>
+          <a:p>
+            <a:pPr algn="l"/>
+            <a:r>
+              <a:rPr sz="1000" b="0" i="0">
+                <a:solidFill>
+                  <a:srgbClr val="F8F8FA"/>
+                </a:solidFill>
+                <a:latin typeface="Courier New"/>
+              </a:rPr>
+              <a:t>Schierenbeck, H., Lister, M. &amp; Kirmsse, S. (2014). Ertragsorientiertes Bankmanagement (9. Aufl., Bd. 2): Risiko-Controlling und integrierte…</a:t>
             </a:r>
           </a:p>
         </p:txBody>
@@ -7651,7 +7820,7 @@
                 </a:solidFill>
                 <a:latin typeface="Georgia"/>
               </a:rPr>
-              <a:t>I.</a:t>
+              <a:t>I</a:t>
             </a:r>
           </a:p>
         </p:txBody>
@@ -7817,7 +7986,7 @@
                 </a:solidFill>
                 <a:latin typeface="Courier New"/>
               </a:rPr>
-              <a:t>§ I · MODULINHALTE</a:t>
+              <a:t>I · MODULINHALTE</a:t>
             </a:r>
           </a:p>
         </p:txBody>
@@ -8366,7 +8535,7 @@
                           </a:solidFill>
                           <a:latin typeface="Courier New"/>
                         </a:rPr>
-                        <a:t>&gt; 20 Mio. EUR</a:t>
+                        <a:t>20 Mio. EUR</a:t>
                       </a:r>
                     </a:p>
                   </a:txBody>
@@ -8388,7 +8557,7 @@
                           </a:solidFill>
                           <a:latin typeface="Courier New"/>
                         </a:rPr>
-                        <a:t>&gt; 40 Mio. EUR</a:t>
+                        <a:t>40 Mio. EUR</a:t>
                       </a:r>
                     </a:p>
                   </a:txBody>
@@ -8410,7 +8579,7 @@
                           </a:solidFill>
                           <a:latin typeface="Courier New"/>
                         </a:rPr>
-                        <a:t>&gt; 250</a:t>
+                        <a:t>250</a:t>
                       </a:r>
                     </a:p>
                   </a:txBody>
@@ -9098,7 +9267,7 @@
                 </a:solidFill>
                 <a:latin typeface="Courier New"/>
               </a:rPr>
-              <a:t>§ I · MODULINHALTE</a:t>
+              <a:t>I · MODULINHALTE</a:t>
             </a:r>
           </a:p>
         </p:txBody>
@@ -9267,8 +9436,8 @@
         </p:nvSpPr>
         <p:spPr>
           <a:xfrm>
-            <a:off x="609600" y="2876550"/>
-            <a:ext cx="254000" cy="355600"/>
+            <a:off x="609600" y="2851150"/>
+            <a:ext cx="10972800" cy="3448050"/>
           </a:xfrm>
           <a:prstGeom prst="rect">
             <a:avLst/>
@@ -9281,546 +9450,99 @@
           </a:bodyPr>
           <a:lstStyle/>
           <a:p>
-            <a:pPr algn="l"/>
-            <a:r>
-              <a:rPr sz="2200" b="0" i="0">
-                <a:solidFill>
-                  <a:srgbClr val="1F2B56"/>
-                </a:solidFill>
-                <a:latin typeface="Georgia"/>
-              </a:rPr>
-              <a:t>–</a:t>
-            </a:r>
-          </a:p>
-        </p:txBody>
-      </p:sp>
-      <p:sp>
-        <p:nvSpPr>
-          <p:cNvPr id="9" name="TextBox 8"/>
-          <p:cNvSpPr txBox="1"/>
-          <p:nvPr/>
-        </p:nvSpPr>
-        <p:spPr>
-          <a:xfrm>
-            <a:off x="939799" y="2851150"/>
-            <a:ext cx="10642600" cy="508000"/>
-          </a:xfrm>
-          <a:prstGeom prst="rect">
-            <a:avLst/>
-          </a:prstGeom>
-          <a:noFill/>
-        </p:spPr>
-        <p:txBody>
-          <a:bodyPr wrap="square">
-            <a:normAutofit/>
-          </a:bodyPr>
-          <a:lstStyle/>
-          <a:p>
-            <a:pPr algn="l"/>
-            <a:r>
-              <a:rPr sz="1400" b="0" i="0">
+            <a:pPr>
+              <a:spcBef>
+                <a:spcPts val="600"/>
+              </a:spcBef>
+              <a:spcAft>
+                <a:spcPts val="600"/>
+              </a:spcAft>
+            </a:pPr>
+            <a:r>
+              <a:rPr sz="1400">
                 <a:solidFill>
                   <a:srgbClr val="191D2E"/>
                 </a:solidFill>
                 <a:latin typeface="Georgia"/>
               </a:rPr>
-              <a:t>Der Jahresabschluss ist die jährliche Zusammenfassung der wirtschaftlichen Lage eines Unternehmens. Für Kapitalgesellschaften (GmbH, AG) schreibt das HGB in §§ 264 ff. folgende Bestandteile vor:</a:t>
-            </a:r>
-          </a:p>
-        </p:txBody>
-      </p:sp>
-      <p:sp>
-        <p:nvSpPr>
-          <p:cNvPr id="10" name="Rectangle 9"/>
-          <p:cNvSpPr/>
-          <p:nvPr/>
-        </p:nvSpPr>
-        <p:spPr>
-          <a:xfrm>
-            <a:off x="939799" y="3333750"/>
-            <a:ext cx="10642600" cy="6350"/>
-          </a:xfrm>
-          <a:prstGeom prst="rect">
-            <a:avLst/>
-          </a:prstGeom>
-          <a:solidFill>
-            <a:srgbClr val="E0E0E8"/>
-          </a:solidFill>
-          <a:ln>
-            <a:noFill/>
-          </a:ln>
-        </p:spPr>
-        <p:style>
-          <a:lnRef idx="1">
-            <a:schemeClr val="accent1"/>
-          </a:lnRef>
-          <a:fillRef idx="3">
-            <a:schemeClr val="accent1"/>
-          </a:fillRef>
-          <a:effectRef idx="2">
-            <a:schemeClr val="accent1"/>
-          </a:effectRef>
-          <a:fontRef idx="minor">
-            <a:schemeClr val="lt1"/>
-          </a:fontRef>
-        </p:style>
-        <p:txBody>
-          <a:bodyPr rtlCol="0" anchor="ctr"/>
-          <a:lstStyle/>
-          <a:p>
-            <a:pPr algn="ctr"/>
-          </a:p>
-        </p:txBody>
-      </p:sp>
-      <p:sp>
-        <p:nvSpPr>
-          <p:cNvPr id="11" name="TextBox 10"/>
-          <p:cNvSpPr txBox="1"/>
-          <p:nvPr/>
-        </p:nvSpPr>
-        <p:spPr>
-          <a:xfrm>
-            <a:off x="609600" y="3409950"/>
-            <a:ext cx="254000" cy="355600"/>
-          </a:xfrm>
-          <a:prstGeom prst="rect">
-            <a:avLst/>
-          </a:prstGeom>
-          <a:noFill/>
-        </p:spPr>
-        <p:txBody>
-          <a:bodyPr wrap="square">
-            <a:normAutofit/>
-          </a:bodyPr>
-          <a:lstStyle/>
-          <a:p>
-            <a:pPr algn="l"/>
-            <a:r>
-              <a:rPr sz="2200" b="0" i="0">
-                <a:solidFill>
-                  <a:srgbClr val="1F2B56"/>
-                </a:solidFill>
-                <a:latin typeface="Georgia"/>
-              </a:rPr>
-              <a:t>–</a:t>
-            </a:r>
-          </a:p>
-        </p:txBody>
-      </p:sp>
-      <p:sp>
-        <p:nvSpPr>
-          <p:cNvPr id="12" name="TextBox 11"/>
-          <p:cNvSpPr txBox="1"/>
-          <p:nvPr/>
-        </p:nvSpPr>
-        <p:spPr>
-          <a:xfrm>
-            <a:off x="939799" y="3384550"/>
-            <a:ext cx="10642600" cy="508000"/>
-          </a:xfrm>
-          <a:prstGeom prst="rect">
-            <a:avLst/>
-          </a:prstGeom>
-          <a:noFill/>
-        </p:spPr>
-        <p:txBody>
-          <a:bodyPr wrap="square">
-            <a:normAutofit/>
-          </a:bodyPr>
-          <a:lstStyle/>
-          <a:p>
-            <a:pPr algn="l"/>
-            <a:r>
-              <a:rPr sz="1400" b="0" i="0">
+              <a:t>–  Der Jahresabschluss ist die jährliche Zusammenfassung der wirtschaftlichen Lage eines Unternehmens. Für Kapitalgesellschaften (GmbH, AG) schreibt das HGB in §§ 264 ff. folgende Bestandteile vor:</a:t>
+            </a:r>
+          </a:p>
+          <a:p>
+            <a:pPr>
+              <a:spcBef>
+                <a:spcPts val="600"/>
+              </a:spcBef>
+              <a:spcAft>
+                <a:spcPts val="600"/>
+              </a:spcAft>
+            </a:pPr>
+            <a:r>
+              <a:rPr sz="1400">
                 <a:solidFill>
                   <a:srgbClr val="191D2E"/>
                 </a:solidFill>
                 <a:latin typeface="Georgia"/>
               </a:rPr>
-              <a:t>Bilanz (§ 266 HGB): Stichtagsbezogene Gegenüberstellung von Vermögen (Aktiva) und Kapital (Passiva). Die Bilanz zeigt, was ein Unternehmen besitzt und wie es finanziert ist.</a:t>
-            </a:r>
-          </a:p>
-        </p:txBody>
-      </p:sp>
-      <p:sp>
-        <p:nvSpPr>
-          <p:cNvPr id="13" name="Rectangle 12"/>
-          <p:cNvSpPr/>
-          <p:nvPr/>
-        </p:nvSpPr>
-        <p:spPr>
-          <a:xfrm>
-            <a:off x="939799" y="3867150"/>
-            <a:ext cx="10642600" cy="6350"/>
-          </a:xfrm>
-          <a:prstGeom prst="rect">
-            <a:avLst/>
-          </a:prstGeom>
-          <a:solidFill>
-            <a:srgbClr val="E0E0E8"/>
-          </a:solidFill>
-          <a:ln>
-            <a:noFill/>
-          </a:ln>
-        </p:spPr>
-        <p:style>
-          <a:lnRef idx="1">
-            <a:schemeClr val="accent1"/>
-          </a:lnRef>
-          <a:fillRef idx="3">
-            <a:schemeClr val="accent1"/>
-          </a:fillRef>
-          <a:effectRef idx="2">
-            <a:schemeClr val="accent1"/>
-          </a:effectRef>
-          <a:fontRef idx="minor">
-            <a:schemeClr val="lt1"/>
-          </a:fontRef>
-        </p:style>
-        <p:txBody>
-          <a:bodyPr rtlCol="0" anchor="ctr"/>
-          <a:lstStyle/>
-          <a:p>
-            <a:pPr algn="ctr"/>
-          </a:p>
-        </p:txBody>
-      </p:sp>
-      <p:sp>
-        <p:nvSpPr>
-          <p:cNvPr id="14" name="TextBox 13"/>
-          <p:cNvSpPr txBox="1"/>
-          <p:nvPr/>
-        </p:nvSpPr>
-        <p:spPr>
-          <a:xfrm>
-            <a:off x="609600" y="3943350"/>
-            <a:ext cx="254000" cy="355600"/>
-          </a:xfrm>
-          <a:prstGeom prst="rect">
-            <a:avLst/>
-          </a:prstGeom>
-          <a:noFill/>
-        </p:spPr>
-        <p:txBody>
-          <a:bodyPr wrap="square">
-            <a:normAutofit/>
-          </a:bodyPr>
-          <a:lstStyle/>
-          <a:p>
-            <a:pPr algn="l"/>
-            <a:r>
-              <a:rPr sz="2200" b="0" i="0">
-                <a:solidFill>
-                  <a:srgbClr val="1F2B56"/>
-                </a:solidFill>
-                <a:latin typeface="Georgia"/>
-              </a:rPr>
-              <a:t>–</a:t>
-            </a:r>
-          </a:p>
-        </p:txBody>
-      </p:sp>
-      <p:sp>
-        <p:nvSpPr>
-          <p:cNvPr id="15" name="TextBox 14"/>
-          <p:cNvSpPr txBox="1"/>
-          <p:nvPr/>
-        </p:nvSpPr>
-        <p:spPr>
-          <a:xfrm>
-            <a:off x="939799" y="3917950"/>
-            <a:ext cx="10642600" cy="508000"/>
-          </a:xfrm>
-          <a:prstGeom prst="rect">
-            <a:avLst/>
-          </a:prstGeom>
-          <a:noFill/>
-        </p:spPr>
-        <p:txBody>
-          <a:bodyPr wrap="square">
-            <a:normAutofit/>
-          </a:bodyPr>
-          <a:lstStyle/>
-          <a:p>
-            <a:pPr algn="l"/>
-            <a:r>
-              <a:rPr sz="1400" b="0" i="0">
+              <a:t>–  Bilanz (§ 266 HGB): Stichtagsbezogene Gegenüberstellung von Vermögen (Aktiva) und Kapital (Passiva). Die Bilanz zeigt, was ein Unternehmen besitzt und wie es finanziert ist.</a:t>
+            </a:r>
+          </a:p>
+          <a:p>
+            <a:pPr>
+              <a:spcBef>
+                <a:spcPts val="600"/>
+              </a:spcBef>
+              <a:spcAft>
+                <a:spcPts val="600"/>
+              </a:spcAft>
+            </a:pPr>
+            <a:r>
+              <a:rPr sz="1400">
                 <a:solidFill>
                   <a:srgbClr val="191D2E"/>
                 </a:solidFill>
                 <a:latin typeface="Georgia"/>
               </a:rPr>
-              <a:t>Gewinn- und Verlustrechnung (§ 275 HGB): Zeitraumbezogene Darstellung von Erträgen und Aufwendungen eines Geschäftsjahres. Sie zeigt, wie ein Unternehmen Geld verdient (oder verliert).</a:t>
-            </a:r>
-          </a:p>
-        </p:txBody>
-      </p:sp>
-      <p:sp>
-        <p:nvSpPr>
-          <p:cNvPr id="16" name="Rectangle 15"/>
-          <p:cNvSpPr/>
-          <p:nvPr/>
-        </p:nvSpPr>
-        <p:spPr>
-          <a:xfrm>
-            <a:off x="939799" y="4400550"/>
-            <a:ext cx="10642600" cy="6350"/>
-          </a:xfrm>
-          <a:prstGeom prst="rect">
-            <a:avLst/>
-          </a:prstGeom>
-          <a:solidFill>
-            <a:srgbClr val="E0E0E8"/>
-          </a:solidFill>
-          <a:ln>
-            <a:noFill/>
-          </a:ln>
-        </p:spPr>
-        <p:style>
-          <a:lnRef idx="1">
-            <a:schemeClr val="accent1"/>
-          </a:lnRef>
-          <a:fillRef idx="3">
-            <a:schemeClr val="accent1"/>
-          </a:fillRef>
-          <a:effectRef idx="2">
-            <a:schemeClr val="accent1"/>
-          </a:effectRef>
-          <a:fontRef idx="minor">
-            <a:schemeClr val="lt1"/>
-          </a:fontRef>
-        </p:style>
-        <p:txBody>
-          <a:bodyPr rtlCol="0" anchor="ctr"/>
-          <a:lstStyle/>
-          <a:p>
-            <a:pPr algn="ctr"/>
-          </a:p>
-        </p:txBody>
-      </p:sp>
-      <p:sp>
-        <p:nvSpPr>
-          <p:cNvPr id="17" name="TextBox 16"/>
-          <p:cNvSpPr txBox="1"/>
-          <p:nvPr/>
-        </p:nvSpPr>
-        <p:spPr>
-          <a:xfrm>
-            <a:off x="609600" y="4476750"/>
-            <a:ext cx="254000" cy="355600"/>
-          </a:xfrm>
-          <a:prstGeom prst="rect">
-            <a:avLst/>
-          </a:prstGeom>
-          <a:noFill/>
-        </p:spPr>
-        <p:txBody>
-          <a:bodyPr wrap="square">
-            <a:normAutofit/>
-          </a:bodyPr>
-          <a:lstStyle/>
-          <a:p>
-            <a:pPr algn="l"/>
-            <a:r>
-              <a:rPr sz="2200" b="0" i="0">
-                <a:solidFill>
-                  <a:srgbClr val="1F2B56"/>
-                </a:solidFill>
-                <a:latin typeface="Georgia"/>
-              </a:rPr>
-              <a:t>–</a:t>
-            </a:r>
-          </a:p>
-        </p:txBody>
-      </p:sp>
-      <p:sp>
-        <p:nvSpPr>
-          <p:cNvPr id="18" name="TextBox 17"/>
-          <p:cNvSpPr txBox="1"/>
-          <p:nvPr/>
-        </p:nvSpPr>
-        <p:spPr>
-          <a:xfrm>
-            <a:off x="939799" y="4451350"/>
-            <a:ext cx="10642600" cy="508000"/>
-          </a:xfrm>
-          <a:prstGeom prst="rect">
-            <a:avLst/>
-          </a:prstGeom>
-          <a:noFill/>
-        </p:spPr>
-        <p:txBody>
-          <a:bodyPr wrap="square">
-            <a:normAutofit/>
-          </a:bodyPr>
-          <a:lstStyle/>
-          <a:p>
-            <a:pPr algn="l"/>
-            <a:r>
-              <a:rPr sz="1400" b="0" i="0">
+              <a:t>–  Gewinn- und Verlustrechnung (§ 275 HGB): Zeitraumbezogene Darstellung von Erträgen und Aufwendungen eines Geschäftsjahres. Sie zeigt, wie ein Unternehmen Geld verdient (oder verliert).</a:t>
+            </a:r>
+          </a:p>
+          <a:p>
+            <a:pPr>
+              <a:spcBef>
+                <a:spcPts val="600"/>
+              </a:spcBef>
+              <a:spcAft>
+                <a:spcPts val="600"/>
+              </a:spcAft>
+            </a:pPr>
+            <a:r>
+              <a:rPr sz="1400">
                 <a:solidFill>
                   <a:srgbClr val="191D2E"/>
                 </a:solidFill>
                 <a:latin typeface="Georgia"/>
               </a:rPr>
-              <a:t>Anhang (§ 284 HGB): Erläuterungen und Ergänzungen zu Bilanz und GuV (z.B. Bilanzierungsmethoden, Haftungsverhältnisse). Für den Kreditgeber oft wertvoller als die nackten Zahlen.</a:t>
-            </a:r>
-          </a:p>
-        </p:txBody>
-      </p:sp>
-      <p:sp>
-        <p:nvSpPr>
-          <p:cNvPr id="19" name="Rectangle 18"/>
-          <p:cNvSpPr/>
-          <p:nvPr/>
-        </p:nvSpPr>
-        <p:spPr>
-          <a:xfrm>
-            <a:off x="939799" y="4933950"/>
-            <a:ext cx="10642600" cy="6350"/>
-          </a:xfrm>
-          <a:prstGeom prst="rect">
-            <a:avLst/>
-          </a:prstGeom>
-          <a:solidFill>
-            <a:srgbClr val="E0E0E8"/>
-          </a:solidFill>
-          <a:ln>
-            <a:noFill/>
-          </a:ln>
-        </p:spPr>
-        <p:style>
-          <a:lnRef idx="1">
-            <a:schemeClr val="accent1"/>
-          </a:lnRef>
-          <a:fillRef idx="3">
-            <a:schemeClr val="accent1"/>
-          </a:fillRef>
-          <a:effectRef idx="2">
-            <a:schemeClr val="accent1"/>
-          </a:effectRef>
-          <a:fontRef idx="minor">
-            <a:schemeClr val="lt1"/>
-          </a:fontRef>
-        </p:style>
-        <p:txBody>
-          <a:bodyPr rtlCol="0" anchor="ctr"/>
-          <a:lstStyle/>
-          <a:p>
-            <a:pPr algn="ctr"/>
-          </a:p>
-        </p:txBody>
-      </p:sp>
-      <p:sp>
-        <p:nvSpPr>
-          <p:cNvPr id="20" name="TextBox 19"/>
-          <p:cNvSpPr txBox="1"/>
-          <p:nvPr/>
-        </p:nvSpPr>
-        <p:spPr>
-          <a:xfrm>
-            <a:off x="609600" y="5010150"/>
-            <a:ext cx="254000" cy="355600"/>
-          </a:xfrm>
-          <a:prstGeom prst="rect">
-            <a:avLst/>
-          </a:prstGeom>
-          <a:noFill/>
-        </p:spPr>
-        <p:txBody>
-          <a:bodyPr wrap="square">
-            <a:normAutofit/>
-          </a:bodyPr>
-          <a:lstStyle/>
-          <a:p>
-            <a:pPr algn="l"/>
-            <a:r>
-              <a:rPr sz="2200" b="0" i="0">
-                <a:solidFill>
-                  <a:srgbClr val="1F2B56"/>
-                </a:solidFill>
-                <a:latin typeface="Georgia"/>
-              </a:rPr>
-              <a:t>–</a:t>
-            </a:r>
-          </a:p>
-        </p:txBody>
-      </p:sp>
-      <p:sp>
-        <p:nvSpPr>
-          <p:cNvPr id="21" name="TextBox 20"/>
-          <p:cNvSpPr txBox="1"/>
-          <p:nvPr/>
-        </p:nvSpPr>
-        <p:spPr>
-          <a:xfrm>
-            <a:off x="939799" y="4984750"/>
-            <a:ext cx="10642600" cy="508000"/>
-          </a:xfrm>
-          <a:prstGeom prst="rect">
-            <a:avLst/>
-          </a:prstGeom>
-          <a:noFill/>
-        </p:spPr>
-        <p:txBody>
-          <a:bodyPr wrap="square">
-            <a:normAutofit/>
-          </a:bodyPr>
-          <a:lstStyle/>
-          <a:p>
-            <a:pPr algn="l"/>
-            <a:r>
-              <a:rPr sz="1400" b="0" i="0">
+              <a:t>–  Anhang (§ 284 HGB): Erläuterungen und Ergänzungen zu Bilanz und GuV (z.B. Bilanzierungsmethoden, Haftungsverhältnisse). Für den Kreditgeber oft wertvoller als die nackten Zahlen.</a:t>
+            </a:r>
+          </a:p>
+          <a:p>
+            <a:pPr>
+              <a:spcBef>
+                <a:spcPts val="600"/>
+              </a:spcBef>
+              <a:spcAft>
+                <a:spcPts val="600"/>
+              </a:spcAft>
+            </a:pPr>
+            <a:r>
+              <a:rPr sz="1400">
                 <a:solidFill>
                   <a:srgbClr val="191D2E"/>
                 </a:solidFill>
                 <a:latin typeface="Georgia"/>
               </a:rPr>
-              <a:t>Lagebericht (§ 289 HGB): Lageeinschätzung des Managements, Risikobericht, Ausblick. Nur für mittelgroße und große Unternehmen verpflichtend.</a:t>
-            </a:r>
-          </a:p>
-        </p:txBody>
-      </p:sp>
-      <p:sp>
-        <p:nvSpPr>
-          <p:cNvPr id="22" name="Rectangle 21"/>
-          <p:cNvSpPr/>
-          <p:nvPr/>
-        </p:nvSpPr>
-        <p:spPr>
-          <a:xfrm>
-            <a:off x="939799" y="5467350"/>
-            <a:ext cx="10642600" cy="6350"/>
-          </a:xfrm>
-          <a:prstGeom prst="rect">
-            <a:avLst/>
-          </a:prstGeom>
-          <a:solidFill>
-            <a:srgbClr val="E0E0E8"/>
-          </a:solidFill>
-          <a:ln>
-            <a:noFill/>
-          </a:ln>
-        </p:spPr>
-        <p:style>
-          <a:lnRef idx="1">
-            <a:schemeClr val="accent1"/>
-          </a:lnRef>
-          <a:fillRef idx="3">
-            <a:schemeClr val="accent1"/>
-          </a:fillRef>
-          <a:effectRef idx="2">
-            <a:schemeClr val="accent1"/>
-          </a:effectRef>
-          <a:fontRef idx="minor">
-            <a:schemeClr val="lt1"/>
-          </a:fontRef>
-        </p:style>
-        <p:txBody>
-          <a:bodyPr rtlCol="0" anchor="ctr"/>
-          <a:lstStyle/>
-          <a:p>
-            <a:pPr algn="ctr"/>
+              <a:t>–  Lagebericht (§ 289 HGB): Lageeinschätzung des Managements, Risikobericht, Ausblick. Nur für mittelgroße und große Unternehmen verpflichtend.</a:t>
+            </a:r>
           </a:p>
         </p:txBody>
       </p:sp>
@@ -9915,7 +9637,7 @@
                 </a:solidFill>
                 <a:latin typeface="Courier New"/>
               </a:rPr>
-              <a:t>§ I · MODULINHALTE</a:t>
+              <a:t>I · MODULINHALTE</a:t>
             </a:r>
           </a:p>
         </p:txBody>
@@ -10084,8 +9806,8 @@
         </p:nvSpPr>
         <p:spPr>
           <a:xfrm>
-            <a:off x="609600" y="2876550"/>
-            <a:ext cx="254000" cy="355600"/>
+            <a:off x="609600" y="2851150"/>
+            <a:ext cx="10972800" cy="3448050"/>
           </a:xfrm>
           <a:prstGeom prst="rect">
             <a:avLst/>
@@ -10098,94 +9820,23 @@
           </a:bodyPr>
           <a:lstStyle/>
           <a:p>
-            <a:pPr algn="l"/>
-            <a:r>
-              <a:rPr sz="2200" b="0" i="0">
-                <a:solidFill>
-                  <a:srgbClr val="1F2B56"/>
-                </a:solidFill>
-                <a:latin typeface="Georgia"/>
-              </a:rPr>
-              <a:t>–</a:t>
-            </a:r>
-          </a:p>
-        </p:txBody>
-      </p:sp>
-      <p:sp>
-        <p:nvSpPr>
-          <p:cNvPr id="9" name="TextBox 8"/>
-          <p:cNvSpPr txBox="1"/>
-          <p:nvPr/>
-        </p:nvSpPr>
-        <p:spPr>
-          <a:xfrm>
-            <a:off x="939799" y="2851150"/>
-            <a:ext cx="10642600" cy="508000"/>
-          </a:xfrm>
-          <a:prstGeom prst="rect">
-            <a:avLst/>
-          </a:prstGeom>
-          <a:noFill/>
-        </p:spPr>
-        <p:txBody>
-          <a:bodyPr wrap="square">
-            <a:normAutofit/>
-          </a:bodyPr>
-          <a:lstStyle/>
-          <a:p>
-            <a:pPr algn="l"/>
-            <a:r>
-              <a:rPr sz="1400" b="0" i="0">
+            <a:pPr>
+              <a:spcBef>
+                <a:spcPts val="600"/>
+              </a:spcBef>
+              <a:spcAft>
+                <a:spcPts val="600"/>
+              </a:spcAft>
+            </a:pPr>
+            <a:r>
+              <a:rPr sz="1400">
                 <a:solidFill>
                   <a:srgbClr val="191D2E"/>
                 </a:solidFill>
                 <a:latin typeface="Georgia"/>
               </a:rPr>
-              <a:t>&gt; Praxishinweis: Viele Ihrer KMU-Kunden sind „kleine" GmbHs – sie legen keine GuV offen. In diesen Fällen müssen Sie die GuV-Daten im Rahmen der Kreditwürdigkeitsprüfung nach § 18 KWG direkt beim Kunden anfordern.</a:t>
-            </a:r>
-          </a:p>
-        </p:txBody>
-      </p:sp>
-      <p:sp>
-        <p:nvSpPr>
-          <p:cNvPr id="10" name="Rectangle 9"/>
-          <p:cNvSpPr/>
-          <p:nvPr/>
-        </p:nvSpPr>
-        <p:spPr>
-          <a:xfrm>
-            <a:off x="939799" y="3333750"/>
-            <a:ext cx="10642600" cy="6350"/>
-          </a:xfrm>
-          <a:prstGeom prst="rect">
-            <a:avLst/>
-          </a:prstGeom>
-          <a:solidFill>
-            <a:srgbClr val="E0E0E8"/>
-          </a:solidFill>
-          <a:ln>
-            <a:noFill/>
-          </a:ln>
-        </p:spPr>
-        <p:style>
-          <a:lnRef idx="1">
-            <a:schemeClr val="accent1"/>
-          </a:lnRef>
-          <a:fillRef idx="3">
-            <a:schemeClr val="accent1"/>
-          </a:fillRef>
-          <a:effectRef idx="2">
-            <a:schemeClr val="accent1"/>
-          </a:effectRef>
-          <a:fontRef idx="minor">
-            <a:schemeClr val="lt1"/>
-          </a:fontRef>
-        </p:style>
-        <p:txBody>
-          <a:bodyPr rtlCol="0" anchor="ctr"/>
-          <a:lstStyle/>
-          <a:p>
-            <a:pPr algn="ctr"/>
+              <a:t>–  Praxishinweis: Viele Ihrer KMU-Kunden sind „kleine" GmbHs – sie legen keine GuV offen. In diesen Fällen müssen Sie die GuV-Daten im Rahmen der Kreditwürdigkeitsprüfung nach § 18 KWG direkt beim Kunden anfordern.</a:t>
+            </a:r>
           </a:p>
         </p:txBody>
       </p:sp>
@@ -10280,7 +9931,7 @@
                 </a:solidFill>
                 <a:latin typeface="Courier New"/>
               </a:rPr>
-              <a:t>§ I · MODULINHALTE</a:t>
+              <a:t>I · MODULINHALTE</a:t>
             </a:r>
           </a:p>
         </p:txBody>
@@ -10449,8 +10100,8 @@
         </p:nvSpPr>
         <p:spPr>
           <a:xfrm>
-            <a:off x="609600" y="2876550"/>
-            <a:ext cx="254000" cy="355600"/>
+            <a:off x="609600" y="2851150"/>
+            <a:ext cx="10972800" cy="3448050"/>
           </a:xfrm>
           <a:prstGeom prst="rect">
             <a:avLst/>
@@ -10463,94 +10114,23 @@
           </a:bodyPr>
           <a:lstStyle/>
           <a:p>
-            <a:pPr algn="l"/>
-            <a:r>
-              <a:rPr sz="2200" b="0" i="0">
-                <a:solidFill>
-                  <a:srgbClr val="1F2B56"/>
-                </a:solidFill>
-                <a:latin typeface="Georgia"/>
-              </a:rPr>
-              <a:t>–</a:t>
-            </a:r>
-          </a:p>
-        </p:txBody>
-      </p:sp>
-      <p:sp>
-        <p:nvSpPr>
-          <p:cNvPr id="9" name="TextBox 8"/>
-          <p:cNvSpPr txBox="1"/>
-          <p:nvPr/>
-        </p:nvSpPr>
-        <p:spPr>
-          <a:xfrm>
-            <a:off x="939799" y="2851150"/>
-            <a:ext cx="10642600" cy="508000"/>
-          </a:xfrm>
-          <a:prstGeom prst="rect">
-            <a:avLst/>
-          </a:prstGeom>
-          <a:noFill/>
-        </p:spPr>
-        <p:txBody>
-          <a:bodyPr wrap="square">
-            <a:normAutofit/>
-          </a:bodyPr>
-          <a:lstStyle/>
-          <a:p>
-            <a:pPr algn="l"/>
-            <a:r>
-              <a:rPr sz="1400" b="0" i="0">
+            <a:pPr>
+              <a:spcBef>
+                <a:spcPts val="600"/>
+              </a:spcBef>
+              <a:spcAft>
+                <a:spcPts val="600"/>
+              </a:spcAft>
+            </a:pPr>
+            <a:r>
+              <a:rPr sz="1400">
                 <a:solidFill>
                   <a:srgbClr val="191D2E"/>
                 </a:solidFill>
                 <a:latin typeface="Georgia"/>
               </a:rPr>
-              <a:t>Die Goldene Bilanzregel lautet: Langfristig gebundenes Vermögen sollte durch langfristiges Kapital finanziert sein (Fristenkongruenz). Eine Verletzung – z.B. kurzfristige Bankdarlehen zur Finanzierung von Maschinen –…</a:t>
-            </a:r>
-          </a:p>
-        </p:txBody>
-      </p:sp>
-      <p:sp>
-        <p:nvSpPr>
-          <p:cNvPr id="10" name="Rectangle 9"/>
-          <p:cNvSpPr/>
-          <p:nvPr/>
-        </p:nvSpPr>
-        <p:spPr>
-          <a:xfrm>
-            <a:off x="939799" y="3333750"/>
-            <a:ext cx="10642600" cy="6350"/>
-          </a:xfrm>
-          <a:prstGeom prst="rect">
-            <a:avLst/>
-          </a:prstGeom>
-          <a:solidFill>
-            <a:srgbClr val="E0E0E8"/>
-          </a:solidFill>
-          <a:ln>
-            <a:noFill/>
-          </a:ln>
-        </p:spPr>
-        <p:style>
-          <a:lnRef idx="1">
-            <a:schemeClr val="accent1"/>
-          </a:lnRef>
-          <a:fillRef idx="3">
-            <a:schemeClr val="accent1"/>
-          </a:fillRef>
-          <a:effectRef idx="2">
-            <a:schemeClr val="accent1"/>
-          </a:effectRef>
-          <a:fontRef idx="minor">
-            <a:schemeClr val="lt1"/>
-          </a:fontRef>
-        </p:style>
-        <p:txBody>
-          <a:bodyPr rtlCol="0" anchor="ctr"/>
-          <a:lstStyle/>
-          <a:p>
-            <a:pPr algn="ctr"/>
+              <a:t>–  Die Goldene Bilanzregel lautet: Langfristig gebundenes Vermögen sollte durch langfristiges Kapital finanziert sein (Fristenkongruenz). Eine Verletzung – z.B. kurzfristige Bankdarlehen zur Finanzierung von Maschinen –…</a:t>
+            </a:r>
           </a:p>
         </p:txBody>
       </p:sp>
@@ -13045,7 +12625,7 @@
                 </a:solidFill>
                 <a:latin typeface="Courier New"/>
               </a:rPr>
-              <a:t>§ I · MODULINHALTE</a:t>
+              <a:t>I · MODULINHALTE</a:t>
             </a:r>
           </a:p>
         </p:txBody>
@@ -13281,7 +12861,7 @@
                 </a:solidFill>
                 <a:latin typeface="Courier New"/>
               </a:rPr>
-              <a:t>§ I · MODULINHALTE</a:t>
+              <a:t>I · MODULINHALTE</a:t>
             </a:r>
           </a:p>
         </p:txBody>
@@ -13450,8 +13030,8 @@
         </p:nvSpPr>
         <p:spPr>
           <a:xfrm>
-            <a:off x="609600" y="2876550"/>
-            <a:ext cx="254000" cy="355600"/>
+            <a:off x="609600" y="2851150"/>
+            <a:ext cx="10972800" cy="3448050"/>
           </a:xfrm>
           <a:prstGeom prst="rect">
             <a:avLst/>
@@ -13464,433 +13044,80 @@
           </a:bodyPr>
           <a:lstStyle/>
           <a:p>
-            <a:pPr algn="l"/>
-            <a:r>
-              <a:rPr sz="2200" b="0" i="0">
-                <a:solidFill>
-                  <a:srgbClr val="1F2B56"/>
-                </a:solidFill>
-                <a:latin typeface="Georgia"/>
-              </a:rPr>
-              <a:t>–</a:t>
-            </a:r>
-          </a:p>
-        </p:txBody>
-      </p:sp>
-      <p:sp>
-        <p:nvSpPr>
-          <p:cNvPr id="9" name="TextBox 8"/>
-          <p:cNvSpPr txBox="1"/>
-          <p:nvPr/>
-        </p:nvSpPr>
-        <p:spPr>
-          <a:xfrm>
-            <a:off x="939799" y="2851150"/>
-            <a:ext cx="10642600" cy="508000"/>
-          </a:xfrm>
-          <a:prstGeom prst="rect">
-            <a:avLst/>
-          </a:prstGeom>
-          <a:noFill/>
-        </p:spPr>
-        <p:txBody>
-          <a:bodyPr wrap="square">
-            <a:normAutofit/>
-          </a:bodyPr>
-          <a:lstStyle/>
-          <a:p>
-            <a:pPr algn="l"/>
-            <a:r>
-              <a:rPr sz="1400" b="0" i="0">
+            <a:pPr>
+              <a:spcBef>
+                <a:spcPts val="600"/>
+              </a:spcBef>
+              <a:spcAft>
+                <a:spcPts val="600"/>
+              </a:spcAft>
+            </a:pPr>
+            <a:r>
+              <a:rPr sz="1400">
                 <a:solidFill>
                   <a:srgbClr val="191D2E"/>
                 </a:solidFill>
                 <a:latin typeface="Georgia"/>
               </a:rPr>
-              <a:t>Welche der sechs Kennzahlen war Ihnen vor diesem Modul noch unklar?</a:t>
-            </a:r>
-          </a:p>
-        </p:txBody>
-      </p:sp>
-      <p:sp>
-        <p:nvSpPr>
-          <p:cNvPr id="10" name="Rectangle 9"/>
-          <p:cNvSpPr/>
-          <p:nvPr/>
-        </p:nvSpPr>
-        <p:spPr>
-          <a:xfrm>
-            <a:off x="939799" y="3333750"/>
-            <a:ext cx="10642600" cy="6350"/>
-          </a:xfrm>
-          <a:prstGeom prst="rect">
-            <a:avLst/>
-          </a:prstGeom>
-          <a:solidFill>
-            <a:srgbClr val="E0E0E8"/>
-          </a:solidFill>
-          <a:ln>
-            <a:noFill/>
-          </a:ln>
-        </p:spPr>
-        <p:style>
-          <a:lnRef idx="1">
-            <a:schemeClr val="accent1"/>
-          </a:lnRef>
-          <a:fillRef idx="3">
-            <a:schemeClr val="accent1"/>
-          </a:fillRef>
-          <a:effectRef idx="2">
-            <a:schemeClr val="accent1"/>
-          </a:effectRef>
-          <a:fontRef idx="minor">
-            <a:schemeClr val="lt1"/>
-          </a:fontRef>
-        </p:style>
-        <p:txBody>
-          <a:bodyPr rtlCol="0" anchor="ctr"/>
-          <a:lstStyle/>
-          <a:p>
-            <a:pPr algn="ctr"/>
-          </a:p>
-        </p:txBody>
-      </p:sp>
-      <p:sp>
-        <p:nvSpPr>
-          <p:cNvPr id="11" name="TextBox 10"/>
-          <p:cNvSpPr txBox="1"/>
-          <p:nvPr/>
-        </p:nvSpPr>
-        <p:spPr>
-          <a:xfrm>
-            <a:off x="609600" y="3409950"/>
-            <a:ext cx="254000" cy="355600"/>
-          </a:xfrm>
-          <a:prstGeom prst="rect">
-            <a:avLst/>
-          </a:prstGeom>
-          <a:noFill/>
-        </p:spPr>
-        <p:txBody>
-          <a:bodyPr wrap="square">
-            <a:normAutofit/>
-          </a:bodyPr>
-          <a:lstStyle/>
-          <a:p>
-            <a:pPr algn="l"/>
-            <a:r>
-              <a:rPr sz="2200" b="0" i="0">
-                <a:solidFill>
-                  <a:srgbClr val="1F2B56"/>
-                </a:solidFill>
-                <a:latin typeface="Georgia"/>
-              </a:rPr>
-              <a:t>–</a:t>
-            </a:r>
-          </a:p>
-        </p:txBody>
-      </p:sp>
-      <p:sp>
-        <p:nvSpPr>
-          <p:cNvPr id="12" name="TextBox 11"/>
-          <p:cNvSpPr txBox="1"/>
-          <p:nvPr/>
-        </p:nvSpPr>
-        <p:spPr>
-          <a:xfrm>
-            <a:off x="939799" y="3384550"/>
-            <a:ext cx="10642600" cy="508000"/>
-          </a:xfrm>
-          <a:prstGeom prst="rect">
-            <a:avLst/>
-          </a:prstGeom>
-          <a:noFill/>
-        </p:spPr>
-        <p:txBody>
-          <a:bodyPr wrap="square">
-            <a:normAutofit/>
-          </a:bodyPr>
-          <a:lstStyle/>
-          <a:p>
-            <a:pPr algn="l"/>
-            <a:r>
-              <a:rPr sz="1400" b="0" i="0">
+              <a:t>–  Welche der sechs Kennzahlen war Ihnen vor diesem Modul noch unklar?</a:t>
+            </a:r>
+          </a:p>
+          <a:p>
+            <a:pPr>
+              <a:spcBef>
+                <a:spcPts val="600"/>
+              </a:spcBef>
+              <a:spcAft>
+                <a:spcPts val="600"/>
+              </a:spcAft>
+            </a:pPr>
+            <a:r>
+              <a:rPr sz="1400">
                 <a:solidFill>
                   <a:srgbClr val="191D2E"/>
                 </a:solidFill>
                 <a:latin typeface="Georgia"/>
               </a:rPr>
-              <a:t>Was ist der kritischste Befund in der Bauer GmbH-Analyse? Wie würden Sie ihn im Kundengespräch ansprechen?</a:t>
-            </a:r>
-          </a:p>
-        </p:txBody>
-      </p:sp>
-      <p:sp>
-        <p:nvSpPr>
-          <p:cNvPr id="13" name="Rectangle 12"/>
-          <p:cNvSpPr/>
-          <p:nvPr/>
-        </p:nvSpPr>
-        <p:spPr>
-          <a:xfrm>
-            <a:off x="939799" y="3867150"/>
-            <a:ext cx="10642600" cy="6350"/>
-          </a:xfrm>
-          <a:prstGeom prst="rect">
-            <a:avLst/>
-          </a:prstGeom>
-          <a:solidFill>
-            <a:srgbClr val="E0E0E8"/>
-          </a:solidFill>
-          <a:ln>
-            <a:noFill/>
-          </a:ln>
-        </p:spPr>
-        <p:style>
-          <a:lnRef idx="1">
-            <a:schemeClr val="accent1"/>
-          </a:lnRef>
-          <a:fillRef idx="3">
-            <a:schemeClr val="accent1"/>
-          </a:fillRef>
-          <a:effectRef idx="2">
-            <a:schemeClr val="accent1"/>
-          </a:effectRef>
-          <a:fontRef idx="minor">
-            <a:schemeClr val="lt1"/>
-          </a:fontRef>
-        </p:style>
-        <p:txBody>
-          <a:bodyPr rtlCol="0" anchor="ctr"/>
-          <a:lstStyle/>
-          <a:p>
-            <a:pPr algn="ctr"/>
-          </a:p>
-        </p:txBody>
-      </p:sp>
-      <p:sp>
-        <p:nvSpPr>
-          <p:cNvPr id="14" name="TextBox 13"/>
-          <p:cNvSpPr txBox="1"/>
-          <p:nvPr/>
-        </p:nvSpPr>
-        <p:spPr>
-          <a:xfrm>
-            <a:off x="609600" y="3943350"/>
-            <a:ext cx="254000" cy="355600"/>
-          </a:xfrm>
-          <a:prstGeom prst="rect">
-            <a:avLst/>
-          </a:prstGeom>
-          <a:noFill/>
-        </p:spPr>
-        <p:txBody>
-          <a:bodyPr wrap="square">
-            <a:normAutofit/>
-          </a:bodyPr>
-          <a:lstStyle/>
-          <a:p>
-            <a:pPr algn="l"/>
-            <a:r>
-              <a:rPr sz="2200" b="0" i="0">
-                <a:solidFill>
-                  <a:srgbClr val="1F2B56"/>
-                </a:solidFill>
-                <a:latin typeface="Georgia"/>
-              </a:rPr>
-              <a:t>–</a:t>
-            </a:r>
-          </a:p>
-        </p:txBody>
-      </p:sp>
-      <p:sp>
-        <p:nvSpPr>
-          <p:cNvPr id="15" name="TextBox 14"/>
-          <p:cNvSpPr txBox="1"/>
-          <p:nvPr/>
-        </p:nvSpPr>
-        <p:spPr>
-          <a:xfrm>
-            <a:off x="939799" y="3917950"/>
-            <a:ext cx="10642600" cy="508000"/>
-          </a:xfrm>
-          <a:prstGeom prst="rect">
-            <a:avLst/>
-          </a:prstGeom>
-          <a:noFill/>
-        </p:spPr>
-        <p:txBody>
-          <a:bodyPr wrap="square">
-            <a:normAutofit/>
-          </a:bodyPr>
-          <a:lstStyle/>
-          <a:p>
-            <a:pPr algn="l"/>
-            <a:r>
-              <a:rPr sz="1400" b="0" i="0">
+              <a:t>–  Was ist der kritischste Befund in der Bauer GmbH-Analyse? Wie würden Sie ihn im Kundengespräch ansprechen?</a:t>
+            </a:r>
+          </a:p>
+          <a:p>
+            <a:pPr>
+              <a:spcBef>
+                <a:spcPts val="600"/>
+              </a:spcBef>
+              <a:spcAft>
+                <a:spcPts val="600"/>
+              </a:spcAft>
+            </a:pPr>
+            <a:r>
+              <a:rPr sz="1400">
                 <a:solidFill>
                   <a:srgbClr val="191D2E"/>
                 </a:solidFill>
                 <a:latin typeface="Georgia"/>
               </a:rPr>
-              <a:t>Welcher Kunde in Ihrem Portfolio kommt Ihnen beim Blick auf die Bauer-Bilanz spontan in den Sinn?</a:t>
-            </a:r>
-          </a:p>
-        </p:txBody>
-      </p:sp>
-      <p:sp>
-        <p:nvSpPr>
-          <p:cNvPr id="16" name="Rectangle 15"/>
-          <p:cNvSpPr/>
-          <p:nvPr/>
-        </p:nvSpPr>
-        <p:spPr>
-          <a:xfrm>
-            <a:off x="939799" y="4400550"/>
-            <a:ext cx="10642600" cy="6350"/>
-          </a:xfrm>
-          <a:prstGeom prst="rect">
-            <a:avLst/>
-          </a:prstGeom>
-          <a:solidFill>
-            <a:srgbClr val="E0E0E8"/>
-          </a:solidFill>
-          <a:ln>
-            <a:noFill/>
-          </a:ln>
-        </p:spPr>
-        <p:style>
-          <a:lnRef idx="1">
-            <a:schemeClr val="accent1"/>
-          </a:lnRef>
-          <a:fillRef idx="3">
-            <a:schemeClr val="accent1"/>
-          </a:fillRef>
-          <a:effectRef idx="2">
-            <a:schemeClr val="accent1"/>
-          </a:effectRef>
-          <a:fontRef idx="minor">
-            <a:schemeClr val="lt1"/>
-          </a:fontRef>
-        </p:style>
-        <p:txBody>
-          <a:bodyPr rtlCol="0" anchor="ctr"/>
-          <a:lstStyle/>
-          <a:p>
-            <a:pPr algn="ctr"/>
-          </a:p>
-        </p:txBody>
-      </p:sp>
-      <p:sp>
-        <p:nvSpPr>
-          <p:cNvPr id="17" name="TextBox 16"/>
-          <p:cNvSpPr txBox="1"/>
-          <p:nvPr/>
-        </p:nvSpPr>
-        <p:spPr>
-          <a:xfrm>
-            <a:off x="609600" y="4476750"/>
-            <a:ext cx="254000" cy="355600"/>
-          </a:xfrm>
-          <a:prstGeom prst="rect">
-            <a:avLst/>
-          </a:prstGeom>
-          <a:noFill/>
-        </p:spPr>
-        <p:txBody>
-          <a:bodyPr wrap="square">
-            <a:normAutofit/>
-          </a:bodyPr>
-          <a:lstStyle/>
-          <a:p>
-            <a:pPr algn="l"/>
-            <a:r>
-              <a:rPr sz="2200" b="0" i="0">
-                <a:solidFill>
-                  <a:srgbClr val="1F2B56"/>
-                </a:solidFill>
-                <a:latin typeface="Georgia"/>
-              </a:rPr>
-              <a:t>–</a:t>
-            </a:r>
-          </a:p>
-        </p:txBody>
-      </p:sp>
-      <p:sp>
-        <p:nvSpPr>
-          <p:cNvPr id="18" name="TextBox 17"/>
-          <p:cNvSpPr txBox="1"/>
-          <p:nvPr/>
-        </p:nvSpPr>
-        <p:spPr>
-          <a:xfrm>
-            <a:off x="939799" y="4451350"/>
-            <a:ext cx="10642600" cy="508000"/>
-          </a:xfrm>
-          <a:prstGeom prst="rect">
-            <a:avLst/>
-          </a:prstGeom>
-          <a:noFill/>
-        </p:spPr>
-        <p:txBody>
-          <a:bodyPr wrap="square">
-            <a:normAutofit/>
-          </a:bodyPr>
-          <a:lstStyle/>
-          <a:p>
-            <a:pPr algn="l"/>
-            <a:r>
-              <a:rPr sz="1400" b="0" i="0">
+              <a:t>–  Welcher Kunde in Ihrem Portfolio kommt Ihnen beim Blick auf die Bauer-Bilanz spontan in den Sinn?</a:t>
+            </a:r>
+          </a:p>
+          <a:p>
+            <a:pPr>
+              <a:spcBef>
+                <a:spcPts val="600"/>
+              </a:spcBef>
+              <a:spcAft>
+                <a:spcPts val="600"/>
+              </a:spcAft>
+            </a:pPr>
+            <a:r>
+              <a:rPr sz="1400">
                 <a:solidFill>
                   <a:srgbClr val="191D2E"/>
                 </a:solidFill>
                 <a:latin typeface="Georgia"/>
               </a:rPr>
-              <a:t>Was werden Sie konkret in den nächsten 30 Tagen anders machen, wenn ein Jahresabschluss auf Ihrem Tisch liegt?</a:t>
-            </a:r>
-          </a:p>
-        </p:txBody>
-      </p:sp>
-      <p:sp>
-        <p:nvSpPr>
-          <p:cNvPr id="19" name="Rectangle 18"/>
-          <p:cNvSpPr/>
-          <p:nvPr/>
-        </p:nvSpPr>
-        <p:spPr>
-          <a:xfrm>
-            <a:off x="939799" y="4933950"/>
-            <a:ext cx="10642600" cy="6350"/>
-          </a:xfrm>
-          <a:prstGeom prst="rect">
-            <a:avLst/>
-          </a:prstGeom>
-          <a:solidFill>
-            <a:srgbClr val="E0E0E8"/>
-          </a:solidFill>
-          <a:ln>
-            <a:noFill/>
-          </a:ln>
-        </p:spPr>
-        <p:style>
-          <a:lnRef idx="1">
-            <a:schemeClr val="accent1"/>
-          </a:lnRef>
-          <a:fillRef idx="3">
-            <a:schemeClr val="accent1"/>
-          </a:fillRef>
-          <a:effectRef idx="2">
-            <a:schemeClr val="accent1"/>
-          </a:effectRef>
-          <a:fontRef idx="minor">
-            <a:schemeClr val="lt1"/>
-          </a:fontRef>
-        </p:style>
-        <p:txBody>
-          <a:bodyPr rtlCol="0" anchor="ctr"/>
-          <a:lstStyle/>
-          <a:p>
-            <a:pPr algn="ctr"/>
+              <a:t>–  Was werden Sie konkret in den nächsten 30 Tagen anders machen, wenn ein Jahresabschluss auf Ihrem Tisch liegt?</a:t>
+            </a:r>
           </a:p>
         </p:txBody>
       </p:sp>

</xml_diff>

<commit_message>
PPTX: Fix ---  als Kontext-Text in Tabellenfolien + clean_title-Refactor
- Horizontallinien (---) aus h3/h4-Kontext-Extraktor gefiltert → Folie 07 zeigt nur noch Tabelle
- clean_title() entfernt Dok.-Nummern und Rollen-Labels aus Folientiteln
- Bullets als Single-Multi-Paragraph-Box statt separater Textboxen
- Quellenapparat-Folie auch bei ## Quellen-Heading erzeugt

Co-Authored-By: Claude Sonnet 4.6 <noreply@anthropic.com>
</commit_message>
<xml_diff>
--- a/public/downloads/praesentation/M01.pptx
+++ b/public/downloads/praesentation/M01.pptx
@@ -3664,7 +3664,7 @@
                 </a:solidFill>
                 <a:latin typeface="Georgia"/>
               </a:rPr>
-              <a:t>5.1 Transferaufgabe (30 Tage nach dem Seminar)</a:t>
+              <a:t>Transferaufgabe (30 Tage nach dem Seminar)</a:t>
             </a:r>
           </a:p>
         </p:txBody>
@@ -3873,7 +3873,7 @@
                 </a:solidFill>
                 <a:latin typeface="Georgia"/>
               </a:rPr>
-              <a:t>5.1 Transferaufgabe (30 Tage nach dem Seminar)</a:t>
+              <a:t>Transferaufgabe (30 Tage nach dem Seminar)</a:t>
             </a:r>
           </a:p>
         </p:txBody>
@@ -4833,7 +4833,7 @@
                 </a:solidFill>
                 <a:latin typeface="Georgia"/>
               </a:rPr>
-              <a:t>5.2 Selbstcheck nach 4 Wochen</a:t>
+              <a:t>Selbstcheck nach 4 Wochen</a:t>
             </a:r>
           </a:p>
         </p:txBody>
@@ -5778,7 +5778,7 @@
                 </a:solidFill>
                 <a:latin typeface="Georgia"/>
               </a:rPr>
-              <a:t>5.3 Empfohlene Vertiefungsliteratur</a:t>
+              <a:t>Empfohlene Vertiefungsliteratur</a:t>
             </a:r>
           </a:p>
         </p:txBody>
@@ -7890,7 +7890,7 @@
                 </a:solidFill>
                 <a:latin typeface="Georgia"/>
               </a:rPr>
-              <a:t>4.1 Theorie-Input: Aufbau des HGB-Jahresabschlusses</a:t>
+              <a:t>Aufbau des HGB-Jahresabschlusses</a:t>
             </a:r>
           </a:p>
         </p:txBody>
@@ -8078,7 +8078,7 @@
         <p:spPr>
           <a:xfrm>
             <a:off x="609600" y="920750"/>
-            <a:ext cx="4826000" cy="1778000"/>
+            <a:ext cx="10972800" cy="1778000"/>
           </a:xfrm>
           <a:prstGeom prst="rect">
             <a:avLst/>
@@ -8099,21 +8099,64 @@
                 </a:solidFill>
                 <a:latin typeface="Georgia"/>
               </a:rPr>
-              <a:t>4.1 Theorie-Input: Aufbau des HGB-Jahresabschlusses</a:t>
-            </a:r>
-          </a:p>
-        </p:txBody>
-      </p:sp>
-      <p:sp>
-        <p:nvSpPr>
-          <p:cNvPr id="7" name="TextBox 6"/>
+              <a:t>Was ist ein Jahresabschluss?</a:t>
+            </a:r>
+          </a:p>
+        </p:txBody>
+      </p:sp>
+      <p:sp>
+        <p:nvSpPr>
+          <p:cNvPr id="7" name="Rectangle 6"/>
+          <p:cNvSpPr/>
+          <p:nvPr/>
+        </p:nvSpPr>
+        <p:spPr>
+          <a:xfrm>
+            <a:off x="609600" y="2762250"/>
+            <a:ext cx="10972800" cy="6350"/>
+          </a:xfrm>
+          <a:prstGeom prst="rect">
+            <a:avLst/>
+          </a:prstGeom>
+          <a:solidFill>
+            <a:srgbClr val="E0E0E8"/>
+          </a:solidFill>
+          <a:ln>
+            <a:noFill/>
+          </a:ln>
+        </p:spPr>
+        <p:style>
+          <a:lnRef idx="1">
+            <a:schemeClr val="accent1"/>
+          </a:lnRef>
+          <a:fillRef idx="3">
+            <a:schemeClr val="accent1"/>
+          </a:fillRef>
+          <a:effectRef idx="2">
+            <a:schemeClr val="accent1"/>
+          </a:effectRef>
+          <a:fontRef idx="minor">
+            <a:schemeClr val="lt1"/>
+          </a:fontRef>
+        </p:style>
+        <p:txBody>
+          <a:bodyPr rtlCol="0" anchor="ctr"/>
+          <a:lstStyle/>
+          <a:p>
+            <a:pPr algn="ctr"/>
+          </a:p>
+        </p:txBody>
+      </p:sp>
+      <p:sp>
+        <p:nvSpPr>
+          <p:cNvPr id="8" name="TextBox 7"/>
           <p:cNvSpPr txBox="1"/>
           <p:nvPr/>
         </p:nvSpPr>
         <p:spPr>
           <a:xfrm>
-            <a:off x="609600" y="2825750"/>
-            <a:ext cx="4826000" cy="1016000"/>
+            <a:off x="609600" y="2851150"/>
+            <a:ext cx="10972800" cy="3448050"/>
           </a:xfrm>
           <a:prstGeom prst="rect">
             <a:avLst/>
@@ -8126,15 +8169,342 @@
           </a:bodyPr>
           <a:lstStyle/>
           <a:p>
-            <a:pPr algn="l"/>
-            <a:r>
-              <a:rPr sz="1400" b="0" i="0">
-                <a:solidFill>
-                  <a:srgbClr val="4D5270"/>
+            <a:pPr>
+              <a:spcBef>
+                <a:spcPts val="600"/>
+              </a:spcBef>
+              <a:spcAft>
+                <a:spcPts val="600"/>
+              </a:spcAft>
+            </a:pPr>
+            <a:r>
+              <a:rPr sz="1400">
+                <a:solidFill>
+                  <a:srgbClr val="191D2E"/>
                 </a:solidFill>
                 <a:latin typeface="Georgia"/>
               </a:rPr>
-              <a:t>Was ist ein Jahresabschluss?</a:t>
+              <a:t>–  Der Jahresabschluss ist die jährliche Zusammenfassung der wirtschaftlichen Lage eines Unternehmens. Für Kapitalgesellschaften (GmbH, AG) schreibt das HGB in §§ 264 ff. folgende Bestandteile vor:</a:t>
+            </a:r>
+          </a:p>
+          <a:p>
+            <a:pPr>
+              <a:spcBef>
+                <a:spcPts val="600"/>
+              </a:spcBef>
+              <a:spcAft>
+                <a:spcPts val="600"/>
+              </a:spcAft>
+            </a:pPr>
+            <a:r>
+              <a:rPr sz="1400">
+                <a:solidFill>
+                  <a:srgbClr val="191D2E"/>
+                </a:solidFill>
+                <a:latin typeface="Georgia"/>
+              </a:rPr>
+              <a:t>–  Bilanz (§ 266 HGB): Stichtagsbezogene Gegenüberstellung von Vermögen (Aktiva) und Kapital (Passiva). Die Bilanz zeigt, was ein Unternehmen besitzt und wie es finanziert ist.</a:t>
+            </a:r>
+          </a:p>
+          <a:p>
+            <a:pPr>
+              <a:spcBef>
+                <a:spcPts val="600"/>
+              </a:spcBef>
+              <a:spcAft>
+                <a:spcPts val="600"/>
+              </a:spcAft>
+            </a:pPr>
+            <a:r>
+              <a:rPr sz="1400">
+                <a:solidFill>
+                  <a:srgbClr val="191D2E"/>
+                </a:solidFill>
+                <a:latin typeface="Georgia"/>
+              </a:rPr>
+              <a:t>–  Gewinn- und Verlustrechnung (§ 275 HGB): Zeitraumbezogene Darstellung von Erträgen und Aufwendungen eines Geschäftsjahres. Sie zeigt, wie ein Unternehmen Geld verdient (oder verliert).</a:t>
+            </a:r>
+          </a:p>
+          <a:p>
+            <a:pPr>
+              <a:spcBef>
+                <a:spcPts val="600"/>
+              </a:spcBef>
+              <a:spcAft>
+                <a:spcPts val="600"/>
+              </a:spcAft>
+            </a:pPr>
+            <a:r>
+              <a:rPr sz="1400">
+                <a:solidFill>
+                  <a:srgbClr val="191D2E"/>
+                </a:solidFill>
+                <a:latin typeface="Georgia"/>
+              </a:rPr>
+              <a:t>–  Anhang (§ 284 HGB): Erläuterungen und Ergänzungen zu Bilanz und GuV (z.B. Bilanzierungsmethoden, Haftungsverhältnisse). Für den Kreditgeber oft wertvoller als die nackten Zahlen.</a:t>
+            </a:r>
+          </a:p>
+          <a:p>
+            <a:pPr>
+              <a:spcBef>
+                <a:spcPts val="600"/>
+              </a:spcBef>
+              <a:spcAft>
+                <a:spcPts val="600"/>
+              </a:spcAft>
+            </a:pPr>
+            <a:r>
+              <a:rPr sz="1400">
+                <a:solidFill>
+                  <a:srgbClr val="191D2E"/>
+                </a:solidFill>
+                <a:latin typeface="Georgia"/>
+              </a:rPr>
+              <a:t>–  Lagebericht (§ 289 HGB): Lageeinschätzung des Managements, Risikobericht, Ausblick. Nur für mittelgroße und große Unternehmen verpflichtend.</a:t>
+            </a:r>
+          </a:p>
+        </p:txBody>
+      </p:sp>
+    </p:spTree>
+  </p:cSld>
+  <p:clrMapOvr>
+    <a:masterClrMapping/>
+  </p:clrMapOvr>
+</p:sld>
+</file>
+
+<file path=ppt/slides/slide5.xml><?xml version="1.0" encoding="utf-8"?>
+<p:sld xmlns:a="http://schemas.openxmlformats.org/drawingml/2006/main" xmlns:p="http://schemas.openxmlformats.org/presentationml/2006/main" xmlns:r="http://schemas.openxmlformats.org/officeDocument/2006/relationships">
+  <p:cSld>
+    <p:bg>
+      <p:bgPr>
+        <a:solidFill>
+          <a:srgbClr val="F8F8FA"/>
+        </a:solidFill>
+        <a:effectLst/>
+      </p:bgPr>
+    </p:bg>
+    <p:spTree>
+      <p:nvGrpSpPr>
+        <p:cNvPr id="1" name=""/>
+        <p:cNvGrpSpPr/>
+        <p:nvPr/>
+      </p:nvGrpSpPr>
+      <p:grpSpPr/>
+      <p:sp>
+        <p:nvSpPr>
+          <p:cNvPr id="2" name="TextBox 1"/>
+          <p:cNvSpPr txBox="1"/>
+          <p:nvPr/>
+        </p:nvSpPr>
+        <p:spPr>
+          <a:xfrm>
+            <a:off x="609600" y="279400"/>
+            <a:ext cx="2540000" cy="279400"/>
+          </a:xfrm>
+          <a:prstGeom prst="rect">
+            <a:avLst/>
+          </a:prstGeom>
+          <a:noFill/>
+        </p:spPr>
+        <p:txBody>
+          <a:bodyPr wrap="square">
+            <a:normAutofit/>
+          </a:bodyPr>
+          <a:lstStyle/>
+          <a:p>
+            <a:pPr algn="l"/>
+            <a:r>
+              <a:rPr sz="1000" b="1" i="0">
+                <a:solidFill>
+                  <a:srgbClr val="191D2E"/>
+                </a:solidFill>
+                <a:latin typeface="Arial"/>
+              </a:rPr>
+              <a:t>FKB  Campus</a:t>
+            </a:r>
+          </a:p>
+        </p:txBody>
+      </p:sp>
+      <p:sp>
+        <p:nvSpPr>
+          <p:cNvPr id="3" name="TextBox 2"/>
+          <p:cNvSpPr txBox="1"/>
+          <p:nvPr/>
+        </p:nvSpPr>
+        <p:spPr>
+          <a:xfrm>
+            <a:off x="609600" y="279400"/>
+            <a:ext cx="10972800" cy="279400"/>
+          </a:xfrm>
+          <a:prstGeom prst="rect">
+            <a:avLst/>
+          </a:prstGeom>
+          <a:noFill/>
+        </p:spPr>
+        <p:txBody>
+          <a:bodyPr wrap="square">
+            <a:normAutofit/>
+          </a:bodyPr>
+          <a:lstStyle/>
+          <a:p>
+            <a:pPr algn="r"/>
+            <a:r>
+              <a:rPr sz="900" b="0" i="0">
+                <a:solidFill>
+                  <a:srgbClr val="7B7FA0"/>
+                </a:solidFill>
+                <a:latin typeface="Courier New"/>
+              </a:rPr>
+              <a:t>I · MODULINHALTE</a:t>
+            </a:r>
+          </a:p>
+        </p:txBody>
+      </p:sp>
+      <p:sp>
+        <p:nvSpPr>
+          <p:cNvPr id="4" name="TextBox 3"/>
+          <p:cNvSpPr txBox="1"/>
+          <p:nvPr/>
+        </p:nvSpPr>
+        <p:spPr>
+          <a:xfrm>
+            <a:off x="609600" y="6426200"/>
+            <a:ext cx="10972800" cy="228600"/>
+          </a:xfrm>
+          <a:prstGeom prst="rect">
+            <a:avLst/>
+          </a:prstGeom>
+          <a:noFill/>
+        </p:spPr>
+        <p:txBody>
+          <a:bodyPr wrap="square">
+            <a:normAutofit/>
+          </a:bodyPr>
+          <a:lstStyle/>
+          <a:p>
+            <a:pPr algn="r"/>
+            <a:r>
+              <a:rPr sz="900" b="0" i="0">
+                <a:solidFill>
+                  <a:srgbClr val="7B7FA0"/>
+                </a:solidFill>
+                <a:latin typeface="Courier New"/>
+              </a:rPr>
+              <a:t>05</a:t>
+            </a:r>
+          </a:p>
+        </p:txBody>
+      </p:sp>
+      <p:sp>
+        <p:nvSpPr>
+          <p:cNvPr id="5" name="Rectangle 4"/>
+          <p:cNvSpPr/>
+          <p:nvPr/>
+        </p:nvSpPr>
+        <p:spPr>
+          <a:xfrm>
+            <a:off x="609600" y="825500"/>
+            <a:ext cx="10972800" cy="6350"/>
+          </a:xfrm>
+          <a:prstGeom prst="rect">
+            <a:avLst/>
+          </a:prstGeom>
+          <a:solidFill>
+            <a:srgbClr val="191D2E"/>
+          </a:solidFill>
+          <a:ln>
+            <a:noFill/>
+          </a:ln>
+        </p:spPr>
+        <p:style>
+          <a:lnRef idx="1">
+            <a:schemeClr val="accent1"/>
+          </a:lnRef>
+          <a:fillRef idx="3">
+            <a:schemeClr val="accent1"/>
+          </a:fillRef>
+          <a:effectRef idx="2">
+            <a:schemeClr val="accent1"/>
+          </a:effectRef>
+          <a:fontRef idx="minor">
+            <a:schemeClr val="lt1"/>
+          </a:fontRef>
+        </p:style>
+        <p:txBody>
+          <a:bodyPr rtlCol="0" anchor="ctr"/>
+          <a:lstStyle/>
+          <a:p>
+            <a:pPr algn="ctr"/>
+          </a:p>
+        </p:txBody>
+      </p:sp>
+      <p:sp>
+        <p:nvSpPr>
+          <p:cNvPr id="6" name="TextBox 5"/>
+          <p:cNvSpPr txBox="1"/>
+          <p:nvPr/>
+        </p:nvSpPr>
+        <p:spPr>
+          <a:xfrm>
+            <a:off x="609600" y="920750"/>
+            <a:ext cx="4826000" cy="1778000"/>
+          </a:xfrm>
+          <a:prstGeom prst="rect">
+            <a:avLst/>
+          </a:prstGeom>
+          <a:noFill/>
+        </p:spPr>
+        <p:txBody>
+          <a:bodyPr wrap="square">
+            <a:normAutofit/>
+          </a:bodyPr>
+          <a:lstStyle/>
+          <a:p>
+            <a:pPr algn="l"/>
+            <a:r>
+              <a:rPr sz="3800" b="0" i="0">
+                <a:solidFill>
+                  <a:srgbClr val="191D2E"/>
+                </a:solidFill>
+                <a:latin typeface="Georgia"/>
+              </a:rPr>
+              <a:t>Offenlegungspflichten und Größenklassen (§ 267 HGB)</a:t>
+            </a:r>
+          </a:p>
+        </p:txBody>
+      </p:sp>
+      <p:sp>
+        <p:nvSpPr>
+          <p:cNvPr id="7" name="TextBox 6"/>
+          <p:cNvSpPr txBox="1"/>
+          <p:nvPr/>
+        </p:nvSpPr>
+        <p:spPr>
+          <a:xfrm>
+            <a:off x="609600" y="2825750"/>
+            <a:ext cx="4826000" cy="1016000"/>
+          </a:xfrm>
+          <a:prstGeom prst="rect">
+            <a:avLst/>
+          </a:prstGeom>
+          <a:noFill/>
+        </p:spPr>
+        <p:txBody>
+          <a:bodyPr wrap="square">
+            <a:normAutofit/>
+          </a:bodyPr>
+          <a:lstStyle/>
+          <a:p>
+            <a:pPr algn="l"/>
+            <a:r>
+              <a:rPr sz="1400" b="0" i="0">
+                <a:solidFill>
+                  <a:srgbClr val="4D5270"/>
+                </a:solidFill>
+                <a:latin typeface="Georgia"/>
+              </a:rPr>
+              <a:t>Praxishinweis: Viele Ihrer KMU-Kunden sind „kleine" GmbHs – sie legen keine GuV offen. In diesen Fällen müssen Sie die GuV-Daten im Rahmen der Kreditwürdigkeitsprüfung nach § 18 KW</a:t>
             </a:r>
           </a:p>
         </p:txBody>
@@ -8149,7 +8519,7 @@
         </p:nvGraphicFramePr>
         <p:xfrm>
           <a:off x="5715000" y="920750"/>
-          <a:ext cx="5867400" cy="3429000"/>
+          <a:ext cx="5867400" cy="1524000"/>
         </p:xfrm>
         <a:graphic>
           <a:graphicData uri="http://schemas.openxmlformats.org/drawingml/2006/table">
@@ -8612,6 +8982,536 @@
                   </a:tcPr>
                 </a:tc>
               </a:tr>
+            </a:tbl>
+          </a:graphicData>
+        </a:graphic>
+      </p:graphicFrame>
+    </p:spTree>
+  </p:cSld>
+  <p:clrMapOvr>
+    <a:masterClrMapping/>
+  </p:clrMapOvr>
+</p:sld>
+</file>
+
+<file path=ppt/slides/slide6.xml><?xml version="1.0" encoding="utf-8"?>
+<p:sld xmlns:a="http://schemas.openxmlformats.org/drawingml/2006/main" xmlns:p="http://schemas.openxmlformats.org/presentationml/2006/main" xmlns:r="http://schemas.openxmlformats.org/officeDocument/2006/relationships">
+  <p:cSld>
+    <p:bg>
+      <p:bgPr>
+        <a:solidFill>
+          <a:srgbClr val="F8F8FA"/>
+        </a:solidFill>
+        <a:effectLst/>
+      </p:bgPr>
+    </p:bg>
+    <p:spTree>
+      <p:nvGrpSpPr>
+        <p:cNvPr id="1" name=""/>
+        <p:cNvGrpSpPr/>
+        <p:nvPr/>
+      </p:nvGrpSpPr>
+      <p:grpSpPr/>
+      <p:sp>
+        <p:nvSpPr>
+          <p:cNvPr id="2" name="TextBox 1"/>
+          <p:cNvSpPr txBox="1"/>
+          <p:nvPr/>
+        </p:nvSpPr>
+        <p:spPr>
+          <a:xfrm>
+            <a:off x="609600" y="279400"/>
+            <a:ext cx="2540000" cy="279400"/>
+          </a:xfrm>
+          <a:prstGeom prst="rect">
+            <a:avLst/>
+          </a:prstGeom>
+          <a:noFill/>
+        </p:spPr>
+        <p:txBody>
+          <a:bodyPr wrap="square">
+            <a:normAutofit/>
+          </a:bodyPr>
+          <a:lstStyle/>
+          <a:p>
+            <a:pPr algn="l"/>
+            <a:r>
+              <a:rPr sz="1000" b="1" i="0">
+                <a:solidFill>
+                  <a:srgbClr val="191D2E"/>
+                </a:solidFill>
+                <a:latin typeface="Arial"/>
+              </a:rPr>
+              <a:t>FKB  Campus</a:t>
+            </a:r>
+          </a:p>
+        </p:txBody>
+      </p:sp>
+      <p:sp>
+        <p:nvSpPr>
+          <p:cNvPr id="3" name="TextBox 2"/>
+          <p:cNvSpPr txBox="1"/>
+          <p:nvPr/>
+        </p:nvSpPr>
+        <p:spPr>
+          <a:xfrm>
+            <a:off x="609600" y="279400"/>
+            <a:ext cx="10972800" cy="279400"/>
+          </a:xfrm>
+          <a:prstGeom prst="rect">
+            <a:avLst/>
+          </a:prstGeom>
+          <a:noFill/>
+        </p:spPr>
+        <p:txBody>
+          <a:bodyPr wrap="square">
+            <a:normAutofit/>
+          </a:bodyPr>
+          <a:lstStyle/>
+          <a:p>
+            <a:pPr algn="r"/>
+            <a:r>
+              <a:rPr sz="900" b="0" i="0">
+                <a:solidFill>
+                  <a:srgbClr val="7B7FA0"/>
+                </a:solidFill>
+                <a:latin typeface="Courier New"/>
+              </a:rPr>
+              <a:t>I · MODULINHALTE</a:t>
+            </a:r>
+          </a:p>
+        </p:txBody>
+      </p:sp>
+      <p:sp>
+        <p:nvSpPr>
+          <p:cNvPr id="4" name="TextBox 3"/>
+          <p:cNvSpPr txBox="1"/>
+          <p:nvPr/>
+        </p:nvSpPr>
+        <p:spPr>
+          <a:xfrm>
+            <a:off x="609600" y="6426200"/>
+            <a:ext cx="10972800" cy="228600"/>
+          </a:xfrm>
+          <a:prstGeom prst="rect">
+            <a:avLst/>
+          </a:prstGeom>
+          <a:noFill/>
+        </p:spPr>
+        <p:txBody>
+          <a:bodyPr wrap="square">
+            <a:normAutofit/>
+          </a:bodyPr>
+          <a:lstStyle/>
+          <a:p>
+            <a:pPr algn="r"/>
+            <a:r>
+              <a:rPr sz="900" b="0" i="0">
+                <a:solidFill>
+                  <a:srgbClr val="7B7FA0"/>
+                </a:solidFill>
+                <a:latin typeface="Courier New"/>
+              </a:rPr>
+              <a:t>06</a:t>
+            </a:r>
+          </a:p>
+        </p:txBody>
+      </p:sp>
+      <p:sp>
+        <p:nvSpPr>
+          <p:cNvPr id="5" name="Rectangle 4"/>
+          <p:cNvSpPr/>
+          <p:nvPr/>
+        </p:nvSpPr>
+        <p:spPr>
+          <a:xfrm>
+            <a:off x="609600" y="825500"/>
+            <a:ext cx="10972800" cy="6350"/>
+          </a:xfrm>
+          <a:prstGeom prst="rect">
+            <a:avLst/>
+          </a:prstGeom>
+          <a:solidFill>
+            <a:srgbClr val="191D2E"/>
+          </a:solidFill>
+          <a:ln>
+            <a:noFill/>
+          </a:ln>
+        </p:spPr>
+        <p:style>
+          <a:lnRef idx="1">
+            <a:schemeClr val="accent1"/>
+          </a:lnRef>
+          <a:fillRef idx="3">
+            <a:schemeClr val="accent1"/>
+          </a:fillRef>
+          <a:effectRef idx="2">
+            <a:schemeClr val="accent1"/>
+          </a:effectRef>
+          <a:fontRef idx="minor">
+            <a:schemeClr val="lt1"/>
+          </a:fontRef>
+        </p:style>
+        <p:txBody>
+          <a:bodyPr rtlCol="0" anchor="ctr"/>
+          <a:lstStyle/>
+          <a:p>
+            <a:pPr algn="ctr"/>
+          </a:p>
+        </p:txBody>
+      </p:sp>
+      <p:sp>
+        <p:nvSpPr>
+          <p:cNvPr id="6" name="TextBox 5"/>
+          <p:cNvSpPr txBox="1"/>
+          <p:nvPr/>
+        </p:nvSpPr>
+        <p:spPr>
+          <a:xfrm>
+            <a:off x="609600" y="920750"/>
+            <a:ext cx="10972800" cy="1778000"/>
+          </a:xfrm>
+          <a:prstGeom prst="rect">
+            <a:avLst/>
+          </a:prstGeom>
+          <a:noFill/>
+        </p:spPr>
+        <p:txBody>
+          <a:bodyPr wrap="square">
+            <a:normAutofit/>
+          </a:bodyPr>
+          <a:lstStyle/>
+          <a:p>
+            <a:pPr algn="l"/>
+            <a:r>
+              <a:rPr sz="3800" b="0" i="0">
+                <a:solidFill>
+                  <a:srgbClr val="191D2E"/>
+                </a:solidFill>
+                <a:latin typeface="Georgia"/>
+              </a:rPr>
+              <a:t>Bilanzstruktur: Mittelherkunft und -verwendung</a:t>
+            </a:r>
+          </a:p>
+        </p:txBody>
+      </p:sp>
+      <p:sp>
+        <p:nvSpPr>
+          <p:cNvPr id="7" name="Rectangle 6"/>
+          <p:cNvSpPr/>
+          <p:nvPr/>
+        </p:nvSpPr>
+        <p:spPr>
+          <a:xfrm>
+            <a:off x="609600" y="2762250"/>
+            <a:ext cx="10972800" cy="6350"/>
+          </a:xfrm>
+          <a:prstGeom prst="rect">
+            <a:avLst/>
+          </a:prstGeom>
+          <a:solidFill>
+            <a:srgbClr val="E0E0E8"/>
+          </a:solidFill>
+          <a:ln>
+            <a:noFill/>
+          </a:ln>
+        </p:spPr>
+        <p:style>
+          <a:lnRef idx="1">
+            <a:schemeClr val="accent1"/>
+          </a:lnRef>
+          <a:fillRef idx="3">
+            <a:schemeClr val="accent1"/>
+          </a:fillRef>
+          <a:effectRef idx="2">
+            <a:schemeClr val="accent1"/>
+          </a:effectRef>
+          <a:fontRef idx="minor">
+            <a:schemeClr val="lt1"/>
+          </a:fontRef>
+        </p:style>
+        <p:txBody>
+          <a:bodyPr rtlCol="0" anchor="ctr"/>
+          <a:lstStyle/>
+          <a:p>
+            <a:pPr algn="ctr"/>
+          </a:p>
+        </p:txBody>
+      </p:sp>
+      <p:sp>
+        <p:nvSpPr>
+          <p:cNvPr id="8" name="TextBox 7"/>
+          <p:cNvSpPr txBox="1"/>
+          <p:nvPr/>
+        </p:nvSpPr>
+        <p:spPr>
+          <a:xfrm>
+            <a:off x="609600" y="2851150"/>
+            <a:ext cx="10972800" cy="3448050"/>
+          </a:xfrm>
+          <a:prstGeom prst="rect">
+            <a:avLst/>
+          </a:prstGeom>
+          <a:noFill/>
+        </p:spPr>
+        <p:txBody>
+          <a:bodyPr wrap="square">
+            <a:normAutofit/>
+          </a:bodyPr>
+          <a:lstStyle/>
+          <a:p>
+            <a:pPr>
+              <a:spcBef>
+                <a:spcPts val="600"/>
+              </a:spcBef>
+              <a:spcAft>
+                <a:spcPts val="600"/>
+              </a:spcAft>
+            </a:pPr>
+            <a:r>
+              <a:rPr sz="1400">
+                <a:solidFill>
+                  <a:srgbClr val="191D2E"/>
+                </a:solidFill>
+                <a:latin typeface="Georgia"/>
+              </a:rPr>
+              <a:t>–  Die Goldene Bilanzregel lautet: Langfristig gebundenes Vermögen sollte durch langfristiges Kapital finanziert sein (Fristenkongruenz). Eine Verletzung – z.B. kurzfristige Bankdarlehen zur Finanzierung von Maschinen –…</a:t>
+            </a:r>
+          </a:p>
+        </p:txBody>
+      </p:sp>
+    </p:spTree>
+  </p:cSld>
+  <p:clrMapOvr>
+    <a:masterClrMapping/>
+  </p:clrMapOvr>
+</p:sld>
+</file>
+
+<file path=ppt/slides/slide7.xml><?xml version="1.0" encoding="utf-8"?>
+<p:sld xmlns:a="http://schemas.openxmlformats.org/drawingml/2006/main" xmlns:p="http://schemas.openxmlformats.org/presentationml/2006/main" xmlns:r="http://schemas.openxmlformats.org/officeDocument/2006/relationships">
+  <p:cSld>
+    <p:bg>
+      <p:bgPr>
+        <a:solidFill>
+          <a:srgbClr val="F8F8FA"/>
+        </a:solidFill>
+        <a:effectLst/>
+      </p:bgPr>
+    </p:bg>
+    <p:spTree>
+      <p:nvGrpSpPr>
+        <p:cNvPr id="1" name=""/>
+        <p:cNvGrpSpPr/>
+        <p:nvPr/>
+      </p:nvGrpSpPr>
+      <p:grpSpPr/>
+      <p:sp>
+        <p:nvSpPr>
+          <p:cNvPr id="2" name="TextBox 1"/>
+          <p:cNvSpPr txBox="1"/>
+          <p:nvPr/>
+        </p:nvSpPr>
+        <p:spPr>
+          <a:xfrm>
+            <a:off x="609600" y="279400"/>
+            <a:ext cx="2540000" cy="279400"/>
+          </a:xfrm>
+          <a:prstGeom prst="rect">
+            <a:avLst/>
+          </a:prstGeom>
+          <a:noFill/>
+        </p:spPr>
+        <p:txBody>
+          <a:bodyPr wrap="square">
+            <a:normAutofit/>
+          </a:bodyPr>
+          <a:lstStyle/>
+          <a:p>
+            <a:pPr algn="l"/>
+            <a:r>
+              <a:rPr sz="1000" b="1" i="0">
+                <a:solidFill>
+                  <a:srgbClr val="191D2E"/>
+                </a:solidFill>
+                <a:latin typeface="Arial"/>
+              </a:rPr>
+              <a:t>FKB  Campus</a:t>
+            </a:r>
+          </a:p>
+        </p:txBody>
+      </p:sp>
+      <p:sp>
+        <p:nvSpPr>
+          <p:cNvPr id="3" name="TextBox 2"/>
+          <p:cNvSpPr txBox="1"/>
+          <p:nvPr/>
+        </p:nvSpPr>
+        <p:spPr>
+          <a:xfrm>
+            <a:off x="609600" y="279400"/>
+            <a:ext cx="10972800" cy="279400"/>
+          </a:xfrm>
+          <a:prstGeom prst="rect">
+            <a:avLst/>
+          </a:prstGeom>
+          <a:noFill/>
+        </p:spPr>
+        <p:txBody>
+          <a:bodyPr wrap="square">
+            <a:normAutofit/>
+          </a:bodyPr>
+          <a:lstStyle/>
+          <a:p>
+            <a:pPr algn="r"/>
+            <a:r>
+              <a:rPr sz="900" b="0" i="0">
+                <a:solidFill>
+                  <a:srgbClr val="7B7FA0"/>
+                </a:solidFill>
+                <a:latin typeface="Courier New"/>
+              </a:rPr>
+              <a:t>I · MODULINHALTE</a:t>
+            </a:r>
+          </a:p>
+        </p:txBody>
+      </p:sp>
+      <p:sp>
+        <p:nvSpPr>
+          <p:cNvPr id="4" name="TextBox 3"/>
+          <p:cNvSpPr txBox="1"/>
+          <p:nvPr/>
+        </p:nvSpPr>
+        <p:spPr>
+          <a:xfrm>
+            <a:off x="609600" y="6426200"/>
+            <a:ext cx="10972800" cy="228600"/>
+          </a:xfrm>
+          <a:prstGeom prst="rect">
+            <a:avLst/>
+          </a:prstGeom>
+          <a:noFill/>
+        </p:spPr>
+        <p:txBody>
+          <a:bodyPr wrap="square">
+            <a:normAutofit/>
+          </a:bodyPr>
+          <a:lstStyle/>
+          <a:p>
+            <a:pPr algn="r"/>
+            <a:r>
+              <a:rPr sz="900" b="0" i="0">
+                <a:solidFill>
+                  <a:srgbClr val="7B7FA0"/>
+                </a:solidFill>
+                <a:latin typeface="Courier New"/>
+              </a:rPr>
+              <a:t>07</a:t>
+            </a:r>
+          </a:p>
+        </p:txBody>
+      </p:sp>
+      <p:sp>
+        <p:nvSpPr>
+          <p:cNvPr id="5" name="Rectangle 4"/>
+          <p:cNvSpPr/>
+          <p:nvPr/>
+        </p:nvSpPr>
+        <p:spPr>
+          <a:xfrm>
+            <a:off x="609600" y="825500"/>
+            <a:ext cx="10972800" cy="6350"/>
+          </a:xfrm>
+          <a:prstGeom prst="rect">
+            <a:avLst/>
+          </a:prstGeom>
+          <a:solidFill>
+            <a:srgbClr val="191D2E"/>
+          </a:solidFill>
+          <a:ln>
+            <a:noFill/>
+          </a:ln>
+        </p:spPr>
+        <p:style>
+          <a:lnRef idx="1">
+            <a:schemeClr val="accent1"/>
+          </a:lnRef>
+          <a:fillRef idx="3">
+            <a:schemeClr val="accent1"/>
+          </a:fillRef>
+          <a:effectRef idx="2">
+            <a:schemeClr val="accent1"/>
+          </a:effectRef>
+          <a:fontRef idx="minor">
+            <a:schemeClr val="lt1"/>
+          </a:fontRef>
+        </p:style>
+        <p:txBody>
+          <a:bodyPr rtlCol="0" anchor="ctr"/>
+          <a:lstStyle/>
+          <a:p>
+            <a:pPr algn="ctr"/>
+          </a:p>
+        </p:txBody>
+      </p:sp>
+      <p:sp>
+        <p:nvSpPr>
+          <p:cNvPr id="6" name="TextBox 5"/>
+          <p:cNvSpPr txBox="1"/>
+          <p:nvPr/>
+        </p:nvSpPr>
+        <p:spPr>
+          <a:xfrm>
+            <a:off x="609600" y="920750"/>
+            <a:ext cx="4826000" cy="1778000"/>
+          </a:xfrm>
+          <a:prstGeom prst="rect">
+            <a:avLst/>
+          </a:prstGeom>
+          <a:noFill/>
+        </p:spPr>
+        <p:txBody>
+          <a:bodyPr wrap="square">
+            <a:normAutofit/>
+          </a:bodyPr>
+          <a:lstStyle/>
+          <a:p>
+            <a:pPr algn="l"/>
+            <a:r>
+              <a:rPr sz="3800" b="0" i="0">
+                <a:solidFill>
+                  <a:srgbClr val="191D2E"/>
+                </a:solidFill>
+                <a:latin typeface="Georgia"/>
+              </a:rPr>
+              <a:t>Bilanzierungswahlrechte und ihre Wirkung</a:t>
+            </a:r>
+          </a:p>
+        </p:txBody>
+      </p:sp>
+      <p:graphicFrame>
+        <p:nvGraphicFramePr>
+          <p:cNvPr id="7" name="Table 6"/>
+          <p:cNvGraphicFramePr>
+            <a:graphicFrameLocks noGrp="1"/>
+          </p:cNvGraphicFramePr>
+          <p:nvPr/>
+        </p:nvGraphicFramePr>
+        <p:xfrm>
+          <a:off x="5715000" y="920750"/>
+          <a:ext cx="5867400" cy="1905000"/>
+        </p:xfrm>
+        <a:graphic>
+          <a:graphicData uri="http://schemas.openxmlformats.org/drawingml/2006/table">
+            <a:tbl>
+              <a:tblPr firstRow="1" bandRow="1">
+                <a:tableStyleId>{5C22544A-7EE6-4342-B048-85BDC9FD1C3A}</a:tableStyleId>
+              </a:tblPr>
+              <a:tblGrid>
+                <a:gridCol w="1955800"/>
+                <a:gridCol w="1955800"/>
+                <a:gridCol w="1955800"/>
+              </a:tblGrid>
               <a:tr h="381000">
                 <a:tc>
                   <a:txBody>
@@ -8619,9 +9519,9 @@
                     <a:lstStyle/>
                     <a:p>
                       <a:r>
-                        <a:rPr sz="1000" b="0">
+                        <a:rPr sz="1000" b="1">
                           <a:solidFill>
-                            <a:srgbClr val="191D2E"/>
+                            <a:srgbClr val="F8F8FA"/>
                           </a:solidFill>
                           <a:latin typeface="Courier New"/>
                         </a:rPr>
@@ -8631,7 +9531,7 @@
                   </a:txBody>
                   <a:tcPr>
                     <a:solidFill>
-                      <a:srgbClr val="F0F0F5"/>
+                      <a:srgbClr val="1F2B56"/>
                     </a:solidFill>
                   </a:tcPr>
                 </a:tc>
@@ -8641,9 +9541,9 @@
                     <a:lstStyle/>
                     <a:p>
                       <a:r>
-                        <a:rPr sz="1000" b="0">
+                        <a:rPr sz="1000" b="1">
                           <a:solidFill>
-                            <a:srgbClr val="191D2E"/>
+                            <a:srgbClr val="F8F8FA"/>
                           </a:solidFill>
                           <a:latin typeface="Courier New"/>
                         </a:rPr>
@@ -8653,7 +9553,7 @@
                   </a:txBody>
                   <a:tcPr>
                     <a:solidFill>
-                      <a:srgbClr val="F0F0F5"/>
+                      <a:srgbClr val="1F2B56"/>
                     </a:solidFill>
                   </a:tcPr>
                 </a:tc>
@@ -8663,9 +9563,9 @@
                     <a:lstStyle/>
                     <a:p>
                       <a:r>
-                        <a:rPr sz="1000" b="0">
+                        <a:rPr sz="1000" b="1">
                           <a:solidFill>
-                            <a:srgbClr val="191D2E"/>
+                            <a:srgbClr val="F8F8FA"/>
                           </a:solidFill>
                           <a:latin typeface="Courier New"/>
                         </a:rPr>
@@ -8675,51 +9575,7 @@
                   </a:txBody>
                   <a:tcPr>
                     <a:solidFill>
-                      <a:srgbClr val="F0F0F5"/>
-                    </a:solidFill>
-                  </a:tcPr>
-                </a:tc>
-                <a:tc>
-                  <a:txBody>
-                    <a:bodyPr wrap="square"/>
-                    <a:lstStyle/>
-                    <a:p>
-                      <a:r>
-                        <a:rPr sz="1000" b="0">
-                          <a:solidFill>
-                            <a:srgbClr val="191D2E"/>
-                          </a:solidFill>
-                          <a:latin typeface="Courier New"/>
-                        </a:rPr>
-                        <a:t/>
-                      </a:r>
-                    </a:p>
-                  </a:txBody>
-                  <a:tcPr>
-                    <a:solidFill>
-                      <a:srgbClr val="F0F0F5"/>
-                    </a:solidFill>
-                  </a:tcPr>
-                </a:tc>
-                <a:tc>
-                  <a:txBody>
-                    <a:bodyPr wrap="square"/>
-                    <a:lstStyle/>
-                    <a:p>
-                      <a:r>
-                        <a:rPr sz="1000" b="0">
-                          <a:solidFill>
-                            <a:srgbClr val="191D2E"/>
-                          </a:solidFill>
-                          <a:latin typeface="Courier New"/>
-                        </a:rPr>
-                        <a:t/>
-                      </a:r>
-                    </a:p>
-                  </a:txBody>
-                  <a:tcPr>
-                    <a:solidFill>
-                      <a:srgbClr val="F0F0F5"/>
+                      <a:srgbClr val="1F2B56"/>
                     </a:solidFill>
                   </a:tcPr>
                 </a:tc>
@@ -8782,50 +9638,6 @@
                           <a:latin typeface="Courier New"/>
                         </a:rPr>
                         <a:t>Hohe Vorräte, hohe Gewinne</a:t>
-                      </a:r>
-                    </a:p>
-                  </a:txBody>
-                  <a:tcPr>
-                    <a:solidFill>
-                      <a:srgbClr val="F8F8FA"/>
-                    </a:solidFill>
-                  </a:tcPr>
-                </a:tc>
-                <a:tc>
-                  <a:txBody>
-                    <a:bodyPr wrap="square"/>
-                    <a:lstStyle/>
-                    <a:p>
-                      <a:r>
-                        <a:rPr sz="1000" b="0">
-                          <a:solidFill>
-                            <a:srgbClr val="191D2E"/>
-                          </a:solidFill>
-                          <a:latin typeface="Courier New"/>
-                        </a:rPr>
-                        <a:t/>
-                      </a:r>
-                    </a:p>
-                  </a:txBody>
-                  <a:tcPr>
-                    <a:solidFill>
-                      <a:srgbClr val="F8F8FA"/>
-                    </a:solidFill>
-                  </a:tcPr>
-                </a:tc>
-                <a:tc>
-                  <a:txBody>
-                    <a:bodyPr wrap="square"/>
-                    <a:lstStyle/>
-                    <a:p>
-                      <a:r>
-                        <a:rPr sz="1000" b="0">
-                          <a:solidFill>
-                            <a:srgbClr val="191D2E"/>
-                          </a:solidFill>
-                          <a:latin typeface="Courier New"/>
-                        </a:rPr>
-                        <a:t/>
                       </a:r>
                     </a:p>
                   </a:txBody>
@@ -8903,50 +9715,6 @@
                     </a:solidFill>
                   </a:tcPr>
                 </a:tc>
-                <a:tc>
-                  <a:txBody>
-                    <a:bodyPr wrap="square"/>
-                    <a:lstStyle/>
-                    <a:p>
-                      <a:r>
-                        <a:rPr sz="1000" b="0">
-                          <a:solidFill>
-                            <a:srgbClr val="191D2E"/>
-                          </a:solidFill>
-                          <a:latin typeface="Courier New"/>
-                        </a:rPr>
-                        <a:t/>
-                      </a:r>
-                    </a:p>
-                  </a:txBody>
-                  <a:tcPr>
-                    <a:solidFill>
-                      <a:srgbClr val="F0F0F5"/>
-                    </a:solidFill>
-                  </a:tcPr>
-                </a:tc>
-                <a:tc>
-                  <a:txBody>
-                    <a:bodyPr wrap="square"/>
-                    <a:lstStyle/>
-                    <a:p>
-                      <a:r>
-                        <a:rPr sz="1000" b="0">
-                          <a:solidFill>
-                            <a:srgbClr val="191D2E"/>
-                          </a:solidFill>
-                          <a:latin typeface="Courier New"/>
-                        </a:rPr>
-                        <a:t/>
-                      </a:r>
-                    </a:p>
-                  </a:txBody>
-                  <a:tcPr>
-                    <a:solidFill>
-                      <a:srgbClr val="F0F0F5"/>
-                    </a:solidFill>
-                  </a:tcPr>
-                </a:tc>
               </a:tr>
               <a:tr h="381000">
                 <a:tc>
@@ -9006,50 +9774,6 @@
                           <a:latin typeface="Courier New"/>
                         </a:rPr>
                         <a:t>Niedrigere Rückstellungen, höherer Gewinn</a:t>
-                      </a:r>
-                    </a:p>
-                  </a:txBody>
-                  <a:tcPr>
-                    <a:solidFill>
-                      <a:srgbClr val="F8F8FA"/>
-                    </a:solidFill>
-                  </a:tcPr>
-                </a:tc>
-                <a:tc>
-                  <a:txBody>
-                    <a:bodyPr wrap="square"/>
-                    <a:lstStyle/>
-                    <a:p>
-                      <a:r>
-                        <a:rPr sz="1000" b="0">
-                          <a:solidFill>
-                            <a:srgbClr val="191D2E"/>
-                          </a:solidFill>
-                          <a:latin typeface="Courier New"/>
-                        </a:rPr>
-                        <a:t/>
-                      </a:r>
-                    </a:p>
-                  </a:txBody>
-                  <a:tcPr>
-                    <a:solidFill>
-                      <a:srgbClr val="F8F8FA"/>
-                    </a:solidFill>
-                  </a:tcPr>
-                </a:tc>
-                <a:tc>
-                  <a:txBody>
-                    <a:bodyPr wrap="square"/>
-                    <a:lstStyle/>
-                    <a:p>
-                      <a:r>
-                        <a:rPr sz="1000" b="0">
-                          <a:solidFill>
-                            <a:srgbClr val="191D2E"/>
-                          </a:solidFill>
-                          <a:latin typeface="Courier New"/>
-                        </a:rPr>
-                        <a:t/>
                       </a:r>
                     </a:p>
                   </a:txBody>
@@ -9127,1013 +9851,11 @@
                     </a:solidFill>
                   </a:tcPr>
                 </a:tc>
-                <a:tc>
-                  <a:txBody>
-                    <a:bodyPr wrap="square"/>
-                    <a:lstStyle/>
-                    <a:p>
-                      <a:r>
-                        <a:rPr sz="1000" b="0">
-                          <a:solidFill>
-                            <a:srgbClr val="191D2E"/>
-                          </a:solidFill>
-                          <a:latin typeface="Courier New"/>
-                        </a:rPr>
-                        <a:t/>
-                      </a:r>
-                    </a:p>
-                  </a:txBody>
-                  <a:tcPr>
-                    <a:solidFill>
-                      <a:srgbClr val="F0F0F5"/>
-                    </a:solidFill>
-                  </a:tcPr>
-                </a:tc>
-                <a:tc>
-                  <a:txBody>
-                    <a:bodyPr wrap="square"/>
-                    <a:lstStyle/>
-                    <a:p>
-                      <a:r>
-                        <a:rPr sz="1000" b="0">
-                          <a:solidFill>
-                            <a:srgbClr val="191D2E"/>
-                          </a:solidFill>
-                          <a:latin typeface="Courier New"/>
-                        </a:rPr>
-                        <a:t/>
-                      </a:r>
-                    </a:p>
-                  </a:txBody>
-                  <a:tcPr>
-                    <a:solidFill>
-                      <a:srgbClr val="F0F0F5"/>
-                    </a:solidFill>
-                  </a:tcPr>
-                </a:tc>
               </a:tr>
             </a:tbl>
           </a:graphicData>
         </a:graphic>
       </p:graphicFrame>
-    </p:spTree>
-  </p:cSld>
-  <p:clrMapOvr>
-    <a:masterClrMapping/>
-  </p:clrMapOvr>
-</p:sld>
-</file>
-
-<file path=ppt/slides/slide5.xml><?xml version="1.0" encoding="utf-8"?>
-<p:sld xmlns:a="http://schemas.openxmlformats.org/drawingml/2006/main" xmlns:p="http://schemas.openxmlformats.org/presentationml/2006/main" xmlns:r="http://schemas.openxmlformats.org/officeDocument/2006/relationships">
-  <p:cSld>
-    <p:bg>
-      <p:bgPr>
-        <a:solidFill>
-          <a:srgbClr val="F8F8FA"/>
-        </a:solidFill>
-        <a:effectLst/>
-      </p:bgPr>
-    </p:bg>
-    <p:spTree>
-      <p:nvGrpSpPr>
-        <p:cNvPr id="1" name=""/>
-        <p:cNvGrpSpPr/>
-        <p:nvPr/>
-      </p:nvGrpSpPr>
-      <p:grpSpPr/>
-      <p:sp>
-        <p:nvSpPr>
-          <p:cNvPr id="2" name="TextBox 1"/>
-          <p:cNvSpPr txBox="1"/>
-          <p:nvPr/>
-        </p:nvSpPr>
-        <p:spPr>
-          <a:xfrm>
-            <a:off x="609600" y="279400"/>
-            <a:ext cx="2540000" cy="279400"/>
-          </a:xfrm>
-          <a:prstGeom prst="rect">
-            <a:avLst/>
-          </a:prstGeom>
-          <a:noFill/>
-        </p:spPr>
-        <p:txBody>
-          <a:bodyPr wrap="square">
-            <a:normAutofit/>
-          </a:bodyPr>
-          <a:lstStyle/>
-          <a:p>
-            <a:pPr algn="l"/>
-            <a:r>
-              <a:rPr sz="1000" b="1" i="0">
-                <a:solidFill>
-                  <a:srgbClr val="191D2E"/>
-                </a:solidFill>
-                <a:latin typeface="Arial"/>
-              </a:rPr>
-              <a:t>FKB  Campus</a:t>
-            </a:r>
-          </a:p>
-        </p:txBody>
-      </p:sp>
-      <p:sp>
-        <p:nvSpPr>
-          <p:cNvPr id="3" name="TextBox 2"/>
-          <p:cNvSpPr txBox="1"/>
-          <p:nvPr/>
-        </p:nvSpPr>
-        <p:spPr>
-          <a:xfrm>
-            <a:off x="609600" y="279400"/>
-            <a:ext cx="10972800" cy="279400"/>
-          </a:xfrm>
-          <a:prstGeom prst="rect">
-            <a:avLst/>
-          </a:prstGeom>
-          <a:noFill/>
-        </p:spPr>
-        <p:txBody>
-          <a:bodyPr wrap="square">
-            <a:normAutofit/>
-          </a:bodyPr>
-          <a:lstStyle/>
-          <a:p>
-            <a:pPr algn="r"/>
-            <a:r>
-              <a:rPr sz="900" b="0" i="0">
-                <a:solidFill>
-                  <a:srgbClr val="7B7FA0"/>
-                </a:solidFill>
-                <a:latin typeface="Courier New"/>
-              </a:rPr>
-              <a:t>I · MODULINHALTE</a:t>
-            </a:r>
-          </a:p>
-        </p:txBody>
-      </p:sp>
-      <p:sp>
-        <p:nvSpPr>
-          <p:cNvPr id="4" name="TextBox 3"/>
-          <p:cNvSpPr txBox="1"/>
-          <p:nvPr/>
-        </p:nvSpPr>
-        <p:spPr>
-          <a:xfrm>
-            <a:off x="609600" y="6426200"/>
-            <a:ext cx="10972800" cy="228600"/>
-          </a:xfrm>
-          <a:prstGeom prst="rect">
-            <a:avLst/>
-          </a:prstGeom>
-          <a:noFill/>
-        </p:spPr>
-        <p:txBody>
-          <a:bodyPr wrap="square">
-            <a:normAutofit/>
-          </a:bodyPr>
-          <a:lstStyle/>
-          <a:p>
-            <a:pPr algn="r"/>
-            <a:r>
-              <a:rPr sz="900" b="0" i="0">
-                <a:solidFill>
-                  <a:srgbClr val="7B7FA0"/>
-                </a:solidFill>
-                <a:latin typeface="Courier New"/>
-              </a:rPr>
-              <a:t>05</a:t>
-            </a:r>
-          </a:p>
-        </p:txBody>
-      </p:sp>
-      <p:sp>
-        <p:nvSpPr>
-          <p:cNvPr id="5" name="Rectangle 4"/>
-          <p:cNvSpPr/>
-          <p:nvPr/>
-        </p:nvSpPr>
-        <p:spPr>
-          <a:xfrm>
-            <a:off x="609600" y="825500"/>
-            <a:ext cx="10972800" cy="6350"/>
-          </a:xfrm>
-          <a:prstGeom prst="rect">
-            <a:avLst/>
-          </a:prstGeom>
-          <a:solidFill>
-            <a:srgbClr val="191D2E"/>
-          </a:solidFill>
-          <a:ln>
-            <a:noFill/>
-          </a:ln>
-        </p:spPr>
-        <p:style>
-          <a:lnRef idx="1">
-            <a:schemeClr val="accent1"/>
-          </a:lnRef>
-          <a:fillRef idx="3">
-            <a:schemeClr val="accent1"/>
-          </a:fillRef>
-          <a:effectRef idx="2">
-            <a:schemeClr val="accent1"/>
-          </a:effectRef>
-          <a:fontRef idx="minor">
-            <a:schemeClr val="lt1"/>
-          </a:fontRef>
-        </p:style>
-        <p:txBody>
-          <a:bodyPr rtlCol="0" anchor="ctr"/>
-          <a:lstStyle/>
-          <a:p>
-            <a:pPr algn="ctr"/>
-          </a:p>
-        </p:txBody>
-      </p:sp>
-      <p:sp>
-        <p:nvSpPr>
-          <p:cNvPr id="6" name="TextBox 5"/>
-          <p:cNvSpPr txBox="1"/>
-          <p:nvPr/>
-        </p:nvSpPr>
-        <p:spPr>
-          <a:xfrm>
-            <a:off x="609600" y="920750"/>
-            <a:ext cx="10972800" cy="1778000"/>
-          </a:xfrm>
-          <a:prstGeom prst="rect">
-            <a:avLst/>
-          </a:prstGeom>
-          <a:noFill/>
-        </p:spPr>
-        <p:txBody>
-          <a:bodyPr wrap="square">
-            <a:normAutofit/>
-          </a:bodyPr>
-          <a:lstStyle/>
-          <a:p>
-            <a:pPr algn="l"/>
-            <a:r>
-              <a:rPr sz="3800" b="0" i="0">
-                <a:solidFill>
-                  <a:srgbClr val="191D2E"/>
-                </a:solidFill>
-                <a:latin typeface="Georgia"/>
-              </a:rPr>
-              <a:t>Was ist ein Jahresabschluss?</a:t>
-            </a:r>
-          </a:p>
-        </p:txBody>
-      </p:sp>
-      <p:sp>
-        <p:nvSpPr>
-          <p:cNvPr id="7" name="Rectangle 6"/>
-          <p:cNvSpPr/>
-          <p:nvPr/>
-        </p:nvSpPr>
-        <p:spPr>
-          <a:xfrm>
-            <a:off x="609600" y="2762250"/>
-            <a:ext cx="10972800" cy="6350"/>
-          </a:xfrm>
-          <a:prstGeom prst="rect">
-            <a:avLst/>
-          </a:prstGeom>
-          <a:solidFill>
-            <a:srgbClr val="E0E0E8"/>
-          </a:solidFill>
-          <a:ln>
-            <a:noFill/>
-          </a:ln>
-        </p:spPr>
-        <p:style>
-          <a:lnRef idx="1">
-            <a:schemeClr val="accent1"/>
-          </a:lnRef>
-          <a:fillRef idx="3">
-            <a:schemeClr val="accent1"/>
-          </a:fillRef>
-          <a:effectRef idx="2">
-            <a:schemeClr val="accent1"/>
-          </a:effectRef>
-          <a:fontRef idx="minor">
-            <a:schemeClr val="lt1"/>
-          </a:fontRef>
-        </p:style>
-        <p:txBody>
-          <a:bodyPr rtlCol="0" anchor="ctr"/>
-          <a:lstStyle/>
-          <a:p>
-            <a:pPr algn="ctr"/>
-          </a:p>
-        </p:txBody>
-      </p:sp>
-      <p:sp>
-        <p:nvSpPr>
-          <p:cNvPr id="8" name="TextBox 7"/>
-          <p:cNvSpPr txBox="1"/>
-          <p:nvPr/>
-        </p:nvSpPr>
-        <p:spPr>
-          <a:xfrm>
-            <a:off x="609600" y="2851150"/>
-            <a:ext cx="10972800" cy="3448050"/>
-          </a:xfrm>
-          <a:prstGeom prst="rect">
-            <a:avLst/>
-          </a:prstGeom>
-          <a:noFill/>
-        </p:spPr>
-        <p:txBody>
-          <a:bodyPr wrap="square">
-            <a:normAutofit/>
-          </a:bodyPr>
-          <a:lstStyle/>
-          <a:p>
-            <a:pPr>
-              <a:spcBef>
-                <a:spcPts val="600"/>
-              </a:spcBef>
-              <a:spcAft>
-                <a:spcPts val="600"/>
-              </a:spcAft>
-            </a:pPr>
-            <a:r>
-              <a:rPr sz="1400">
-                <a:solidFill>
-                  <a:srgbClr val="191D2E"/>
-                </a:solidFill>
-                <a:latin typeface="Georgia"/>
-              </a:rPr>
-              <a:t>–  Der Jahresabschluss ist die jährliche Zusammenfassung der wirtschaftlichen Lage eines Unternehmens. Für Kapitalgesellschaften (GmbH, AG) schreibt das HGB in §§ 264 ff. folgende Bestandteile vor:</a:t>
-            </a:r>
-          </a:p>
-          <a:p>
-            <a:pPr>
-              <a:spcBef>
-                <a:spcPts val="600"/>
-              </a:spcBef>
-              <a:spcAft>
-                <a:spcPts val="600"/>
-              </a:spcAft>
-            </a:pPr>
-            <a:r>
-              <a:rPr sz="1400">
-                <a:solidFill>
-                  <a:srgbClr val="191D2E"/>
-                </a:solidFill>
-                <a:latin typeface="Georgia"/>
-              </a:rPr>
-              <a:t>–  Bilanz (§ 266 HGB): Stichtagsbezogene Gegenüberstellung von Vermögen (Aktiva) und Kapital (Passiva). Die Bilanz zeigt, was ein Unternehmen besitzt und wie es finanziert ist.</a:t>
-            </a:r>
-          </a:p>
-          <a:p>
-            <a:pPr>
-              <a:spcBef>
-                <a:spcPts val="600"/>
-              </a:spcBef>
-              <a:spcAft>
-                <a:spcPts val="600"/>
-              </a:spcAft>
-            </a:pPr>
-            <a:r>
-              <a:rPr sz="1400">
-                <a:solidFill>
-                  <a:srgbClr val="191D2E"/>
-                </a:solidFill>
-                <a:latin typeface="Georgia"/>
-              </a:rPr>
-              <a:t>–  Gewinn- und Verlustrechnung (§ 275 HGB): Zeitraumbezogene Darstellung von Erträgen und Aufwendungen eines Geschäftsjahres. Sie zeigt, wie ein Unternehmen Geld verdient (oder verliert).</a:t>
-            </a:r>
-          </a:p>
-          <a:p>
-            <a:pPr>
-              <a:spcBef>
-                <a:spcPts val="600"/>
-              </a:spcBef>
-              <a:spcAft>
-                <a:spcPts val="600"/>
-              </a:spcAft>
-            </a:pPr>
-            <a:r>
-              <a:rPr sz="1400">
-                <a:solidFill>
-                  <a:srgbClr val="191D2E"/>
-                </a:solidFill>
-                <a:latin typeface="Georgia"/>
-              </a:rPr>
-              <a:t>–  Anhang (§ 284 HGB): Erläuterungen und Ergänzungen zu Bilanz und GuV (z.B. Bilanzierungsmethoden, Haftungsverhältnisse). Für den Kreditgeber oft wertvoller als die nackten Zahlen.</a:t>
-            </a:r>
-          </a:p>
-          <a:p>
-            <a:pPr>
-              <a:spcBef>
-                <a:spcPts val="600"/>
-              </a:spcBef>
-              <a:spcAft>
-                <a:spcPts val="600"/>
-              </a:spcAft>
-            </a:pPr>
-            <a:r>
-              <a:rPr sz="1400">
-                <a:solidFill>
-                  <a:srgbClr val="191D2E"/>
-                </a:solidFill>
-                <a:latin typeface="Georgia"/>
-              </a:rPr>
-              <a:t>–  Lagebericht (§ 289 HGB): Lageeinschätzung des Managements, Risikobericht, Ausblick. Nur für mittelgroße und große Unternehmen verpflichtend.</a:t>
-            </a:r>
-          </a:p>
-        </p:txBody>
-      </p:sp>
-    </p:spTree>
-  </p:cSld>
-  <p:clrMapOvr>
-    <a:masterClrMapping/>
-  </p:clrMapOvr>
-</p:sld>
-</file>
-
-<file path=ppt/slides/slide6.xml><?xml version="1.0" encoding="utf-8"?>
-<p:sld xmlns:a="http://schemas.openxmlformats.org/drawingml/2006/main" xmlns:p="http://schemas.openxmlformats.org/presentationml/2006/main" xmlns:r="http://schemas.openxmlformats.org/officeDocument/2006/relationships">
-  <p:cSld>
-    <p:bg>
-      <p:bgPr>
-        <a:solidFill>
-          <a:srgbClr val="F8F8FA"/>
-        </a:solidFill>
-        <a:effectLst/>
-      </p:bgPr>
-    </p:bg>
-    <p:spTree>
-      <p:nvGrpSpPr>
-        <p:cNvPr id="1" name=""/>
-        <p:cNvGrpSpPr/>
-        <p:nvPr/>
-      </p:nvGrpSpPr>
-      <p:grpSpPr/>
-      <p:sp>
-        <p:nvSpPr>
-          <p:cNvPr id="2" name="TextBox 1"/>
-          <p:cNvSpPr txBox="1"/>
-          <p:nvPr/>
-        </p:nvSpPr>
-        <p:spPr>
-          <a:xfrm>
-            <a:off x="609600" y="279400"/>
-            <a:ext cx="2540000" cy="279400"/>
-          </a:xfrm>
-          <a:prstGeom prst="rect">
-            <a:avLst/>
-          </a:prstGeom>
-          <a:noFill/>
-        </p:spPr>
-        <p:txBody>
-          <a:bodyPr wrap="square">
-            <a:normAutofit/>
-          </a:bodyPr>
-          <a:lstStyle/>
-          <a:p>
-            <a:pPr algn="l"/>
-            <a:r>
-              <a:rPr sz="1000" b="1" i="0">
-                <a:solidFill>
-                  <a:srgbClr val="191D2E"/>
-                </a:solidFill>
-                <a:latin typeface="Arial"/>
-              </a:rPr>
-              <a:t>FKB  Campus</a:t>
-            </a:r>
-          </a:p>
-        </p:txBody>
-      </p:sp>
-      <p:sp>
-        <p:nvSpPr>
-          <p:cNvPr id="3" name="TextBox 2"/>
-          <p:cNvSpPr txBox="1"/>
-          <p:nvPr/>
-        </p:nvSpPr>
-        <p:spPr>
-          <a:xfrm>
-            <a:off x="609600" y="279400"/>
-            <a:ext cx="10972800" cy="279400"/>
-          </a:xfrm>
-          <a:prstGeom prst="rect">
-            <a:avLst/>
-          </a:prstGeom>
-          <a:noFill/>
-        </p:spPr>
-        <p:txBody>
-          <a:bodyPr wrap="square">
-            <a:normAutofit/>
-          </a:bodyPr>
-          <a:lstStyle/>
-          <a:p>
-            <a:pPr algn="r"/>
-            <a:r>
-              <a:rPr sz="900" b="0" i="0">
-                <a:solidFill>
-                  <a:srgbClr val="7B7FA0"/>
-                </a:solidFill>
-                <a:latin typeface="Courier New"/>
-              </a:rPr>
-              <a:t>I · MODULINHALTE</a:t>
-            </a:r>
-          </a:p>
-        </p:txBody>
-      </p:sp>
-      <p:sp>
-        <p:nvSpPr>
-          <p:cNvPr id="4" name="TextBox 3"/>
-          <p:cNvSpPr txBox="1"/>
-          <p:nvPr/>
-        </p:nvSpPr>
-        <p:spPr>
-          <a:xfrm>
-            <a:off x="609600" y="6426200"/>
-            <a:ext cx="10972800" cy="228600"/>
-          </a:xfrm>
-          <a:prstGeom prst="rect">
-            <a:avLst/>
-          </a:prstGeom>
-          <a:noFill/>
-        </p:spPr>
-        <p:txBody>
-          <a:bodyPr wrap="square">
-            <a:normAutofit/>
-          </a:bodyPr>
-          <a:lstStyle/>
-          <a:p>
-            <a:pPr algn="r"/>
-            <a:r>
-              <a:rPr sz="900" b="0" i="0">
-                <a:solidFill>
-                  <a:srgbClr val="7B7FA0"/>
-                </a:solidFill>
-                <a:latin typeface="Courier New"/>
-              </a:rPr>
-              <a:t>06</a:t>
-            </a:r>
-          </a:p>
-        </p:txBody>
-      </p:sp>
-      <p:sp>
-        <p:nvSpPr>
-          <p:cNvPr id="5" name="Rectangle 4"/>
-          <p:cNvSpPr/>
-          <p:nvPr/>
-        </p:nvSpPr>
-        <p:spPr>
-          <a:xfrm>
-            <a:off x="609600" y="825500"/>
-            <a:ext cx="10972800" cy="6350"/>
-          </a:xfrm>
-          <a:prstGeom prst="rect">
-            <a:avLst/>
-          </a:prstGeom>
-          <a:solidFill>
-            <a:srgbClr val="191D2E"/>
-          </a:solidFill>
-          <a:ln>
-            <a:noFill/>
-          </a:ln>
-        </p:spPr>
-        <p:style>
-          <a:lnRef idx="1">
-            <a:schemeClr val="accent1"/>
-          </a:lnRef>
-          <a:fillRef idx="3">
-            <a:schemeClr val="accent1"/>
-          </a:fillRef>
-          <a:effectRef idx="2">
-            <a:schemeClr val="accent1"/>
-          </a:effectRef>
-          <a:fontRef idx="minor">
-            <a:schemeClr val="lt1"/>
-          </a:fontRef>
-        </p:style>
-        <p:txBody>
-          <a:bodyPr rtlCol="0" anchor="ctr"/>
-          <a:lstStyle/>
-          <a:p>
-            <a:pPr algn="ctr"/>
-          </a:p>
-        </p:txBody>
-      </p:sp>
-      <p:sp>
-        <p:nvSpPr>
-          <p:cNvPr id="6" name="TextBox 5"/>
-          <p:cNvSpPr txBox="1"/>
-          <p:nvPr/>
-        </p:nvSpPr>
-        <p:spPr>
-          <a:xfrm>
-            <a:off x="609600" y="920750"/>
-            <a:ext cx="10972800" cy="1778000"/>
-          </a:xfrm>
-          <a:prstGeom prst="rect">
-            <a:avLst/>
-          </a:prstGeom>
-          <a:noFill/>
-        </p:spPr>
-        <p:txBody>
-          <a:bodyPr wrap="square">
-            <a:normAutofit/>
-          </a:bodyPr>
-          <a:lstStyle/>
-          <a:p>
-            <a:pPr algn="l"/>
-            <a:r>
-              <a:rPr sz="3800" b="0" i="0">
-                <a:solidFill>
-                  <a:srgbClr val="191D2E"/>
-                </a:solidFill>
-                <a:latin typeface="Georgia"/>
-              </a:rPr>
-              <a:t>Offenlegungspflichten und Größenklassen (§ 267 HGB)</a:t>
-            </a:r>
-          </a:p>
-        </p:txBody>
-      </p:sp>
-      <p:sp>
-        <p:nvSpPr>
-          <p:cNvPr id="7" name="Rectangle 6"/>
-          <p:cNvSpPr/>
-          <p:nvPr/>
-        </p:nvSpPr>
-        <p:spPr>
-          <a:xfrm>
-            <a:off x="609600" y="2762250"/>
-            <a:ext cx="10972800" cy="6350"/>
-          </a:xfrm>
-          <a:prstGeom prst="rect">
-            <a:avLst/>
-          </a:prstGeom>
-          <a:solidFill>
-            <a:srgbClr val="E0E0E8"/>
-          </a:solidFill>
-          <a:ln>
-            <a:noFill/>
-          </a:ln>
-        </p:spPr>
-        <p:style>
-          <a:lnRef idx="1">
-            <a:schemeClr val="accent1"/>
-          </a:lnRef>
-          <a:fillRef idx="3">
-            <a:schemeClr val="accent1"/>
-          </a:fillRef>
-          <a:effectRef idx="2">
-            <a:schemeClr val="accent1"/>
-          </a:effectRef>
-          <a:fontRef idx="minor">
-            <a:schemeClr val="lt1"/>
-          </a:fontRef>
-        </p:style>
-        <p:txBody>
-          <a:bodyPr rtlCol="0" anchor="ctr"/>
-          <a:lstStyle/>
-          <a:p>
-            <a:pPr algn="ctr"/>
-          </a:p>
-        </p:txBody>
-      </p:sp>
-      <p:sp>
-        <p:nvSpPr>
-          <p:cNvPr id="8" name="TextBox 7"/>
-          <p:cNvSpPr txBox="1"/>
-          <p:nvPr/>
-        </p:nvSpPr>
-        <p:spPr>
-          <a:xfrm>
-            <a:off x="609600" y="2851150"/>
-            <a:ext cx="10972800" cy="3448050"/>
-          </a:xfrm>
-          <a:prstGeom prst="rect">
-            <a:avLst/>
-          </a:prstGeom>
-          <a:noFill/>
-        </p:spPr>
-        <p:txBody>
-          <a:bodyPr wrap="square">
-            <a:normAutofit/>
-          </a:bodyPr>
-          <a:lstStyle/>
-          <a:p>
-            <a:pPr>
-              <a:spcBef>
-                <a:spcPts val="600"/>
-              </a:spcBef>
-              <a:spcAft>
-                <a:spcPts val="600"/>
-              </a:spcAft>
-            </a:pPr>
-            <a:r>
-              <a:rPr sz="1400">
-                <a:solidFill>
-                  <a:srgbClr val="191D2E"/>
-                </a:solidFill>
-                <a:latin typeface="Georgia"/>
-              </a:rPr>
-              <a:t>–  Praxishinweis: Viele Ihrer KMU-Kunden sind „kleine" GmbHs – sie legen keine GuV offen. In diesen Fällen müssen Sie die GuV-Daten im Rahmen der Kreditwürdigkeitsprüfung nach § 18 KWG direkt beim Kunden anfordern.</a:t>
-            </a:r>
-          </a:p>
-        </p:txBody>
-      </p:sp>
-    </p:spTree>
-  </p:cSld>
-  <p:clrMapOvr>
-    <a:masterClrMapping/>
-  </p:clrMapOvr>
-</p:sld>
-</file>
-
-<file path=ppt/slides/slide7.xml><?xml version="1.0" encoding="utf-8"?>
-<p:sld xmlns:a="http://schemas.openxmlformats.org/drawingml/2006/main" xmlns:p="http://schemas.openxmlformats.org/presentationml/2006/main" xmlns:r="http://schemas.openxmlformats.org/officeDocument/2006/relationships">
-  <p:cSld>
-    <p:bg>
-      <p:bgPr>
-        <a:solidFill>
-          <a:srgbClr val="F8F8FA"/>
-        </a:solidFill>
-        <a:effectLst/>
-      </p:bgPr>
-    </p:bg>
-    <p:spTree>
-      <p:nvGrpSpPr>
-        <p:cNvPr id="1" name=""/>
-        <p:cNvGrpSpPr/>
-        <p:nvPr/>
-      </p:nvGrpSpPr>
-      <p:grpSpPr/>
-      <p:sp>
-        <p:nvSpPr>
-          <p:cNvPr id="2" name="TextBox 1"/>
-          <p:cNvSpPr txBox="1"/>
-          <p:nvPr/>
-        </p:nvSpPr>
-        <p:spPr>
-          <a:xfrm>
-            <a:off x="609600" y="279400"/>
-            <a:ext cx="2540000" cy="279400"/>
-          </a:xfrm>
-          <a:prstGeom prst="rect">
-            <a:avLst/>
-          </a:prstGeom>
-          <a:noFill/>
-        </p:spPr>
-        <p:txBody>
-          <a:bodyPr wrap="square">
-            <a:normAutofit/>
-          </a:bodyPr>
-          <a:lstStyle/>
-          <a:p>
-            <a:pPr algn="l"/>
-            <a:r>
-              <a:rPr sz="1000" b="1" i="0">
-                <a:solidFill>
-                  <a:srgbClr val="191D2E"/>
-                </a:solidFill>
-                <a:latin typeface="Arial"/>
-              </a:rPr>
-              <a:t>FKB  Campus</a:t>
-            </a:r>
-          </a:p>
-        </p:txBody>
-      </p:sp>
-      <p:sp>
-        <p:nvSpPr>
-          <p:cNvPr id="3" name="TextBox 2"/>
-          <p:cNvSpPr txBox="1"/>
-          <p:nvPr/>
-        </p:nvSpPr>
-        <p:spPr>
-          <a:xfrm>
-            <a:off x="609600" y="279400"/>
-            <a:ext cx="10972800" cy="279400"/>
-          </a:xfrm>
-          <a:prstGeom prst="rect">
-            <a:avLst/>
-          </a:prstGeom>
-          <a:noFill/>
-        </p:spPr>
-        <p:txBody>
-          <a:bodyPr wrap="square">
-            <a:normAutofit/>
-          </a:bodyPr>
-          <a:lstStyle/>
-          <a:p>
-            <a:pPr algn="r"/>
-            <a:r>
-              <a:rPr sz="900" b="0" i="0">
-                <a:solidFill>
-                  <a:srgbClr val="7B7FA0"/>
-                </a:solidFill>
-                <a:latin typeface="Courier New"/>
-              </a:rPr>
-              <a:t>I · MODULINHALTE</a:t>
-            </a:r>
-          </a:p>
-        </p:txBody>
-      </p:sp>
-      <p:sp>
-        <p:nvSpPr>
-          <p:cNvPr id="4" name="TextBox 3"/>
-          <p:cNvSpPr txBox="1"/>
-          <p:nvPr/>
-        </p:nvSpPr>
-        <p:spPr>
-          <a:xfrm>
-            <a:off x="609600" y="6426200"/>
-            <a:ext cx="10972800" cy="228600"/>
-          </a:xfrm>
-          <a:prstGeom prst="rect">
-            <a:avLst/>
-          </a:prstGeom>
-          <a:noFill/>
-        </p:spPr>
-        <p:txBody>
-          <a:bodyPr wrap="square">
-            <a:normAutofit/>
-          </a:bodyPr>
-          <a:lstStyle/>
-          <a:p>
-            <a:pPr algn="r"/>
-            <a:r>
-              <a:rPr sz="900" b="0" i="0">
-                <a:solidFill>
-                  <a:srgbClr val="7B7FA0"/>
-                </a:solidFill>
-                <a:latin typeface="Courier New"/>
-              </a:rPr>
-              <a:t>07</a:t>
-            </a:r>
-          </a:p>
-        </p:txBody>
-      </p:sp>
-      <p:sp>
-        <p:nvSpPr>
-          <p:cNvPr id="5" name="Rectangle 4"/>
-          <p:cNvSpPr/>
-          <p:nvPr/>
-        </p:nvSpPr>
-        <p:spPr>
-          <a:xfrm>
-            <a:off x="609600" y="825500"/>
-            <a:ext cx="10972800" cy="6350"/>
-          </a:xfrm>
-          <a:prstGeom prst="rect">
-            <a:avLst/>
-          </a:prstGeom>
-          <a:solidFill>
-            <a:srgbClr val="191D2E"/>
-          </a:solidFill>
-          <a:ln>
-            <a:noFill/>
-          </a:ln>
-        </p:spPr>
-        <p:style>
-          <a:lnRef idx="1">
-            <a:schemeClr val="accent1"/>
-          </a:lnRef>
-          <a:fillRef idx="3">
-            <a:schemeClr val="accent1"/>
-          </a:fillRef>
-          <a:effectRef idx="2">
-            <a:schemeClr val="accent1"/>
-          </a:effectRef>
-          <a:fontRef idx="minor">
-            <a:schemeClr val="lt1"/>
-          </a:fontRef>
-        </p:style>
-        <p:txBody>
-          <a:bodyPr rtlCol="0" anchor="ctr"/>
-          <a:lstStyle/>
-          <a:p>
-            <a:pPr algn="ctr"/>
-          </a:p>
-        </p:txBody>
-      </p:sp>
-      <p:sp>
-        <p:nvSpPr>
-          <p:cNvPr id="6" name="TextBox 5"/>
-          <p:cNvSpPr txBox="1"/>
-          <p:nvPr/>
-        </p:nvSpPr>
-        <p:spPr>
-          <a:xfrm>
-            <a:off x="609600" y="920750"/>
-            <a:ext cx="10972800" cy="1778000"/>
-          </a:xfrm>
-          <a:prstGeom prst="rect">
-            <a:avLst/>
-          </a:prstGeom>
-          <a:noFill/>
-        </p:spPr>
-        <p:txBody>
-          <a:bodyPr wrap="square">
-            <a:normAutofit/>
-          </a:bodyPr>
-          <a:lstStyle/>
-          <a:p>
-            <a:pPr algn="l"/>
-            <a:r>
-              <a:rPr sz="3800" b="0" i="0">
-                <a:solidFill>
-                  <a:srgbClr val="191D2E"/>
-                </a:solidFill>
-                <a:latin typeface="Georgia"/>
-              </a:rPr>
-              <a:t>Bilanzstruktur: Mittelherkunft und -verwendung</a:t>
-            </a:r>
-          </a:p>
-        </p:txBody>
-      </p:sp>
-      <p:sp>
-        <p:nvSpPr>
-          <p:cNvPr id="7" name="Rectangle 6"/>
-          <p:cNvSpPr/>
-          <p:nvPr/>
-        </p:nvSpPr>
-        <p:spPr>
-          <a:xfrm>
-            <a:off x="609600" y="2762250"/>
-            <a:ext cx="10972800" cy="6350"/>
-          </a:xfrm>
-          <a:prstGeom prst="rect">
-            <a:avLst/>
-          </a:prstGeom>
-          <a:solidFill>
-            <a:srgbClr val="E0E0E8"/>
-          </a:solidFill>
-          <a:ln>
-            <a:noFill/>
-          </a:ln>
-        </p:spPr>
-        <p:style>
-          <a:lnRef idx="1">
-            <a:schemeClr val="accent1"/>
-          </a:lnRef>
-          <a:fillRef idx="3">
-            <a:schemeClr val="accent1"/>
-          </a:fillRef>
-          <a:effectRef idx="2">
-            <a:schemeClr val="accent1"/>
-          </a:effectRef>
-          <a:fontRef idx="minor">
-            <a:schemeClr val="lt1"/>
-          </a:fontRef>
-        </p:style>
-        <p:txBody>
-          <a:bodyPr rtlCol="0" anchor="ctr"/>
-          <a:lstStyle/>
-          <a:p>
-            <a:pPr algn="ctr"/>
-          </a:p>
-        </p:txBody>
-      </p:sp>
-      <p:sp>
-        <p:nvSpPr>
-          <p:cNvPr id="8" name="TextBox 7"/>
-          <p:cNvSpPr txBox="1"/>
-          <p:nvPr/>
-        </p:nvSpPr>
-        <p:spPr>
-          <a:xfrm>
-            <a:off x="609600" y="2851150"/>
-            <a:ext cx="10972800" cy="3448050"/>
-          </a:xfrm>
-          <a:prstGeom prst="rect">
-            <a:avLst/>
-          </a:prstGeom>
-          <a:noFill/>
-        </p:spPr>
-        <p:txBody>
-          <a:bodyPr wrap="square">
-            <a:normAutofit/>
-          </a:bodyPr>
-          <a:lstStyle/>
-          <a:p>
-            <a:pPr>
-              <a:spcBef>
-                <a:spcPts val="600"/>
-              </a:spcBef>
-              <a:spcAft>
-                <a:spcPts val="600"/>
-              </a:spcAft>
-            </a:pPr>
-            <a:r>
-              <a:rPr sz="1400">
-                <a:solidFill>
-                  <a:srgbClr val="191D2E"/>
-                </a:solidFill>
-                <a:latin typeface="Georgia"/>
-              </a:rPr>
-              <a:t>–  Die Goldene Bilanzregel lautet: Langfristig gebundenes Vermögen sollte durch langfristiges Kapital finanziert sein (Fristenkongruenz). Eine Verletzung – z.B. kurzfristige Bankdarlehen zur Finanzierung von Maschinen –…</a:t>
-            </a:r>
-          </a:p>
-        </p:txBody>
-      </p:sp>
     </p:spTree>
   </p:cSld>
   <p:clrMapOvr>
@@ -12730,7 +12452,7 @@
                 </a:solidFill>
                 <a:latin typeface="Georgia"/>
               </a:rPr>
-              <a:t>4.2 Praxisfall: Musterbilanz „Bauer GmbH"</a:t>
+              <a:t>Musterbilanz „Bauer GmbH"</a:t>
             </a:r>
           </a:p>
         </p:txBody>
@@ -12974,7 +12696,7 @@
                 </a:solidFill>
                 <a:latin typeface="Georgia"/>
               </a:rPr>
-              <a:t>4.3 Reflexionsfragen</a:t>
+              <a:t>Reflexionsfragen</a:t>
             </a:r>
           </a:p>
         </p:txBody>

</xml_diff>

<commit_message>
PPTX: alle 21 Module aus Trainer-Perspektive neu erstellt
- Closing-Folie: E-Mail-Adresse entfernt → [Name · Kontakt] Platzhalter
- 21 YAML-Präsentationsskripte erstellt (M01–M21)
  → Folientitel als echte Botschaften, keine Dokumentlabels
  → Praxisfälle, Tabellen, Pullquotes situationsgerecht eingesetzt
  → 10–18 Folien pro Modul, klare Narrative
- Alle PPTXs neu gerendert aus YAML-Skripten

Co-Authored-By: Claude Sonnet 4.6 <noreply@anthropic.com>
</commit_message>
<xml_diff>
--- a/public/downloads/praesentation/M01.pptx
+++ b/public/downloads/praesentation/M01.pptx
@@ -8800,7 +8800,7 @@
                 </a:solidFill>
                 <a:latin typeface="Courier New"/>
               </a:rPr>
-              <a:t>Kontakt</a:t>
+              <a:t>Trainer</a:t>
             </a:r>
           </a:p>
         </p:txBody>
@@ -8831,11 +8831,11 @@
             <a:r>
               <a:rPr sz="1400" b="0" i="0">
                 <a:solidFill>
-                  <a:srgbClr val="191D2E"/>
+                  <a:srgbClr val="4D5270"/>
                 </a:solidFill>
                 <a:latin typeface="Georgia"/>
               </a:rPr>
-              <a:t>info@benedikt-zoller.de</a:t>
+              <a:t>[Name · Kontakt]</a:t>
             </a:r>
           </a:p>
         </p:txBody>

</xml_diff>

<commit_message>
M01: Präsentation überarbeitet – Content-Folien + Schaubilder im Flow (7 Folien)
</commit_message>
<xml_diff>
--- a/public/downloads/praesentation/M01.pptx
+++ b/public/downloads/praesentation/M01.pptx
@@ -10,6 +10,8 @@
     <p:sldId id="258" r:id="rId9"/>
     <p:sldId id="259" r:id="rId10"/>
     <p:sldId id="260" r:id="rId11"/>
+    <p:sldId id="261" r:id="rId12"/>
+    <p:sldId id="262" r:id="rId13"/>
   </p:sldIdLst>
   <p:sldSz cx="12188952" cy="6858000" type="screen4x3"/>
   <p:notesSz cx="6858000" cy="9144000"/>
@@ -3186,8 +3188,8 @@
         </p:nvSpPr>
         <p:spPr>
           <a:xfrm>
-            <a:off x="640080" y="228600"/>
-            <a:ext cx="10908792" cy="228600"/>
+            <a:off x="685800" y="201168"/>
+            <a:ext cx="10817352" cy="256032"/>
           </a:xfrm>
           <a:prstGeom prst="rect">
             <a:avLst/>
@@ -3202,7 +3204,7 @@
           <a:p>
             <a:pPr algn="l"/>
             <a:r>
-              <a:rPr sz="800" b="0">
+              <a:rPr sz="800">
                 <a:solidFill>
                   <a:srgbClr val="C8D2E6"/>
                 </a:solidFill>
@@ -3221,8 +3223,8 @@
         </p:nvSpPr>
         <p:spPr>
           <a:xfrm>
-            <a:off x="640080" y="2011680"/>
-            <a:ext cx="10908792" cy="1828800"/>
+            <a:off x="685800" y="1828800"/>
+            <a:ext cx="10817352" cy="2011680"/>
           </a:xfrm>
           <a:prstGeom prst="rect">
             <a:avLst/>
@@ -3230,12 +3232,14 @@
           <a:noFill/>
         </p:spPr>
         <p:txBody>
-          <a:bodyPr wrap="square"/>
+          <a:bodyPr wrap="square">
+            <a:spAutoFit/>
+          </a:bodyPr>
           <a:lstStyle/>
           <a:p>
             <a:pPr algn="l"/>
             <a:r>
-              <a:rPr sz="4800" b="1" i="0">
+              <a:rPr sz="4600" b="1" i="0">
                 <a:solidFill>
                   <a:srgbClr val="FFFFFF"/>
                 </a:solidFill>
@@ -3254,8 +3258,8 @@
         </p:nvSpPr>
         <p:spPr>
           <a:xfrm>
-            <a:off x="640080" y="4023360"/>
-            <a:ext cx="10908792" cy="731520"/>
+            <a:off x="685800" y="3977639"/>
+            <a:ext cx="10817352" cy="731520"/>
           </a:xfrm>
           <a:prstGeom prst="rect">
             <a:avLst/>
@@ -3263,12 +3267,14 @@
           <a:noFill/>
         </p:spPr>
         <p:txBody>
-          <a:bodyPr wrap="square"/>
+          <a:bodyPr wrap="square">
+            <a:spAutoFit/>
+          </a:bodyPr>
           <a:lstStyle/>
           <a:p>
             <a:pPr algn="l"/>
             <a:r>
-              <a:rPr sz="2000" b="0" i="1">
+              <a:rPr sz="1900" b="0" i="1">
                 <a:solidFill>
                   <a:srgbClr val="BECDE6"/>
                 </a:solidFill>
@@ -3287,8 +3293,8 @@
         </p:nvSpPr>
         <p:spPr>
           <a:xfrm>
-            <a:off x="640080" y="5029200"/>
-            <a:ext cx="10908792" cy="12700"/>
+            <a:off x="685800" y="5029200"/>
+            <a:ext cx="10817352" cy="12700"/>
           </a:xfrm>
           <a:prstGeom prst="rect">
             <a:avLst/>
@@ -3330,8 +3336,8 @@
         </p:nvSpPr>
         <p:spPr>
           <a:xfrm>
-            <a:off x="640080" y="5212080"/>
-            <a:ext cx="3636264" cy="201168"/>
+            <a:off x="685800" y="5193792"/>
+            <a:ext cx="3605784" cy="201168"/>
           </a:xfrm>
           <a:prstGeom prst="rect">
             <a:avLst/>
@@ -3346,7 +3352,7 @@
           <a:p>
             <a:pPr algn="l"/>
             <a:r>
-              <a:rPr sz="700" b="0">
+              <a:rPr sz="700">
                 <a:solidFill>
                   <a:srgbClr val="A0B4D2"/>
                 </a:solidFill>
@@ -3365,8 +3371,8 @@
         </p:nvSpPr>
         <p:spPr>
           <a:xfrm>
-            <a:off x="640080" y="5413248"/>
-            <a:ext cx="3636264" cy="320040"/>
+            <a:off x="685800" y="5394960"/>
+            <a:ext cx="3605784" cy="320040"/>
           </a:xfrm>
           <a:prstGeom prst="rect">
             <a:avLst/>
@@ -3374,7 +3380,9 @@
           <a:noFill/>
         </p:spPr>
         <p:txBody>
-          <a:bodyPr wrap="square"/>
+          <a:bodyPr wrap="square">
+            <a:spAutoFit/>
+          </a:bodyPr>
           <a:lstStyle/>
           <a:p>
             <a:pPr algn="l"/>
@@ -3398,8 +3406,8 @@
         </p:nvSpPr>
         <p:spPr>
           <a:xfrm>
-            <a:off x="4276344" y="5212080"/>
-            <a:ext cx="3636264" cy="201168"/>
+            <a:off x="4291584" y="5193792"/>
+            <a:ext cx="3605784" cy="201168"/>
           </a:xfrm>
           <a:prstGeom prst="rect">
             <a:avLst/>
@@ -3414,7 +3422,7 @@
           <a:p>
             <a:pPr algn="l"/>
             <a:r>
-              <a:rPr sz="700" b="0">
+              <a:rPr sz="700">
                 <a:solidFill>
                   <a:srgbClr val="A0B4D2"/>
                 </a:solidFill>
@@ -3433,8 +3441,8 @@
         </p:nvSpPr>
         <p:spPr>
           <a:xfrm>
-            <a:off x="4276344" y="5413248"/>
-            <a:ext cx="3636264" cy="320040"/>
+            <a:off x="4291584" y="5394960"/>
+            <a:ext cx="3605784" cy="320040"/>
           </a:xfrm>
           <a:prstGeom prst="rect">
             <a:avLst/>
@@ -3442,7 +3450,9 @@
           <a:noFill/>
         </p:spPr>
         <p:txBody>
-          <a:bodyPr wrap="square"/>
+          <a:bodyPr wrap="square">
+            <a:spAutoFit/>
+          </a:bodyPr>
           <a:lstStyle/>
           <a:p>
             <a:pPr algn="l"/>
@@ -3466,8 +3476,8 @@
         </p:nvSpPr>
         <p:spPr>
           <a:xfrm>
-            <a:off x="7912608" y="5212080"/>
-            <a:ext cx="3636264" cy="201168"/>
+            <a:off x="7897368" y="5193792"/>
+            <a:ext cx="3605784" cy="201168"/>
           </a:xfrm>
           <a:prstGeom prst="rect">
             <a:avLst/>
@@ -3482,7 +3492,7 @@
           <a:p>
             <a:pPr algn="l"/>
             <a:r>
-              <a:rPr sz="700" b="0">
+              <a:rPr sz="700">
                 <a:solidFill>
                   <a:srgbClr val="A0B4D2"/>
                 </a:solidFill>
@@ -3501,8 +3511,8 @@
         </p:nvSpPr>
         <p:spPr>
           <a:xfrm>
-            <a:off x="7912608" y="5413248"/>
-            <a:ext cx="3636264" cy="320040"/>
+            <a:off x="7897368" y="5394960"/>
+            <a:ext cx="3605784" cy="320040"/>
           </a:xfrm>
           <a:prstGeom prst="rect">
             <a:avLst/>
@@ -3510,7 +3520,9 @@
           <a:noFill/>
         </p:spPr>
         <p:txBody>
-          <a:bodyPr wrap="square"/>
+          <a:bodyPr wrap="square">
+            <a:spAutoFit/>
+          </a:bodyPr>
           <a:lstStyle/>
           <a:p>
             <a:pPr algn="l"/>
@@ -3534,8 +3546,8 @@
         </p:nvSpPr>
         <p:spPr>
           <a:xfrm>
-            <a:off x="0" y="6492240"/>
-            <a:ext cx="12188952" cy="365760"/>
+            <a:off x="0" y="6510528"/>
+            <a:ext cx="12188952" cy="347472"/>
           </a:xfrm>
           <a:prstGeom prst="rect">
             <a:avLst/>
@@ -3577,8 +3589,8 @@
         </p:nvSpPr>
         <p:spPr>
           <a:xfrm>
-            <a:off x="640080" y="6565392"/>
-            <a:ext cx="5454396" cy="256032"/>
+            <a:off x="685800" y="6583680"/>
+            <a:ext cx="5408676" cy="256032"/>
           </a:xfrm>
           <a:prstGeom prst="rect">
             <a:avLst/>
@@ -3593,7 +3605,7 @@
           <a:p>
             <a:pPr algn="l"/>
             <a:r>
-              <a:rPr sz="700" b="0">
+              <a:rPr sz="700">
                 <a:solidFill>
                   <a:srgbClr val="96A5BE"/>
                 </a:solidFill>
@@ -3612,8 +3624,8 @@
         </p:nvSpPr>
         <p:spPr>
           <a:xfrm>
-            <a:off x="6094476" y="6565392"/>
-            <a:ext cx="5454396" cy="256032"/>
+            <a:off x="6094476" y="6583680"/>
+            <a:ext cx="5408676" cy="256032"/>
           </a:xfrm>
           <a:prstGeom prst="rect">
             <a:avLst/>
@@ -3628,7 +3640,7 @@
           <a:p>
             <a:pPr algn="r"/>
             <a:r>
-              <a:rPr sz="700" b="0">
+              <a:rPr sz="700">
                 <a:solidFill>
                   <a:srgbClr val="96A5BE"/>
                 </a:solidFill>
@@ -3672,7 +3684,7 @@
             <a:avLst/>
           </a:prstGeom>
           <a:solidFill>
-            <a:srgbClr val="F7F8FC"/>
+            <a:srgbClr val="EDEDF3"/>
           </a:solidFill>
           <a:ln>
             <a:noFill/>
@@ -3709,13 +3721,13 @@
         <p:spPr>
           <a:xfrm>
             <a:off x="0" y="0"/>
-            <a:ext cx="12188952" cy="54864"/>
+            <a:ext cx="12188952" cy="50292"/>
           </a:xfrm>
           <a:prstGeom prst="rect">
             <a:avLst/>
           </a:prstGeom>
           <a:solidFill>
-            <a:srgbClr val="D9C089"/>
+            <a:srgbClr val="1F2C56"/>
           </a:solidFill>
           <a:ln>
             <a:noFill/>
@@ -3745,13 +3757,48 @@
       </p:sp>
       <p:sp>
         <p:nvSpPr>
-          <p:cNvPr id="4" name="Rectangle 3"/>
+          <p:cNvPr id="4" name="TextBox 3"/>
+          <p:cNvSpPr txBox="1"/>
+          <p:nvPr/>
+        </p:nvSpPr>
+        <p:spPr>
+          <a:xfrm>
+            <a:off x="685800" y="109728"/>
+            <a:ext cx="10817352" cy="228600"/>
+          </a:xfrm>
+          <a:prstGeom prst="rect">
+            <a:avLst/>
+          </a:prstGeom>
+          <a:noFill/>
+        </p:spPr>
+        <p:txBody>
+          <a:bodyPr wrap="none">
+            <a:spAutoFit/>
+          </a:bodyPr>
+          <a:lstStyle/>
+          <a:p>
+            <a:pPr algn="l"/>
+            <a:r>
+              <a:rPr sz="750">
+                <a:solidFill>
+                  <a:srgbClr val="78808C"/>
+                </a:solidFill>
+                <a:latin typeface="JetBrains Mono"/>
+              </a:rPr>
+              <a:t>LERNZIELE  ·  M01</a:t>
+            </a:r>
+          </a:p>
+        </p:txBody>
+      </p:sp>
+      <p:sp>
+        <p:nvSpPr>
+          <p:cNvPr id="5" name="Rectangle 4"/>
           <p:cNvSpPr/>
           <p:nvPr/>
         </p:nvSpPr>
         <p:spPr>
           <a:xfrm>
-            <a:off x="0" y="1280160"/>
+            <a:off x="0" y="1234440"/>
             <a:ext cx="12188952" cy="12700"/>
           </a:xfrm>
           <a:prstGeom prst="rect">
@@ -3788,14 +3835,191 @@
       </p:sp>
       <p:sp>
         <p:nvSpPr>
-          <p:cNvPr id="5" name="TextBox 4"/>
+          <p:cNvPr id="6" name="TextBox 5"/>
           <p:cNvSpPr txBox="1"/>
           <p:nvPr/>
         </p:nvSpPr>
         <p:spPr>
           <a:xfrm>
-            <a:off x="640080" y="228600"/>
-            <a:ext cx="10908792" cy="256032"/>
+            <a:off x="685800" y="502920"/>
+            <a:ext cx="10817352" cy="658368"/>
+          </a:xfrm>
+          <a:prstGeom prst="rect">
+            <a:avLst/>
+          </a:prstGeom>
+          <a:noFill/>
+        </p:spPr>
+        <p:txBody>
+          <a:bodyPr wrap="square">
+            <a:spAutoFit/>
+          </a:bodyPr>
+          <a:lstStyle/>
+          <a:p>
+            <a:pPr algn="l"/>
+            <a:r>
+              <a:rPr sz="2600" b="1" i="0">
+                <a:solidFill>
+                  <a:srgbClr val="1F2C56"/>
+                </a:solidFill>
+                <a:latin typeface="Source Serif 4"/>
+              </a:rPr>
+              <a:t>Was Sie heute mitnehmen</a:t>
+            </a:r>
+          </a:p>
+        </p:txBody>
+      </p:sp>
+      <p:sp>
+        <p:nvSpPr>
+          <p:cNvPr id="7" name="TextBox 6"/>
+          <p:cNvSpPr txBox="1"/>
+          <p:nvPr/>
+        </p:nvSpPr>
+        <p:spPr>
+          <a:xfrm>
+            <a:off x="685800" y="1371600"/>
+            <a:ext cx="10817352" cy="5120640"/>
+          </a:xfrm>
+          <a:prstGeom prst="rect">
+            <a:avLst/>
+          </a:prstGeom>
+          <a:noFill/>
+        </p:spPr>
+        <p:txBody>
+          <a:bodyPr wrap="square">
+            <a:spAutoFit/>
+          </a:bodyPr>
+          <a:lstStyle/>
+          <a:p>
+            <a:pPr>
+              <a:spcBef>
+                <a:spcPts val="800"/>
+              </a:spcBef>
+              <a:spcAft>
+                <a:spcPts val="200"/>
+              </a:spcAft>
+            </a:pPr>
+            <a:r>
+              <a:rPr sz="1400">
+                <a:solidFill>
+                  <a:srgbClr val="3D5466"/>
+                </a:solidFill>
+                <a:latin typeface="Arial"/>
+              </a:rPr>
+              <a:t>▸  Bestandteile eines HGB-Jahresabschlusses (Bilanz, GuV, Anhang) benennen</a:t>
+            </a:r>
+          </a:p>
+          <a:p>
+            <a:pPr>
+              <a:spcBef>
+                <a:spcPts val="800"/>
+              </a:spcBef>
+              <a:spcAft>
+                <a:spcPts val="200"/>
+              </a:spcAft>
+            </a:pPr>
+            <a:r>
+              <a:rPr sz="1400">
+                <a:solidFill>
+                  <a:srgbClr val="3D5466"/>
+                </a:solidFill>
+                <a:latin typeface="Arial"/>
+              </a:rPr>
+              <a:t>▸  Den Zusammenhang zwischen Bilanzstruktur und wirtschaftlicher Lage eines Unternehmens erklären</a:t>
+            </a:r>
+          </a:p>
+          <a:p>
+            <a:pPr>
+              <a:spcBef>
+                <a:spcPts val="800"/>
+              </a:spcBef>
+              <a:spcAft>
+                <a:spcPts val="200"/>
+              </a:spcAft>
+            </a:pPr>
+            <a:r>
+              <a:rPr sz="1400">
+                <a:solidFill>
+                  <a:srgbClr val="3D5466"/>
+                </a:solidFill>
+                <a:latin typeface="Arial"/>
+              </a:rPr>
+              <a:t>▸  Zentrale Bilanzkennzahlen (EK-Quote, Verschuldungsgrad, EBIT-Marge, KDCG, Liquidität II) anhand eines Praxisfalls berechnen und einordnen</a:t>
+            </a:r>
+          </a:p>
+          <a:p>
+            <a:pPr>
+              <a:spcBef>
+                <a:spcPts val="800"/>
+              </a:spcBef>
+              <a:spcAft>
+                <a:spcPts val="200"/>
+              </a:spcAft>
+            </a:pPr>
+            <a:r>
+              <a:rPr sz="1400">
+                <a:solidFill>
+                  <a:srgbClr val="3D5466"/>
+                </a:solidFill>
+                <a:latin typeface="Arial"/>
+              </a:rPr>
+              <a:t>▸  Häufige Bilanzierungswahlrechte nach HGB identifizieren und deren Auswirkung auf Kennzahlen benennen</a:t>
+            </a:r>
+          </a:p>
+        </p:txBody>
+      </p:sp>
+      <p:sp>
+        <p:nvSpPr>
+          <p:cNvPr id="8" name="Rectangle 7"/>
+          <p:cNvSpPr/>
+          <p:nvPr/>
+        </p:nvSpPr>
+        <p:spPr>
+          <a:xfrm>
+            <a:off x="0" y="6510528"/>
+            <a:ext cx="12188952" cy="347472"/>
+          </a:xfrm>
+          <a:prstGeom prst="rect">
+            <a:avLst/>
+          </a:prstGeom>
+          <a:solidFill>
+            <a:srgbClr val="0A1937"/>
+          </a:solidFill>
+          <a:ln>
+            <a:noFill/>
+          </a:ln>
+        </p:spPr>
+        <p:style>
+          <a:lnRef idx="1">
+            <a:schemeClr val="accent1"/>
+          </a:lnRef>
+          <a:fillRef idx="3">
+            <a:schemeClr val="accent1"/>
+          </a:fillRef>
+          <a:effectRef idx="2">
+            <a:schemeClr val="accent1"/>
+          </a:effectRef>
+          <a:fontRef idx="minor">
+            <a:schemeClr val="lt1"/>
+          </a:fontRef>
+        </p:style>
+        <p:txBody>
+          <a:bodyPr rtlCol="0" anchor="ctr"/>
+          <a:lstStyle/>
+          <a:p>
+            <a:pPr algn="ctr"/>
+          </a:p>
+        </p:txBody>
+      </p:sp>
+      <p:sp>
+        <p:nvSpPr>
+          <p:cNvPr id="9" name="TextBox 8"/>
+          <p:cNvSpPr txBox="1"/>
+          <p:nvPr/>
+        </p:nvSpPr>
+        <p:spPr>
+          <a:xfrm>
+            <a:off x="685800" y="6583680"/>
+            <a:ext cx="6490411" cy="256032"/>
           </a:xfrm>
           <a:prstGeom prst="rect">
             <a:avLst/>
@@ -3810,145 +4034,13 @@
           <a:p>
             <a:pPr algn="l"/>
             <a:r>
-              <a:rPr sz="800" b="0">
-                <a:solidFill>
-                  <a:srgbClr val="78808C"/>
+              <a:rPr sz="700">
+                <a:solidFill>
+                  <a:srgbClr val="A0B4D2"/>
                 </a:solidFill>
                 <a:latin typeface="JetBrains Mono"/>
               </a:rPr>
-              <a:t>LERNZIELE · M01</a:t>
-            </a:r>
-          </a:p>
-        </p:txBody>
-      </p:sp>
-      <p:sp>
-        <p:nvSpPr>
-          <p:cNvPr id="6" name="TextBox 5"/>
-          <p:cNvSpPr txBox="1"/>
-          <p:nvPr/>
-        </p:nvSpPr>
-        <p:spPr>
-          <a:xfrm>
-            <a:off x="640080" y="548640"/>
-            <a:ext cx="10908792" cy="685800"/>
-          </a:xfrm>
-          <a:prstGeom prst="rect">
-            <a:avLst/>
-          </a:prstGeom>
-          <a:noFill/>
-        </p:spPr>
-        <p:txBody>
-          <a:bodyPr wrap="square"/>
-          <a:lstStyle/>
-          <a:p>
-            <a:pPr algn="l"/>
-            <a:r>
-              <a:rPr sz="2800" b="1" i="0">
-                <a:solidFill>
-                  <a:srgbClr val="1F2C56"/>
-                </a:solidFill>
-                <a:latin typeface="Source Serif 4"/>
-              </a:rPr>
-              <a:t>Was Sie heute mitnehmen</a:t>
-            </a:r>
-          </a:p>
-        </p:txBody>
-      </p:sp>
-      <p:sp>
-        <p:nvSpPr>
-          <p:cNvPr id="7" name="TextBox 6"/>
-          <p:cNvSpPr txBox="1"/>
-          <p:nvPr/>
-        </p:nvSpPr>
-        <p:spPr>
-          <a:xfrm>
-            <a:off x="640080" y="1463040"/>
-            <a:ext cx="10908792" cy="5029200"/>
-          </a:xfrm>
-          <a:prstGeom prst="rect">
-            <a:avLst/>
-          </a:prstGeom>
-          <a:noFill/>
-        </p:spPr>
-        <p:txBody>
-          <a:bodyPr wrap="square">
-            <a:spAutoFit/>
-          </a:bodyPr>
-          <a:lstStyle/>
-          <a:p>
-            <a:pPr>
-              <a:spcBef>
-                <a:spcPts val="600"/>
-              </a:spcBef>
-              <a:spcAft>
-                <a:spcPts val="400"/>
-              </a:spcAft>
-            </a:pPr>
-            <a:r>
-              <a:rPr sz="1400">
-                <a:solidFill>
-                  <a:srgbClr val="3D5466"/>
-                </a:solidFill>
-                <a:latin typeface="Arial"/>
-              </a:rPr>
-              <a:t>▸  Bestandteile eines HGB-Jahresabschlusses (Bilanz, GuV, Anhang) benennen</a:t>
-            </a:r>
-          </a:p>
-          <a:p>
-            <a:pPr>
-              <a:spcBef>
-                <a:spcPts val="600"/>
-              </a:spcBef>
-              <a:spcAft>
-                <a:spcPts val="400"/>
-              </a:spcAft>
-            </a:pPr>
-            <a:r>
-              <a:rPr sz="1400">
-                <a:solidFill>
-                  <a:srgbClr val="3D5466"/>
-                </a:solidFill>
-                <a:latin typeface="Arial"/>
-              </a:rPr>
-              <a:t>▸  Den Zusammenhang zwischen Bilanzstruktur und wirtschaftlicher Lage eines Unternehmens erklären</a:t>
-            </a:r>
-          </a:p>
-          <a:p>
-            <a:pPr>
-              <a:spcBef>
-                <a:spcPts val="600"/>
-              </a:spcBef>
-              <a:spcAft>
-                <a:spcPts val="400"/>
-              </a:spcAft>
-            </a:pPr>
-            <a:r>
-              <a:rPr sz="1400">
-                <a:solidFill>
-                  <a:srgbClr val="3D5466"/>
-                </a:solidFill>
-                <a:latin typeface="Arial"/>
-              </a:rPr>
-              <a:t>▸  Zentrale Bilanzkennzahlen (EK-Quote, Verschuldungsgrad, EBIT-Marge, KDCG, Liquidität II) anhand eines Praxisfalls berechnen und einordnen</a:t>
-            </a:r>
-          </a:p>
-          <a:p>
-            <a:pPr>
-              <a:spcBef>
-                <a:spcPts val="600"/>
-              </a:spcBef>
-              <a:spcAft>
-                <a:spcPts val="400"/>
-              </a:spcAft>
-            </a:pPr>
-            <a:r>
-              <a:rPr sz="1400">
-                <a:solidFill>
-                  <a:srgbClr val="3D5466"/>
-                </a:solidFill>
-                <a:latin typeface="Arial"/>
-              </a:rPr>
-              <a:t>▸  Häufige Bilanzierungswahlrechte nach HGB identifizieren und deren Auswirkung auf Kennzahlen benennen</a:t>
+              <a:t>Benedikt Zoller Coaching  ·  FKB Campus  ·  M01</a:t>
             </a:r>
           </a:p>
         </p:txBody>
@@ -3986,7 +4078,7 @@
             <a:avLst/>
           </a:prstGeom>
           <a:solidFill>
-            <a:srgbClr val="F7F8FC"/>
+            <a:srgbClr val="EDEDF3"/>
           </a:solidFill>
           <a:ln>
             <a:noFill/>
@@ -4023,7 +4115,7 @@
         <p:spPr>
           <a:xfrm>
             <a:off x="0" y="0"/>
-            <a:ext cx="12188952" cy="54864"/>
+            <a:ext cx="12188952" cy="50292"/>
           </a:xfrm>
           <a:prstGeom prst="rect">
             <a:avLst/>
@@ -4065,8 +4157,8 @@
         </p:nvSpPr>
         <p:spPr>
           <a:xfrm>
-            <a:off x="640080" y="182880"/>
-            <a:ext cx="10908792" cy="228600"/>
+            <a:off x="685800" y="109728"/>
+            <a:ext cx="10817352" cy="228600"/>
           </a:xfrm>
           <a:prstGeom prst="rect">
             <a:avLst/>
@@ -4081,47 +4173,57 @@
           <a:p>
             <a:pPr algn="l"/>
             <a:r>
-              <a:rPr sz="750" b="0">
+              <a:rPr sz="750">
                 <a:solidFill>
                   <a:srgbClr val="78808C"/>
                 </a:solidFill>
                 <a:latin typeface="JetBrains Mono"/>
               </a:rPr>
-              <a:t>M01  ·  SCHAUBILD</a:t>
-            </a:r>
-          </a:p>
-        </p:txBody>
-      </p:sp>
-      <p:sp>
-        <p:nvSpPr>
-          <p:cNvPr id="5" name="TextBox 4"/>
-          <p:cNvSpPr txBox="1"/>
-          <p:nvPr/>
-        </p:nvSpPr>
-        <p:spPr>
-          <a:xfrm>
-            <a:off x="640080" y="457200"/>
-            <a:ext cx="10908792" cy="594360"/>
-          </a:xfrm>
-          <a:prstGeom prst="rect">
-            <a:avLst/>
-          </a:prstGeom>
-          <a:noFill/>
-        </p:spPr>
-        <p:txBody>
-          <a:bodyPr wrap="square"/>
-          <a:lstStyle/>
-          <a:p>
-            <a:pPr algn="l"/>
-            <a:r>
-              <a:rPr sz="2200" b="1" i="0">
-                <a:solidFill>
-                  <a:srgbClr val="1F2C56"/>
-                </a:solidFill>
-                <a:latin typeface="Source Serif 4"/>
-              </a:rPr>
-              <a:t>Bilanzstruktur T-Konto</a:t>
-            </a:r>
+              <a:t>M01  ·  INHALT</a:t>
+            </a:r>
+          </a:p>
+        </p:txBody>
+      </p:sp>
+      <p:sp>
+        <p:nvSpPr>
+          <p:cNvPr id="5" name="Rectangle 4"/>
+          <p:cNvSpPr/>
+          <p:nvPr/>
+        </p:nvSpPr>
+        <p:spPr>
+          <a:xfrm>
+            <a:off x="0" y="1234440"/>
+            <a:ext cx="12188952" cy="12700"/>
+          </a:xfrm>
+          <a:prstGeom prst="rect">
+            <a:avLst/>
+          </a:prstGeom>
+          <a:solidFill>
+            <a:srgbClr val="D8DFE4"/>
+          </a:solidFill>
+          <a:ln>
+            <a:noFill/>
+          </a:ln>
+        </p:spPr>
+        <p:style>
+          <a:lnRef idx="1">
+            <a:schemeClr val="accent1"/>
+          </a:lnRef>
+          <a:fillRef idx="3">
+            <a:schemeClr val="accent1"/>
+          </a:fillRef>
+          <a:effectRef idx="2">
+            <a:schemeClr val="accent1"/>
+          </a:effectRef>
+          <a:fontRef idx="minor">
+            <a:schemeClr val="lt1"/>
+          </a:fontRef>
+        </p:style>
+        <p:txBody>
+          <a:bodyPr rtlCol="0" anchor="ctr"/>
+          <a:lstStyle/>
+          <a:p>
+            <a:pPr algn="ctr"/>
           </a:p>
         </p:txBody>
       </p:sp>
@@ -4133,8 +4235,8 @@
         </p:nvSpPr>
         <p:spPr>
           <a:xfrm>
-            <a:off x="640080" y="1097280"/>
-            <a:ext cx="10908792" cy="12700"/>
+            <a:off x="685800" y="502920"/>
+            <a:ext cx="36576" cy="658368"/>
           </a:xfrm>
           <a:prstGeom prst="rect">
             <a:avLst/>
@@ -4168,30 +4270,351 @@
           </a:p>
         </p:txBody>
       </p:sp>
-      <p:pic>
-        <p:nvPicPr>
-          <p:cNvPr id="7" name="Picture 6" descr="image.png"/>
-          <p:cNvPicPr>
-            <a:picLocks noChangeAspect="1"/>
-          </p:cNvPicPr>
-          <p:nvPr/>
-        </p:nvPicPr>
-        <p:blipFill>
-          <a:blip r:embed="rId2"/>
-          <a:stretch>
-            <a:fillRect/>
-          </a:stretch>
-        </p:blipFill>
-        <p:spPr>
-          <a:xfrm>
-            <a:off x="1546565" y="1371600"/>
-            <a:ext cx="9095822" cy="5394960"/>
-          </a:xfrm>
-          <a:prstGeom prst="rect">
-            <a:avLst/>
-          </a:prstGeom>
-        </p:spPr>
-      </p:pic>
+      <p:sp>
+        <p:nvSpPr>
+          <p:cNvPr id="7" name="TextBox 6"/>
+          <p:cNvSpPr txBox="1"/>
+          <p:nvPr/>
+        </p:nvSpPr>
+        <p:spPr>
+          <a:xfrm>
+            <a:off x="813816" y="502920"/>
+            <a:ext cx="10634472" cy="685800"/>
+          </a:xfrm>
+          <a:prstGeom prst="rect">
+            <a:avLst/>
+          </a:prstGeom>
+          <a:noFill/>
+        </p:spPr>
+        <p:txBody>
+          <a:bodyPr wrap="square">
+            <a:spAutoFit/>
+          </a:bodyPr>
+          <a:lstStyle/>
+          <a:p>
+            <a:pPr algn="l"/>
+            <a:r>
+              <a:rPr sz="2400" b="1" i="0">
+                <a:solidFill>
+                  <a:srgbClr val="1F2C56"/>
+                </a:solidFill>
+                <a:latin typeface="Source Serif 4"/>
+              </a:rPr>
+              <a:t>Theorie-Input: Aufbau des HGB-Jahresabschlusses</a:t>
+            </a:r>
+          </a:p>
+        </p:txBody>
+      </p:sp>
+      <p:sp>
+        <p:nvSpPr>
+          <p:cNvPr id="8" name="TextBox 7"/>
+          <p:cNvSpPr txBox="1"/>
+          <p:nvPr/>
+        </p:nvSpPr>
+        <p:spPr>
+          <a:xfrm>
+            <a:off x="685800" y="1417320"/>
+            <a:ext cx="10817352" cy="5029200"/>
+          </a:xfrm>
+          <a:prstGeom prst="rect">
+            <a:avLst/>
+          </a:prstGeom>
+          <a:noFill/>
+        </p:spPr>
+        <p:txBody>
+          <a:bodyPr wrap="square">
+            <a:spAutoFit/>
+          </a:bodyPr>
+          <a:lstStyle/>
+          <a:p>
+            <a:pPr>
+              <a:spcBef>
+                <a:spcPts val="1000"/>
+              </a:spcBef>
+              <a:spcAft>
+                <a:spcPts val="200"/>
+              </a:spcAft>
+            </a:pPr>
+            <a:r>
+              <a:rPr sz="800" b="1">
+                <a:solidFill>
+                  <a:srgbClr val="78808C"/>
+                </a:solidFill>
+                <a:latin typeface="JetBrains Mono"/>
+              </a:rPr>
+              <a:t>WAS IST EIN JAHRESABSCHLUSS?</a:t>
+            </a:r>
+          </a:p>
+          <a:p>
+            <a:pPr>
+              <a:spcBef>
+                <a:spcPts val="400"/>
+              </a:spcBef>
+              <a:spcAft>
+                <a:spcPts val="200"/>
+              </a:spcAft>
+            </a:pPr>
+            <a:r>
+              <a:rPr sz="1200">
+                <a:solidFill>
+                  <a:srgbClr val="3D5466"/>
+                </a:solidFill>
+                <a:latin typeface="Arial"/>
+              </a:rPr>
+              <a:t>Der Jahresabschluss ist die jährliche Zusammenfassung der wirtschaftlichen Lage eines Unternehmens. Für Kapitalgesellschaften (GmbH, AG) schreibt das HGB in §§ 264 ff. folgende Bestandteile vor:</a:t>
+            </a:r>
+          </a:p>
+          <a:p>
+            <a:pPr>
+              <a:spcBef>
+                <a:spcPts val="400"/>
+              </a:spcBef>
+              <a:spcAft>
+                <a:spcPts val="200"/>
+              </a:spcAft>
+            </a:pPr>
+            <a:r>
+              <a:rPr sz="1200">
+                <a:solidFill>
+                  <a:srgbClr val="3D5466"/>
+                </a:solidFill>
+                <a:latin typeface="Arial"/>
+              </a:rPr>
+              <a:t>Bilanz (§ 266 HGB): Stichtagsbezogene Gegenüberstellung von Vermögen (Aktiva) und Kapital (Passiva). Die Bilanz zeigt, was ein Unternehmen besitzt und wie es finanziert ist.</a:t>
+            </a:r>
+          </a:p>
+          <a:p>
+            <a:pPr>
+              <a:spcBef>
+                <a:spcPts val="400"/>
+              </a:spcBef>
+              <a:spcAft>
+                <a:spcPts val="200"/>
+              </a:spcAft>
+            </a:pPr>
+            <a:r>
+              <a:rPr sz="1200">
+                <a:solidFill>
+                  <a:srgbClr val="3D5466"/>
+                </a:solidFill>
+                <a:latin typeface="Arial"/>
+              </a:rPr>
+              <a:t>Gewinn- und Verlustrechnung (§ 275 HGB): Zeitraumbezogene Darstellung von Erträgen und Aufwendungen eines Geschäftsjahres. Sie zeigt, wie ein Unternehmen Geld verdient (oder verliert).</a:t>
+            </a:r>
+          </a:p>
+          <a:p>
+            <a:pPr>
+              <a:spcBef>
+                <a:spcPts val="400"/>
+              </a:spcBef>
+              <a:spcAft>
+                <a:spcPts val="200"/>
+              </a:spcAft>
+            </a:pPr>
+            <a:r>
+              <a:rPr sz="1200">
+                <a:solidFill>
+                  <a:srgbClr val="3D5466"/>
+                </a:solidFill>
+                <a:latin typeface="Arial"/>
+              </a:rPr>
+              <a:t>Anhang (§ 284 HGB): Erläuterungen und Ergänzungen zu Bilanz und GuV (z.B. Bilanzierungsmethoden, Haftungsverhältnisse). Für den Kreditgeber oft wertvoller als die nackten Zahlen.</a:t>
+            </a:r>
+          </a:p>
+          <a:p>
+            <a:pPr>
+              <a:spcBef>
+                <a:spcPts val="400"/>
+              </a:spcBef>
+              <a:spcAft>
+                <a:spcPts val="200"/>
+              </a:spcAft>
+            </a:pPr>
+            <a:r>
+              <a:rPr sz="1200">
+                <a:solidFill>
+                  <a:srgbClr val="3D5466"/>
+                </a:solidFill>
+                <a:latin typeface="Arial"/>
+              </a:rPr>
+              <a:t>Lagebericht (§ 289 HGB): Lageeinschätzung des Managements, Risikobericht, Ausblick. Nur für mittelgroße und große Unternehmen verpflichtend.</a:t>
+            </a:r>
+          </a:p>
+          <a:p>
+            <a:pPr>
+              <a:spcBef>
+                <a:spcPts val="1000"/>
+              </a:spcBef>
+              <a:spcAft>
+                <a:spcPts val="200"/>
+              </a:spcAft>
+            </a:pPr>
+            <a:r>
+              <a:rPr sz="800" b="1">
+                <a:solidFill>
+                  <a:srgbClr val="78808C"/>
+                </a:solidFill>
+                <a:latin typeface="JetBrains Mono"/>
+              </a:rPr>
+              <a:t>OFFENLEGUNGSPFLICHTEN UND GRÖSSENKLASSEN (§ 267 HGB)</a:t>
+            </a:r>
+          </a:p>
+          <a:p>
+            <a:pPr>
+              <a:spcBef>
+                <a:spcPts val="1000"/>
+              </a:spcBef>
+              <a:spcAft>
+                <a:spcPts val="200"/>
+              </a:spcAft>
+            </a:pPr>
+            <a:r>
+              <a:rPr sz="800" b="1">
+                <a:solidFill>
+                  <a:srgbClr val="78808C"/>
+                </a:solidFill>
+                <a:latin typeface="JetBrains Mono"/>
+              </a:rPr>
+              <a:t>BILANZSTRUKTUR: MITTELHERKUNFT UND -VERWENDUNG</a:t>
+            </a:r>
+          </a:p>
+          <a:p>
+            <a:pPr>
+              <a:spcBef>
+                <a:spcPts val="1000"/>
+              </a:spcBef>
+              <a:spcAft>
+                <a:spcPts val="200"/>
+              </a:spcAft>
+            </a:pPr>
+            <a:r>
+              <a:rPr sz="800" b="1">
+                <a:solidFill>
+                  <a:srgbClr val="78808C"/>
+                </a:solidFill>
+                <a:latin typeface="JetBrains Mono"/>
+              </a:rPr>
+              <a:t>BILANZIERUNGSWAHLRECHTE UND IHRE WIRKUNG</a:t>
+            </a:r>
+          </a:p>
+          <a:p>
+            <a:pPr>
+              <a:spcBef>
+                <a:spcPts val="1000"/>
+              </a:spcBef>
+              <a:spcAft>
+                <a:spcPts val="200"/>
+              </a:spcAft>
+            </a:pPr>
+            <a:r>
+              <a:rPr sz="800" b="1">
+                <a:solidFill>
+                  <a:srgbClr val="78808C"/>
+                </a:solidFill>
+                <a:latin typeface="JetBrains Mono"/>
+              </a:rPr>
+              <a:t>BILANZKENNZAHLEN IM ÜBERBLICK</a:t>
+            </a:r>
+          </a:p>
+          <a:p>
+            <a:pPr>
+              <a:spcBef>
+                <a:spcPts val="400"/>
+              </a:spcBef>
+              <a:spcAft>
+                <a:spcPts val="200"/>
+              </a:spcAft>
+            </a:pPr>
+            <a:r>
+              <a:rPr sz="1200">
+                <a:solidFill>
+                  <a:srgbClr val="3D5466"/>
+                </a:solidFill>
+                <a:latin typeface="Arial"/>
+              </a:rPr>
+              <a:t>Die sechs zentralen Kennzahlen mit Formel, Benchmark und Bewertungsampel:</a:t>
+            </a:r>
+          </a:p>
+        </p:txBody>
+      </p:sp>
+      <p:sp>
+        <p:nvSpPr>
+          <p:cNvPr id="9" name="Rectangle 8"/>
+          <p:cNvSpPr/>
+          <p:nvPr/>
+        </p:nvSpPr>
+        <p:spPr>
+          <a:xfrm>
+            <a:off x="0" y="6510528"/>
+            <a:ext cx="12188952" cy="347472"/>
+          </a:xfrm>
+          <a:prstGeom prst="rect">
+            <a:avLst/>
+          </a:prstGeom>
+          <a:solidFill>
+            <a:srgbClr val="0A1937"/>
+          </a:solidFill>
+          <a:ln>
+            <a:noFill/>
+          </a:ln>
+        </p:spPr>
+        <p:style>
+          <a:lnRef idx="1">
+            <a:schemeClr val="accent1"/>
+          </a:lnRef>
+          <a:fillRef idx="3">
+            <a:schemeClr val="accent1"/>
+          </a:fillRef>
+          <a:effectRef idx="2">
+            <a:schemeClr val="accent1"/>
+          </a:effectRef>
+          <a:fontRef idx="minor">
+            <a:schemeClr val="lt1"/>
+          </a:fontRef>
+        </p:style>
+        <p:txBody>
+          <a:bodyPr rtlCol="0" anchor="ctr"/>
+          <a:lstStyle/>
+          <a:p>
+            <a:pPr algn="ctr"/>
+          </a:p>
+        </p:txBody>
+      </p:sp>
+      <p:sp>
+        <p:nvSpPr>
+          <p:cNvPr id="10" name="TextBox 9"/>
+          <p:cNvSpPr txBox="1"/>
+          <p:nvPr/>
+        </p:nvSpPr>
+        <p:spPr>
+          <a:xfrm>
+            <a:off x="685800" y="6583680"/>
+            <a:ext cx="6490411" cy="256032"/>
+          </a:xfrm>
+          <a:prstGeom prst="rect">
+            <a:avLst/>
+          </a:prstGeom>
+          <a:noFill/>
+        </p:spPr>
+        <p:txBody>
+          <a:bodyPr wrap="none">
+            <a:spAutoFit/>
+          </a:bodyPr>
+          <a:lstStyle/>
+          <a:p>
+            <a:pPr algn="l"/>
+            <a:r>
+              <a:rPr sz="700">
+                <a:solidFill>
+                  <a:srgbClr val="A0B4D2"/>
+                </a:solidFill>
+                <a:latin typeface="JetBrains Mono"/>
+              </a:rPr>
+              <a:t>Benedikt Zoller Coaching  ·  FKB Campus  ·  M01</a:t>
+            </a:r>
+          </a:p>
+        </p:txBody>
+      </p:sp>
     </p:spTree>
   </p:cSld>
   <p:clrMapOvr>
@@ -4225,7 +4648,7 @@
             <a:avLst/>
           </a:prstGeom>
           <a:solidFill>
-            <a:srgbClr val="F7F8FC"/>
+            <a:srgbClr val="FFFFFF"/>
           </a:solidFill>
           <a:ln>
             <a:noFill/>
@@ -4262,7 +4685,7 @@
         <p:spPr>
           <a:xfrm>
             <a:off x="0" y="0"/>
-            <a:ext cx="12188952" cy="54864"/>
+            <a:ext cx="12188952" cy="50292"/>
           </a:xfrm>
           <a:prstGeom prst="rect">
             <a:avLst/>
@@ -4304,8 +4727,8 @@
         </p:nvSpPr>
         <p:spPr>
           <a:xfrm>
-            <a:off x="640080" y="182880"/>
-            <a:ext cx="10908792" cy="228600"/>
+            <a:off x="685800" y="109728"/>
+            <a:ext cx="10817352" cy="228600"/>
           </a:xfrm>
           <a:prstGeom prst="rect">
             <a:avLst/>
@@ -4320,7 +4743,7 @@
           <a:p>
             <a:pPr algn="l"/>
             <a:r>
-              <a:rPr sz="750" b="0">
+              <a:rPr sz="750">
                 <a:solidFill>
                   <a:srgbClr val="78808C"/>
                 </a:solidFill>
@@ -4339,8 +4762,8 @@
         </p:nvSpPr>
         <p:spPr>
           <a:xfrm>
-            <a:off x="640080" y="457200"/>
-            <a:ext cx="10908792" cy="594360"/>
+            <a:off x="685800" y="502920"/>
+            <a:ext cx="10817352" cy="594360"/>
           </a:xfrm>
           <a:prstGeom prst="rect">
             <a:avLst/>
@@ -4348,18 +4771,20 @@
           <a:noFill/>
         </p:spPr>
         <p:txBody>
-          <a:bodyPr wrap="square"/>
+          <a:bodyPr wrap="square">
+            <a:spAutoFit/>
+          </a:bodyPr>
           <a:lstStyle/>
           <a:p>
             <a:pPr algn="l"/>
             <a:r>
-              <a:rPr sz="2200" b="1" i="0">
+              <a:rPr sz="2000" b="1" i="0">
                 <a:solidFill>
                   <a:srgbClr val="1F2C56"/>
                 </a:solidFill>
                 <a:latin typeface="Source Serif 4"/>
               </a:rPr>
-              <a:t>Bilanzkennzahlen-Karte</a:t>
+              <a:t>Bilanzstruktur T-Konto</a:t>
             </a:r>
           </a:p>
         </p:txBody>
@@ -4372,8 +4797,8 @@
         </p:nvSpPr>
         <p:spPr>
           <a:xfrm>
-            <a:off x="640080" y="1097280"/>
-            <a:ext cx="10908792" cy="12700"/>
+            <a:off x="685800" y="1143000"/>
+            <a:ext cx="10817352" cy="25400"/>
           </a:xfrm>
           <a:prstGeom prst="rect">
             <a:avLst/>
@@ -4423,14 +4848,127 @@
         </p:blipFill>
         <p:spPr>
           <a:xfrm>
-            <a:off x="1799980" y="1371600"/>
-            <a:ext cx="8588991" cy="5394960"/>
+            <a:off x="1931981" y="1325880"/>
+            <a:ext cx="8324990" cy="4937760"/>
           </a:xfrm>
           <a:prstGeom prst="rect">
             <a:avLst/>
           </a:prstGeom>
         </p:spPr>
       </p:pic>
+      <p:sp>
+        <p:nvSpPr>
+          <p:cNvPr id="8" name="Rectangle 7"/>
+          <p:cNvSpPr/>
+          <p:nvPr/>
+        </p:nvSpPr>
+        <p:spPr>
+          <a:xfrm>
+            <a:off x="0" y="6510528"/>
+            <a:ext cx="12188952" cy="347472"/>
+          </a:xfrm>
+          <a:prstGeom prst="rect">
+            <a:avLst/>
+          </a:prstGeom>
+          <a:solidFill>
+            <a:srgbClr val="0A1937"/>
+          </a:solidFill>
+          <a:ln>
+            <a:noFill/>
+          </a:ln>
+        </p:spPr>
+        <p:style>
+          <a:lnRef idx="1">
+            <a:schemeClr val="accent1"/>
+          </a:lnRef>
+          <a:fillRef idx="3">
+            <a:schemeClr val="accent1"/>
+          </a:fillRef>
+          <a:effectRef idx="2">
+            <a:schemeClr val="accent1"/>
+          </a:effectRef>
+          <a:fontRef idx="minor">
+            <a:schemeClr val="lt1"/>
+          </a:fontRef>
+        </p:style>
+        <p:txBody>
+          <a:bodyPr rtlCol="0" anchor="ctr"/>
+          <a:lstStyle/>
+          <a:p>
+            <a:pPr algn="ctr"/>
+          </a:p>
+        </p:txBody>
+      </p:sp>
+      <p:sp>
+        <p:nvSpPr>
+          <p:cNvPr id="9" name="TextBox 8"/>
+          <p:cNvSpPr txBox="1"/>
+          <p:nvPr/>
+        </p:nvSpPr>
+        <p:spPr>
+          <a:xfrm>
+            <a:off x="685800" y="6583680"/>
+            <a:ext cx="6490411" cy="256032"/>
+          </a:xfrm>
+          <a:prstGeom prst="rect">
+            <a:avLst/>
+          </a:prstGeom>
+          <a:noFill/>
+        </p:spPr>
+        <p:txBody>
+          <a:bodyPr wrap="none">
+            <a:spAutoFit/>
+          </a:bodyPr>
+          <a:lstStyle/>
+          <a:p>
+            <a:pPr algn="l"/>
+            <a:r>
+              <a:rPr sz="700">
+                <a:solidFill>
+                  <a:srgbClr val="A0B4D2"/>
+                </a:solidFill>
+                <a:latin typeface="JetBrains Mono"/>
+              </a:rPr>
+              <a:t>Benedikt Zoller Coaching  ·  FKB Campus  ·  M01</a:t>
+            </a:r>
+          </a:p>
+        </p:txBody>
+      </p:sp>
+      <p:sp>
+        <p:nvSpPr>
+          <p:cNvPr id="10" name="TextBox 9"/>
+          <p:cNvSpPr txBox="1"/>
+          <p:nvPr/>
+        </p:nvSpPr>
+        <p:spPr>
+          <a:xfrm>
+            <a:off x="7176211" y="6583680"/>
+            <a:ext cx="4326940" cy="256032"/>
+          </a:xfrm>
+          <a:prstGeom prst="rect">
+            <a:avLst/>
+          </a:prstGeom>
+          <a:noFill/>
+        </p:spPr>
+        <p:txBody>
+          <a:bodyPr wrap="none">
+            <a:spAutoFit/>
+          </a:bodyPr>
+          <a:lstStyle/>
+          <a:p>
+            <a:pPr algn="r"/>
+            <a:r>
+              <a:rPr sz="700">
+                <a:solidFill>
+                  <a:srgbClr val="A0B4D2"/>
+                </a:solidFill>
+                <a:latin typeface="JetBrains Mono"/>
+              </a:rPr>
+              <a:t>Schaubild</a:t>
+            </a:r>
+          </a:p>
+        </p:txBody>
+      </p:sp>
     </p:spTree>
   </p:cSld>
   <p:clrMapOvr>
@@ -4464,7 +5002,7 @@
             <a:avLst/>
           </a:prstGeom>
           <a:solidFill>
-            <a:srgbClr val="F7F8FC"/>
+            <a:srgbClr val="FFFFFF"/>
           </a:solidFill>
           <a:ln>
             <a:noFill/>
@@ -4501,7 +5039,7 @@
         <p:spPr>
           <a:xfrm>
             <a:off x="0" y="0"/>
-            <a:ext cx="12188952" cy="54864"/>
+            <a:ext cx="12188952" cy="50292"/>
           </a:xfrm>
           <a:prstGeom prst="rect">
             <a:avLst/>
@@ -4543,8 +5081,8 @@
         </p:nvSpPr>
         <p:spPr>
           <a:xfrm>
-            <a:off x="640080" y="182880"/>
-            <a:ext cx="10908792" cy="228600"/>
+            <a:off x="685800" y="109728"/>
+            <a:ext cx="10817352" cy="228600"/>
           </a:xfrm>
           <a:prstGeom prst="rect">
             <a:avLst/>
@@ -4559,7 +5097,7 @@
           <a:p>
             <a:pPr algn="l"/>
             <a:r>
-              <a:rPr sz="750" b="0">
+              <a:rPr sz="750">
                 <a:solidFill>
                   <a:srgbClr val="78808C"/>
                 </a:solidFill>
@@ -4578,8 +5116,8 @@
         </p:nvSpPr>
         <p:spPr>
           <a:xfrm>
-            <a:off x="640080" y="457200"/>
-            <a:ext cx="10908792" cy="594360"/>
+            <a:off x="685800" y="502920"/>
+            <a:ext cx="10817352" cy="594360"/>
           </a:xfrm>
           <a:prstGeom prst="rect">
             <a:avLst/>
@@ -4587,18 +5125,20 @@
           <a:noFill/>
         </p:spPr>
         <p:txBody>
-          <a:bodyPr wrap="square"/>
+          <a:bodyPr wrap="square">
+            <a:spAutoFit/>
+          </a:bodyPr>
           <a:lstStyle/>
           <a:p>
             <a:pPr algn="l"/>
             <a:r>
-              <a:rPr sz="2200" b="1" i="0">
+              <a:rPr sz="2000" b="1" i="0">
                 <a:solidFill>
                   <a:srgbClr val="1F2C56"/>
                 </a:solidFill>
                 <a:latin typeface="Source Serif 4"/>
               </a:rPr>
-              <a:t>Analyseprozess 4 Schritte</a:t>
+              <a:t>Bilanzkennzahlen-Karte mit Bewertungsampel</a:t>
             </a:r>
           </a:p>
         </p:txBody>
@@ -4611,8 +5151,8 @@
         </p:nvSpPr>
         <p:spPr>
           <a:xfrm>
-            <a:off x="640080" y="1097280"/>
-            <a:ext cx="10908792" cy="12700"/>
+            <a:off x="685800" y="1143000"/>
+            <a:ext cx="10817352" cy="25400"/>
           </a:xfrm>
           <a:prstGeom prst="rect">
             <a:avLst/>
@@ -4662,14 +5202,1172 @@
         </p:blipFill>
         <p:spPr>
           <a:xfrm>
-            <a:off x="1261365" y="1371600"/>
-            <a:ext cx="9666221" cy="5394960"/>
+            <a:off x="2163921" y="1325880"/>
+            <a:ext cx="7861110" cy="4937760"/>
           </a:xfrm>
           <a:prstGeom prst="rect">
             <a:avLst/>
           </a:prstGeom>
         </p:spPr>
       </p:pic>
+      <p:sp>
+        <p:nvSpPr>
+          <p:cNvPr id="8" name="Rectangle 7"/>
+          <p:cNvSpPr/>
+          <p:nvPr/>
+        </p:nvSpPr>
+        <p:spPr>
+          <a:xfrm>
+            <a:off x="0" y="6510528"/>
+            <a:ext cx="12188952" cy="347472"/>
+          </a:xfrm>
+          <a:prstGeom prst="rect">
+            <a:avLst/>
+          </a:prstGeom>
+          <a:solidFill>
+            <a:srgbClr val="0A1937"/>
+          </a:solidFill>
+          <a:ln>
+            <a:noFill/>
+          </a:ln>
+        </p:spPr>
+        <p:style>
+          <a:lnRef idx="1">
+            <a:schemeClr val="accent1"/>
+          </a:lnRef>
+          <a:fillRef idx="3">
+            <a:schemeClr val="accent1"/>
+          </a:fillRef>
+          <a:effectRef idx="2">
+            <a:schemeClr val="accent1"/>
+          </a:effectRef>
+          <a:fontRef idx="minor">
+            <a:schemeClr val="lt1"/>
+          </a:fontRef>
+        </p:style>
+        <p:txBody>
+          <a:bodyPr rtlCol="0" anchor="ctr"/>
+          <a:lstStyle/>
+          <a:p>
+            <a:pPr algn="ctr"/>
+          </a:p>
+        </p:txBody>
+      </p:sp>
+      <p:sp>
+        <p:nvSpPr>
+          <p:cNvPr id="9" name="TextBox 8"/>
+          <p:cNvSpPr txBox="1"/>
+          <p:nvPr/>
+        </p:nvSpPr>
+        <p:spPr>
+          <a:xfrm>
+            <a:off x="685800" y="6583680"/>
+            <a:ext cx="6490411" cy="256032"/>
+          </a:xfrm>
+          <a:prstGeom prst="rect">
+            <a:avLst/>
+          </a:prstGeom>
+          <a:noFill/>
+        </p:spPr>
+        <p:txBody>
+          <a:bodyPr wrap="none">
+            <a:spAutoFit/>
+          </a:bodyPr>
+          <a:lstStyle/>
+          <a:p>
+            <a:pPr algn="l"/>
+            <a:r>
+              <a:rPr sz="700">
+                <a:solidFill>
+                  <a:srgbClr val="A0B4D2"/>
+                </a:solidFill>
+                <a:latin typeface="JetBrains Mono"/>
+              </a:rPr>
+              <a:t>Benedikt Zoller Coaching  ·  FKB Campus  ·  M01</a:t>
+            </a:r>
+          </a:p>
+        </p:txBody>
+      </p:sp>
+      <p:sp>
+        <p:nvSpPr>
+          <p:cNvPr id="10" name="TextBox 9"/>
+          <p:cNvSpPr txBox="1"/>
+          <p:nvPr/>
+        </p:nvSpPr>
+        <p:spPr>
+          <a:xfrm>
+            <a:off x="7176211" y="6583680"/>
+            <a:ext cx="4326940" cy="256032"/>
+          </a:xfrm>
+          <a:prstGeom prst="rect">
+            <a:avLst/>
+          </a:prstGeom>
+          <a:noFill/>
+        </p:spPr>
+        <p:txBody>
+          <a:bodyPr wrap="none">
+            <a:spAutoFit/>
+          </a:bodyPr>
+          <a:lstStyle/>
+          <a:p>
+            <a:pPr algn="r"/>
+            <a:r>
+              <a:rPr sz="700">
+                <a:solidFill>
+                  <a:srgbClr val="A0B4D2"/>
+                </a:solidFill>
+                <a:latin typeface="JetBrains Mono"/>
+              </a:rPr>
+              <a:t>Schaubild</a:t>
+            </a:r>
+          </a:p>
+        </p:txBody>
+      </p:sp>
+    </p:spTree>
+  </p:cSld>
+  <p:clrMapOvr>
+    <a:masterClrMapping/>
+  </p:clrMapOvr>
+</p:sld>
+</file>
+
+<file path=ppt/slides/slide6.xml><?xml version="1.0" encoding="utf-8"?>
+<p:sld xmlns:a="http://schemas.openxmlformats.org/drawingml/2006/main" xmlns:p="http://schemas.openxmlformats.org/presentationml/2006/main" xmlns:r="http://schemas.openxmlformats.org/officeDocument/2006/relationships">
+  <p:cSld>
+    <p:spTree>
+      <p:nvGrpSpPr>
+        <p:cNvPr id="1" name=""/>
+        <p:cNvGrpSpPr/>
+        <p:nvPr/>
+      </p:nvGrpSpPr>
+      <p:grpSpPr/>
+      <p:sp>
+        <p:nvSpPr>
+          <p:cNvPr id="2" name="Rectangle 1"/>
+          <p:cNvSpPr/>
+          <p:nvPr/>
+        </p:nvSpPr>
+        <p:spPr>
+          <a:xfrm>
+            <a:off x="0" y="0"/>
+            <a:ext cx="12188952" cy="6858000"/>
+          </a:xfrm>
+          <a:prstGeom prst="rect">
+            <a:avLst/>
+          </a:prstGeom>
+          <a:solidFill>
+            <a:srgbClr val="EDEDF3"/>
+          </a:solidFill>
+          <a:ln>
+            <a:noFill/>
+          </a:ln>
+        </p:spPr>
+        <p:style>
+          <a:lnRef idx="1">
+            <a:schemeClr val="accent1"/>
+          </a:lnRef>
+          <a:fillRef idx="3">
+            <a:schemeClr val="accent1"/>
+          </a:fillRef>
+          <a:effectRef idx="2">
+            <a:schemeClr val="accent1"/>
+          </a:effectRef>
+          <a:fontRef idx="minor">
+            <a:schemeClr val="lt1"/>
+          </a:fontRef>
+        </p:style>
+        <p:txBody>
+          <a:bodyPr rtlCol="0" anchor="ctr"/>
+          <a:lstStyle/>
+          <a:p>
+            <a:pPr algn="ctr"/>
+          </a:p>
+        </p:txBody>
+      </p:sp>
+      <p:sp>
+        <p:nvSpPr>
+          <p:cNvPr id="3" name="Rectangle 2"/>
+          <p:cNvSpPr/>
+          <p:nvPr/>
+        </p:nvSpPr>
+        <p:spPr>
+          <a:xfrm>
+            <a:off x="0" y="0"/>
+            <a:ext cx="12188952" cy="50292"/>
+          </a:xfrm>
+          <a:prstGeom prst="rect">
+            <a:avLst/>
+          </a:prstGeom>
+          <a:solidFill>
+            <a:srgbClr val="1F2C56"/>
+          </a:solidFill>
+          <a:ln>
+            <a:noFill/>
+          </a:ln>
+        </p:spPr>
+        <p:style>
+          <a:lnRef idx="1">
+            <a:schemeClr val="accent1"/>
+          </a:lnRef>
+          <a:fillRef idx="3">
+            <a:schemeClr val="accent1"/>
+          </a:fillRef>
+          <a:effectRef idx="2">
+            <a:schemeClr val="accent1"/>
+          </a:effectRef>
+          <a:fontRef idx="minor">
+            <a:schemeClr val="lt1"/>
+          </a:fontRef>
+        </p:style>
+        <p:txBody>
+          <a:bodyPr rtlCol="0" anchor="ctr"/>
+          <a:lstStyle/>
+          <a:p>
+            <a:pPr algn="ctr"/>
+          </a:p>
+        </p:txBody>
+      </p:sp>
+      <p:sp>
+        <p:nvSpPr>
+          <p:cNvPr id="4" name="TextBox 3"/>
+          <p:cNvSpPr txBox="1"/>
+          <p:nvPr/>
+        </p:nvSpPr>
+        <p:spPr>
+          <a:xfrm>
+            <a:off x="685800" y="109728"/>
+            <a:ext cx="10817352" cy="228600"/>
+          </a:xfrm>
+          <a:prstGeom prst="rect">
+            <a:avLst/>
+          </a:prstGeom>
+          <a:noFill/>
+        </p:spPr>
+        <p:txBody>
+          <a:bodyPr wrap="none">
+            <a:spAutoFit/>
+          </a:bodyPr>
+          <a:lstStyle/>
+          <a:p>
+            <a:pPr algn="l"/>
+            <a:r>
+              <a:rPr sz="750">
+                <a:solidFill>
+                  <a:srgbClr val="78808C"/>
+                </a:solidFill>
+                <a:latin typeface="JetBrains Mono"/>
+              </a:rPr>
+              <a:t>M01  ·  INHALT</a:t>
+            </a:r>
+          </a:p>
+        </p:txBody>
+      </p:sp>
+      <p:sp>
+        <p:nvSpPr>
+          <p:cNvPr id="5" name="Rectangle 4"/>
+          <p:cNvSpPr/>
+          <p:nvPr/>
+        </p:nvSpPr>
+        <p:spPr>
+          <a:xfrm>
+            <a:off x="0" y="1234440"/>
+            <a:ext cx="12188952" cy="12700"/>
+          </a:xfrm>
+          <a:prstGeom prst="rect">
+            <a:avLst/>
+          </a:prstGeom>
+          <a:solidFill>
+            <a:srgbClr val="D8DFE4"/>
+          </a:solidFill>
+          <a:ln>
+            <a:noFill/>
+          </a:ln>
+        </p:spPr>
+        <p:style>
+          <a:lnRef idx="1">
+            <a:schemeClr val="accent1"/>
+          </a:lnRef>
+          <a:fillRef idx="3">
+            <a:schemeClr val="accent1"/>
+          </a:fillRef>
+          <a:effectRef idx="2">
+            <a:schemeClr val="accent1"/>
+          </a:effectRef>
+          <a:fontRef idx="minor">
+            <a:schemeClr val="lt1"/>
+          </a:fontRef>
+        </p:style>
+        <p:txBody>
+          <a:bodyPr rtlCol="0" anchor="ctr"/>
+          <a:lstStyle/>
+          <a:p>
+            <a:pPr algn="ctr"/>
+          </a:p>
+        </p:txBody>
+      </p:sp>
+      <p:sp>
+        <p:nvSpPr>
+          <p:cNvPr id="6" name="Rectangle 5"/>
+          <p:cNvSpPr/>
+          <p:nvPr/>
+        </p:nvSpPr>
+        <p:spPr>
+          <a:xfrm>
+            <a:off x="685800" y="502920"/>
+            <a:ext cx="36576" cy="658368"/>
+          </a:xfrm>
+          <a:prstGeom prst="rect">
+            <a:avLst/>
+          </a:prstGeom>
+          <a:solidFill>
+            <a:srgbClr val="D9C089"/>
+          </a:solidFill>
+          <a:ln>
+            <a:noFill/>
+          </a:ln>
+        </p:spPr>
+        <p:style>
+          <a:lnRef idx="1">
+            <a:schemeClr val="accent1"/>
+          </a:lnRef>
+          <a:fillRef idx="3">
+            <a:schemeClr val="accent1"/>
+          </a:fillRef>
+          <a:effectRef idx="2">
+            <a:schemeClr val="accent1"/>
+          </a:effectRef>
+          <a:fontRef idx="minor">
+            <a:schemeClr val="lt1"/>
+          </a:fontRef>
+        </p:style>
+        <p:txBody>
+          <a:bodyPr rtlCol="0" anchor="ctr"/>
+          <a:lstStyle/>
+          <a:p>
+            <a:pPr algn="ctr"/>
+          </a:p>
+        </p:txBody>
+      </p:sp>
+      <p:sp>
+        <p:nvSpPr>
+          <p:cNvPr id="7" name="TextBox 6"/>
+          <p:cNvSpPr txBox="1"/>
+          <p:nvPr/>
+        </p:nvSpPr>
+        <p:spPr>
+          <a:xfrm>
+            <a:off x="813816" y="502920"/>
+            <a:ext cx="10634472" cy="685800"/>
+          </a:xfrm>
+          <a:prstGeom prst="rect">
+            <a:avLst/>
+          </a:prstGeom>
+          <a:noFill/>
+        </p:spPr>
+        <p:txBody>
+          <a:bodyPr wrap="square">
+            <a:spAutoFit/>
+          </a:bodyPr>
+          <a:lstStyle/>
+          <a:p>
+            <a:pPr algn="l"/>
+            <a:r>
+              <a:rPr sz="2400" b="1" i="0">
+                <a:solidFill>
+                  <a:srgbClr val="1F2C56"/>
+                </a:solidFill>
+                <a:latin typeface="Source Serif 4"/>
+              </a:rPr>
+              <a:t>Praxisfall: Musterbilanz „Bauer GmbH"</a:t>
+            </a:r>
+          </a:p>
+        </p:txBody>
+      </p:sp>
+      <p:sp>
+        <p:nvSpPr>
+          <p:cNvPr id="8" name="TextBox 7"/>
+          <p:cNvSpPr txBox="1"/>
+          <p:nvPr/>
+        </p:nvSpPr>
+        <p:spPr>
+          <a:xfrm>
+            <a:off x="685800" y="1417320"/>
+            <a:ext cx="10817352" cy="5029200"/>
+          </a:xfrm>
+          <a:prstGeom prst="rect">
+            <a:avLst/>
+          </a:prstGeom>
+          <a:noFill/>
+        </p:spPr>
+        <p:txBody>
+          <a:bodyPr wrap="square">
+            <a:spAutoFit/>
+          </a:bodyPr>
+          <a:lstStyle/>
+          <a:p>
+            <a:pPr>
+              <a:spcBef>
+                <a:spcPts val="400"/>
+              </a:spcBef>
+              <a:spcAft>
+                <a:spcPts val="200"/>
+              </a:spcAft>
+            </a:pPr>
+            <a:r>
+              <a:rPr sz="1200">
+                <a:solidFill>
+                  <a:srgbClr val="3D5466"/>
+                </a:solidFill>
+                <a:latin typeface="Arial"/>
+              </a:rPr>
+              <a:t>Unternehmensportrait (anonymisiert, branchentypisch)</a:t>
+            </a:r>
+          </a:p>
+          <a:p>
+            <a:pPr>
+              <a:spcBef>
+                <a:spcPts val="400"/>
+              </a:spcBef>
+              <a:spcAft>
+                <a:spcPts val="200"/>
+              </a:spcAft>
+            </a:pPr>
+            <a:r>
+              <a:rPr sz="1200">
+                <a:solidFill>
+                  <a:srgbClr val="3D5466"/>
+                </a:solidFill>
+                <a:latin typeface="Arial"/>
+              </a:rPr>
+              <a:t>Situation: Der Kunde beantragt ein neues Investitionsdarlehen über 650.000 EUR für eine neue CNC-Fräsmaschine. Sie bereiten die Kreditvorlage vor und lesen den Jahresabschluss 2023.</a:t>
+            </a:r>
+          </a:p>
+          <a:p>
+            <a:pPr>
+              <a:spcBef>
+                <a:spcPts val="1000"/>
+              </a:spcBef>
+              <a:spcAft>
+                <a:spcPts val="200"/>
+              </a:spcAft>
+            </a:pPr>
+            <a:r>
+              <a:rPr sz="800" b="1">
+                <a:solidFill>
+                  <a:srgbClr val="78808C"/>
+                </a:solidFill>
+                <a:latin typeface="JetBrains Mono"/>
+              </a:rPr>
+              <a:t>MUSTERBILANZ BAUER GMBH (31.12.2023)</a:t>
+            </a:r>
+          </a:p>
+          <a:p>
+            <a:pPr>
+              <a:spcBef>
+                <a:spcPts val="400"/>
+              </a:spcBef>
+              <a:spcAft>
+                <a:spcPts val="200"/>
+              </a:spcAft>
+            </a:pPr>
+            <a:r>
+              <a:rPr sz="1200">
+                <a:solidFill>
+                  <a:srgbClr val="3D5466"/>
+                </a:solidFill>
+                <a:latin typeface="Arial"/>
+              </a:rPr>
+              <a:t>BILANZ – Aktivseite</a:t>
+            </a:r>
+          </a:p>
+          <a:p>
+            <a:pPr>
+              <a:spcBef>
+                <a:spcPts val="400"/>
+              </a:spcBef>
+              <a:spcAft>
+                <a:spcPts val="200"/>
+              </a:spcAft>
+            </a:pPr>
+            <a:r>
+              <a:rPr sz="1200">
+                <a:solidFill>
+                  <a:srgbClr val="3D5466"/>
+                </a:solidFill>
+                <a:latin typeface="Arial"/>
+              </a:rPr>
+              <a:t>BILANZ – Passivseite</a:t>
+            </a:r>
+          </a:p>
+          <a:p>
+            <a:pPr>
+              <a:spcBef>
+                <a:spcPts val="400"/>
+              </a:spcBef>
+              <a:spcAft>
+                <a:spcPts val="200"/>
+              </a:spcAft>
+            </a:pPr>
+            <a:r>
+              <a:rPr sz="1200">
+                <a:solidFill>
+                  <a:srgbClr val="3D5466"/>
+                </a:solidFill>
+                <a:latin typeface="Arial"/>
+              </a:rPr>
+              <a:t>GEWINN- UND VERLUSTRECHNUNG (Gesamtkostenverfahren, § 275 Abs. 2 HGB)</a:t>
+            </a:r>
+          </a:p>
+          <a:p>
+            <a:pPr>
+              <a:spcBef>
+                <a:spcPts val="1000"/>
+              </a:spcBef>
+              <a:spcAft>
+                <a:spcPts val="200"/>
+              </a:spcAft>
+            </a:pPr>
+            <a:r>
+              <a:rPr sz="800" b="1">
+                <a:solidFill>
+                  <a:srgbClr val="78808C"/>
+                </a:solidFill>
+                <a:latin typeface="JetBrains Mono"/>
+              </a:rPr>
+              <a:t>KENNZAHLEN SELBST BERECHNEN – ARBEITSBLATT</a:t>
+            </a:r>
+          </a:p>
+          <a:p>
+            <a:pPr>
+              <a:spcBef>
+                <a:spcPts val="400"/>
+              </a:spcBef>
+              <a:spcAft>
+                <a:spcPts val="200"/>
+              </a:spcAft>
+            </a:pPr>
+            <a:r>
+              <a:rPr sz="1200">
+                <a:solidFill>
+                  <a:srgbClr val="3D5466"/>
+                </a:solidFill>
+                <a:latin typeface="Arial"/>
+              </a:rPr>
+              <a:t>Anleitung: Berechnen Sie alle sechs Kennzahlen anhand der Musterbilanz (2023). Tragen Sie Ihre Ergebnisse ein und vergleichen Sie danach mit Ihrem Partner.</a:t>
+            </a:r>
+          </a:p>
+          <a:p>
+            <a:pPr>
+              <a:spcBef>
+                <a:spcPts val="400"/>
+              </a:spcBef>
+              <a:spcAft>
+                <a:spcPts val="200"/>
+              </a:spcAft>
+            </a:pPr>
+            <a:r>
+              <a:rPr sz="1200">
+                <a:solidFill>
+                  <a:srgbClr val="3D5466"/>
+                </a:solidFill>
+                <a:latin typeface="Arial"/>
+              </a:rPr>
+              <a:t>Kennzahl 1: Eigenkapitalquote</a:t>
+            </a:r>
+          </a:p>
+          <a:p>
+            <a:pPr>
+              <a:spcBef>
+                <a:spcPts val="400"/>
+              </a:spcBef>
+              <a:spcAft>
+                <a:spcPts val="200"/>
+              </a:spcAft>
+            </a:pPr>
+            <a:r>
+              <a:rPr sz="1200">
+                <a:solidFill>
+                  <a:srgbClr val="3D5466"/>
+                </a:solidFill>
+                <a:latin typeface="Arial"/>
+              </a:rPr>
+              <a:t>Formel: EK / Bilanzsumme × 100</a:t>
+            </a:r>
+          </a:p>
+          <a:p>
+            <a:pPr>
+              <a:spcBef>
+                <a:spcPts val="400"/>
+              </a:spcBef>
+              <a:spcAft>
+                <a:spcPts val="200"/>
+              </a:spcAft>
+            </a:pPr>
+            <a:r>
+              <a:rPr sz="1200">
+                <a:solidFill>
+                  <a:srgbClr val="3D5466"/>
+                </a:solidFill>
+                <a:latin typeface="Arial"/>
+              </a:rPr>
+              <a:t>Ihre Rechnung: _______ / _______ × 100 = _______ %</a:t>
+            </a:r>
+          </a:p>
+          <a:p>
+            <a:pPr>
+              <a:spcBef>
+                <a:spcPts val="400"/>
+              </a:spcBef>
+              <a:spcAft>
+                <a:spcPts val="200"/>
+              </a:spcAft>
+            </a:pPr>
+            <a:r>
+              <a:rPr sz="1200">
+                <a:solidFill>
+                  <a:srgbClr val="3D5466"/>
+                </a:solidFill>
+                <a:latin typeface="Arial"/>
+              </a:rPr>
+              <a:t>Bewertung: Grün (&gt; 30 %) | Gelb (15–30 %) | Rot (&lt; 15 %)</a:t>
+            </a:r>
+          </a:p>
+        </p:txBody>
+      </p:sp>
+      <p:sp>
+        <p:nvSpPr>
+          <p:cNvPr id="9" name="Rectangle 8"/>
+          <p:cNvSpPr/>
+          <p:nvPr/>
+        </p:nvSpPr>
+        <p:spPr>
+          <a:xfrm>
+            <a:off x="0" y="6510528"/>
+            <a:ext cx="12188952" cy="347472"/>
+          </a:xfrm>
+          <a:prstGeom prst="rect">
+            <a:avLst/>
+          </a:prstGeom>
+          <a:solidFill>
+            <a:srgbClr val="0A1937"/>
+          </a:solidFill>
+          <a:ln>
+            <a:noFill/>
+          </a:ln>
+        </p:spPr>
+        <p:style>
+          <a:lnRef idx="1">
+            <a:schemeClr val="accent1"/>
+          </a:lnRef>
+          <a:fillRef idx="3">
+            <a:schemeClr val="accent1"/>
+          </a:fillRef>
+          <a:effectRef idx="2">
+            <a:schemeClr val="accent1"/>
+          </a:effectRef>
+          <a:fontRef idx="minor">
+            <a:schemeClr val="lt1"/>
+          </a:fontRef>
+        </p:style>
+        <p:txBody>
+          <a:bodyPr rtlCol="0" anchor="ctr"/>
+          <a:lstStyle/>
+          <a:p>
+            <a:pPr algn="ctr"/>
+          </a:p>
+        </p:txBody>
+      </p:sp>
+      <p:sp>
+        <p:nvSpPr>
+          <p:cNvPr id="10" name="TextBox 9"/>
+          <p:cNvSpPr txBox="1"/>
+          <p:nvPr/>
+        </p:nvSpPr>
+        <p:spPr>
+          <a:xfrm>
+            <a:off x="685800" y="6583680"/>
+            <a:ext cx="6490411" cy="256032"/>
+          </a:xfrm>
+          <a:prstGeom prst="rect">
+            <a:avLst/>
+          </a:prstGeom>
+          <a:noFill/>
+        </p:spPr>
+        <p:txBody>
+          <a:bodyPr wrap="none">
+            <a:spAutoFit/>
+          </a:bodyPr>
+          <a:lstStyle/>
+          <a:p>
+            <a:pPr algn="l"/>
+            <a:r>
+              <a:rPr sz="700">
+                <a:solidFill>
+                  <a:srgbClr val="A0B4D2"/>
+                </a:solidFill>
+                <a:latin typeface="JetBrains Mono"/>
+              </a:rPr>
+              <a:t>Benedikt Zoller Coaching  ·  FKB Campus  ·  M01</a:t>
+            </a:r>
+          </a:p>
+        </p:txBody>
+      </p:sp>
+    </p:spTree>
+  </p:cSld>
+  <p:clrMapOvr>
+    <a:masterClrMapping/>
+  </p:clrMapOvr>
+</p:sld>
+</file>
+
+<file path=ppt/slides/slide7.xml><?xml version="1.0" encoding="utf-8"?>
+<p:sld xmlns:a="http://schemas.openxmlformats.org/drawingml/2006/main" xmlns:p="http://schemas.openxmlformats.org/presentationml/2006/main" xmlns:r="http://schemas.openxmlformats.org/officeDocument/2006/relationships">
+  <p:cSld>
+    <p:spTree>
+      <p:nvGrpSpPr>
+        <p:cNvPr id="1" name=""/>
+        <p:cNvGrpSpPr/>
+        <p:nvPr/>
+      </p:nvGrpSpPr>
+      <p:grpSpPr/>
+      <p:sp>
+        <p:nvSpPr>
+          <p:cNvPr id="2" name="Rectangle 1"/>
+          <p:cNvSpPr/>
+          <p:nvPr/>
+        </p:nvSpPr>
+        <p:spPr>
+          <a:xfrm>
+            <a:off x="0" y="0"/>
+            <a:ext cx="12188952" cy="6858000"/>
+          </a:xfrm>
+          <a:prstGeom prst="rect">
+            <a:avLst/>
+          </a:prstGeom>
+          <a:solidFill>
+            <a:srgbClr val="EDEDF3"/>
+          </a:solidFill>
+          <a:ln>
+            <a:noFill/>
+          </a:ln>
+        </p:spPr>
+        <p:style>
+          <a:lnRef idx="1">
+            <a:schemeClr val="accent1"/>
+          </a:lnRef>
+          <a:fillRef idx="3">
+            <a:schemeClr val="accent1"/>
+          </a:fillRef>
+          <a:effectRef idx="2">
+            <a:schemeClr val="accent1"/>
+          </a:effectRef>
+          <a:fontRef idx="minor">
+            <a:schemeClr val="lt1"/>
+          </a:fontRef>
+        </p:style>
+        <p:txBody>
+          <a:bodyPr rtlCol="0" anchor="ctr"/>
+          <a:lstStyle/>
+          <a:p>
+            <a:pPr algn="ctr"/>
+          </a:p>
+        </p:txBody>
+      </p:sp>
+      <p:sp>
+        <p:nvSpPr>
+          <p:cNvPr id="3" name="Rectangle 2"/>
+          <p:cNvSpPr/>
+          <p:nvPr/>
+        </p:nvSpPr>
+        <p:spPr>
+          <a:xfrm>
+            <a:off x="0" y="0"/>
+            <a:ext cx="12188952" cy="50292"/>
+          </a:xfrm>
+          <a:prstGeom prst="rect">
+            <a:avLst/>
+          </a:prstGeom>
+          <a:solidFill>
+            <a:srgbClr val="1F2C56"/>
+          </a:solidFill>
+          <a:ln>
+            <a:noFill/>
+          </a:ln>
+        </p:spPr>
+        <p:style>
+          <a:lnRef idx="1">
+            <a:schemeClr val="accent1"/>
+          </a:lnRef>
+          <a:fillRef idx="3">
+            <a:schemeClr val="accent1"/>
+          </a:fillRef>
+          <a:effectRef idx="2">
+            <a:schemeClr val="accent1"/>
+          </a:effectRef>
+          <a:fontRef idx="minor">
+            <a:schemeClr val="lt1"/>
+          </a:fontRef>
+        </p:style>
+        <p:txBody>
+          <a:bodyPr rtlCol="0" anchor="ctr"/>
+          <a:lstStyle/>
+          <a:p>
+            <a:pPr algn="ctr"/>
+          </a:p>
+        </p:txBody>
+      </p:sp>
+      <p:sp>
+        <p:nvSpPr>
+          <p:cNvPr id="4" name="TextBox 3"/>
+          <p:cNvSpPr txBox="1"/>
+          <p:nvPr/>
+        </p:nvSpPr>
+        <p:spPr>
+          <a:xfrm>
+            <a:off x="685800" y="109728"/>
+            <a:ext cx="10817352" cy="228600"/>
+          </a:xfrm>
+          <a:prstGeom prst="rect">
+            <a:avLst/>
+          </a:prstGeom>
+          <a:noFill/>
+        </p:spPr>
+        <p:txBody>
+          <a:bodyPr wrap="none">
+            <a:spAutoFit/>
+          </a:bodyPr>
+          <a:lstStyle/>
+          <a:p>
+            <a:pPr algn="l"/>
+            <a:r>
+              <a:rPr sz="750">
+                <a:solidFill>
+                  <a:srgbClr val="78808C"/>
+                </a:solidFill>
+                <a:latin typeface="JetBrains Mono"/>
+              </a:rPr>
+              <a:t>M01  ·  INHALT</a:t>
+            </a:r>
+          </a:p>
+        </p:txBody>
+      </p:sp>
+      <p:sp>
+        <p:nvSpPr>
+          <p:cNvPr id="5" name="Rectangle 4"/>
+          <p:cNvSpPr/>
+          <p:nvPr/>
+        </p:nvSpPr>
+        <p:spPr>
+          <a:xfrm>
+            <a:off x="0" y="1234440"/>
+            <a:ext cx="12188952" cy="12700"/>
+          </a:xfrm>
+          <a:prstGeom prst="rect">
+            <a:avLst/>
+          </a:prstGeom>
+          <a:solidFill>
+            <a:srgbClr val="D8DFE4"/>
+          </a:solidFill>
+          <a:ln>
+            <a:noFill/>
+          </a:ln>
+        </p:spPr>
+        <p:style>
+          <a:lnRef idx="1">
+            <a:schemeClr val="accent1"/>
+          </a:lnRef>
+          <a:fillRef idx="3">
+            <a:schemeClr val="accent1"/>
+          </a:fillRef>
+          <a:effectRef idx="2">
+            <a:schemeClr val="accent1"/>
+          </a:effectRef>
+          <a:fontRef idx="minor">
+            <a:schemeClr val="lt1"/>
+          </a:fontRef>
+        </p:style>
+        <p:txBody>
+          <a:bodyPr rtlCol="0" anchor="ctr"/>
+          <a:lstStyle/>
+          <a:p>
+            <a:pPr algn="ctr"/>
+          </a:p>
+        </p:txBody>
+      </p:sp>
+      <p:sp>
+        <p:nvSpPr>
+          <p:cNvPr id="6" name="Rectangle 5"/>
+          <p:cNvSpPr/>
+          <p:nvPr/>
+        </p:nvSpPr>
+        <p:spPr>
+          <a:xfrm>
+            <a:off x="685800" y="502920"/>
+            <a:ext cx="36576" cy="658368"/>
+          </a:xfrm>
+          <a:prstGeom prst="rect">
+            <a:avLst/>
+          </a:prstGeom>
+          <a:solidFill>
+            <a:srgbClr val="D9C089"/>
+          </a:solidFill>
+          <a:ln>
+            <a:noFill/>
+          </a:ln>
+        </p:spPr>
+        <p:style>
+          <a:lnRef idx="1">
+            <a:schemeClr val="accent1"/>
+          </a:lnRef>
+          <a:fillRef idx="3">
+            <a:schemeClr val="accent1"/>
+          </a:fillRef>
+          <a:effectRef idx="2">
+            <a:schemeClr val="accent1"/>
+          </a:effectRef>
+          <a:fontRef idx="minor">
+            <a:schemeClr val="lt1"/>
+          </a:fontRef>
+        </p:style>
+        <p:txBody>
+          <a:bodyPr rtlCol="0" anchor="ctr"/>
+          <a:lstStyle/>
+          <a:p>
+            <a:pPr algn="ctr"/>
+          </a:p>
+        </p:txBody>
+      </p:sp>
+      <p:sp>
+        <p:nvSpPr>
+          <p:cNvPr id="7" name="TextBox 6"/>
+          <p:cNvSpPr txBox="1"/>
+          <p:nvPr/>
+        </p:nvSpPr>
+        <p:spPr>
+          <a:xfrm>
+            <a:off x="813816" y="502920"/>
+            <a:ext cx="10634472" cy="685800"/>
+          </a:xfrm>
+          <a:prstGeom prst="rect">
+            <a:avLst/>
+          </a:prstGeom>
+          <a:noFill/>
+        </p:spPr>
+        <p:txBody>
+          <a:bodyPr wrap="square">
+            <a:spAutoFit/>
+          </a:bodyPr>
+          <a:lstStyle/>
+          <a:p>
+            <a:pPr algn="l"/>
+            <a:r>
+              <a:rPr sz="2400" b="1" i="0">
+                <a:solidFill>
+                  <a:srgbClr val="1F2C56"/>
+                </a:solidFill>
+                <a:latin typeface="Source Serif 4"/>
+              </a:rPr>
+              <a:t>Reflexionsfragen</a:t>
+            </a:r>
+          </a:p>
+        </p:txBody>
+      </p:sp>
+      <p:sp>
+        <p:nvSpPr>
+          <p:cNvPr id="8" name="TextBox 7"/>
+          <p:cNvSpPr txBox="1"/>
+          <p:nvPr/>
+        </p:nvSpPr>
+        <p:spPr>
+          <a:xfrm>
+            <a:off x="685800" y="1417320"/>
+            <a:ext cx="10817352" cy="5029200"/>
+          </a:xfrm>
+          <a:prstGeom prst="rect">
+            <a:avLst/>
+          </a:prstGeom>
+          <a:noFill/>
+        </p:spPr>
+        <p:txBody>
+          <a:bodyPr wrap="square">
+            <a:spAutoFit/>
+          </a:bodyPr>
+          <a:lstStyle/>
+          <a:p>
+            <a:pPr>
+              <a:spcBef>
+                <a:spcPts val="400"/>
+              </a:spcBef>
+              <a:spcAft>
+                <a:spcPts val="200"/>
+              </a:spcAft>
+            </a:pPr>
+            <a:r>
+              <a:rPr sz="1200">
+                <a:solidFill>
+                  <a:srgbClr val="3D5466"/>
+                </a:solidFill>
+                <a:latin typeface="Arial"/>
+              </a:rPr>
+              <a:t>Beantworten Sie diese Fragen am Ende des Moduls schriftlich (5 Minuten):</a:t>
+            </a:r>
+          </a:p>
+          <a:p>
+            <a:pPr>
+              <a:spcBef>
+                <a:spcPts val="400"/>
+              </a:spcBef>
+              <a:spcAft>
+                <a:spcPts val="200"/>
+              </a:spcAft>
+            </a:pPr>
+            <a:r>
+              <a:rPr sz="1300">
+                <a:solidFill>
+                  <a:srgbClr val="3D5466"/>
+                </a:solidFill>
+                <a:latin typeface="Arial"/>
+              </a:rPr>
+              <a:t>▸  Welche der sechs Kennzahlen war Ihnen vor diesem Modul noch unklar?</a:t>
+            </a:r>
+          </a:p>
+          <a:p>
+            <a:pPr>
+              <a:spcBef>
+                <a:spcPts val="400"/>
+              </a:spcBef>
+              <a:spcAft>
+                <a:spcPts val="200"/>
+              </a:spcAft>
+            </a:pPr>
+            <a:r>
+              <a:rPr sz="1300">
+                <a:solidFill>
+                  <a:srgbClr val="3D5466"/>
+                </a:solidFill>
+                <a:latin typeface="Arial"/>
+              </a:rPr>
+              <a:t>▸  Was ist der kritischste Befund in der Bauer GmbH-Analyse? Wie würden Sie ihn im Kundengespräch ansprechen?</a:t>
+            </a:r>
+          </a:p>
+          <a:p>
+            <a:pPr>
+              <a:spcBef>
+                <a:spcPts val="400"/>
+              </a:spcBef>
+              <a:spcAft>
+                <a:spcPts val="200"/>
+              </a:spcAft>
+            </a:pPr>
+            <a:r>
+              <a:rPr sz="1300">
+                <a:solidFill>
+                  <a:srgbClr val="3D5466"/>
+                </a:solidFill>
+                <a:latin typeface="Arial"/>
+              </a:rPr>
+              <a:t>▸  Welcher Kunde in Ihrem Portfolio kommt Ihnen beim Blick auf die Bauer-Bilanz spontan in den Sinn?</a:t>
+            </a:r>
+          </a:p>
+          <a:p>
+            <a:pPr>
+              <a:spcBef>
+                <a:spcPts val="400"/>
+              </a:spcBef>
+              <a:spcAft>
+                <a:spcPts val="200"/>
+              </a:spcAft>
+            </a:pPr>
+            <a:r>
+              <a:rPr sz="1300">
+                <a:solidFill>
+                  <a:srgbClr val="3D5466"/>
+                </a:solidFill>
+                <a:latin typeface="Arial"/>
+              </a:rPr>
+              <a:t>▸  Was werden Sie konkret in den nächsten 30 Tagen anders machen, wenn ein Jahresabschluss auf Ihrem Tisch liegt?</a:t>
+            </a:r>
+          </a:p>
+        </p:txBody>
+      </p:sp>
+      <p:sp>
+        <p:nvSpPr>
+          <p:cNvPr id="9" name="Rectangle 8"/>
+          <p:cNvSpPr/>
+          <p:nvPr/>
+        </p:nvSpPr>
+        <p:spPr>
+          <a:xfrm>
+            <a:off x="0" y="6510528"/>
+            <a:ext cx="12188952" cy="347472"/>
+          </a:xfrm>
+          <a:prstGeom prst="rect">
+            <a:avLst/>
+          </a:prstGeom>
+          <a:solidFill>
+            <a:srgbClr val="0A1937"/>
+          </a:solidFill>
+          <a:ln>
+            <a:noFill/>
+          </a:ln>
+        </p:spPr>
+        <p:style>
+          <a:lnRef idx="1">
+            <a:schemeClr val="accent1"/>
+          </a:lnRef>
+          <a:fillRef idx="3">
+            <a:schemeClr val="accent1"/>
+          </a:fillRef>
+          <a:effectRef idx="2">
+            <a:schemeClr val="accent1"/>
+          </a:effectRef>
+          <a:fontRef idx="minor">
+            <a:schemeClr val="lt1"/>
+          </a:fontRef>
+        </p:style>
+        <p:txBody>
+          <a:bodyPr rtlCol="0" anchor="ctr"/>
+          <a:lstStyle/>
+          <a:p>
+            <a:pPr algn="ctr"/>
+          </a:p>
+        </p:txBody>
+      </p:sp>
+      <p:sp>
+        <p:nvSpPr>
+          <p:cNvPr id="10" name="TextBox 9"/>
+          <p:cNvSpPr txBox="1"/>
+          <p:nvPr/>
+        </p:nvSpPr>
+        <p:spPr>
+          <a:xfrm>
+            <a:off x="685800" y="6583680"/>
+            <a:ext cx="6490411" cy="256032"/>
+          </a:xfrm>
+          <a:prstGeom prst="rect">
+            <a:avLst/>
+          </a:prstGeom>
+          <a:noFill/>
+        </p:spPr>
+        <p:txBody>
+          <a:bodyPr wrap="none">
+            <a:spAutoFit/>
+          </a:bodyPr>
+          <a:lstStyle/>
+          <a:p>
+            <a:pPr algn="l"/>
+            <a:r>
+              <a:rPr sz="700">
+                <a:solidFill>
+                  <a:srgbClr val="A0B4D2"/>
+                </a:solidFill>
+                <a:latin typeface="JetBrains Mono"/>
+              </a:rPr>
+              <a:t>Benedikt Zoller Coaching  ·  FKB Campus  ·  M01</a:t>
+            </a:r>
+          </a:p>
+        </p:txBody>
+      </p:sp>
     </p:spTree>
   </p:cSld>
   <p:clrMapOvr>

</xml_diff>

<commit_message>
M01: Konzeptgrafiken in alle Artefakte integriert (Analyseprozess + Handlungsempfehlung)
Web-Modulseite, Teilnehmerunterlagen, Trainerhandbuch und PPTX zeigen jetzt
die Modulgrafiken. Pilot für den Rollout M02-M22.

Co-Authored-By: Claude Opus 4 <noreply@anthropic.com>
</commit_message>
<xml_diff>
--- a/public/downloads/praesentation/M01.pptx
+++ b/public/downloads/praesentation/M01.pptx
@@ -12,6 +12,8 @@
     <p:sldId id="260" r:id="rId11"/>
     <p:sldId id="261" r:id="rId12"/>
     <p:sldId id="262" r:id="rId13"/>
+    <p:sldId id="263" r:id="rId14"/>
+    <p:sldId id="264" r:id="rId15"/>
   </p:sldIdLst>
   <p:sldSz cx="12188952" cy="6858000" type="screen4x3"/>
   <p:notesSz cx="6858000" cy="9144000"/>
@@ -5645,6 +5647,25 @@
           <a:p>
             <a:pPr>
               <a:spcBef>
+                <a:spcPts val="400"/>
+              </a:spcBef>
+              <a:spcAft>
+                <a:spcPts val="200"/>
+              </a:spcAft>
+            </a:pPr>
+            <a:r>
+              <a:rPr sz="1200">
+                <a:solidFill>
+                  <a:srgbClr val="3D5466"/>
+                </a:solidFill>
+                <a:latin typeface="Arial"/>
+              </a:rPr>
+              <a:t>Die folgende Handlungsempfehlung verknüpft typische Bilanzsignale mit der passenden Reaktion im Kreditgespräch – nutzen Sie sie als Orientierung bei der Auswertung des Praxisfalls.</a:t>
+            </a:r>
+          </a:p>
+          <a:p>
+            <a:pPr>
+              <a:spcBef>
                 <a:spcPts val="1000"/>
               </a:spcBef>
               <a:spcAft>
@@ -5811,25 +5832,6 @@
                 <a:latin typeface="Arial"/>
               </a:rPr>
               <a:t>Ihre Rechnung: _______ / _______ × 100 = _______ %</a:t>
-            </a:r>
-          </a:p>
-          <a:p>
-            <a:pPr>
-              <a:spcBef>
-                <a:spcPts val="400"/>
-              </a:spcBef>
-              <a:spcAft>
-                <a:spcPts val="200"/>
-              </a:spcAft>
-            </a:pPr>
-            <a:r>
-              <a:rPr sz="1200">
-                <a:solidFill>
-                  <a:srgbClr val="3D5466"/>
-                </a:solidFill>
-                <a:latin typeface="Arial"/>
-              </a:rPr>
-              <a:t>Bewertung: Grün (&gt; 30 %) | Gelb (15–30 %) | Rot (&lt; 15 %)</a:t>
             </a:r>
           </a:p>
         </p:txBody>
@@ -5921,6 +5923,714 @@
 </file>
 
 <file path=ppt/slides/slide7.xml><?xml version="1.0" encoding="utf-8"?>
+<p:sld xmlns:a="http://schemas.openxmlformats.org/drawingml/2006/main" xmlns:p="http://schemas.openxmlformats.org/presentationml/2006/main" xmlns:r="http://schemas.openxmlformats.org/officeDocument/2006/relationships">
+  <p:cSld>
+    <p:spTree>
+      <p:nvGrpSpPr>
+        <p:cNvPr id="1" name=""/>
+        <p:cNvGrpSpPr/>
+        <p:nvPr/>
+      </p:nvGrpSpPr>
+      <p:grpSpPr/>
+      <p:sp>
+        <p:nvSpPr>
+          <p:cNvPr id="2" name="Rectangle 1"/>
+          <p:cNvSpPr/>
+          <p:nvPr/>
+        </p:nvSpPr>
+        <p:spPr>
+          <a:xfrm>
+            <a:off x="0" y="0"/>
+            <a:ext cx="12188952" cy="6858000"/>
+          </a:xfrm>
+          <a:prstGeom prst="rect">
+            <a:avLst/>
+          </a:prstGeom>
+          <a:solidFill>
+            <a:srgbClr val="FFFFFF"/>
+          </a:solidFill>
+          <a:ln>
+            <a:noFill/>
+          </a:ln>
+        </p:spPr>
+        <p:style>
+          <a:lnRef idx="1">
+            <a:schemeClr val="accent1"/>
+          </a:lnRef>
+          <a:fillRef idx="3">
+            <a:schemeClr val="accent1"/>
+          </a:fillRef>
+          <a:effectRef idx="2">
+            <a:schemeClr val="accent1"/>
+          </a:effectRef>
+          <a:fontRef idx="minor">
+            <a:schemeClr val="lt1"/>
+          </a:fontRef>
+        </p:style>
+        <p:txBody>
+          <a:bodyPr rtlCol="0" anchor="ctr"/>
+          <a:lstStyle/>
+          <a:p>
+            <a:pPr algn="ctr"/>
+          </a:p>
+        </p:txBody>
+      </p:sp>
+      <p:sp>
+        <p:nvSpPr>
+          <p:cNvPr id="3" name="Rectangle 2"/>
+          <p:cNvSpPr/>
+          <p:nvPr/>
+        </p:nvSpPr>
+        <p:spPr>
+          <a:xfrm>
+            <a:off x="0" y="0"/>
+            <a:ext cx="12188952" cy="50292"/>
+          </a:xfrm>
+          <a:prstGeom prst="rect">
+            <a:avLst/>
+          </a:prstGeom>
+          <a:solidFill>
+            <a:srgbClr val="1F2C56"/>
+          </a:solidFill>
+          <a:ln>
+            <a:noFill/>
+          </a:ln>
+        </p:spPr>
+        <p:style>
+          <a:lnRef idx="1">
+            <a:schemeClr val="accent1"/>
+          </a:lnRef>
+          <a:fillRef idx="3">
+            <a:schemeClr val="accent1"/>
+          </a:fillRef>
+          <a:effectRef idx="2">
+            <a:schemeClr val="accent1"/>
+          </a:effectRef>
+          <a:fontRef idx="minor">
+            <a:schemeClr val="lt1"/>
+          </a:fontRef>
+        </p:style>
+        <p:txBody>
+          <a:bodyPr rtlCol="0" anchor="ctr"/>
+          <a:lstStyle/>
+          <a:p>
+            <a:pPr algn="ctr"/>
+          </a:p>
+        </p:txBody>
+      </p:sp>
+      <p:sp>
+        <p:nvSpPr>
+          <p:cNvPr id="4" name="TextBox 3"/>
+          <p:cNvSpPr txBox="1"/>
+          <p:nvPr/>
+        </p:nvSpPr>
+        <p:spPr>
+          <a:xfrm>
+            <a:off x="685800" y="109728"/>
+            <a:ext cx="10817352" cy="228600"/>
+          </a:xfrm>
+          <a:prstGeom prst="rect">
+            <a:avLst/>
+          </a:prstGeom>
+          <a:noFill/>
+        </p:spPr>
+        <p:txBody>
+          <a:bodyPr wrap="none">
+            <a:spAutoFit/>
+          </a:bodyPr>
+          <a:lstStyle/>
+          <a:p>
+            <a:pPr algn="l"/>
+            <a:r>
+              <a:rPr sz="750">
+                <a:solidFill>
+                  <a:srgbClr val="78808C"/>
+                </a:solidFill>
+                <a:latin typeface="JetBrains Mono"/>
+              </a:rPr>
+              <a:t>M01  ·  SCHAUBILD</a:t>
+            </a:r>
+          </a:p>
+        </p:txBody>
+      </p:sp>
+      <p:sp>
+        <p:nvSpPr>
+          <p:cNvPr id="5" name="TextBox 4"/>
+          <p:cNvSpPr txBox="1"/>
+          <p:nvPr/>
+        </p:nvSpPr>
+        <p:spPr>
+          <a:xfrm>
+            <a:off x="685800" y="502920"/>
+            <a:ext cx="10817352" cy="594360"/>
+          </a:xfrm>
+          <a:prstGeom prst="rect">
+            <a:avLst/>
+          </a:prstGeom>
+          <a:noFill/>
+        </p:spPr>
+        <p:txBody>
+          <a:bodyPr wrap="square">
+            <a:spAutoFit/>
+          </a:bodyPr>
+          <a:lstStyle/>
+          <a:p>
+            <a:pPr algn="l"/>
+            <a:r>
+              <a:rPr sz="2000" b="1" i="0">
+                <a:solidFill>
+                  <a:srgbClr val="1F2C56"/>
+                </a:solidFill>
+                <a:latin typeface="Source Serif 4"/>
+              </a:rPr>
+              <a:t>Analyseprozess in vier Schritten</a:t>
+            </a:r>
+          </a:p>
+        </p:txBody>
+      </p:sp>
+      <p:sp>
+        <p:nvSpPr>
+          <p:cNvPr id="6" name="Rectangle 5"/>
+          <p:cNvSpPr/>
+          <p:nvPr/>
+        </p:nvSpPr>
+        <p:spPr>
+          <a:xfrm>
+            <a:off x="685800" y="1143000"/>
+            <a:ext cx="10817352" cy="25400"/>
+          </a:xfrm>
+          <a:prstGeom prst="rect">
+            <a:avLst/>
+          </a:prstGeom>
+          <a:solidFill>
+            <a:srgbClr val="D9C089"/>
+          </a:solidFill>
+          <a:ln>
+            <a:noFill/>
+          </a:ln>
+        </p:spPr>
+        <p:style>
+          <a:lnRef idx="1">
+            <a:schemeClr val="accent1"/>
+          </a:lnRef>
+          <a:fillRef idx="3">
+            <a:schemeClr val="accent1"/>
+          </a:fillRef>
+          <a:effectRef idx="2">
+            <a:schemeClr val="accent1"/>
+          </a:effectRef>
+          <a:fontRef idx="minor">
+            <a:schemeClr val="lt1"/>
+          </a:fontRef>
+        </p:style>
+        <p:txBody>
+          <a:bodyPr rtlCol="0" anchor="ctr"/>
+          <a:lstStyle/>
+          <a:p>
+            <a:pPr algn="ctr"/>
+          </a:p>
+        </p:txBody>
+      </p:sp>
+      <p:pic>
+        <p:nvPicPr>
+          <p:cNvPr id="7" name="Picture 6" descr="image.png"/>
+          <p:cNvPicPr>
+            <a:picLocks noChangeAspect="1"/>
+          </p:cNvPicPr>
+          <p:nvPr/>
+        </p:nvPicPr>
+        <p:blipFill>
+          <a:blip r:embed="rId2"/>
+          <a:stretch>
+            <a:fillRect/>
+          </a:stretch>
+        </p:blipFill>
+        <p:spPr>
+          <a:xfrm>
+            <a:off x="1670951" y="1325880"/>
+            <a:ext cx="8847050" cy="4937760"/>
+          </a:xfrm>
+          <a:prstGeom prst="rect">
+            <a:avLst/>
+          </a:prstGeom>
+        </p:spPr>
+      </p:pic>
+      <p:sp>
+        <p:nvSpPr>
+          <p:cNvPr id="8" name="Rectangle 7"/>
+          <p:cNvSpPr/>
+          <p:nvPr/>
+        </p:nvSpPr>
+        <p:spPr>
+          <a:xfrm>
+            <a:off x="0" y="6510528"/>
+            <a:ext cx="12188952" cy="347472"/>
+          </a:xfrm>
+          <a:prstGeom prst="rect">
+            <a:avLst/>
+          </a:prstGeom>
+          <a:solidFill>
+            <a:srgbClr val="0A1937"/>
+          </a:solidFill>
+          <a:ln>
+            <a:noFill/>
+          </a:ln>
+        </p:spPr>
+        <p:style>
+          <a:lnRef idx="1">
+            <a:schemeClr val="accent1"/>
+          </a:lnRef>
+          <a:fillRef idx="3">
+            <a:schemeClr val="accent1"/>
+          </a:fillRef>
+          <a:effectRef idx="2">
+            <a:schemeClr val="accent1"/>
+          </a:effectRef>
+          <a:fontRef idx="minor">
+            <a:schemeClr val="lt1"/>
+          </a:fontRef>
+        </p:style>
+        <p:txBody>
+          <a:bodyPr rtlCol="0" anchor="ctr"/>
+          <a:lstStyle/>
+          <a:p>
+            <a:pPr algn="ctr"/>
+          </a:p>
+        </p:txBody>
+      </p:sp>
+      <p:sp>
+        <p:nvSpPr>
+          <p:cNvPr id="9" name="TextBox 8"/>
+          <p:cNvSpPr txBox="1"/>
+          <p:nvPr/>
+        </p:nvSpPr>
+        <p:spPr>
+          <a:xfrm>
+            <a:off x="685800" y="6583680"/>
+            <a:ext cx="6490411" cy="256032"/>
+          </a:xfrm>
+          <a:prstGeom prst="rect">
+            <a:avLst/>
+          </a:prstGeom>
+          <a:noFill/>
+        </p:spPr>
+        <p:txBody>
+          <a:bodyPr wrap="none">
+            <a:spAutoFit/>
+          </a:bodyPr>
+          <a:lstStyle/>
+          <a:p>
+            <a:pPr algn="l"/>
+            <a:r>
+              <a:rPr sz="700">
+                <a:solidFill>
+                  <a:srgbClr val="A0B4D2"/>
+                </a:solidFill>
+                <a:latin typeface="JetBrains Mono"/>
+              </a:rPr>
+              <a:t>Benedikt Zoller Coaching  ·  FKB Campus  ·  M01</a:t>
+            </a:r>
+          </a:p>
+        </p:txBody>
+      </p:sp>
+      <p:sp>
+        <p:nvSpPr>
+          <p:cNvPr id="10" name="TextBox 9"/>
+          <p:cNvSpPr txBox="1"/>
+          <p:nvPr/>
+        </p:nvSpPr>
+        <p:spPr>
+          <a:xfrm>
+            <a:off x="7176211" y="6583680"/>
+            <a:ext cx="4326940" cy="256032"/>
+          </a:xfrm>
+          <a:prstGeom prst="rect">
+            <a:avLst/>
+          </a:prstGeom>
+          <a:noFill/>
+        </p:spPr>
+        <p:txBody>
+          <a:bodyPr wrap="none">
+            <a:spAutoFit/>
+          </a:bodyPr>
+          <a:lstStyle/>
+          <a:p>
+            <a:pPr algn="r"/>
+            <a:r>
+              <a:rPr sz="700">
+                <a:solidFill>
+                  <a:srgbClr val="A0B4D2"/>
+                </a:solidFill>
+                <a:latin typeface="JetBrains Mono"/>
+              </a:rPr>
+              <a:t>Schaubild</a:t>
+            </a:r>
+          </a:p>
+        </p:txBody>
+      </p:sp>
+    </p:spTree>
+  </p:cSld>
+  <p:clrMapOvr>
+    <a:masterClrMapping/>
+  </p:clrMapOvr>
+</p:sld>
+</file>
+
+<file path=ppt/slides/slide8.xml><?xml version="1.0" encoding="utf-8"?>
+<p:sld xmlns:a="http://schemas.openxmlformats.org/drawingml/2006/main" xmlns:p="http://schemas.openxmlformats.org/presentationml/2006/main" xmlns:r="http://schemas.openxmlformats.org/officeDocument/2006/relationships">
+  <p:cSld>
+    <p:spTree>
+      <p:nvGrpSpPr>
+        <p:cNvPr id="1" name=""/>
+        <p:cNvGrpSpPr/>
+        <p:nvPr/>
+      </p:nvGrpSpPr>
+      <p:grpSpPr/>
+      <p:sp>
+        <p:nvSpPr>
+          <p:cNvPr id="2" name="Rectangle 1"/>
+          <p:cNvSpPr/>
+          <p:nvPr/>
+        </p:nvSpPr>
+        <p:spPr>
+          <a:xfrm>
+            <a:off x="0" y="0"/>
+            <a:ext cx="12188952" cy="6858000"/>
+          </a:xfrm>
+          <a:prstGeom prst="rect">
+            <a:avLst/>
+          </a:prstGeom>
+          <a:solidFill>
+            <a:srgbClr val="FFFFFF"/>
+          </a:solidFill>
+          <a:ln>
+            <a:noFill/>
+          </a:ln>
+        </p:spPr>
+        <p:style>
+          <a:lnRef idx="1">
+            <a:schemeClr val="accent1"/>
+          </a:lnRef>
+          <a:fillRef idx="3">
+            <a:schemeClr val="accent1"/>
+          </a:fillRef>
+          <a:effectRef idx="2">
+            <a:schemeClr val="accent1"/>
+          </a:effectRef>
+          <a:fontRef idx="minor">
+            <a:schemeClr val="lt1"/>
+          </a:fontRef>
+        </p:style>
+        <p:txBody>
+          <a:bodyPr rtlCol="0" anchor="ctr"/>
+          <a:lstStyle/>
+          <a:p>
+            <a:pPr algn="ctr"/>
+          </a:p>
+        </p:txBody>
+      </p:sp>
+      <p:sp>
+        <p:nvSpPr>
+          <p:cNvPr id="3" name="Rectangle 2"/>
+          <p:cNvSpPr/>
+          <p:nvPr/>
+        </p:nvSpPr>
+        <p:spPr>
+          <a:xfrm>
+            <a:off x="0" y="0"/>
+            <a:ext cx="12188952" cy="50292"/>
+          </a:xfrm>
+          <a:prstGeom prst="rect">
+            <a:avLst/>
+          </a:prstGeom>
+          <a:solidFill>
+            <a:srgbClr val="1F2C56"/>
+          </a:solidFill>
+          <a:ln>
+            <a:noFill/>
+          </a:ln>
+        </p:spPr>
+        <p:style>
+          <a:lnRef idx="1">
+            <a:schemeClr val="accent1"/>
+          </a:lnRef>
+          <a:fillRef idx="3">
+            <a:schemeClr val="accent1"/>
+          </a:fillRef>
+          <a:effectRef idx="2">
+            <a:schemeClr val="accent1"/>
+          </a:effectRef>
+          <a:fontRef idx="minor">
+            <a:schemeClr val="lt1"/>
+          </a:fontRef>
+        </p:style>
+        <p:txBody>
+          <a:bodyPr rtlCol="0" anchor="ctr"/>
+          <a:lstStyle/>
+          <a:p>
+            <a:pPr algn="ctr"/>
+          </a:p>
+        </p:txBody>
+      </p:sp>
+      <p:sp>
+        <p:nvSpPr>
+          <p:cNvPr id="4" name="TextBox 3"/>
+          <p:cNvSpPr txBox="1"/>
+          <p:nvPr/>
+        </p:nvSpPr>
+        <p:spPr>
+          <a:xfrm>
+            <a:off x="685800" y="109728"/>
+            <a:ext cx="10817352" cy="228600"/>
+          </a:xfrm>
+          <a:prstGeom prst="rect">
+            <a:avLst/>
+          </a:prstGeom>
+          <a:noFill/>
+        </p:spPr>
+        <p:txBody>
+          <a:bodyPr wrap="none">
+            <a:spAutoFit/>
+          </a:bodyPr>
+          <a:lstStyle/>
+          <a:p>
+            <a:pPr algn="l"/>
+            <a:r>
+              <a:rPr sz="750">
+                <a:solidFill>
+                  <a:srgbClr val="78808C"/>
+                </a:solidFill>
+                <a:latin typeface="JetBrains Mono"/>
+              </a:rPr>
+              <a:t>M01  ·  SCHAUBILD</a:t>
+            </a:r>
+          </a:p>
+        </p:txBody>
+      </p:sp>
+      <p:sp>
+        <p:nvSpPr>
+          <p:cNvPr id="5" name="TextBox 4"/>
+          <p:cNvSpPr txBox="1"/>
+          <p:nvPr/>
+        </p:nvSpPr>
+        <p:spPr>
+          <a:xfrm>
+            <a:off x="685800" y="502920"/>
+            <a:ext cx="10817352" cy="594360"/>
+          </a:xfrm>
+          <a:prstGeom prst="rect">
+            <a:avLst/>
+          </a:prstGeom>
+          <a:noFill/>
+        </p:spPr>
+        <p:txBody>
+          <a:bodyPr wrap="square">
+            <a:spAutoFit/>
+          </a:bodyPr>
+          <a:lstStyle/>
+          <a:p>
+            <a:pPr algn="l"/>
+            <a:r>
+              <a:rPr sz="2000" b="1" i="0">
+                <a:solidFill>
+                  <a:srgbClr val="1F2C56"/>
+                </a:solidFill>
+                <a:latin typeface="Source Serif 4"/>
+              </a:rPr>
+              <a:t>Handlungsempfehlung</a:t>
+            </a:r>
+          </a:p>
+        </p:txBody>
+      </p:sp>
+      <p:sp>
+        <p:nvSpPr>
+          <p:cNvPr id="6" name="Rectangle 5"/>
+          <p:cNvSpPr/>
+          <p:nvPr/>
+        </p:nvSpPr>
+        <p:spPr>
+          <a:xfrm>
+            <a:off x="685800" y="1143000"/>
+            <a:ext cx="10817352" cy="25400"/>
+          </a:xfrm>
+          <a:prstGeom prst="rect">
+            <a:avLst/>
+          </a:prstGeom>
+          <a:solidFill>
+            <a:srgbClr val="D9C089"/>
+          </a:solidFill>
+          <a:ln>
+            <a:noFill/>
+          </a:ln>
+        </p:spPr>
+        <p:style>
+          <a:lnRef idx="1">
+            <a:schemeClr val="accent1"/>
+          </a:lnRef>
+          <a:fillRef idx="3">
+            <a:schemeClr val="accent1"/>
+          </a:fillRef>
+          <a:effectRef idx="2">
+            <a:schemeClr val="accent1"/>
+          </a:effectRef>
+          <a:fontRef idx="minor">
+            <a:schemeClr val="lt1"/>
+          </a:fontRef>
+        </p:style>
+        <p:txBody>
+          <a:bodyPr rtlCol="0" anchor="ctr"/>
+          <a:lstStyle/>
+          <a:p>
+            <a:pPr algn="ctr"/>
+          </a:p>
+        </p:txBody>
+      </p:sp>
+      <p:pic>
+        <p:nvPicPr>
+          <p:cNvPr id="7" name="Picture 6" descr="image.png"/>
+          <p:cNvPicPr>
+            <a:picLocks noChangeAspect="1"/>
+          </p:cNvPicPr>
+          <p:nvPr/>
+        </p:nvPicPr>
+        <p:blipFill>
+          <a:blip r:embed="rId2"/>
+          <a:stretch>
+            <a:fillRect/>
+          </a:stretch>
+        </p:blipFill>
+        <p:spPr>
+          <a:xfrm>
+            <a:off x="2303489" y="1325880"/>
+            <a:ext cx="7581973" cy="4937760"/>
+          </a:xfrm>
+          <a:prstGeom prst="rect">
+            <a:avLst/>
+          </a:prstGeom>
+        </p:spPr>
+      </p:pic>
+      <p:sp>
+        <p:nvSpPr>
+          <p:cNvPr id="8" name="Rectangle 7"/>
+          <p:cNvSpPr/>
+          <p:nvPr/>
+        </p:nvSpPr>
+        <p:spPr>
+          <a:xfrm>
+            <a:off x="0" y="6510528"/>
+            <a:ext cx="12188952" cy="347472"/>
+          </a:xfrm>
+          <a:prstGeom prst="rect">
+            <a:avLst/>
+          </a:prstGeom>
+          <a:solidFill>
+            <a:srgbClr val="0A1937"/>
+          </a:solidFill>
+          <a:ln>
+            <a:noFill/>
+          </a:ln>
+        </p:spPr>
+        <p:style>
+          <a:lnRef idx="1">
+            <a:schemeClr val="accent1"/>
+          </a:lnRef>
+          <a:fillRef idx="3">
+            <a:schemeClr val="accent1"/>
+          </a:fillRef>
+          <a:effectRef idx="2">
+            <a:schemeClr val="accent1"/>
+          </a:effectRef>
+          <a:fontRef idx="minor">
+            <a:schemeClr val="lt1"/>
+          </a:fontRef>
+        </p:style>
+        <p:txBody>
+          <a:bodyPr rtlCol="0" anchor="ctr"/>
+          <a:lstStyle/>
+          <a:p>
+            <a:pPr algn="ctr"/>
+          </a:p>
+        </p:txBody>
+      </p:sp>
+      <p:sp>
+        <p:nvSpPr>
+          <p:cNvPr id="9" name="TextBox 8"/>
+          <p:cNvSpPr txBox="1"/>
+          <p:nvPr/>
+        </p:nvSpPr>
+        <p:spPr>
+          <a:xfrm>
+            <a:off x="685800" y="6583680"/>
+            <a:ext cx="6490411" cy="256032"/>
+          </a:xfrm>
+          <a:prstGeom prst="rect">
+            <a:avLst/>
+          </a:prstGeom>
+          <a:noFill/>
+        </p:spPr>
+        <p:txBody>
+          <a:bodyPr wrap="none">
+            <a:spAutoFit/>
+          </a:bodyPr>
+          <a:lstStyle/>
+          <a:p>
+            <a:pPr algn="l"/>
+            <a:r>
+              <a:rPr sz="700">
+                <a:solidFill>
+                  <a:srgbClr val="A0B4D2"/>
+                </a:solidFill>
+                <a:latin typeface="JetBrains Mono"/>
+              </a:rPr>
+              <a:t>Benedikt Zoller Coaching  ·  FKB Campus  ·  M01</a:t>
+            </a:r>
+          </a:p>
+        </p:txBody>
+      </p:sp>
+      <p:sp>
+        <p:nvSpPr>
+          <p:cNvPr id="10" name="TextBox 9"/>
+          <p:cNvSpPr txBox="1"/>
+          <p:nvPr/>
+        </p:nvSpPr>
+        <p:spPr>
+          <a:xfrm>
+            <a:off x="7176211" y="6583680"/>
+            <a:ext cx="4326940" cy="256032"/>
+          </a:xfrm>
+          <a:prstGeom prst="rect">
+            <a:avLst/>
+          </a:prstGeom>
+          <a:noFill/>
+        </p:spPr>
+        <p:txBody>
+          <a:bodyPr wrap="none">
+            <a:spAutoFit/>
+          </a:bodyPr>
+          <a:lstStyle/>
+          <a:p>
+            <a:pPr algn="r"/>
+            <a:r>
+              <a:rPr sz="700">
+                <a:solidFill>
+                  <a:srgbClr val="A0B4D2"/>
+                </a:solidFill>
+                <a:latin typeface="JetBrains Mono"/>
+              </a:rPr>
+              <a:t>Schaubild</a:t>
+            </a:r>
+          </a:p>
+        </p:txBody>
+      </p:sp>
+    </p:spTree>
+  </p:cSld>
+  <p:clrMapOvr>
+    <a:masterClrMapping/>
+  </p:clrMapOvr>
+</p:sld>
+</file>
+
+<file path=ppt/slides/slide9.xml><?xml version="1.0" encoding="utf-8"?>
 <p:sld xmlns:a="http://schemas.openxmlformats.org/drawingml/2006/main" xmlns:p="http://schemas.openxmlformats.org/presentationml/2006/main" xmlns:r="http://schemas.openxmlformats.org/officeDocument/2006/relationships">
   <p:cSld>
     <p:spTree>

</xml_diff>